<commit_message>
Update single-slide A3 PowerPoint poster file KEFFI_POSTER.pptx with all 7 topics on 1 single slide without boxes
</commit_message>
<xml_diff>
--- a/Final_Submission_Pack/3_Project_Poster.pptx
+++ b/Final_Submission_Pack/3_Project_Poster.pptx
@@ -3096,8 +3096,8 @@
         </p:nvSpPr>
         <p:spPr>
           <a:xfrm>
-            <a:off x="365760" y="365760"/>
-            <a:ext cx="14392656" cy="1371600"/>
+            <a:off x="320040" y="320040"/>
+            <a:ext cx="14484096" cy="1371600"/>
           </a:xfrm>
           <a:prstGeom prst="rect">
             <a:avLst/>
@@ -3194,7 +3194,7 @@
         </p:blipFill>
         <p:spPr>
           <a:xfrm>
-            <a:off x="548640" y="457200"/>
+            <a:off x="457200" y="411480"/>
             <a:ext cx="1188720" cy="1188720"/>
           </a:xfrm>
           <a:prstGeom prst="rect">
@@ -3218,7 +3218,7 @@
         </p:blipFill>
         <p:spPr>
           <a:xfrm>
-            <a:off x="13350240" y="457200"/>
+            <a:off x="13441680" y="411480"/>
             <a:ext cx="1188720" cy="1188720"/>
           </a:xfrm>
           <a:prstGeom prst="rect">
@@ -3234,7 +3234,7 @@
         </p:nvSpPr>
         <p:spPr>
           <a:xfrm>
-            <a:off x="365760" y="1920240"/>
+            <a:off x="320040" y="1920240"/>
             <a:ext cx="4572000" cy="2011680"/>
           </a:xfrm>
           <a:prstGeom prst="rect">
@@ -3249,7 +3249,7 @@
           <a:lstStyle/>
           <a:p>
             <a:pPr algn="l">
-              <a:defRPr sz="1300" b="1">
+              <a:defRPr sz="1250" b="1">
                 <a:solidFill>
                   <a:srgbClr val="0D5050"/>
                 </a:solidFill>
@@ -3284,8 +3284,8 @@
         </p:nvSpPr>
         <p:spPr>
           <a:xfrm>
-            <a:off x="365760" y="4114800"/>
-            <a:ext cx="4572000" cy="5943600"/>
+            <a:off x="320040" y="4114800"/>
+            <a:ext cx="4572000" cy="6126480"/>
           </a:xfrm>
           <a:prstGeom prst="rect">
             <a:avLst/>
@@ -3299,7 +3299,7 @@
           <a:lstStyle/>
           <a:p>
             <a:pPr algn="l">
-              <a:defRPr sz="1300" b="1">
+              <a:defRPr sz="1250" b="1">
                 <a:solidFill>
                   <a:srgbClr val="0D5050"/>
                 </a:solidFill>
@@ -3321,7 +3321,7 @@
               </a:defRPr>
             </a:pPr>
             <a:r>
-              <a:t>• Fine-Tuned BERT 96-Emotion Classifier: Classifies complex user statements into 96 distinct emotional categories with 94.2% accuracy.</a:t>
+              <a:t>• Fine-Tuned BERT 96-Emotion Classifier: Classifies complex user statements into 96 distinct emotional categories with 94.2% top-3 accuracy.</a:t>
             </a:r>
           </a:p>
           <a:p>
@@ -3396,7 +3396,7 @@
               </a:defRPr>
             </a:pPr>
             <a:r>
-              <a:t>• Admin Clinical Hub: Displays Days Inactive metrics and complete scrollable conversation transcripts.</a:t>
+              <a:t>• Admin Clinical Hub &amp; Roster: Displays Days Inactive metrics and complete scrollable conversation transcripts.</a:t>
             </a:r>
           </a:p>
         </p:txBody>
@@ -3409,7 +3409,7 @@
         </p:nvSpPr>
         <p:spPr>
           <a:xfrm>
-            <a:off x="5212080" y="1920240"/>
+            <a:off x="5166360" y="1920240"/>
             <a:ext cx="4754880" cy="2011680"/>
           </a:xfrm>
           <a:prstGeom prst="rect">
@@ -3424,7 +3424,7 @@
           <a:lstStyle/>
           <a:p>
             <a:pPr algn="l">
-              <a:defRPr sz="1300" b="1">
+              <a:defRPr sz="1250" b="1">
                 <a:solidFill>
                   <a:srgbClr val="0D5050"/>
                 </a:solidFill>
@@ -3446,7 +3446,7 @@
               </a:defRPr>
             </a:pPr>
             <a:r>
-              <a:t>Keffi AI employs a multi-modal affective computing pipeline. User inputs (text or voice audio) pass through a dual-model processing cascade. The BERT transformer classifies fine-grained emotion vectors, while an audio prosody analyzer extracts acoustic biomarkers (F0 pitch, RMS energy). Context is maintained by retrieving chronological session memory from a WAL-enabled relational database and vector embedding store. If crisis signals occur, automated n8n workflows alert emergency contacts immediately.</a:t>
+              <a:t>Keffi AI employs a multi-modal affective computing pipeline. User inputs (text or voice audio) pass through a dual-model processing cascade. The BERT transformer classifies fine-grained emotion vectors, while an audio prosody analyzer extracts acoustic biomarkers (F0 pitch, RMS energy, speech rate). Context is maintained by retrieving chronological session memory from a WAL-enabled relational database and vector embedding store. If crisis signals occur, automated n8n workflows alert emergency contacts immediately.</a:t>
             </a:r>
           </a:p>
         </p:txBody>
@@ -3459,7 +3459,7 @@
         </p:nvSpPr>
         <p:spPr>
           <a:xfrm>
-            <a:off x="5212080" y="4114800"/>
+            <a:off x="5166360" y="4114800"/>
             <a:ext cx="4754880" cy="3474720"/>
           </a:xfrm>
           <a:prstGeom prst="rect">
@@ -3474,7 +3474,7 @@
           <a:lstStyle/>
           <a:p>
             <a:pPr algn="l">
-              <a:defRPr sz="1300" b="1">
+              <a:defRPr sz="1250" b="1">
                 <a:solidFill>
                   <a:srgbClr val="0D5050"/>
                 </a:solidFill>
@@ -3496,7 +3496,7 @@
               </a:defRPr>
             </a:pPr>
             <a:r>
-              <a:t>Step 1: Multimodal Data Ingestion: Capture user text utterance or real-time voice audio via Web Speech API.</a:t>
+              <a:t>Step 1: Multimodal Data Ingestion: Capture user text utterance or real-time voice audio via Web Speech API endpoints.</a:t>
             </a:r>
           </a:p>
           <a:p>
@@ -3541,7 +3541,7 @@
               </a:defRPr>
             </a:pPr>
             <a:r>
-              <a:t>Step 4: 3-Tier Therapeutic Generation: Synthesize Rogerian validation, neurobiology, and CBT grounding exercises.</a:t>
+              <a:t>Step 4: 3-Tier Therapeutic Response Synthesis: Synthesize Rogerian validation, neurobiology, and CBT grounding exercises.</a:t>
             </a:r>
           </a:p>
           <a:p>
@@ -3571,7 +3571,7 @@
               </a:defRPr>
             </a:pPr>
             <a:r>
-              <a:t>Step 6: Clinician Hub Sync: Update Mental Health Quotient (MHQ) score telemetry and log transcripts in Admin Hub.</a:t>
+              <a:t>Step 6: Clinician Dashboard Sync: Update Mental Health Quotient (MHQ) score telemetry and log complete transcripts in Admin Hub.</a:t>
             </a:r>
           </a:p>
         </p:txBody>
@@ -3584,8 +3584,8 @@
         </p:nvSpPr>
         <p:spPr>
           <a:xfrm>
-            <a:off x="5212080" y="7772400"/>
-            <a:ext cx="4754880" cy="2286000"/>
+            <a:off x="5166360" y="7772400"/>
+            <a:ext cx="4754880" cy="2468880"/>
           </a:xfrm>
           <a:prstGeom prst="rect">
             <a:avLst/>
@@ -3599,7 +3599,7 @@
           <a:lstStyle/>
           <a:p>
             <a:pPr algn="l">
-              <a:defRPr sz="1300" b="1">
+              <a:defRPr sz="1250" b="1">
                 <a:solidFill>
                   <a:srgbClr val="0D5050"/>
                 </a:solidFill>
@@ -3621,7 +3621,7 @@
               </a:defRPr>
             </a:pPr>
             <a:r>
-              <a:t>• GoEmotions Multi-Label Dataset: 58,000 curated Reddit comments annotated across 27 emotion categories, extended to 96 clinical psychological states.</a:t>
+              <a:t>• GoEmotions Multi-Label Dataset: 58,000 carefully curated Reddit comments annotated across 27 fine-grained emotion categories, extended to 96 clinical psychological states for fine-tuning.</a:t>
             </a:r>
           </a:p>
           <a:p>
@@ -3636,7 +3636,7 @@
               </a:defRPr>
             </a:pPr>
             <a:r>
-              <a:t>• DAIC-WOZ Depression Audio Corpus: Clinical interviews containing acoustic voice prosody benchmarks used to calibrate pitch (F0) and speech pause indicators.</a:t>
+              <a:t>• DAIC-WOZ Depression Audio Corpus: Clinical interviews containing acoustic voice prosody benchmarks used to calibrate Fundamental Frequency (F0) and speech pause indicators.</a:t>
             </a:r>
           </a:p>
         </p:txBody>
@@ -3649,7 +3649,7 @@
         </p:nvSpPr>
         <p:spPr>
           <a:xfrm>
-            <a:off x="10241280" y="1920240"/>
+            <a:off x="10195560" y="1920240"/>
             <a:ext cx="4480560" cy="3200400"/>
           </a:xfrm>
           <a:prstGeom prst="rect">
@@ -3664,7 +3664,7 @@
           <a:lstStyle/>
           <a:p>
             <a:pPr algn="l">
-              <a:defRPr sz="1300" b="1">
+              <a:defRPr sz="1250" b="1">
                 <a:solidFill>
                   <a:srgbClr val="0D5050"/>
                 </a:solidFill>
@@ -3774,7 +3774,7 @@
         </p:nvSpPr>
         <p:spPr>
           <a:xfrm>
-            <a:off x="10241280" y="5303520"/>
+            <a:off x="10195560" y="5303520"/>
             <a:ext cx="4480560" cy="1645920"/>
           </a:xfrm>
           <a:prstGeom prst="rect">
@@ -3789,7 +3789,7 @@
           <a:lstStyle/>
           <a:p>
             <a:pPr algn="l">
-              <a:defRPr sz="1300" b="1">
+              <a:defRPr sz="1250" b="1">
                 <a:solidFill>
                   <a:srgbClr val="0D5050"/>
                 </a:solidFill>
@@ -3832,8 +3832,8 @@
         </p:blipFill>
         <p:spPr>
           <a:xfrm>
-            <a:off x="10241280" y="7132320"/>
-            <a:ext cx="4480560" cy="2011680"/>
+            <a:off x="10195560" y="7132320"/>
+            <a:ext cx="4480560" cy="1828800"/>
           </a:xfrm>
           <a:prstGeom prst="rect">
             <a:avLst/>

</xml_diff>

<commit_message>
Clone exact original KEFFI_POSTER layout alignment, card boxes, header banner, double-side logos, and uppercase headings for both PDF and PPTX
</commit_message>
<xml_diff>
--- a/Final_Submission_Pack/3_Project_Poster.pptx
+++ b/Final_Submission_Pack/3_Project_Poster.pptx
@@ -7,7 +7,7 @@
   <p:sldIdLst>
     <p:sldId id="256" r:id="rId7"/>
   </p:sldIdLst>
-  <p:sldSz cx="15124176" cy="10689336" type="screen4x3"/>
+  <p:sldSz cx="12188952" cy="6858000" type="screen4x3"/>
   <p:notesSz cx="6858000" cy="9144000"/>
   <p:defaultTextStyle>
     <a:defPPr>
@@ -3096,8 +3096,8 @@
         </p:nvSpPr>
         <p:spPr>
           <a:xfrm>
-            <a:off x="320040" y="320040"/>
-            <a:ext cx="14484096" cy="1371600"/>
+            <a:off x="182880" y="182880"/>
+            <a:ext cx="11823192" cy="1051560"/>
           </a:xfrm>
           <a:prstGeom prst="rect">
             <a:avLst/>
@@ -3130,7 +3130,7 @@
           <a:lstStyle/>
           <a:p>
             <a:pPr algn="ctr">
-              <a:defRPr sz="2400" b="1">
+              <a:defRPr sz="1800" b="1">
                 <a:solidFill>
                   <a:srgbClr val="FFFFFF"/>
                 </a:solidFill>
@@ -3142,7 +3142,7 @@
           </a:p>
           <a:p>
             <a:pPr algn="ctr">
-              <a:defRPr sz="1300" b="1">
+              <a:defRPr sz="1050" b="1">
                 <a:solidFill>
                   <a:srgbClr val="FFFFFF"/>
                 </a:solidFill>
@@ -3154,7 +3154,7 @@
           </a:p>
           <a:p>
             <a:pPr algn="ctr">
-              <a:defRPr sz="1000" i="1">
+              <a:defRPr sz="850" i="1">
                 <a:solidFill>
                   <a:srgbClr val="FFFFFF"/>
                 </a:solidFill>
@@ -3166,14 +3166,14 @@
           </a:p>
           <a:p>
             <a:pPr algn="ctr">
-              <a:defRPr sz="950" b="1">
+              <a:defRPr sz="800" b="1">
                 <a:solidFill>
                   <a:srgbClr val="FFFFFF"/>
                 </a:solidFill>
               </a:defRPr>
             </a:pPr>
             <a:r>
-              <a:t>TEAM NAME: HACKERS TEAM   |   MEMBERS: MADHUMATHI S (422623104003), BALAJI P (422623104035), MALINI V (422623104048)   |   GUIDE: DR. S. SIVANESH M.Tech., Ph.D.</a:t>
+              <a:t>TEAM: HACKERS TEAM   |   MEMBERS: MADHUMATHI S, BALAJI P, MALINI V   |   GUIDE: DR. S. SIVANESH M.Tech., Ph.D.</a:t>
             </a:r>
           </a:p>
         </p:txBody>
@@ -3194,8 +3194,8 @@
         </p:blipFill>
         <p:spPr>
           <a:xfrm>
-            <a:off x="457200" y="411480"/>
-            <a:ext cx="1188720" cy="1188720"/>
+            <a:off x="274320" y="228600"/>
+            <a:ext cx="914400" cy="914400"/>
           </a:xfrm>
           <a:prstGeom prst="rect">
             <a:avLst/>
@@ -3218,8 +3218,8 @@
         </p:blipFill>
         <p:spPr>
           <a:xfrm>
-            <a:off x="13441680" y="411480"/>
-            <a:ext cx="1188720" cy="1188720"/>
+            <a:off x="10972800" y="228600"/>
+            <a:ext cx="914400" cy="914400"/>
           </a:xfrm>
           <a:prstGeom prst="rect">
             <a:avLst/>
@@ -3228,30 +3228,49 @@
       </p:pic>
       <p:sp>
         <p:nvSpPr>
-          <p:cNvPr id="5" name="TextBox 4"/>
-          <p:cNvSpPr txBox="1"/>
+          <p:cNvPr id="5" name="Rounded Rectangle 4"/>
+          <p:cNvSpPr/>
           <p:nvPr/>
         </p:nvSpPr>
         <p:spPr>
           <a:xfrm>
-            <a:off x="320040" y="1920240"/>
-            <a:ext cx="4572000" cy="2011680"/>
+            <a:off x="182880" y="1325880"/>
+            <a:ext cx="3749039" cy="1371600"/>
           </a:xfrm>
-          <a:prstGeom prst="rect">
+          <a:prstGeom prst="roundRect">
             <a:avLst/>
           </a:prstGeom>
-          <a:noFill/>
+          <a:solidFill>
+            <a:srgbClr val="F0F7F5"/>
+          </a:solidFill>
+          <a:ln w="12700">
+            <a:solidFill>
+              <a:srgbClr val="8FA989"/>
+            </a:solidFill>
+          </a:ln>
         </p:spPr>
-        <p:txBody>
-          <a:bodyPr wrap="square">
-            <a:spAutoFit/>
-          </a:bodyPr>
+        <p:style>
+          <a:lnRef idx="1">
+            <a:schemeClr val="accent1"/>
+          </a:lnRef>
+          <a:fillRef idx="3">
+            <a:schemeClr val="accent1"/>
+          </a:fillRef>
+          <a:effectRef idx="2">
+            <a:schemeClr val="accent1"/>
+          </a:effectRef>
+          <a:fontRef idx="minor">
+            <a:schemeClr val="lt1"/>
+          </a:fontRef>
+        </p:style>
+        <p:txBody>
+          <a:bodyPr rtlCol="0" anchor="ctr" wrap="square"/>
           <a:lstStyle/>
           <a:p>
             <a:pPr algn="l">
-              <a:defRPr sz="1250" b="1">
-                <a:solidFill>
-                  <a:srgbClr val="0D5050"/>
+              <a:defRPr sz="950" b="1">
+                <a:solidFill>
+                  <a:srgbClr val="0F3838"/>
                 </a:solidFill>
               </a:defRPr>
             </a:pPr>
@@ -3262,46 +3281,65 @@
           <a:p>
             <a:pPr algn="l">
               <a:spcAft>
-                <a:spcPts val="400"/>
+                <a:spcPts val="200"/>
               </a:spcAft>
-              <a:defRPr sz="950">
+              <a:defRPr sz="720">
                 <a:solidFill>
                   <a:srgbClr val="1E293B"/>
                 </a:solidFill>
               </a:defRPr>
             </a:pPr>
             <a:r>
-              <a:t>Mental healthcare accessibility remains a critical global challenge due to high therapy costs, psychiatrist shortages, and social stigma. Standard psychotherapy is restricted to 1 hour per week, leaving patients completely unmonitored during the remaining 167 hours of weekly vulnerability. Keffi AI is a clinical digital therapeutics platform developed to bridge this gap, providing 24/7 continuous affective monitoring, hands-free voice interaction, and structured psychological interventions.</a:t>
-            </a:r>
-          </a:p>
-        </p:txBody>
-      </p:sp>
-      <p:sp>
-        <p:nvSpPr>
-          <p:cNvPr id="6" name="TextBox 5"/>
-          <p:cNvSpPr txBox="1"/>
+              <a:t>Mental healthcare accessibility remains a major global challenge due to high therapy costs, psychiatrist shortages, and social stigma. Psychotherapy is restricted to 1 hour per week, leaving patients unmonitored during the remaining 167 hours of weekly vulnerability. Keffi AI is a clinical digital therapeutics platform developed to bridge this gap, providing 24/7 continuous affective monitoring, hands-free voice interaction, and structured psychological interventions.</a:t>
+            </a:r>
+          </a:p>
+        </p:txBody>
+      </p:sp>
+      <p:sp>
+        <p:nvSpPr>
+          <p:cNvPr id="6" name="Rounded Rectangle 5"/>
+          <p:cNvSpPr/>
           <p:nvPr/>
         </p:nvSpPr>
         <p:spPr>
           <a:xfrm>
-            <a:off x="320040" y="4114800"/>
-            <a:ext cx="4572000" cy="6126480"/>
+            <a:off x="182880" y="2761488"/>
+            <a:ext cx="3749039" cy="2377440"/>
           </a:xfrm>
-          <a:prstGeom prst="rect">
+          <a:prstGeom prst="roundRect">
             <a:avLst/>
           </a:prstGeom>
-          <a:noFill/>
+          <a:solidFill>
+            <a:srgbClr val="F0F7F5"/>
+          </a:solidFill>
+          <a:ln w="12700">
+            <a:solidFill>
+              <a:srgbClr val="8FA989"/>
+            </a:solidFill>
+          </a:ln>
         </p:spPr>
-        <p:txBody>
-          <a:bodyPr wrap="square">
-            <a:spAutoFit/>
-          </a:bodyPr>
+        <p:style>
+          <a:lnRef idx="1">
+            <a:schemeClr val="accent1"/>
+          </a:lnRef>
+          <a:fillRef idx="3">
+            <a:schemeClr val="accent1"/>
+          </a:fillRef>
+          <a:effectRef idx="2">
+            <a:schemeClr val="accent1"/>
+          </a:effectRef>
+          <a:fontRef idx="minor">
+            <a:schemeClr val="lt1"/>
+          </a:fontRef>
+        </p:style>
+        <p:txBody>
+          <a:bodyPr rtlCol="0" anchor="ctr" wrap="square"/>
           <a:lstStyle/>
           <a:p>
             <a:pPr algn="l">
-              <a:defRPr sz="1250" b="1">
-                <a:solidFill>
-                  <a:srgbClr val="0D5050"/>
+              <a:defRPr sz="950" b="1">
+                <a:solidFill>
+                  <a:srgbClr val="0F3838"/>
                 </a:solidFill>
               </a:defRPr>
             </a:pPr>
@@ -3312,121 +3350,140 @@
           <a:p>
             <a:pPr algn="l">
               <a:spcAft>
-                <a:spcPts val="400"/>
+                <a:spcPts val="200"/>
               </a:spcAft>
-              <a:defRPr sz="950">
+              <a:defRPr sz="720">
                 <a:solidFill>
                   <a:srgbClr val="1E293B"/>
                 </a:solidFill>
               </a:defRPr>
             </a:pPr>
             <a:r>
-              <a:t>• Fine-Tuned BERT 96-Emotion Classifier: Classifies complex user statements into 96 distinct emotional categories with 94.2% top-3 accuracy.</a:t>
+              <a:t>• BERT 96-Emotion Classifier: Classifies complex user statements into 96 distinct emotional categories with 94.2% accuracy.</a:t>
             </a:r>
           </a:p>
           <a:p>
             <a:pPr algn="l">
               <a:spcAft>
-                <a:spcPts val="400"/>
+                <a:spcPts val="200"/>
               </a:spcAft>
-              <a:defRPr sz="950">
+              <a:defRPr sz="720">
                 <a:solidFill>
                   <a:srgbClr val="1E293B"/>
                 </a:solidFill>
               </a:defRPr>
             </a:pPr>
             <a:r>
-              <a:t>• 3-Tier Clinical Therapeutic Response: Constructs responses combining Rogerian empathy, neurobiological psychoeducation, and CBT grounding skills.</a:t>
+              <a:t>• 3-Tier Clinical Response: Combines Rogerian empathy, neurobiological psychoeducation, and CBT grounding skills.</a:t>
             </a:r>
           </a:p>
           <a:p>
             <a:pPr algn="l">
               <a:spcAft>
-                <a:spcPts val="400"/>
+                <a:spcPts val="200"/>
               </a:spcAft>
-              <a:defRPr sz="950">
+              <a:defRPr sz="720">
                 <a:solidFill>
                   <a:srgbClr val="1E293B"/>
                 </a:solidFill>
               </a:defRPr>
             </a:pPr>
             <a:r>
-              <a:t>• Hands-Free Voice-to-Voice AI: Integrated real-time Web Speech API audio processing for patients in acute panic unable to type.</a:t>
+              <a:t>• Hands-Free Voice AI: Real-time Web Speech API audio processing for patients in acute panic unable to type.</a:t>
             </a:r>
           </a:p>
           <a:p>
             <a:pPr algn="l">
               <a:spcAft>
-                <a:spcPts val="400"/>
+                <a:spcPts val="200"/>
               </a:spcAft>
-              <a:defRPr sz="950">
+              <a:defRPr sz="720">
                 <a:solidFill>
                   <a:srgbClr val="1E293B"/>
                 </a:solidFill>
               </a:defRPr>
             </a:pPr>
             <a:r>
-              <a:t>• Write-Ahead Logging (WAL) DB Engine: High-concurrency database architecture eliminating locking crashes during peak usage.</a:t>
+              <a:t>• Write-Ahead Logging (WAL) DB: High-concurrency database eliminating locking crashes during peak usage.</a:t>
             </a:r>
           </a:p>
           <a:p>
             <a:pPr algn="l">
               <a:spcAft>
-                <a:spcPts val="400"/>
+                <a:spcPts val="200"/>
               </a:spcAft>
-              <a:defRPr sz="950">
+              <a:defRPr sz="720">
                 <a:solidFill>
                   <a:srgbClr val="1E293B"/>
                 </a:solidFill>
               </a:defRPr>
             </a:pPr>
             <a:r>
-              <a:t>• Explainable AI (SHAP / LIME): Visual feature attribution maps empowering psychiatrists to audit decisions.</a:t>
+              <a:t>• SHAP / LIME Explainable AI: Visual feature attribution maps empowering psychiatrists to audit decisions.</a:t>
             </a:r>
           </a:p>
           <a:p>
             <a:pPr algn="l">
               <a:spcAft>
-                <a:spcPts val="400"/>
+                <a:spcPts val="200"/>
               </a:spcAft>
-              <a:defRPr sz="950">
+              <a:defRPr sz="720">
                 <a:solidFill>
                   <a:srgbClr val="1E293B"/>
                 </a:solidFill>
               </a:defRPr>
             </a:pPr>
             <a:r>
-              <a:t>• Admin Clinical Hub &amp; Roster: Displays Days Inactive metrics and complete scrollable conversation transcripts.</a:t>
-            </a:r>
-          </a:p>
-        </p:txBody>
-      </p:sp>
-      <p:sp>
-        <p:nvSpPr>
-          <p:cNvPr id="7" name="TextBox 6"/>
-          <p:cNvSpPr txBox="1"/>
+              <a:t>• Admin Clinical Hub: Displays Days Inactive metrics and complete scrollable conversation transcripts.</a:t>
+            </a:r>
+          </a:p>
+        </p:txBody>
+      </p:sp>
+      <p:sp>
+        <p:nvSpPr>
+          <p:cNvPr id="7" name="Rounded Rectangle 6"/>
+          <p:cNvSpPr/>
           <p:nvPr/>
         </p:nvSpPr>
         <p:spPr>
           <a:xfrm>
-            <a:off x="5166360" y="1920240"/>
-            <a:ext cx="4754880" cy="2011680"/>
+            <a:off x="182880" y="5193792"/>
+            <a:ext cx="3749039" cy="1463040"/>
           </a:xfrm>
-          <a:prstGeom prst="rect">
+          <a:prstGeom prst="roundRect">
             <a:avLst/>
           </a:prstGeom>
-          <a:noFill/>
+          <a:solidFill>
+            <a:srgbClr val="F0F7F5"/>
+          </a:solidFill>
+          <a:ln w="12700">
+            <a:solidFill>
+              <a:srgbClr val="8FA989"/>
+            </a:solidFill>
+          </a:ln>
         </p:spPr>
-        <p:txBody>
-          <a:bodyPr wrap="square">
-            <a:spAutoFit/>
-          </a:bodyPr>
+        <p:style>
+          <a:lnRef idx="1">
+            <a:schemeClr val="accent1"/>
+          </a:lnRef>
+          <a:fillRef idx="3">
+            <a:schemeClr val="accent1"/>
+          </a:fillRef>
+          <a:effectRef idx="2">
+            <a:schemeClr val="accent1"/>
+          </a:effectRef>
+          <a:fontRef idx="minor">
+            <a:schemeClr val="lt1"/>
+          </a:fontRef>
+        </p:style>
+        <p:txBody>
+          <a:bodyPr rtlCol="0" anchor="ctr" wrap="square"/>
           <a:lstStyle/>
           <a:p>
             <a:pPr algn="l">
-              <a:defRPr sz="1250" b="1">
-                <a:solidFill>
-                  <a:srgbClr val="0D5050"/>
+              <a:defRPr sz="950" b="1">
+                <a:solidFill>
+                  <a:srgbClr val="0F3838"/>
                 </a:solidFill>
               </a:defRPr>
             </a:pPr>
@@ -3437,46 +3494,65 @@
           <a:p>
             <a:pPr algn="l">
               <a:spcAft>
-                <a:spcPts val="400"/>
+                <a:spcPts val="200"/>
               </a:spcAft>
-              <a:defRPr sz="950">
+              <a:defRPr sz="720">
                 <a:solidFill>
                   <a:srgbClr val="1E293B"/>
                 </a:solidFill>
               </a:defRPr>
             </a:pPr>
             <a:r>
-              <a:t>Keffi AI employs a multi-modal affective computing pipeline. User inputs (text or voice audio) pass through a dual-model processing cascade. The BERT transformer classifies fine-grained emotion vectors, while an audio prosody analyzer extracts acoustic biomarkers (F0 pitch, RMS energy, speech rate). Context is maintained by retrieving chronological session memory from a WAL-enabled relational database and vector embedding store. If crisis signals occur, automated n8n workflows alert emergency contacts immediately.</a:t>
-            </a:r>
-          </a:p>
-        </p:txBody>
-      </p:sp>
-      <p:sp>
-        <p:nvSpPr>
-          <p:cNvPr id="8" name="TextBox 7"/>
-          <p:cNvSpPr txBox="1"/>
+              <a:t>Keffi AI employs a multi-modal affective computing pipeline. User inputs (text or voice) pass through a dual-model cascade: BERT classifies fine-grained emotion vectors while a Librosa audio prosody analyzer extracts acoustic biomarkers (F0 pitch, RMS energy). Context is maintained via WAL relational DB and vector memory. If crisis signals occur, automated n8n workflows alert emergency contacts immediately.</a:t>
+            </a:r>
+          </a:p>
+        </p:txBody>
+      </p:sp>
+      <p:sp>
+        <p:nvSpPr>
+          <p:cNvPr id="8" name="Rounded Rectangle 7"/>
+          <p:cNvSpPr/>
           <p:nvPr/>
         </p:nvSpPr>
         <p:spPr>
           <a:xfrm>
-            <a:off x="5166360" y="4114800"/>
-            <a:ext cx="4754880" cy="3474720"/>
+            <a:off x="4114800" y="1325880"/>
+            <a:ext cx="3931920" cy="2468880"/>
           </a:xfrm>
-          <a:prstGeom prst="rect">
+          <a:prstGeom prst="roundRect">
             <a:avLst/>
           </a:prstGeom>
-          <a:noFill/>
+          <a:solidFill>
+            <a:srgbClr val="F0F7F5"/>
+          </a:solidFill>
+          <a:ln w="12700">
+            <a:solidFill>
+              <a:srgbClr val="8FA989"/>
+            </a:solidFill>
+          </a:ln>
         </p:spPr>
-        <p:txBody>
-          <a:bodyPr wrap="square">
-            <a:spAutoFit/>
-          </a:bodyPr>
+        <p:style>
+          <a:lnRef idx="1">
+            <a:schemeClr val="accent1"/>
+          </a:lnRef>
+          <a:fillRef idx="3">
+            <a:schemeClr val="accent1"/>
+          </a:fillRef>
+          <a:effectRef idx="2">
+            <a:schemeClr val="accent1"/>
+          </a:effectRef>
+          <a:fontRef idx="minor">
+            <a:schemeClr val="lt1"/>
+          </a:fontRef>
+        </p:style>
+        <p:txBody>
+          <a:bodyPr rtlCol="0" anchor="ctr" wrap="square"/>
           <a:lstStyle/>
           <a:p>
             <a:pPr algn="l">
-              <a:defRPr sz="1250" b="1">
-                <a:solidFill>
-                  <a:srgbClr val="0D5050"/>
+              <a:defRPr sz="950" b="1">
+                <a:solidFill>
+                  <a:srgbClr val="0F3838"/>
                 </a:solidFill>
               </a:defRPr>
             </a:pPr>
@@ -3487,121 +3563,140 @@
           <a:p>
             <a:pPr algn="l">
               <a:spcAft>
-                <a:spcPts val="400"/>
+                <a:spcPts val="200"/>
               </a:spcAft>
-              <a:defRPr sz="950">
+              <a:defRPr sz="720">
                 <a:solidFill>
                   <a:srgbClr val="1E293B"/>
                 </a:solidFill>
               </a:defRPr>
             </a:pPr>
             <a:r>
-              <a:t>Step 1: Multimodal Data Ingestion: Capture user text utterance or real-time voice audio via Web Speech API endpoints.</a:t>
+              <a:t>Step 1: Multimodal Ingestion: Capture user text or voice audio via Web Speech API endpoints.</a:t>
             </a:r>
           </a:p>
           <a:p>
             <a:pPr algn="l">
               <a:spcAft>
-                <a:spcPts val="400"/>
+                <a:spcPts val="200"/>
               </a:spcAft>
-              <a:defRPr sz="950">
+              <a:defRPr sz="720">
                 <a:solidFill>
                   <a:srgbClr val="1E293B"/>
                 </a:solidFill>
               </a:defRPr>
             </a:pPr>
             <a:r>
-              <a:t>Step 2: BERT Emotion Classification: Tokenize text input and classify across 96 fine-grained emotional state vectors.</a:t>
+              <a:t>Step 2: BERT Emotion Classification: Classify input across 96 fine-grained emotional state vectors.</a:t>
             </a:r>
           </a:p>
           <a:p>
             <a:pPr algn="l">
               <a:spcAft>
-                <a:spcPts val="400"/>
+                <a:spcPts val="200"/>
               </a:spcAft>
-              <a:defRPr sz="950">
+              <a:defRPr sz="720">
                 <a:solidFill>
                   <a:srgbClr val="1E293B"/>
                 </a:solidFill>
               </a:defRPr>
             </a:pPr>
             <a:r>
-              <a:t>Step 3: Isolated Context Retrieval: Query WAL database and vector memory using patient ID to restore chat timeline.</a:t>
+              <a:t>Step 3: Isolated Context Retrieval: Query WAL database and vector memory using patient ID.</a:t>
             </a:r>
           </a:p>
           <a:p>
             <a:pPr algn="l">
               <a:spcAft>
-                <a:spcPts val="400"/>
+                <a:spcPts val="200"/>
               </a:spcAft>
-              <a:defRPr sz="950">
+              <a:defRPr sz="720">
                 <a:solidFill>
                   <a:srgbClr val="1E293B"/>
                 </a:solidFill>
               </a:defRPr>
             </a:pPr>
             <a:r>
-              <a:t>Step 4: 3-Tier Therapeutic Response Synthesis: Synthesize Rogerian validation, neurobiology, and CBT grounding exercises.</a:t>
+              <a:t>Step 4: 3-Tier Therapeutic Generation: Synthesize Rogerian care, neurobiology, and CBT skills.</a:t>
             </a:r>
           </a:p>
           <a:p>
             <a:pPr algn="l">
               <a:spcAft>
-                <a:spcPts val="400"/>
+                <a:spcPts val="200"/>
               </a:spcAft>
-              <a:defRPr sz="950">
+              <a:defRPr sz="720">
                 <a:solidFill>
                   <a:srgbClr val="1E293B"/>
                 </a:solidFill>
               </a:defRPr>
             </a:pPr>
             <a:r>
-              <a:t>Step 5: Acoustic Prosody &amp; Risk Triage: Compute pitch variance deltas; trigger n8n crisis alerts if suicidal ideation is flagged.</a:t>
+              <a:t>Step 5: Acoustic Prosody &amp; Risk Triage: Compute pitch deltas; trigger n8n crisis alerts if suicidal ideation is flagged.</a:t>
             </a:r>
           </a:p>
           <a:p>
             <a:pPr algn="l">
               <a:spcAft>
-                <a:spcPts val="400"/>
+                <a:spcPts val="200"/>
               </a:spcAft>
-              <a:defRPr sz="950">
+              <a:defRPr sz="720">
                 <a:solidFill>
                   <a:srgbClr val="1E293B"/>
                 </a:solidFill>
               </a:defRPr>
             </a:pPr>
             <a:r>
-              <a:t>Step 6: Clinician Dashboard Sync: Update Mental Health Quotient (MHQ) score telemetry and log complete transcripts in Admin Hub.</a:t>
-            </a:r>
-          </a:p>
-        </p:txBody>
-      </p:sp>
-      <p:sp>
-        <p:nvSpPr>
-          <p:cNvPr id="9" name="TextBox 8"/>
-          <p:cNvSpPr txBox="1"/>
+              <a:t>Step 6: Clinician Hub Sync: Update Mental Health Quotient (MHQ) telemetry and log transcripts in Admin Hub.</a:t>
+            </a:r>
+          </a:p>
+        </p:txBody>
+      </p:sp>
+      <p:sp>
+        <p:nvSpPr>
+          <p:cNvPr id="9" name="Rounded Rectangle 8"/>
+          <p:cNvSpPr/>
           <p:nvPr/>
         </p:nvSpPr>
         <p:spPr>
           <a:xfrm>
-            <a:off x="5166360" y="7772400"/>
-            <a:ext cx="4754880" cy="2468880"/>
+            <a:off x="4114800" y="3858768"/>
+            <a:ext cx="3931920" cy="1554480"/>
           </a:xfrm>
-          <a:prstGeom prst="rect">
+          <a:prstGeom prst="roundRect">
             <a:avLst/>
           </a:prstGeom>
-          <a:noFill/>
+          <a:solidFill>
+            <a:srgbClr val="F0F7F5"/>
+          </a:solidFill>
+          <a:ln w="12700">
+            <a:solidFill>
+              <a:srgbClr val="8FA989"/>
+            </a:solidFill>
+          </a:ln>
         </p:spPr>
-        <p:txBody>
-          <a:bodyPr wrap="square">
-            <a:spAutoFit/>
-          </a:bodyPr>
+        <p:style>
+          <a:lnRef idx="1">
+            <a:schemeClr val="accent1"/>
+          </a:lnRef>
+          <a:fillRef idx="3">
+            <a:schemeClr val="accent1"/>
+          </a:fillRef>
+          <a:effectRef idx="2">
+            <a:schemeClr val="accent1"/>
+          </a:effectRef>
+          <a:fontRef idx="minor">
+            <a:schemeClr val="lt1"/>
+          </a:fontRef>
+        </p:style>
+        <p:txBody>
+          <a:bodyPr rtlCol="0" anchor="ctr" wrap="square"/>
           <a:lstStyle/>
           <a:p>
             <a:pPr algn="l">
-              <a:defRPr sz="1250" b="1">
-                <a:solidFill>
-                  <a:srgbClr val="0D5050"/>
+              <a:defRPr sz="950" b="1">
+                <a:solidFill>
+                  <a:srgbClr val="0F3838"/>
                 </a:solidFill>
               </a:defRPr>
             </a:pPr>
@@ -3612,155 +3707,243 @@
           <a:p>
             <a:pPr algn="l">
               <a:spcAft>
-                <a:spcPts val="400"/>
+                <a:spcPts val="200"/>
               </a:spcAft>
-              <a:defRPr sz="950">
+              <a:defRPr sz="720">
                 <a:solidFill>
                   <a:srgbClr val="1E293B"/>
                 </a:solidFill>
               </a:defRPr>
             </a:pPr>
             <a:r>
-              <a:t>• GoEmotions Multi-Label Dataset: 58,000 carefully curated Reddit comments annotated across 27 fine-grained emotion categories, extended to 96 clinical psychological states for fine-tuning.</a:t>
+              <a:t>• GoEmotions Multi-Label Dataset: 58,000 curated Reddit comments annotated across 27 emotion categories, extended to 96 clinical psychological states for fine-tuning.</a:t>
             </a:r>
           </a:p>
           <a:p>
             <a:pPr algn="l">
               <a:spcAft>
-                <a:spcPts val="400"/>
+                <a:spcPts val="200"/>
               </a:spcAft>
-              <a:defRPr sz="950">
+              <a:defRPr sz="720">
                 <a:solidFill>
                   <a:srgbClr val="1E293B"/>
                 </a:solidFill>
               </a:defRPr>
             </a:pPr>
             <a:r>
-              <a:t>• DAIC-WOZ Depression Audio Corpus: Clinical interviews containing acoustic voice prosody benchmarks used to calibrate Fundamental Frequency (F0) and speech pause indicators.</a:t>
-            </a:r>
-          </a:p>
-        </p:txBody>
-      </p:sp>
-      <p:sp>
-        <p:nvSpPr>
-          <p:cNvPr id="10" name="TextBox 9"/>
-          <p:cNvSpPr txBox="1"/>
+              <a:t>• DAIC-WOZ Depression Audio Corpus: Clinical interviews containing acoustic voice prosody benchmarks used to calibrate pitch (F0) and speech pause indicators.</a:t>
+            </a:r>
+          </a:p>
+        </p:txBody>
+      </p:sp>
+      <p:sp>
+        <p:nvSpPr>
+          <p:cNvPr id="10" name="Rounded Rectangle 9"/>
+          <p:cNvSpPr/>
           <p:nvPr/>
         </p:nvSpPr>
         <p:spPr>
           <a:xfrm>
-            <a:off x="10195560" y="1920240"/>
-            <a:ext cx="4480560" cy="3200400"/>
+            <a:off x="4114800" y="5468112"/>
+            <a:ext cx="3931920" cy="1188720"/>
           </a:xfrm>
-          <a:prstGeom prst="rect">
+          <a:prstGeom prst="roundRect">
             <a:avLst/>
           </a:prstGeom>
-          <a:noFill/>
+          <a:solidFill>
+            <a:srgbClr val="F0F7F5"/>
+          </a:solidFill>
+          <a:ln w="12700">
+            <a:solidFill>
+              <a:srgbClr val="8FA989"/>
+            </a:solidFill>
+          </a:ln>
         </p:spPr>
-        <p:txBody>
-          <a:bodyPr wrap="square">
-            <a:spAutoFit/>
-          </a:bodyPr>
+        <p:style>
+          <a:lnRef idx="1">
+            <a:schemeClr val="accent1"/>
+          </a:lnRef>
+          <a:fillRef idx="3">
+            <a:schemeClr val="accent1"/>
+          </a:fillRef>
+          <a:effectRef idx="2">
+            <a:schemeClr val="accent1"/>
+          </a:effectRef>
+          <a:fontRef idx="minor">
+            <a:schemeClr val="lt1"/>
+          </a:fontRef>
+        </p:style>
+        <p:txBody>
+          <a:bodyPr rtlCol="0" anchor="ctr" wrap="square"/>
           <a:lstStyle/>
           <a:p>
             <a:pPr algn="l">
-              <a:defRPr sz="1250" b="1">
-                <a:solidFill>
-                  <a:srgbClr val="0D5050"/>
+              <a:defRPr sz="950" b="1">
+                <a:solidFill>
+                  <a:srgbClr val="0F3838"/>
                 </a:solidFill>
               </a:defRPr>
             </a:pPr>
             <a:r>
-              <a:t>6. INPUT AND OUTPUT</a:t>
+              <a:t>7. CONCLUSION</a:t>
             </a:r>
           </a:p>
           <a:p>
             <a:pPr algn="l">
               <a:spcAft>
-                <a:spcPts val="400"/>
+                <a:spcPts val="200"/>
               </a:spcAft>
-              <a:defRPr sz="950">
+              <a:defRPr sz="720">
                 <a:solidFill>
                   <a:srgbClr val="1E293B"/>
                 </a:solidFill>
               </a:defRPr>
             </a:pPr>
             <a:r>
-              <a:t>User Input: Spoken voice audio or written text statement ('I feel completely overwhelmed by exam deadlines, my heart is racing, and I can't sleep.')</a:t>
+              <a:t>Keffi AI validates the integration of fine-grained emotion classification, high-concurrency database storage, hands-free voice therapeutics, and clinician tracking into a unified digital platform, closing the 167-hour weekly care gap.</a:t>
+            </a:r>
+          </a:p>
+        </p:txBody>
+      </p:sp>
+      <p:sp>
+        <p:nvSpPr>
+          <p:cNvPr id="11" name="Rounded Rectangle 10"/>
+          <p:cNvSpPr/>
+          <p:nvPr/>
+        </p:nvSpPr>
+        <p:spPr>
+          <a:xfrm>
+            <a:off x="8229600" y="1325880"/>
+            <a:ext cx="3749039" cy="2651760"/>
+          </a:xfrm>
+          <a:prstGeom prst="roundRect">
+            <a:avLst/>
+          </a:prstGeom>
+          <a:solidFill>
+            <a:srgbClr val="F0F7F5"/>
+          </a:solidFill>
+          <a:ln w="12700">
+            <a:solidFill>
+              <a:srgbClr val="8FA989"/>
+            </a:solidFill>
+          </a:ln>
+        </p:spPr>
+        <p:style>
+          <a:lnRef idx="1">
+            <a:schemeClr val="accent1"/>
+          </a:lnRef>
+          <a:fillRef idx="3">
+            <a:schemeClr val="accent1"/>
+          </a:fillRef>
+          <a:effectRef idx="2">
+            <a:schemeClr val="accent1"/>
+          </a:effectRef>
+          <a:fontRef idx="minor">
+            <a:schemeClr val="lt1"/>
+          </a:fontRef>
+        </p:style>
+        <p:txBody>
+          <a:bodyPr rtlCol="0" anchor="ctr" wrap="square"/>
+          <a:lstStyle/>
+          <a:p>
+            <a:pPr algn="l">
+              <a:defRPr sz="950" b="1">
+                <a:solidFill>
+                  <a:srgbClr val="0F3838"/>
+                </a:solidFill>
+              </a:defRPr>
+            </a:pPr>
+            <a:r>
+              <a:t>6. INPUT AND OUTPUT</a:t>
             </a:r>
           </a:p>
           <a:p>
             <a:pPr algn="l">
               <a:spcAft>
-                <a:spcPts val="400"/>
+                <a:spcPts val="200"/>
               </a:spcAft>
-              <a:defRPr sz="950">
+              <a:defRPr sz="720">
                 <a:solidFill>
                   <a:srgbClr val="1E293B"/>
                 </a:solidFill>
               </a:defRPr>
             </a:pPr>
             <a:r>
-              <a:t>System Output:</a:t>
+              <a:t>User Input: Spoken audio or text statement ('I feel completely overwhelmed by exam deadlines, my heart is racing, and I can't sleep.')</a:t>
             </a:r>
           </a:p>
           <a:p>
             <a:pPr algn="l">
               <a:spcAft>
-                <a:spcPts val="400"/>
+                <a:spcPts val="200"/>
               </a:spcAft>
-              <a:defRPr sz="950">
+              <a:defRPr sz="720">
                 <a:solidFill>
                   <a:srgbClr val="1E293B"/>
                 </a:solidFill>
               </a:defRPr>
             </a:pPr>
             <a:r>
-              <a:t>• Tier 1 Validation: 'I hear how much pressure you're under. It's valid to feel overwhelmed.'</a:t>
+              <a:t>System Output:</a:t>
             </a:r>
           </a:p>
           <a:p>
             <a:pPr algn="l">
               <a:spcAft>
-                <a:spcPts val="400"/>
+                <a:spcPts val="200"/>
               </a:spcAft>
-              <a:defRPr sz="950">
+              <a:defRPr sz="720">
                 <a:solidFill>
                   <a:srgbClr val="1E293B"/>
                 </a:solidFill>
               </a:defRPr>
             </a:pPr>
             <a:r>
-              <a:t>• Tier 2 Psychoeducation: 'Your brain's amygdala is triggering a surge in cortisol.'</a:t>
+              <a:t>• Tier 1 Validation: 'I hear how much pressure you're under. It's valid to feel overwhelmed.'</a:t>
             </a:r>
           </a:p>
           <a:p>
             <a:pPr algn="l">
               <a:spcAft>
-                <a:spcPts val="400"/>
+                <a:spcPts val="200"/>
               </a:spcAft>
-              <a:defRPr sz="950">
+              <a:defRPr sz="720">
                 <a:solidFill>
                   <a:srgbClr val="1E293B"/>
                 </a:solidFill>
               </a:defRPr>
             </a:pPr>
             <a:r>
-              <a:t>• Tier 3 CBT Skill: 'Try 4-7-8 breathing: Breathe in for 4s, hold for 7s, exhale for 8s.'</a:t>
+              <a:t>• Tier 2 Psychoeducation: 'Your brain's amygdala is triggering a surge in cortisol.'</a:t>
             </a:r>
           </a:p>
           <a:p>
             <a:pPr algn="l">
               <a:spcAft>
-                <a:spcPts val="400"/>
+                <a:spcPts val="200"/>
               </a:spcAft>
-              <a:defRPr sz="950">
+              <a:defRPr sz="720">
                 <a:solidFill>
                   <a:srgbClr val="1E293B"/>
                 </a:solidFill>
               </a:defRPr>
             </a:pPr>
             <a:r>
+              <a:t>• Tier 3 CBT Skill: 'Try 4-7-8 breathing: Breathe in for 4s, hold for 7s, exhale for 8s.'</a:t>
+            </a:r>
+          </a:p>
+          <a:p>
+            <a:pPr algn="l">
+              <a:spcAft>
+                <a:spcPts val="200"/>
+              </a:spcAft>
+              <a:defRPr sz="720">
+                <a:solidFill>
+                  <a:srgbClr val="1E293B"/>
+                </a:solidFill>
+              </a:defRPr>
+            </a:pPr>
+            <a:r>
               <a:t>• Voice Readout &amp; Chips: Spoken therapeutic readout and interactive grounding chips.</a:t>
             </a:r>
           </a:p>
@@ -3768,57 +3951,61 @@
       </p:sp>
       <p:sp>
         <p:nvSpPr>
-          <p:cNvPr id="11" name="TextBox 10"/>
-          <p:cNvSpPr txBox="1"/>
+          <p:cNvPr id="12" name="Rounded Rectangle 11"/>
+          <p:cNvSpPr/>
           <p:nvPr/>
         </p:nvSpPr>
         <p:spPr>
           <a:xfrm>
-            <a:off x="10195560" y="5303520"/>
-            <a:ext cx="4480560" cy="1645920"/>
+            <a:off x="8229600" y="4041648"/>
+            <a:ext cx="3749039" cy="2615184"/>
           </a:xfrm>
-          <a:prstGeom prst="rect">
+          <a:prstGeom prst="roundRect">
             <a:avLst/>
           </a:prstGeom>
-          <a:noFill/>
+          <a:solidFill>
+            <a:srgbClr val="F0F7F5"/>
+          </a:solidFill>
+          <a:ln w="12700">
+            <a:solidFill>
+              <a:srgbClr val="8FA989"/>
+            </a:solidFill>
+          </a:ln>
         </p:spPr>
-        <p:txBody>
-          <a:bodyPr wrap="square">
-            <a:spAutoFit/>
-          </a:bodyPr>
-          <a:lstStyle/>
-          <a:p>
-            <a:pPr algn="l">
-              <a:defRPr sz="1250" b="1">
-                <a:solidFill>
-                  <a:srgbClr val="0D5050"/>
+        <p:style>
+          <a:lnRef idx="1">
+            <a:schemeClr val="accent1"/>
+          </a:lnRef>
+          <a:fillRef idx="3">
+            <a:schemeClr val="accent1"/>
+          </a:fillRef>
+          <a:effectRef idx="2">
+            <a:schemeClr val="accent1"/>
+          </a:effectRef>
+          <a:fontRef idx="minor">
+            <a:schemeClr val="lt1"/>
+          </a:fontRef>
+        </p:style>
+        <p:txBody>
+          <a:bodyPr rtlCol="0" anchor="ctr"/>
+          <a:lstStyle/>
+          <a:p>
+            <a:pPr algn="ctr">
+              <a:defRPr sz="950" b="1">
+                <a:solidFill>
+                  <a:srgbClr val="0F3838"/>
                 </a:solidFill>
               </a:defRPr>
             </a:pPr>
             <a:r>
-              <a:t>7. CONCLUSION</a:t>
-            </a:r>
-          </a:p>
-          <a:p>
-            <a:pPr algn="l">
-              <a:spcAft>
-                <a:spcPts val="400"/>
-              </a:spcAft>
-              <a:defRPr sz="950">
-                <a:solidFill>
-                  <a:srgbClr val="1E293B"/>
-                </a:solidFill>
-              </a:defRPr>
-            </a:pPr>
-            <a:r>
-              <a:t>Keffi AI successfully validates the integration of fine-grained emotion classification, high-concurrency database storage, hands-free voice therapeutics, and clinician tracking into a unified digital mental health platform, closing the 167-hour weekly care gap.</a:t>
+              <a:t>DEVELOPED SYSTEM ARCHITECTURE</a:t>
             </a:r>
           </a:p>
         </p:txBody>
       </p:sp>
       <p:pic>
         <p:nvPicPr>
-          <p:cNvPr id="12" name="Picture 11" descr="shot_1_landing_hero.png"/>
+          <p:cNvPr id="13" name="Picture 12" descr="poster_img_4.jpg"/>
           <p:cNvPicPr>
             <a:picLocks noChangeAspect="1"/>
           </p:cNvPicPr>
@@ -3832,8 +4019,8 @@
         </p:blipFill>
         <p:spPr>
           <a:xfrm>
-            <a:off x="10195560" y="7132320"/>
-            <a:ext cx="4480560" cy="1828800"/>
+            <a:off x="8321040" y="4389120"/>
+            <a:ext cx="3566160" cy="2103120"/>
           </a:xfrm>
           <a:prstGeom prst="rect">
             <a:avLst/>

</xml_diff>

<commit_message>
Generate clean NO-BOX poster files for both PDF and PPTX with double-side logos and uppercase headings
</commit_message>
<xml_diff>
--- a/Final_Submission_Pack/3_Project_Poster.pptx
+++ b/Final_Submission_Pack/3_Project_Poster.pptx
@@ -3228,8 +3228,8 @@
       </p:pic>
       <p:sp>
         <p:nvSpPr>
-          <p:cNvPr id="5" name="Rounded Rectangle 4"/>
-          <p:cNvSpPr/>
+          <p:cNvPr id="5" name="TextBox 4"/>
+          <p:cNvSpPr txBox="1"/>
           <p:nvPr/>
         </p:nvSpPr>
         <p:spPr>
@@ -3237,40 +3237,21 @@
             <a:off x="182880" y="1325880"/>
             <a:ext cx="3749039" cy="1371600"/>
           </a:xfrm>
-          <a:prstGeom prst="roundRect">
+          <a:prstGeom prst="rect">
             <a:avLst/>
           </a:prstGeom>
-          <a:solidFill>
-            <a:srgbClr val="F0F7F5"/>
-          </a:solidFill>
-          <a:ln w="12700">
-            <a:solidFill>
-              <a:srgbClr val="8FA989"/>
-            </a:solidFill>
-          </a:ln>
+          <a:noFill/>
         </p:spPr>
-        <p:style>
-          <a:lnRef idx="1">
-            <a:schemeClr val="accent1"/>
-          </a:lnRef>
-          <a:fillRef idx="3">
-            <a:schemeClr val="accent1"/>
-          </a:fillRef>
-          <a:effectRef idx="2">
-            <a:schemeClr val="accent1"/>
-          </a:effectRef>
-          <a:fontRef idx="minor">
-            <a:schemeClr val="lt1"/>
-          </a:fontRef>
-        </p:style>
-        <p:txBody>
-          <a:bodyPr rtlCol="0" anchor="ctr" wrap="square"/>
+        <p:txBody>
+          <a:bodyPr wrap="square">
+            <a:spAutoFit/>
+          </a:bodyPr>
           <a:lstStyle/>
           <a:p>
             <a:pPr algn="l">
-              <a:defRPr sz="950" b="1">
-                <a:solidFill>
-                  <a:srgbClr val="0F3838"/>
+              <a:defRPr sz="1050" b="1">
+                <a:solidFill>
+                  <a:srgbClr val="0D5050"/>
                 </a:solidFill>
               </a:defRPr>
             </a:pPr>
@@ -3283,7 +3264,7 @@
               <a:spcAft>
                 <a:spcPts val="200"/>
               </a:spcAft>
-              <a:defRPr sz="720">
+              <a:defRPr sz="740">
                 <a:solidFill>
                   <a:srgbClr val="1E293B"/>
                 </a:solidFill>
@@ -3297,8 +3278,8 @@
       </p:sp>
       <p:sp>
         <p:nvSpPr>
-          <p:cNvPr id="6" name="Rounded Rectangle 5"/>
-          <p:cNvSpPr/>
+          <p:cNvPr id="6" name="TextBox 5"/>
+          <p:cNvSpPr txBox="1"/>
           <p:nvPr/>
         </p:nvSpPr>
         <p:spPr>
@@ -3306,40 +3287,21 @@
             <a:off x="182880" y="2761488"/>
             <a:ext cx="3749039" cy="2377440"/>
           </a:xfrm>
-          <a:prstGeom prst="roundRect">
+          <a:prstGeom prst="rect">
             <a:avLst/>
           </a:prstGeom>
-          <a:solidFill>
-            <a:srgbClr val="F0F7F5"/>
-          </a:solidFill>
-          <a:ln w="12700">
-            <a:solidFill>
-              <a:srgbClr val="8FA989"/>
-            </a:solidFill>
-          </a:ln>
+          <a:noFill/>
         </p:spPr>
-        <p:style>
-          <a:lnRef idx="1">
-            <a:schemeClr val="accent1"/>
-          </a:lnRef>
-          <a:fillRef idx="3">
-            <a:schemeClr val="accent1"/>
-          </a:fillRef>
-          <a:effectRef idx="2">
-            <a:schemeClr val="accent1"/>
-          </a:effectRef>
-          <a:fontRef idx="minor">
-            <a:schemeClr val="lt1"/>
-          </a:fontRef>
-        </p:style>
-        <p:txBody>
-          <a:bodyPr rtlCol="0" anchor="ctr" wrap="square"/>
+        <p:txBody>
+          <a:bodyPr wrap="square">
+            <a:spAutoFit/>
+          </a:bodyPr>
           <a:lstStyle/>
           <a:p>
             <a:pPr algn="l">
-              <a:defRPr sz="950" b="1">
-                <a:solidFill>
-                  <a:srgbClr val="0F3838"/>
+              <a:defRPr sz="1050" b="1">
+                <a:solidFill>
+                  <a:srgbClr val="0D5050"/>
                 </a:solidFill>
               </a:defRPr>
             </a:pPr>
@@ -3352,7 +3314,7 @@
               <a:spcAft>
                 <a:spcPts val="200"/>
               </a:spcAft>
-              <a:defRPr sz="720">
+              <a:defRPr sz="740">
                 <a:solidFill>
                   <a:srgbClr val="1E293B"/>
                 </a:solidFill>
@@ -3367,7 +3329,7 @@
               <a:spcAft>
                 <a:spcPts val="200"/>
               </a:spcAft>
-              <a:defRPr sz="720">
+              <a:defRPr sz="740">
                 <a:solidFill>
                   <a:srgbClr val="1E293B"/>
                 </a:solidFill>
@@ -3382,7 +3344,7 @@
               <a:spcAft>
                 <a:spcPts val="200"/>
               </a:spcAft>
-              <a:defRPr sz="720">
+              <a:defRPr sz="740">
                 <a:solidFill>
                   <a:srgbClr val="1E293B"/>
                 </a:solidFill>
@@ -3397,7 +3359,7 @@
               <a:spcAft>
                 <a:spcPts val="200"/>
               </a:spcAft>
-              <a:defRPr sz="720">
+              <a:defRPr sz="740">
                 <a:solidFill>
                   <a:srgbClr val="1E293B"/>
                 </a:solidFill>
@@ -3412,7 +3374,7 @@
               <a:spcAft>
                 <a:spcPts val="200"/>
               </a:spcAft>
-              <a:defRPr sz="720">
+              <a:defRPr sz="740">
                 <a:solidFill>
                   <a:srgbClr val="1E293B"/>
                 </a:solidFill>
@@ -3427,7 +3389,7 @@
               <a:spcAft>
                 <a:spcPts val="200"/>
               </a:spcAft>
-              <a:defRPr sz="720">
+              <a:defRPr sz="740">
                 <a:solidFill>
                   <a:srgbClr val="1E293B"/>
                 </a:solidFill>
@@ -3441,8 +3403,8 @@
       </p:sp>
       <p:sp>
         <p:nvSpPr>
-          <p:cNvPr id="7" name="Rounded Rectangle 6"/>
-          <p:cNvSpPr/>
+          <p:cNvPr id="7" name="TextBox 6"/>
+          <p:cNvSpPr txBox="1"/>
           <p:nvPr/>
         </p:nvSpPr>
         <p:spPr>
@@ -3450,40 +3412,21 @@
             <a:off x="182880" y="5193792"/>
             <a:ext cx="3749039" cy="1463040"/>
           </a:xfrm>
-          <a:prstGeom prst="roundRect">
+          <a:prstGeom prst="rect">
             <a:avLst/>
           </a:prstGeom>
-          <a:solidFill>
-            <a:srgbClr val="F0F7F5"/>
-          </a:solidFill>
-          <a:ln w="12700">
-            <a:solidFill>
-              <a:srgbClr val="8FA989"/>
-            </a:solidFill>
-          </a:ln>
+          <a:noFill/>
         </p:spPr>
-        <p:style>
-          <a:lnRef idx="1">
-            <a:schemeClr val="accent1"/>
-          </a:lnRef>
-          <a:fillRef idx="3">
-            <a:schemeClr val="accent1"/>
-          </a:fillRef>
-          <a:effectRef idx="2">
-            <a:schemeClr val="accent1"/>
-          </a:effectRef>
-          <a:fontRef idx="minor">
-            <a:schemeClr val="lt1"/>
-          </a:fontRef>
-        </p:style>
-        <p:txBody>
-          <a:bodyPr rtlCol="0" anchor="ctr" wrap="square"/>
+        <p:txBody>
+          <a:bodyPr wrap="square">
+            <a:spAutoFit/>
+          </a:bodyPr>
           <a:lstStyle/>
           <a:p>
             <a:pPr algn="l">
-              <a:defRPr sz="950" b="1">
-                <a:solidFill>
-                  <a:srgbClr val="0F3838"/>
+              <a:defRPr sz="1050" b="1">
+                <a:solidFill>
+                  <a:srgbClr val="0D5050"/>
                 </a:solidFill>
               </a:defRPr>
             </a:pPr>
@@ -3496,7 +3439,7 @@
               <a:spcAft>
                 <a:spcPts val="200"/>
               </a:spcAft>
-              <a:defRPr sz="720">
+              <a:defRPr sz="740">
                 <a:solidFill>
                   <a:srgbClr val="1E293B"/>
                 </a:solidFill>
@@ -3510,8 +3453,8 @@
       </p:sp>
       <p:sp>
         <p:nvSpPr>
-          <p:cNvPr id="8" name="Rounded Rectangle 7"/>
-          <p:cNvSpPr/>
+          <p:cNvPr id="8" name="TextBox 7"/>
+          <p:cNvSpPr txBox="1"/>
           <p:nvPr/>
         </p:nvSpPr>
         <p:spPr>
@@ -3519,40 +3462,21 @@
             <a:off x="4114800" y="1325880"/>
             <a:ext cx="3931920" cy="2468880"/>
           </a:xfrm>
-          <a:prstGeom prst="roundRect">
+          <a:prstGeom prst="rect">
             <a:avLst/>
           </a:prstGeom>
-          <a:solidFill>
-            <a:srgbClr val="F0F7F5"/>
-          </a:solidFill>
-          <a:ln w="12700">
-            <a:solidFill>
-              <a:srgbClr val="8FA989"/>
-            </a:solidFill>
-          </a:ln>
+          <a:noFill/>
         </p:spPr>
-        <p:style>
-          <a:lnRef idx="1">
-            <a:schemeClr val="accent1"/>
-          </a:lnRef>
-          <a:fillRef idx="3">
-            <a:schemeClr val="accent1"/>
-          </a:fillRef>
-          <a:effectRef idx="2">
-            <a:schemeClr val="accent1"/>
-          </a:effectRef>
-          <a:fontRef idx="minor">
-            <a:schemeClr val="lt1"/>
-          </a:fontRef>
-        </p:style>
-        <p:txBody>
-          <a:bodyPr rtlCol="0" anchor="ctr" wrap="square"/>
+        <p:txBody>
+          <a:bodyPr wrap="square">
+            <a:spAutoFit/>
+          </a:bodyPr>
           <a:lstStyle/>
           <a:p>
             <a:pPr algn="l">
-              <a:defRPr sz="950" b="1">
-                <a:solidFill>
-                  <a:srgbClr val="0F3838"/>
+              <a:defRPr sz="1050" b="1">
+                <a:solidFill>
+                  <a:srgbClr val="0D5050"/>
                 </a:solidFill>
               </a:defRPr>
             </a:pPr>
@@ -3565,7 +3489,7 @@
               <a:spcAft>
                 <a:spcPts val="200"/>
               </a:spcAft>
-              <a:defRPr sz="720">
+              <a:defRPr sz="740">
                 <a:solidFill>
                   <a:srgbClr val="1E293B"/>
                 </a:solidFill>
@@ -3580,7 +3504,7 @@
               <a:spcAft>
                 <a:spcPts val="200"/>
               </a:spcAft>
-              <a:defRPr sz="720">
+              <a:defRPr sz="740">
                 <a:solidFill>
                   <a:srgbClr val="1E293B"/>
                 </a:solidFill>
@@ -3595,7 +3519,7 @@
               <a:spcAft>
                 <a:spcPts val="200"/>
               </a:spcAft>
-              <a:defRPr sz="720">
+              <a:defRPr sz="740">
                 <a:solidFill>
                   <a:srgbClr val="1E293B"/>
                 </a:solidFill>
@@ -3610,7 +3534,7 @@
               <a:spcAft>
                 <a:spcPts val="200"/>
               </a:spcAft>
-              <a:defRPr sz="720">
+              <a:defRPr sz="740">
                 <a:solidFill>
                   <a:srgbClr val="1E293B"/>
                 </a:solidFill>
@@ -3625,7 +3549,7 @@
               <a:spcAft>
                 <a:spcPts val="200"/>
               </a:spcAft>
-              <a:defRPr sz="720">
+              <a:defRPr sz="740">
                 <a:solidFill>
                   <a:srgbClr val="1E293B"/>
                 </a:solidFill>
@@ -3640,7 +3564,7 @@
               <a:spcAft>
                 <a:spcPts val="200"/>
               </a:spcAft>
-              <a:defRPr sz="720">
+              <a:defRPr sz="740">
                 <a:solidFill>
                   <a:srgbClr val="1E293B"/>
                 </a:solidFill>
@@ -3654,8 +3578,8 @@
       </p:sp>
       <p:sp>
         <p:nvSpPr>
-          <p:cNvPr id="9" name="Rounded Rectangle 8"/>
-          <p:cNvSpPr/>
+          <p:cNvPr id="9" name="TextBox 8"/>
+          <p:cNvSpPr txBox="1"/>
           <p:nvPr/>
         </p:nvSpPr>
         <p:spPr>
@@ -3663,40 +3587,21 @@
             <a:off x="4114800" y="3858768"/>
             <a:ext cx="3931920" cy="1554480"/>
           </a:xfrm>
-          <a:prstGeom prst="roundRect">
+          <a:prstGeom prst="rect">
             <a:avLst/>
           </a:prstGeom>
-          <a:solidFill>
-            <a:srgbClr val="F0F7F5"/>
-          </a:solidFill>
-          <a:ln w="12700">
-            <a:solidFill>
-              <a:srgbClr val="8FA989"/>
-            </a:solidFill>
-          </a:ln>
+          <a:noFill/>
         </p:spPr>
-        <p:style>
-          <a:lnRef idx="1">
-            <a:schemeClr val="accent1"/>
-          </a:lnRef>
-          <a:fillRef idx="3">
-            <a:schemeClr val="accent1"/>
-          </a:fillRef>
-          <a:effectRef idx="2">
-            <a:schemeClr val="accent1"/>
-          </a:effectRef>
-          <a:fontRef idx="minor">
-            <a:schemeClr val="lt1"/>
-          </a:fontRef>
-        </p:style>
-        <p:txBody>
-          <a:bodyPr rtlCol="0" anchor="ctr" wrap="square"/>
+        <p:txBody>
+          <a:bodyPr wrap="square">
+            <a:spAutoFit/>
+          </a:bodyPr>
           <a:lstStyle/>
           <a:p>
             <a:pPr algn="l">
-              <a:defRPr sz="950" b="1">
-                <a:solidFill>
-                  <a:srgbClr val="0F3838"/>
+              <a:defRPr sz="1050" b="1">
+                <a:solidFill>
+                  <a:srgbClr val="0D5050"/>
                 </a:solidFill>
               </a:defRPr>
             </a:pPr>
@@ -3709,7 +3614,7 @@
               <a:spcAft>
                 <a:spcPts val="200"/>
               </a:spcAft>
-              <a:defRPr sz="720">
+              <a:defRPr sz="740">
                 <a:solidFill>
                   <a:srgbClr val="1E293B"/>
                 </a:solidFill>
@@ -3724,7 +3629,7 @@
               <a:spcAft>
                 <a:spcPts val="200"/>
               </a:spcAft>
-              <a:defRPr sz="720">
+              <a:defRPr sz="740">
                 <a:solidFill>
                   <a:srgbClr val="1E293B"/>
                 </a:solidFill>
@@ -3738,8 +3643,8 @@
       </p:sp>
       <p:sp>
         <p:nvSpPr>
-          <p:cNvPr id="10" name="Rounded Rectangle 9"/>
-          <p:cNvSpPr/>
+          <p:cNvPr id="10" name="TextBox 9"/>
+          <p:cNvSpPr txBox="1"/>
           <p:nvPr/>
         </p:nvSpPr>
         <p:spPr>
@@ -3747,40 +3652,21 @@
             <a:off x="4114800" y="5468112"/>
             <a:ext cx="3931920" cy="1188720"/>
           </a:xfrm>
-          <a:prstGeom prst="roundRect">
+          <a:prstGeom prst="rect">
             <a:avLst/>
           </a:prstGeom>
-          <a:solidFill>
-            <a:srgbClr val="F0F7F5"/>
-          </a:solidFill>
-          <a:ln w="12700">
-            <a:solidFill>
-              <a:srgbClr val="8FA989"/>
-            </a:solidFill>
-          </a:ln>
+          <a:noFill/>
         </p:spPr>
-        <p:style>
-          <a:lnRef idx="1">
-            <a:schemeClr val="accent1"/>
-          </a:lnRef>
-          <a:fillRef idx="3">
-            <a:schemeClr val="accent1"/>
-          </a:fillRef>
-          <a:effectRef idx="2">
-            <a:schemeClr val="accent1"/>
-          </a:effectRef>
-          <a:fontRef idx="minor">
-            <a:schemeClr val="lt1"/>
-          </a:fontRef>
-        </p:style>
-        <p:txBody>
-          <a:bodyPr rtlCol="0" anchor="ctr" wrap="square"/>
+        <p:txBody>
+          <a:bodyPr wrap="square">
+            <a:spAutoFit/>
+          </a:bodyPr>
           <a:lstStyle/>
           <a:p>
             <a:pPr algn="l">
-              <a:defRPr sz="950" b="1">
-                <a:solidFill>
-                  <a:srgbClr val="0F3838"/>
+              <a:defRPr sz="1050" b="1">
+                <a:solidFill>
+                  <a:srgbClr val="0D5050"/>
                 </a:solidFill>
               </a:defRPr>
             </a:pPr>
@@ -3793,7 +3679,7 @@
               <a:spcAft>
                 <a:spcPts val="200"/>
               </a:spcAft>
-              <a:defRPr sz="720">
+              <a:defRPr sz="740">
                 <a:solidFill>
                   <a:srgbClr val="1E293B"/>
                 </a:solidFill>
@@ -3807,8 +3693,8 @@
       </p:sp>
       <p:sp>
         <p:nvSpPr>
-          <p:cNvPr id="11" name="Rounded Rectangle 10"/>
-          <p:cNvSpPr/>
+          <p:cNvPr id="11" name="TextBox 10"/>
+          <p:cNvSpPr txBox="1"/>
           <p:nvPr/>
         </p:nvSpPr>
         <p:spPr>
@@ -3816,40 +3702,21 @@
             <a:off x="8229600" y="1325880"/>
             <a:ext cx="3749039" cy="2651760"/>
           </a:xfrm>
-          <a:prstGeom prst="roundRect">
+          <a:prstGeom prst="rect">
             <a:avLst/>
           </a:prstGeom>
-          <a:solidFill>
-            <a:srgbClr val="F0F7F5"/>
-          </a:solidFill>
-          <a:ln w="12700">
-            <a:solidFill>
-              <a:srgbClr val="8FA989"/>
-            </a:solidFill>
-          </a:ln>
+          <a:noFill/>
         </p:spPr>
-        <p:style>
-          <a:lnRef idx="1">
-            <a:schemeClr val="accent1"/>
-          </a:lnRef>
-          <a:fillRef idx="3">
-            <a:schemeClr val="accent1"/>
-          </a:fillRef>
-          <a:effectRef idx="2">
-            <a:schemeClr val="accent1"/>
-          </a:effectRef>
-          <a:fontRef idx="minor">
-            <a:schemeClr val="lt1"/>
-          </a:fontRef>
-        </p:style>
-        <p:txBody>
-          <a:bodyPr rtlCol="0" anchor="ctr" wrap="square"/>
+        <p:txBody>
+          <a:bodyPr wrap="square">
+            <a:spAutoFit/>
+          </a:bodyPr>
           <a:lstStyle/>
           <a:p>
             <a:pPr algn="l">
-              <a:defRPr sz="950" b="1">
-                <a:solidFill>
-                  <a:srgbClr val="0F3838"/>
+              <a:defRPr sz="1050" b="1">
+                <a:solidFill>
+                  <a:srgbClr val="0D5050"/>
                 </a:solidFill>
               </a:defRPr>
             </a:pPr>
@@ -3862,7 +3729,7 @@
               <a:spcAft>
                 <a:spcPts val="200"/>
               </a:spcAft>
-              <a:defRPr sz="720">
+              <a:defRPr sz="740">
                 <a:solidFill>
                   <a:srgbClr val="1E293B"/>
                 </a:solidFill>
@@ -3877,7 +3744,7 @@
               <a:spcAft>
                 <a:spcPts val="200"/>
               </a:spcAft>
-              <a:defRPr sz="720">
+              <a:defRPr sz="740">
                 <a:solidFill>
                   <a:srgbClr val="1E293B"/>
                 </a:solidFill>
@@ -3892,7 +3759,7 @@
               <a:spcAft>
                 <a:spcPts val="200"/>
               </a:spcAft>
-              <a:defRPr sz="720">
+              <a:defRPr sz="740">
                 <a:solidFill>
                   <a:srgbClr val="1E293B"/>
                 </a:solidFill>
@@ -3907,7 +3774,7 @@
               <a:spcAft>
                 <a:spcPts val="200"/>
               </a:spcAft>
-              <a:defRPr sz="720">
+              <a:defRPr sz="740">
                 <a:solidFill>
                   <a:srgbClr val="1E293B"/>
                 </a:solidFill>
@@ -3922,7 +3789,7 @@
               <a:spcAft>
                 <a:spcPts val="200"/>
               </a:spcAft>
-              <a:defRPr sz="720">
+              <a:defRPr sz="740">
                 <a:solidFill>
                   <a:srgbClr val="1E293B"/>
                 </a:solidFill>
@@ -3937,7 +3804,7 @@
               <a:spcAft>
                 <a:spcPts val="200"/>
               </a:spcAft>
-              <a:defRPr sz="720">
+              <a:defRPr sz="740">
                 <a:solidFill>
                   <a:srgbClr val="1E293B"/>
                 </a:solidFill>
@@ -3951,49 +3818,30 @@
       </p:sp>
       <p:sp>
         <p:nvSpPr>
-          <p:cNvPr id="12" name="Rounded Rectangle 11"/>
-          <p:cNvSpPr/>
+          <p:cNvPr id="12" name="TextBox 11"/>
+          <p:cNvSpPr txBox="1"/>
           <p:nvPr/>
         </p:nvSpPr>
         <p:spPr>
           <a:xfrm>
-            <a:off x="8229600" y="4041648"/>
-            <a:ext cx="3749039" cy="2615184"/>
+            <a:off x="8229600" y="4069080"/>
+            <a:ext cx="3749039" cy="365760"/>
           </a:xfrm>
-          <a:prstGeom prst="roundRect">
+          <a:prstGeom prst="rect">
             <a:avLst/>
           </a:prstGeom>
-          <a:solidFill>
-            <a:srgbClr val="F0F7F5"/>
-          </a:solidFill>
-          <a:ln w="12700">
-            <a:solidFill>
-              <a:srgbClr val="8FA989"/>
-            </a:solidFill>
-          </a:ln>
+          <a:noFill/>
         </p:spPr>
-        <p:style>
-          <a:lnRef idx="1">
-            <a:schemeClr val="accent1"/>
-          </a:lnRef>
-          <a:fillRef idx="3">
-            <a:schemeClr val="accent1"/>
-          </a:fillRef>
-          <a:effectRef idx="2">
-            <a:schemeClr val="accent1"/>
-          </a:effectRef>
-          <a:fontRef idx="minor">
-            <a:schemeClr val="lt1"/>
-          </a:fontRef>
-        </p:style>
-        <p:txBody>
-          <a:bodyPr rtlCol="0" anchor="ctr"/>
-          <a:lstStyle/>
-          <a:p>
-            <a:pPr algn="ctr">
-              <a:defRPr sz="950" b="1">
-                <a:solidFill>
-                  <a:srgbClr val="0F3838"/>
+        <p:txBody>
+          <a:bodyPr wrap="none">
+            <a:spAutoFit/>
+          </a:bodyPr>
+          <a:lstStyle/>
+          <a:p>
+            <a:pPr>
+              <a:defRPr sz="1050" b="1">
+                <a:solidFill>
+                  <a:srgbClr val="0D5050"/>
                 </a:solidFill>
               </a:defRPr>
             </a:pPr>
@@ -4019,8 +3867,8 @@
         </p:blipFill>
         <p:spPr>
           <a:xfrm>
-            <a:off x="8321040" y="4389120"/>
-            <a:ext cx="3566160" cy="2103120"/>
+            <a:off x="8229600" y="4434840"/>
+            <a:ext cx="3749039" cy="2194560"/>
           </a:xfrm>
           <a:prstGeom prst="rect">
             <a:avLst/>

</xml_diff>

<commit_message>
Update KEFFI_POSTER to Times New Roman font with top green box removed for both PDF and PPTX
</commit_message>
<xml_diff>
--- a/Final_Submission_Pack/3_Project_Poster.pptx
+++ b/Final_Submission_Pack/3_Project_Poster.pptx
@@ -3090,14 +3090,137 @@
       <p:grpSpPr/>
       <p:sp>
         <p:nvSpPr>
-          <p:cNvPr id="2" name="Rectangle 1"/>
+          <p:cNvPr id="2" name="TextBox 1"/>
+          <p:cNvSpPr txBox="1"/>
+          <p:nvPr/>
+        </p:nvSpPr>
+        <p:spPr>
+          <a:xfrm>
+            <a:off x="1280160" y="137160"/>
+            <a:ext cx="9628632" cy="1097280"/>
+          </a:xfrm>
+          <a:prstGeom prst="rect">
+            <a:avLst/>
+          </a:prstGeom>
+          <a:noFill/>
+        </p:spPr>
+        <p:txBody>
+          <a:bodyPr wrap="square">
+            <a:spAutoFit/>
+          </a:bodyPr>
+          <a:lstStyle/>
+          <a:p>
+            <a:pPr algn="ctr">
+              <a:defRPr sz="2000" b="1">
+                <a:solidFill>
+                  <a:srgbClr val="0F3838"/>
+                </a:solidFill>
+                <a:latin typeface="Times New Roman"/>
+              </a:defRPr>
+            </a:pPr>
+            <a:r>
+              <a:t>KEFFI AI – A MENTAL HEALTH CHATBOT</a:t>
+            </a:r>
+          </a:p>
+          <a:p>
+            <a:pPr algn="ctr">
+              <a:defRPr sz="1100" b="1">
+                <a:solidFill>
+                  <a:srgbClr val="0D5050"/>
+                </a:solidFill>
+                <a:latin typeface="Times New Roman"/>
+              </a:defRPr>
+            </a:pPr>
+            <a:r>
+              <a:t>UNIVERSITY COLLEGE OF ENGINEERING PANRUTI</a:t>
+            </a:r>
+          </a:p>
+          <a:p>
+            <a:pPr algn="ctr">
+              <a:defRPr sz="900" i="1">
+                <a:solidFill>
+                  <a:srgbClr val="334155"/>
+                </a:solidFill>
+                <a:latin typeface="Times New Roman"/>
+              </a:defRPr>
+            </a:pPr>
+            <a:r>
+              <a:t>(A Constituent College of Anna University, Chennai) • Department of Computer Science and Engineering</a:t>
+            </a:r>
+          </a:p>
+          <a:p>
+            <a:pPr algn="ctr">
+              <a:defRPr sz="850" b="1">
+                <a:solidFill>
+                  <a:srgbClr val="1E293B"/>
+                </a:solidFill>
+                <a:latin typeface="Times New Roman"/>
+              </a:defRPr>
+            </a:pPr>
+            <a:r>
+              <a:t>TEAM: HACKERS TEAM   |   MEMBERS: MADHUMATHI S, BALAJI P, MALINI V   |   GUIDE: DR. S. SIVANESH M.Tech., Ph.D.</a:t>
+            </a:r>
+          </a:p>
+        </p:txBody>
+      </p:sp>
+      <p:pic>
+        <p:nvPicPr>
+          <p:cNvPr id="3" name="Picture 2" descr="poster_img_1.png"/>
+          <p:cNvPicPr>
+            <a:picLocks noChangeAspect="1"/>
+          </p:cNvPicPr>
+          <p:nvPr/>
+        </p:nvPicPr>
+        <p:blipFill>
+          <a:blip r:embed="rId2"/>
+          <a:stretch>
+            <a:fillRect/>
+          </a:stretch>
+        </p:blipFill>
+        <p:spPr>
+          <a:xfrm>
+            <a:off x="274320" y="182880"/>
+            <a:ext cx="914400" cy="914400"/>
+          </a:xfrm>
+          <a:prstGeom prst="rect">
+            <a:avLst/>
+          </a:prstGeom>
+        </p:spPr>
+      </p:pic>
+      <p:pic>
+        <p:nvPicPr>
+          <p:cNvPr id="4" name="Picture 3" descr="poster_img_3.jpg"/>
+          <p:cNvPicPr>
+            <a:picLocks noChangeAspect="1"/>
+          </p:cNvPicPr>
+          <p:nvPr/>
+        </p:nvPicPr>
+        <p:blipFill>
+          <a:blip r:embed="rId3"/>
+          <a:stretch>
+            <a:fillRect/>
+          </a:stretch>
+        </p:blipFill>
+        <p:spPr>
+          <a:xfrm>
+            <a:off x="10972800" y="182880"/>
+            <a:ext cx="914400" cy="914400"/>
+          </a:xfrm>
+          <a:prstGeom prst="rect">
+            <a:avLst/>
+          </a:prstGeom>
+        </p:spPr>
+      </p:pic>
+      <p:sp>
+        <p:nvSpPr>
+          <p:cNvPr id="5" name="Rectangle 4"/>
           <p:cNvSpPr/>
           <p:nvPr/>
         </p:nvSpPr>
         <p:spPr>
           <a:xfrm>
-            <a:off x="182880" y="182880"/>
-            <a:ext cx="11823192" cy="1051560"/>
+            <a:off x="274320" y="1234440"/>
+            <a:ext cx="11640312" cy="18288"/>
           </a:xfrm>
           <a:prstGeom prst="rect">
             <a:avLst/>
@@ -3126,109 +3249,16 @@
           </a:fontRef>
         </p:style>
         <p:txBody>
-          <a:bodyPr rtlCol="0" anchor="ctr" wrap="square"/>
-          <a:lstStyle/>
-          <a:p>
-            <a:pPr algn="ctr">
-              <a:defRPr sz="1800" b="1">
-                <a:solidFill>
-                  <a:srgbClr val="FFFFFF"/>
-                </a:solidFill>
-              </a:defRPr>
-            </a:pPr>
-            <a:r>
-              <a:t>KEFFI AI – A MENTAL HEALTH CHATBOT</a:t>
-            </a:r>
-          </a:p>
-          <a:p>
-            <a:pPr algn="ctr">
-              <a:defRPr sz="1050" b="1">
-                <a:solidFill>
-                  <a:srgbClr val="FFFFFF"/>
-                </a:solidFill>
-              </a:defRPr>
-            </a:pPr>
-            <a:r>
-              <a:t>UNIVERSITY COLLEGE OF ENGINEERING PANRUTI</a:t>
-            </a:r>
-          </a:p>
-          <a:p>
-            <a:pPr algn="ctr">
-              <a:defRPr sz="850" i="1">
-                <a:solidFill>
-                  <a:srgbClr val="FFFFFF"/>
-                </a:solidFill>
-              </a:defRPr>
-            </a:pPr>
-            <a:r>
-              <a:t>(A Constituent College of Anna University, Chennai) • Department of Computer Science and Engineering</a:t>
-            </a:r>
-          </a:p>
-          <a:p>
-            <a:pPr algn="ctr">
-              <a:defRPr sz="800" b="1">
-                <a:solidFill>
-                  <a:srgbClr val="FFFFFF"/>
-                </a:solidFill>
-              </a:defRPr>
-            </a:pPr>
-            <a:r>
-              <a:t>TEAM: HACKERS TEAM   |   MEMBERS: MADHUMATHI S, BALAJI P, MALINI V   |   GUIDE: DR. S. SIVANESH M.Tech., Ph.D.</a:t>
-            </a:r>
-          </a:p>
-        </p:txBody>
-      </p:sp>
-      <p:pic>
-        <p:nvPicPr>
-          <p:cNvPr id="3" name="Picture 2" descr="poster_img_1.png"/>
-          <p:cNvPicPr>
-            <a:picLocks noChangeAspect="1"/>
-          </p:cNvPicPr>
-          <p:nvPr/>
-        </p:nvPicPr>
-        <p:blipFill>
-          <a:blip r:embed="rId2"/>
-          <a:stretch>
-            <a:fillRect/>
-          </a:stretch>
-        </p:blipFill>
-        <p:spPr>
-          <a:xfrm>
-            <a:off x="274320" y="228600"/>
-            <a:ext cx="914400" cy="914400"/>
-          </a:xfrm>
-          <a:prstGeom prst="rect">
-            <a:avLst/>
-          </a:prstGeom>
-        </p:spPr>
-      </p:pic>
-      <p:pic>
-        <p:nvPicPr>
-          <p:cNvPr id="4" name="Picture 3" descr="poster_img_3.jpg"/>
-          <p:cNvPicPr>
-            <a:picLocks noChangeAspect="1"/>
-          </p:cNvPicPr>
-          <p:nvPr/>
-        </p:nvPicPr>
-        <p:blipFill>
-          <a:blip r:embed="rId3"/>
-          <a:stretch>
-            <a:fillRect/>
-          </a:stretch>
-        </p:blipFill>
-        <p:spPr>
-          <a:xfrm>
-            <a:off x="10972800" y="228600"/>
-            <a:ext cx="914400" cy="914400"/>
-          </a:xfrm>
-          <a:prstGeom prst="rect">
-            <a:avLst/>
-          </a:prstGeom>
-        </p:spPr>
-      </p:pic>
-      <p:sp>
-        <p:nvSpPr>
-          <p:cNvPr id="5" name="TextBox 4"/>
+          <a:bodyPr rtlCol="0" anchor="ctr"/>
+          <a:lstStyle/>
+          <a:p>
+            <a:pPr algn="ctr"/>
+          </a:p>
+        </p:txBody>
+      </p:sp>
+      <p:sp>
+        <p:nvSpPr>
+          <p:cNvPr id="6" name="TextBox 5"/>
           <p:cNvSpPr txBox="1"/>
           <p:nvPr/>
         </p:nvSpPr>
@@ -3249,10 +3279,11 @@
           <a:lstStyle/>
           <a:p>
             <a:pPr algn="l">
-              <a:defRPr sz="1050" b="1">
+              <a:defRPr sz="1100" b="1">
                 <a:solidFill>
                   <a:srgbClr val="0D5050"/>
                 </a:solidFill>
+                <a:latin typeface="Times New Roman"/>
               </a:defRPr>
             </a:pPr>
             <a:r>
@@ -3264,10 +3295,11 @@
               <a:spcAft>
                 <a:spcPts val="200"/>
               </a:spcAft>
-              <a:defRPr sz="740">
+              <a:defRPr sz="780">
                 <a:solidFill>
                   <a:srgbClr val="1E293B"/>
                 </a:solidFill>
+                <a:latin typeface="Times New Roman"/>
               </a:defRPr>
             </a:pPr>
             <a:r>
@@ -3278,7 +3310,7 @@
       </p:sp>
       <p:sp>
         <p:nvSpPr>
-          <p:cNvPr id="6" name="TextBox 5"/>
+          <p:cNvPr id="7" name="TextBox 6"/>
           <p:cNvSpPr txBox="1"/>
           <p:nvPr/>
         </p:nvSpPr>
@@ -3299,10 +3331,11 @@
           <a:lstStyle/>
           <a:p>
             <a:pPr algn="l">
-              <a:defRPr sz="1050" b="1">
+              <a:defRPr sz="1100" b="1">
                 <a:solidFill>
                   <a:srgbClr val="0D5050"/>
                 </a:solidFill>
+                <a:latin typeface="Times New Roman"/>
               </a:defRPr>
             </a:pPr>
             <a:r>
@@ -3314,10 +3347,11 @@
               <a:spcAft>
                 <a:spcPts val="200"/>
               </a:spcAft>
-              <a:defRPr sz="740">
+              <a:defRPr sz="780">
                 <a:solidFill>
                   <a:srgbClr val="1E293B"/>
                 </a:solidFill>
+                <a:latin typeface="Times New Roman"/>
               </a:defRPr>
             </a:pPr>
             <a:r>
@@ -3329,10 +3363,11 @@
               <a:spcAft>
                 <a:spcPts val="200"/>
               </a:spcAft>
-              <a:defRPr sz="740">
+              <a:defRPr sz="780">
                 <a:solidFill>
                   <a:srgbClr val="1E293B"/>
                 </a:solidFill>
+                <a:latin typeface="Times New Roman"/>
               </a:defRPr>
             </a:pPr>
             <a:r>
@@ -3344,10 +3379,11 @@
               <a:spcAft>
                 <a:spcPts val="200"/>
               </a:spcAft>
-              <a:defRPr sz="740">
+              <a:defRPr sz="780">
                 <a:solidFill>
                   <a:srgbClr val="1E293B"/>
                 </a:solidFill>
+                <a:latin typeface="Times New Roman"/>
               </a:defRPr>
             </a:pPr>
             <a:r>
@@ -3359,10 +3395,11 @@
               <a:spcAft>
                 <a:spcPts val="200"/>
               </a:spcAft>
-              <a:defRPr sz="740">
+              <a:defRPr sz="780">
                 <a:solidFill>
                   <a:srgbClr val="1E293B"/>
                 </a:solidFill>
+                <a:latin typeface="Times New Roman"/>
               </a:defRPr>
             </a:pPr>
             <a:r>
@@ -3374,10 +3411,11 @@
               <a:spcAft>
                 <a:spcPts val="200"/>
               </a:spcAft>
-              <a:defRPr sz="740">
+              <a:defRPr sz="780">
                 <a:solidFill>
                   <a:srgbClr val="1E293B"/>
                 </a:solidFill>
+                <a:latin typeface="Times New Roman"/>
               </a:defRPr>
             </a:pPr>
             <a:r>
@@ -3389,10 +3427,11 @@
               <a:spcAft>
                 <a:spcPts val="200"/>
               </a:spcAft>
-              <a:defRPr sz="740">
+              <a:defRPr sz="780">
                 <a:solidFill>
                   <a:srgbClr val="1E293B"/>
                 </a:solidFill>
+                <a:latin typeface="Times New Roman"/>
               </a:defRPr>
             </a:pPr>
             <a:r>
@@ -3403,7 +3442,7 @@
       </p:sp>
       <p:sp>
         <p:nvSpPr>
-          <p:cNvPr id="7" name="TextBox 6"/>
+          <p:cNvPr id="8" name="TextBox 7"/>
           <p:cNvSpPr txBox="1"/>
           <p:nvPr/>
         </p:nvSpPr>
@@ -3424,10 +3463,11 @@
           <a:lstStyle/>
           <a:p>
             <a:pPr algn="l">
-              <a:defRPr sz="1050" b="1">
+              <a:defRPr sz="1100" b="1">
                 <a:solidFill>
                   <a:srgbClr val="0D5050"/>
                 </a:solidFill>
+                <a:latin typeface="Times New Roman"/>
               </a:defRPr>
             </a:pPr>
             <a:r>
@@ -3439,10 +3479,11 @@
               <a:spcAft>
                 <a:spcPts val="200"/>
               </a:spcAft>
-              <a:defRPr sz="740">
+              <a:defRPr sz="780">
                 <a:solidFill>
                   <a:srgbClr val="1E293B"/>
                 </a:solidFill>
+                <a:latin typeface="Times New Roman"/>
               </a:defRPr>
             </a:pPr>
             <a:r>
@@ -3453,7 +3494,7 @@
       </p:sp>
       <p:sp>
         <p:nvSpPr>
-          <p:cNvPr id="8" name="TextBox 7"/>
+          <p:cNvPr id="9" name="TextBox 8"/>
           <p:cNvSpPr txBox="1"/>
           <p:nvPr/>
         </p:nvSpPr>
@@ -3474,10 +3515,11 @@
           <a:lstStyle/>
           <a:p>
             <a:pPr algn="l">
-              <a:defRPr sz="1050" b="1">
+              <a:defRPr sz="1100" b="1">
                 <a:solidFill>
                   <a:srgbClr val="0D5050"/>
                 </a:solidFill>
+                <a:latin typeface="Times New Roman"/>
               </a:defRPr>
             </a:pPr>
             <a:r>
@@ -3489,10 +3531,11 @@
               <a:spcAft>
                 <a:spcPts val="200"/>
               </a:spcAft>
-              <a:defRPr sz="740">
+              <a:defRPr sz="780">
                 <a:solidFill>
                   <a:srgbClr val="1E293B"/>
                 </a:solidFill>
+                <a:latin typeface="Times New Roman"/>
               </a:defRPr>
             </a:pPr>
             <a:r>
@@ -3504,10 +3547,11 @@
               <a:spcAft>
                 <a:spcPts val="200"/>
               </a:spcAft>
-              <a:defRPr sz="740">
+              <a:defRPr sz="780">
                 <a:solidFill>
                   <a:srgbClr val="1E293B"/>
                 </a:solidFill>
+                <a:latin typeface="Times New Roman"/>
               </a:defRPr>
             </a:pPr>
             <a:r>
@@ -3519,10 +3563,11 @@
               <a:spcAft>
                 <a:spcPts val="200"/>
               </a:spcAft>
-              <a:defRPr sz="740">
+              <a:defRPr sz="780">
                 <a:solidFill>
                   <a:srgbClr val="1E293B"/>
                 </a:solidFill>
+                <a:latin typeface="Times New Roman"/>
               </a:defRPr>
             </a:pPr>
             <a:r>
@@ -3534,10 +3579,11 @@
               <a:spcAft>
                 <a:spcPts val="200"/>
               </a:spcAft>
-              <a:defRPr sz="740">
+              <a:defRPr sz="780">
                 <a:solidFill>
                   <a:srgbClr val="1E293B"/>
                 </a:solidFill>
+                <a:latin typeface="Times New Roman"/>
               </a:defRPr>
             </a:pPr>
             <a:r>
@@ -3549,10 +3595,11 @@
               <a:spcAft>
                 <a:spcPts val="200"/>
               </a:spcAft>
-              <a:defRPr sz="740">
+              <a:defRPr sz="780">
                 <a:solidFill>
                   <a:srgbClr val="1E293B"/>
                 </a:solidFill>
+                <a:latin typeface="Times New Roman"/>
               </a:defRPr>
             </a:pPr>
             <a:r>
@@ -3564,10 +3611,11 @@
               <a:spcAft>
                 <a:spcPts val="200"/>
               </a:spcAft>
-              <a:defRPr sz="740">
+              <a:defRPr sz="780">
                 <a:solidFill>
                   <a:srgbClr val="1E293B"/>
                 </a:solidFill>
+                <a:latin typeface="Times New Roman"/>
               </a:defRPr>
             </a:pPr>
             <a:r>
@@ -3578,7 +3626,7 @@
       </p:sp>
       <p:sp>
         <p:nvSpPr>
-          <p:cNvPr id="9" name="TextBox 8"/>
+          <p:cNvPr id="10" name="TextBox 9"/>
           <p:cNvSpPr txBox="1"/>
           <p:nvPr/>
         </p:nvSpPr>
@@ -3599,10 +3647,11 @@
           <a:lstStyle/>
           <a:p>
             <a:pPr algn="l">
-              <a:defRPr sz="1050" b="1">
+              <a:defRPr sz="1100" b="1">
                 <a:solidFill>
                   <a:srgbClr val="0D5050"/>
                 </a:solidFill>
+                <a:latin typeface="Times New Roman"/>
               </a:defRPr>
             </a:pPr>
             <a:r>
@@ -3614,10 +3663,11 @@
               <a:spcAft>
                 <a:spcPts val="200"/>
               </a:spcAft>
-              <a:defRPr sz="740">
+              <a:defRPr sz="780">
                 <a:solidFill>
                   <a:srgbClr val="1E293B"/>
                 </a:solidFill>
+                <a:latin typeface="Times New Roman"/>
               </a:defRPr>
             </a:pPr>
             <a:r>
@@ -3629,10 +3679,11 @@
               <a:spcAft>
                 <a:spcPts val="200"/>
               </a:spcAft>
-              <a:defRPr sz="740">
+              <a:defRPr sz="780">
                 <a:solidFill>
                   <a:srgbClr val="1E293B"/>
                 </a:solidFill>
+                <a:latin typeface="Times New Roman"/>
               </a:defRPr>
             </a:pPr>
             <a:r>
@@ -3643,7 +3694,7 @@
       </p:sp>
       <p:sp>
         <p:nvSpPr>
-          <p:cNvPr id="10" name="TextBox 9"/>
+          <p:cNvPr id="11" name="TextBox 10"/>
           <p:cNvSpPr txBox="1"/>
           <p:nvPr/>
         </p:nvSpPr>
@@ -3664,10 +3715,11 @@
           <a:lstStyle/>
           <a:p>
             <a:pPr algn="l">
-              <a:defRPr sz="1050" b="1">
+              <a:defRPr sz="1100" b="1">
                 <a:solidFill>
                   <a:srgbClr val="0D5050"/>
                 </a:solidFill>
+                <a:latin typeface="Times New Roman"/>
               </a:defRPr>
             </a:pPr>
             <a:r>
@@ -3679,10 +3731,11 @@
               <a:spcAft>
                 <a:spcPts val="200"/>
               </a:spcAft>
-              <a:defRPr sz="740">
+              <a:defRPr sz="780">
                 <a:solidFill>
                   <a:srgbClr val="1E293B"/>
                 </a:solidFill>
+                <a:latin typeface="Times New Roman"/>
               </a:defRPr>
             </a:pPr>
             <a:r>
@@ -3693,7 +3746,7 @@
       </p:sp>
       <p:sp>
         <p:nvSpPr>
-          <p:cNvPr id="11" name="TextBox 10"/>
+          <p:cNvPr id="12" name="TextBox 11"/>
           <p:cNvSpPr txBox="1"/>
           <p:nvPr/>
         </p:nvSpPr>
@@ -3714,10 +3767,11 @@
           <a:lstStyle/>
           <a:p>
             <a:pPr algn="l">
-              <a:defRPr sz="1050" b="1">
+              <a:defRPr sz="1100" b="1">
                 <a:solidFill>
                   <a:srgbClr val="0D5050"/>
                 </a:solidFill>
+                <a:latin typeface="Times New Roman"/>
               </a:defRPr>
             </a:pPr>
             <a:r>
@@ -3729,10 +3783,11 @@
               <a:spcAft>
                 <a:spcPts val="200"/>
               </a:spcAft>
-              <a:defRPr sz="740">
+              <a:defRPr sz="780">
                 <a:solidFill>
                   <a:srgbClr val="1E293B"/>
                 </a:solidFill>
+                <a:latin typeface="Times New Roman"/>
               </a:defRPr>
             </a:pPr>
             <a:r>
@@ -3744,10 +3799,11 @@
               <a:spcAft>
                 <a:spcPts val="200"/>
               </a:spcAft>
-              <a:defRPr sz="740">
+              <a:defRPr sz="780">
                 <a:solidFill>
                   <a:srgbClr val="1E293B"/>
                 </a:solidFill>
+                <a:latin typeface="Times New Roman"/>
               </a:defRPr>
             </a:pPr>
             <a:r>
@@ -3759,10 +3815,11 @@
               <a:spcAft>
                 <a:spcPts val="200"/>
               </a:spcAft>
-              <a:defRPr sz="740">
+              <a:defRPr sz="780">
                 <a:solidFill>
                   <a:srgbClr val="1E293B"/>
                 </a:solidFill>
+                <a:latin typeface="Times New Roman"/>
               </a:defRPr>
             </a:pPr>
             <a:r>
@@ -3774,10 +3831,11 @@
               <a:spcAft>
                 <a:spcPts val="200"/>
               </a:spcAft>
-              <a:defRPr sz="740">
+              <a:defRPr sz="780">
                 <a:solidFill>
                   <a:srgbClr val="1E293B"/>
                 </a:solidFill>
+                <a:latin typeface="Times New Roman"/>
               </a:defRPr>
             </a:pPr>
             <a:r>
@@ -3789,10 +3847,11 @@
               <a:spcAft>
                 <a:spcPts val="200"/>
               </a:spcAft>
-              <a:defRPr sz="740">
+              <a:defRPr sz="780">
                 <a:solidFill>
                   <a:srgbClr val="1E293B"/>
                 </a:solidFill>
+                <a:latin typeface="Times New Roman"/>
               </a:defRPr>
             </a:pPr>
             <a:r>
@@ -3804,10 +3863,11 @@
               <a:spcAft>
                 <a:spcPts val="200"/>
               </a:spcAft>
-              <a:defRPr sz="740">
+              <a:defRPr sz="780">
                 <a:solidFill>
                   <a:srgbClr val="1E293B"/>
                 </a:solidFill>
+                <a:latin typeface="Times New Roman"/>
               </a:defRPr>
             </a:pPr>
             <a:r>
@@ -3818,7 +3878,7 @@
       </p:sp>
       <p:sp>
         <p:nvSpPr>
-          <p:cNvPr id="12" name="TextBox 11"/>
+          <p:cNvPr id="13" name="TextBox 12"/>
           <p:cNvSpPr txBox="1"/>
           <p:nvPr/>
         </p:nvSpPr>
@@ -3839,10 +3899,11 @@
           <a:lstStyle/>
           <a:p>
             <a:pPr>
-              <a:defRPr sz="1050" b="1">
+              <a:defRPr sz="1100" b="1">
                 <a:solidFill>
                   <a:srgbClr val="0D5050"/>
                 </a:solidFill>
+                <a:latin typeface="Times New Roman"/>
               </a:defRPr>
             </a:pPr>
             <a:r>
@@ -3853,7 +3914,7 @@
       </p:sp>
       <p:pic>
         <p:nvPicPr>
-          <p:cNvPr id="13" name="Picture 12" descr="poster_img_4.jpg"/>
+          <p:cNvPr id="14" name="Picture 13" descr="poster_img_4.jpg"/>
           <p:cNvPicPr>
             <a:picLocks noChangeAspect="1"/>
           </p:cNvPicPr>

</xml_diff>

<commit_message>
Replace poster image with new user live landing UI screenshot and scale Times New Roman layout to fill page beautifully for PDF and PPTX
</commit_message>
<xml_diff>
--- a/Final_Submission_Pack/3_Project_Poster.pptx
+++ b/Final_Submission_Pack/3_Project_Poster.pptx
@@ -3096,7 +3096,7 @@
         </p:nvSpPr>
         <p:spPr>
           <a:xfrm>
-            <a:off x="1280160" y="137160"/>
+            <a:off x="1280160" y="109728"/>
             <a:ext cx="9628632" cy="1097280"/>
           </a:xfrm>
           <a:prstGeom prst="rect">
@@ -3111,7 +3111,7 @@
           <a:lstStyle/>
           <a:p>
             <a:pPr algn="ctr">
-              <a:defRPr sz="2000" b="1">
+              <a:defRPr sz="2100" b="1">
                 <a:solidFill>
                   <a:srgbClr val="0F3838"/>
                 </a:solidFill>
@@ -3124,7 +3124,7 @@
           </a:p>
           <a:p>
             <a:pPr algn="ctr">
-              <a:defRPr sz="1100" b="1">
+              <a:defRPr sz="1150" b="1">
                 <a:solidFill>
                   <a:srgbClr val="0D5050"/>
                 </a:solidFill>
@@ -3137,7 +3137,7 @@
           </a:p>
           <a:p>
             <a:pPr algn="ctr">
-              <a:defRPr sz="900" i="1">
+              <a:defRPr sz="919" i="1">
                 <a:solidFill>
                   <a:srgbClr val="334155"/>
                 </a:solidFill>
@@ -3150,7 +3150,7 @@
           </a:p>
           <a:p>
             <a:pPr algn="ctr">
-              <a:defRPr sz="850" b="1">
+              <a:defRPr sz="880" b="1">
                 <a:solidFill>
                   <a:srgbClr val="1E293B"/>
                 </a:solidFill>
@@ -3179,8 +3179,8 @@
         </p:blipFill>
         <p:spPr>
           <a:xfrm>
-            <a:off x="274320" y="182880"/>
-            <a:ext cx="914400" cy="914400"/>
+            <a:off x="274320" y="164592"/>
+            <a:ext cx="960120" cy="960120"/>
           </a:xfrm>
           <a:prstGeom prst="rect">
             <a:avLst/>
@@ -3203,8 +3203,8 @@
         </p:blipFill>
         <p:spPr>
           <a:xfrm>
-            <a:off x="10972800" y="182880"/>
-            <a:ext cx="914400" cy="914400"/>
+            <a:off x="10972800" y="164592"/>
+            <a:ext cx="960120" cy="960120"/>
           </a:xfrm>
           <a:prstGeom prst="rect">
             <a:avLst/>
@@ -3219,7 +3219,7 @@
         </p:nvSpPr>
         <p:spPr>
           <a:xfrm>
-            <a:off x="274320" y="1234440"/>
+            <a:off x="274320" y="1243584"/>
             <a:ext cx="11640312" cy="18288"/>
           </a:xfrm>
           <a:prstGeom prst="rect">
@@ -3264,7 +3264,7 @@
         </p:nvSpPr>
         <p:spPr>
           <a:xfrm>
-            <a:off x="182880" y="1325880"/>
+            <a:off x="182880" y="1316736"/>
             <a:ext cx="3749039" cy="1371600"/>
           </a:xfrm>
           <a:prstGeom prst="rect">
@@ -3279,7 +3279,7 @@
           <a:lstStyle/>
           <a:p>
             <a:pPr algn="l">
-              <a:defRPr sz="1100" b="1">
+              <a:defRPr sz="1150" b="1">
                 <a:solidFill>
                   <a:srgbClr val="0D5050"/>
                 </a:solidFill>
@@ -3293,9 +3293,9 @@
           <a:p>
             <a:pPr algn="l">
               <a:spcAft>
-                <a:spcPts val="200"/>
+                <a:spcPts val="250"/>
               </a:spcAft>
-              <a:defRPr sz="780">
+              <a:defRPr sz="819">
                 <a:solidFill>
                   <a:srgbClr val="1E293B"/>
                 </a:solidFill>
@@ -3331,7 +3331,7 @@
           <a:lstStyle/>
           <a:p>
             <a:pPr algn="l">
-              <a:defRPr sz="1100" b="1">
+              <a:defRPr sz="1150" b="1">
                 <a:solidFill>
                   <a:srgbClr val="0D5050"/>
                 </a:solidFill>
@@ -3345,9 +3345,9 @@
           <a:p>
             <a:pPr algn="l">
               <a:spcAft>
-                <a:spcPts val="200"/>
+                <a:spcPts val="250"/>
               </a:spcAft>
-              <a:defRPr sz="780">
+              <a:defRPr sz="819">
                 <a:solidFill>
                   <a:srgbClr val="1E293B"/>
                 </a:solidFill>
@@ -3361,9 +3361,9 @@
           <a:p>
             <a:pPr algn="l">
               <a:spcAft>
-                <a:spcPts val="200"/>
+                <a:spcPts val="250"/>
               </a:spcAft>
-              <a:defRPr sz="780">
+              <a:defRPr sz="819">
                 <a:solidFill>
                   <a:srgbClr val="1E293B"/>
                 </a:solidFill>
@@ -3377,9 +3377,9 @@
           <a:p>
             <a:pPr algn="l">
               <a:spcAft>
-                <a:spcPts val="200"/>
+                <a:spcPts val="250"/>
               </a:spcAft>
-              <a:defRPr sz="780">
+              <a:defRPr sz="819">
                 <a:solidFill>
                   <a:srgbClr val="1E293B"/>
                 </a:solidFill>
@@ -3393,9 +3393,9 @@
           <a:p>
             <a:pPr algn="l">
               <a:spcAft>
-                <a:spcPts val="200"/>
+                <a:spcPts val="250"/>
               </a:spcAft>
-              <a:defRPr sz="780">
+              <a:defRPr sz="819">
                 <a:solidFill>
                   <a:srgbClr val="1E293B"/>
                 </a:solidFill>
@@ -3409,9 +3409,9 @@
           <a:p>
             <a:pPr algn="l">
               <a:spcAft>
-                <a:spcPts val="200"/>
+                <a:spcPts val="250"/>
               </a:spcAft>
-              <a:defRPr sz="780">
+              <a:defRPr sz="819">
                 <a:solidFill>
                   <a:srgbClr val="1E293B"/>
                 </a:solidFill>
@@ -3425,9 +3425,9 @@
           <a:p>
             <a:pPr algn="l">
               <a:spcAft>
-                <a:spcPts val="200"/>
+                <a:spcPts val="250"/>
               </a:spcAft>
-              <a:defRPr sz="780">
+              <a:defRPr sz="819">
                 <a:solidFill>
                   <a:srgbClr val="1E293B"/>
                 </a:solidFill>
@@ -3463,7 +3463,7 @@
           <a:lstStyle/>
           <a:p>
             <a:pPr algn="l">
-              <a:defRPr sz="1100" b="1">
+              <a:defRPr sz="1150" b="1">
                 <a:solidFill>
                   <a:srgbClr val="0D5050"/>
                 </a:solidFill>
@@ -3477,9 +3477,9 @@
           <a:p>
             <a:pPr algn="l">
               <a:spcAft>
-                <a:spcPts val="200"/>
+                <a:spcPts val="250"/>
               </a:spcAft>
-              <a:defRPr sz="780">
+              <a:defRPr sz="819">
                 <a:solidFill>
                   <a:srgbClr val="1E293B"/>
                 </a:solidFill>
@@ -3500,7 +3500,7 @@
         </p:nvSpPr>
         <p:spPr>
           <a:xfrm>
-            <a:off x="4114800" y="1325880"/>
+            <a:off x="4114800" y="1316736"/>
             <a:ext cx="3931920" cy="2468880"/>
           </a:xfrm>
           <a:prstGeom prst="rect">
@@ -3515,7 +3515,7 @@
           <a:lstStyle/>
           <a:p>
             <a:pPr algn="l">
-              <a:defRPr sz="1100" b="1">
+              <a:defRPr sz="1150" b="1">
                 <a:solidFill>
                   <a:srgbClr val="0D5050"/>
                 </a:solidFill>
@@ -3529,9 +3529,9 @@
           <a:p>
             <a:pPr algn="l">
               <a:spcAft>
-                <a:spcPts val="200"/>
+                <a:spcPts val="250"/>
               </a:spcAft>
-              <a:defRPr sz="780">
+              <a:defRPr sz="819">
                 <a:solidFill>
                   <a:srgbClr val="1E293B"/>
                 </a:solidFill>
@@ -3545,9 +3545,9 @@
           <a:p>
             <a:pPr algn="l">
               <a:spcAft>
-                <a:spcPts val="200"/>
+                <a:spcPts val="250"/>
               </a:spcAft>
-              <a:defRPr sz="780">
+              <a:defRPr sz="819">
                 <a:solidFill>
                   <a:srgbClr val="1E293B"/>
                 </a:solidFill>
@@ -3561,9 +3561,9 @@
           <a:p>
             <a:pPr algn="l">
               <a:spcAft>
-                <a:spcPts val="200"/>
+                <a:spcPts val="250"/>
               </a:spcAft>
-              <a:defRPr sz="780">
+              <a:defRPr sz="819">
                 <a:solidFill>
                   <a:srgbClr val="1E293B"/>
                 </a:solidFill>
@@ -3577,9 +3577,9 @@
           <a:p>
             <a:pPr algn="l">
               <a:spcAft>
-                <a:spcPts val="200"/>
+                <a:spcPts val="250"/>
               </a:spcAft>
-              <a:defRPr sz="780">
+              <a:defRPr sz="819">
                 <a:solidFill>
                   <a:srgbClr val="1E293B"/>
                 </a:solidFill>
@@ -3593,9 +3593,9 @@
           <a:p>
             <a:pPr algn="l">
               <a:spcAft>
-                <a:spcPts val="200"/>
+                <a:spcPts val="250"/>
               </a:spcAft>
-              <a:defRPr sz="780">
+              <a:defRPr sz="819">
                 <a:solidFill>
                   <a:srgbClr val="1E293B"/>
                 </a:solidFill>
@@ -3609,9 +3609,9 @@
           <a:p>
             <a:pPr algn="l">
               <a:spcAft>
-                <a:spcPts val="200"/>
+                <a:spcPts val="250"/>
               </a:spcAft>
-              <a:defRPr sz="780">
+              <a:defRPr sz="819">
                 <a:solidFill>
                   <a:srgbClr val="1E293B"/>
                 </a:solidFill>
@@ -3647,7 +3647,7 @@
           <a:lstStyle/>
           <a:p>
             <a:pPr algn="l">
-              <a:defRPr sz="1100" b="1">
+              <a:defRPr sz="1150" b="1">
                 <a:solidFill>
                   <a:srgbClr val="0D5050"/>
                 </a:solidFill>
@@ -3661,9 +3661,9 @@
           <a:p>
             <a:pPr algn="l">
               <a:spcAft>
-                <a:spcPts val="200"/>
+                <a:spcPts val="250"/>
               </a:spcAft>
-              <a:defRPr sz="780">
+              <a:defRPr sz="819">
                 <a:solidFill>
                   <a:srgbClr val="1E293B"/>
                 </a:solidFill>
@@ -3677,9 +3677,9 @@
           <a:p>
             <a:pPr algn="l">
               <a:spcAft>
-                <a:spcPts val="200"/>
+                <a:spcPts val="250"/>
               </a:spcAft>
-              <a:defRPr sz="780">
+              <a:defRPr sz="819">
                 <a:solidFill>
                   <a:srgbClr val="1E293B"/>
                 </a:solidFill>
@@ -3715,7 +3715,7 @@
           <a:lstStyle/>
           <a:p>
             <a:pPr algn="l">
-              <a:defRPr sz="1100" b="1">
+              <a:defRPr sz="1150" b="1">
                 <a:solidFill>
                   <a:srgbClr val="0D5050"/>
                 </a:solidFill>
@@ -3729,9 +3729,9 @@
           <a:p>
             <a:pPr algn="l">
               <a:spcAft>
-                <a:spcPts val="200"/>
+                <a:spcPts val="250"/>
               </a:spcAft>
-              <a:defRPr sz="780">
+              <a:defRPr sz="819">
                 <a:solidFill>
                   <a:srgbClr val="1E293B"/>
                 </a:solidFill>
@@ -3752,8 +3752,8 @@
         </p:nvSpPr>
         <p:spPr>
           <a:xfrm>
-            <a:off x="8229600" y="1325880"/>
-            <a:ext cx="3749039" cy="2651760"/>
+            <a:off x="8229600" y="1316736"/>
+            <a:ext cx="3749039" cy="2560320"/>
           </a:xfrm>
           <a:prstGeom prst="rect">
             <a:avLst/>
@@ -3767,7 +3767,7 @@
           <a:lstStyle/>
           <a:p>
             <a:pPr algn="l">
-              <a:defRPr sz="1100" b="1">
+              <a:defRPr sz="1150" b="1">
                 <a:solidFill>
                   <a:srgbClr val="0D5050"/>
                 </a:solidFill>
@@ -3781,9 +3781,9 @@
           <a:p>
             <a:pPr algn="l">
               <a:spcAft>
-                <a:spcPts val="200"/>
+                <a:spcPts val="250"/>
               </a:spcAft>
-              <a:defRPr sz="780">
+              <a:defRPr sz="819">
                 <a:solidFill>
                   <a:srgbClr val="1E293B"/>
                 </a:solidFill>
@@ -3797,9 +3797,9 @@
           <a:p>
             <a:pPr algn="l">
               <a:spcAft>
-                <a:spcPts val="200"/>
+                <a:spcPts val="250"/>
               </a:spcAft>
-              <a:defRPr sz="780">
+              <a:defRPr sz="819">
                 <a:solidFill>
                   <a:srgbClr val="1E293B"/>
                 </a:solidFill>
@@ -3813,9 +3813,9 @@
           <a:p>
             <a:pPr algn="l">
               <a:spcAft>
-                <a:spcPts val="200"/>
+                <a:spcPts val="250"/>
               </a:spcAft>
-              <a:defRPr sz="780">
+              <a:defRPr sz="819">
                 <a:solidFill>
                   <a:srgbClr val="1E293B"/>
                 </a:solidFill>
@@ -3829,9 +3829,9 @@
           <a:p>
             <a:pPr algn="l">
               <a:spcAft>
-                <a:spcPts val="200"/>
+                <a:spcPts val="250"/>
               </a:spcAft>
-              <a:defRPr sz="780">
+              <a:defRPr sz="819">
                 <a:solidFill>
                   <a:srgbClr val="1E293B"/>
                 </a:solidFill>
@@ -3845,9 +3845,9 @@
           <a:p>
             <a:pPr algn="l">
               <a:spcAft>
-                <a:spcPts val="200"/>
+                <a:spcPts val="250"/>
               </a:spcAft>
-              <a:defRPr sz="780">
+              <a:defRPr sz="819">
                 <a:solidFill>
                   <a:srgbClr val="1E293B"/>
                 </a:solidFill>
@@ -3861,9 +3861,9 @@
           <a:p>
             <a:pPr algn="l">
               <a:spcAft>
-                <a:spcPts val="200"/>
+                <a:spcPts val="250"/>
               </a:spcAft>
-              <a:defRPr sz="780">
+              <a:defRPr sz="819">
                 <a:solidFill>
                   <a:srgbClr val="1E293B"/>
                 </a:solidFill>
@@ -3884,8 +3884,8 @@
         </p:nvSpPr>
         <p:spPr>
           <a:xfrm>
-            <a:off x="8229600" y="4069080"/>
-            <a:ext cx="3749039" cy="365760"/>
+            <a:off x="8229600" y="3977639"/>
+            <a:ext cx="3749039" cy="320040"/>
           </a:xfrm>
           <a:prstGeom prst="rect">
             <a:avLst/>
@@ -3899,7 +3899,7 @@
           <a:lstStyle/>
           <a:p>
             <a:pPr>
-              <a:defRPr sz="1100" b="1">
+              <a:defRPr sz="1150" b="1">
                 <a:solidFill>
                   <a:srgbClr val="0D5050"/>
                 </a:solidFill>
@@ -3907,14 +3907,14 @@
               </a:defRPr>
             </a:pPr>
             <a:r>
-              <a:t>DEVELOPED SYSTEM ARCHITECTURE</a:t>
+              <a:t>DEVELOPED LIVE SYSTEM INTERFACE</a:t>
             </a:r>
           </a:p>
         </p:txBody>
       </p:sp>
       <p:pic>
         <p:nvPicPr>
-          <p:cNvPr id="14" name="Picture 13" descr="poster_img_4.jpg"/>
+          <p:cNvPr id="14" name="Picture 13" descr="new_user_landing_screenshot.png"/>
           <p:cNvPicPr>
             <a:picLocks noChangeAspect="1"/>
           </p:cNvPicPr>
@@ -3928,8 +3928,8 @@
         </p:blipFill>
         <p:spPr>
           <a:xfrm>
-            <a:off x="8229600" y="4434840"/>
-            <a:ext cx="3749039" cy="2194560"/>
+            <a:off x="8229600" y="4343400"/>
+            <a:ext cx="3749039" cy="2331720"/>
           </a:xfrm>
           <a:prstGeom prst="rect">
             <a:avLst/>

</xml_diff>

<commit_message>
Expand poster topics with detailed clinical explanations, increase Times New Roman font sizes to 15pt/10.5pt, and replace image with user new landing screenshot for PDF and PPTX
</commit_message>
<xml_diff>
--- a/Final_Submission_Pack/3_Project_Poster.pptx
+++ b/Final_Submission_Pack/3_Project_Poster.pptx
@@ -7,7 +7,7 @@
   <p:sldIdLst>
     <p:sldId id="256" r:id="rId7"/>
   </p:sldIdLst>
-  <p:sldSz cx="12188952" cy="6858000" type="screen4x3"/>
+  <p:sldSz cx="15124176" cy="10689336" type="screen4x3"/>
   <p:notesSz cx="6858000" cy="9144000"/>
   <p:defaultTextStyle>
     <a:defPPr>
@@ -3096,8 +3096,8 @@
         </p:nvSpPr>
         <p:spPr>
           <a:xfrm>
-            <a:off x="1280160" y="109728"/>
-            <a:ext cx="9628632" cy="1097280"/>
+            <a:off x="1371600" y="182880"/>
+            <a:ext cx="12380976" cy="1371600"/>
           </a:xfrm>
           <a:prstGeom prst="rect">
             <a:avLst/>
@@ -3111,7 +3111,7 @@
           <a:lstStyle/>
           <a:p>
             <a:pPr algn="ctr">
-              <a:defRPr sz="2100" b="1">
+              <a:defRPr sz="2600" b="1">
                 <a:solidFill>
                   <a:srgbClr val="0F3838"/>
                 </a:solidFill>
@@ -3124,7 +3124,7 @@
           </a:p>
           <a:p>
             <a:pPr algn="ctr">
-              <a:defRPr sz="1150" b="1">
+              <a:defRPr sz="1400" b="1">
                 <a:solidFill>
                   <a:srgbClr val="0D5050"/>
                 </a:solidFill>
@@ -3137,7 +3137,7 @@
           </a:p>
           <a:p>
             <a:pPr algn="ctr">
-              <a:defRPr sz="919" i="1">
+              <a:defRPr sz="1100" i="1">
                 <a:solidFill>
                   <a:srgbClr val="334155"/>
                 </a:solidFill>
@@ -3150,7 +3150,7 @@
           </a:p>
           <a:p>
             <a:pPr algn="ctr">
-              <a:defRPr sz="880" b="1">
+              <a:defRPr sz="1050" b="1">
                 <a:solidFill>
                   <a:srgbClr val="1E293B"/>
                 </a:solidFill>
@@ -3158,7 +3158,7 @@
               </a:defRPr>
             </a:pPr>
             <a:r>
-              <a:t>TEAM: HACKERS TEAM   |   MEMBERS: MADHUMATHI S, BALAJI P, MALINI V   |   GUIDE: DR. S. SIVANESH M.Tech., Ph.D.</a:t>
+              <a:t>TEAM NAME: HACKERS TEAM   |   MEMBERS: MADHUMATHI S, BALAJI P, MALINI V   |   GUIDE: DR. S. SIVANESH M.Tech., Ph.D.</a:t>
             </a:r>
           </a:p>
         </p:txBody>
@@ -3179,8 +3179,8 @@
         </p:blipFill>
         <p:spPr>
           <a:xfrm>
-            <a:off x="274320" y="164592"/>
-            <a:ext cx="960120" cy="960120"/>
+            <a:off x="365760" y="182880"/>
+            <a:ext cx="1188720" cy="1188720"/>
           </a:xfrm>
           <a:prstGeom prst="rect">
             <a:avLst/>
@@ -3203,8 +3203,8 @@
         </p:blipFill>
         <p:spPr>
           <a:xfrm>
-            <a:off x="10972800" y="164592"/>
-            <a:ext cx="960120" cy="960120"/>
+            <a:off x="13533120" y="182880"/>
+            <a:ext cx="1188720" cy="1188720"/>
           </a:xfrm>
           <a:prstGeom prst="rect">
             <a:avLst/>
@@ -3219,8 +3219,8 @@
         </p:nvSpPr>
         <p:spPr>
           <a:xfrm>
-            <a:off x="274320" y="1243584"/>
-            <a:ext cx="11640312" cy="18288"/>
+            <a:off x="365760" y="1600200"/>
+            <a:ext cx="14392656" cy="27432"/>
           </a:xfrm>
           <a:prstGeom prst="rect">
             <a:avLst/>
@@ -3264,8 +3264,8 @@
         </p:nvSpPr>
         <p:spPr>
           <a:xfrm>
-            <a:off x="182880" y="1316736"/>
-            <a:ext cx="3749039" cy="1371600"/>
+            <a:off x="365760" y="1737360"/>
+            <a:ext cx="4572000" cy="2286000"/>
           </a:xfrm>
           <a:prstGeom prst="rect">
             <a:avLst/>
@@ -3279,7 +3279,7 @@
           <a:lstStyle/>
           <a:p>
             <a:pPr algn="l">
-              <a:defRPr sz="1150" b="1">
+              <a:defRPr sz="1500" b="1">
                 <a:solidFill>
                   <a:srgbClr val="0D5050"/>
                 </a:solidFill>
@@ -3293,9 +3293,9 @@
           <a:p>
             <a:pPr algn="l">
               <a:spcAft>
-                <a:spcPts val="250"/>
+                <a:spcPts val="400"/>
               </a:spcAft>
-              <a:defRPr sz="819">
+              <a:defRPr sz="1050">
                 <a:solidFill>
                   <a:srgbClr val="1E293B"/>
                 </a:solidFill>
@@ -3303,7 +3303,7 @@
               </a:defRPr>
             </a:pPr>
             <a:r>
-              <a:t>Mental healthcare accessibility remains a major global challenge due to high therapy costs, psychiatrist shortages, and social stigma. Psychotherapy is restricted to 1 hour per week, leaving patients unmonitored during the remaining 167 hours of weekly vulnerability. Keffi AI is a clinical digital therapeutics platform developed to bridge this gap, providing 24/7 continuous affective monitoring, hands-free voice interaction, and structured psychological interventions.</a:t>
+              <a:t>Mental healthcare accessibility remains a critical global emergency due to exorbitant therapy costs, severe psychiatrist shortages, and persistent social stigma. Standard psychotherapy is restricted to 1 hour per week, leaving patients completely unmonitored during the remaining 167 hours of weekly vulnerability. Keffi AI is a clinically-grounded digital therapeutics platform engineered to bridge this gap, delivering 24/7 continuous affective monitoring, hands-free voice-to-voice therapeutics, and structured cognitive behavioral interventions.</a:t>
             </a:r>
           </a:p>
         </p:txBody>
@@ -3316,8 +3316,8 @@
         </p:nvSpPr>
         <p:spPr>
           <a:xfrm>
-            <a:off x="182880" y="2761488"/>
-            <a:ext cx="3749039" cy="2377440"/>
+            <a:off x="365760" y="4206240"/>
+            <a:ext cx="4572000" cy="5943600"/>
           </a:xfrm>
           <a:prstGeom prst="rect">
             <a:avLst/>
@@ -3331,7 +3331,7 @@
           <a:lstStyle/>
           <a:p>
             <a:pPr algn="l">
-              <a:defRPr sz="1150" b="1">
+              <a:defRPr sz="1500" b="1">
                 <a:solidFill>
                   <a:srgbClr val="0D5050"/>
                 </a:solidFill>
@@ -3345,9 +3345,9 @@
           <a:p>
             <a:pPr algn="l">
               <a:spcAft>
-                <a:spcPts val="250"/>
+                <a:spcPts val="400"/>
               </a:spcAft>
-              <a:defRPr sz="819">
+              <a:defRPr sz="1050">
                 <a:solidFill>
                   <a:srgbClr val="1E293B"/>
                 </a:solidFill>
@@ -3355,15 +3355,15 @@
               </a:defRPr>
             </a:pPr>
             <a:r>
-              <a:t>• BERT 96-Emotion Classifier: Classifies complex user statements into 96 distinct emotional categories with 94.2% accuracy.</a:t>
+              <a:t>• Fine-Tuned BERT 96-Emotion Engine: Classifies complex user statements into 96 distinct clinical emotional categories with 94.2% top-3 accuracy.</a:t>
             </a:r>
           </a:p>
           <a:p>
             <a:pPr algn="l">
               <a:spcAft>
-                <a:spcPts val="250"/>
+                <a:spcPts val="400"/>
               </a:spcAft>
-              <a:defRPr sz="819">
+              <a:defRPr sz="1050">
                 <a:solidFill>
                   <a:srgbClr val="1E293B"/>
                 </a:solidFill>
@@ -3371,15 +3371,15 @@
               </a:defRPr>
             </a:pPr>
             <a:r>
-              <a:t>• 3-Tier Clinical Response: Combines Rogerian empathy, neurobiological psychoeducation, and CBT grounding skills.</a:t>
+              <a:t>• 3-Tier Clinical Response Framework: Constructs responses combining Rogerian validation, neurobiology, and CBT grounding skills.</a:t>
             </a:r>
           </a:p>
           <a:p>
             <a:pPr algn="l">
               <a:spcAft>
-                <a:spcPts val="250"/>
+                <a:spcPts val="400"/>
               </a:spcAft>
-              <a:defRPr sz="819">
+              <a:defRPr sz="1050">
                 <a:solidFill>
                   <a:srgbClr val="1E293B"/>
                 </a:solidFill>
@@ -3387,15 +3387,15 @@
               </a:defRPr>
             </a:pPr>
             <a:r>
-              <a:t>• Hands-Free Voice AI: Real-time Web Speech API audio processing for patients in acute panic unable to type.</a:t>
+              <a:t>• Hands-Free Real-Time Voice AI: Integrated Web Speech API audio processing for patients in acute panic unable to type.</a:t>
             </a:r>
           </a:p>
           <a:p>
             <a:pPr algn="l">
               <a:spcAft>
-                <a:spcPts val="250"/>
+                <a:spcPts val="400"/>
               </a:spcAft>
-              <a:defRPr sz="819">
+              <a:defRPr sz="1050">
                 <a:solidFill>
                   <a:srgbClr val="1E293B"/>
                 </a:solidFill>
@@ -3403,15 +3403,15 @@
               </a:defRPr>
             </a:pPr>
             <a:r>
-              <a:t>• Write-Ahead Logging (WAL) DB: High-concurrency database eliminating locking crashes during peak usage.</a:t>
+              <a:t>• High-Concurrency WAL Database Engine: Write-Ahead Logging database architecture eliminating concurrency lock crashes.</a:t>
             </a:r>
           </a:p>
           <a:p>
             <a:pPr algn="l">
               <a:spcAft>
-                <a:spcPts val="250"/>
+                <a:spcPts val="400"/>
               </a:spcAft>
-              <a:defRPr sz="819">
+              <a:defRPr sz="1050">
                 <a:solidFill>
                   <a:srgbClr val="1E293B"/>
                 </a:solidFill>
@@ -3419,15 +3419,15 @@
               </a:defRPr>
             </a:pPr>
             <a:r>
-              <a:t>• SHAP / LIME Explainable AI: Visual feature attribution maps empowering psychiatrists to audit decisions.</a:t>
+              <a:t>• Explainable AI (SHAP &amp; LIME): Visual feature attribution maps calculating exact token-level weights for psychiatrist auditing.</a:t>
             </a:r>
           </a:p>
           <a:p>
             <a:pPr algn="l">
               <a:spcAft>
-                <a:spcPts val="250"/>
+                <a:spcPts val="400"/>
               </a:spcAft>
-              <a:defRPr sz="819">
+              <a:defRPr sz="1050">
                 <a:solidFill>
                   <a:srgbClr val="1E293B"/>
                 </a:solidFill>
@@ -3435,7 +3435,7 @@
               </a:defRPr>
             </a:pPr>
             <a:r>
-              <a:t>• Admin Clinical Hub: Displays Days Inactive metrics and complete scrollable conversation transcripts.</a:t>
+              <a:t>• Admin Clinical Dashboard &amp; Roster: Displays Days Inactive metrics and complete scrollable conversation transcripts.</a:t>
             </a:r>
           </a:p>
         </p:txBody>
@@ -3448,8 +3448,8 @@
         </p:nvSpPr>
         <p:spPr>
           <a:xfrm>
-            <a:off x="182880" y="5193792"/>
-            <a:ext cx="3749039" cy="1463040"/>
+            <a:off x="5212080" y="1737360"/>
+            <a:ext cx="4754880" cy="2286000"/>
           </a:xfrm>
           <a:prstGeom prst="rect">
             <a:avLst/>
@@ -3463,7 +3463,7 @@
           <a:lstStyle/>
           <a:p>
             <a:pPr algn="l">
-              <a:defRPr sz="1150" b="1">
+              <a:defRPr sz="1500" b="1">
                 <a:solidFill>
                   <a:srgbClr val="0D5050"/>
                 </a:solidFill>
@@ -3477,9 +3477,9 @@
           <a:p>
             <a:pPr algn="l">
               <a:spcAft>
-                <a:spcPts val="250"/>
+                <a:spcPts val="400"/>
               </a:spcAft>
-              <a:defRPr sz="819">
+              <a:defRPr sz="1050">
                 <a:solidFill>
                   <a:srgbClr val="1E293B"/>
                 </a:solidFill>
@@ -3487,7 +3487,7 @@
               </a:defRPr>
             </a:pPr>
             <a:r>
-              <a:t>Keffi AI employs a multi-modal affective computing pipeline. User inputs (text or voice) pass through a dual-model cascade: BERT classifies fine-grained emotion vectors while a Librosa audio prosody analyzer extracts acoustic biomarkers (F0 pitch, RMS energy). Context is maintained via WAL relational DB and vector memory. If crisis signals occur, automated n8n workflows alert emergency contacts immediately.</a:t>
+              <a:t>Keffi AI employs a multi-modal affective computing pipeline. User inputs pass through a dual-model cascade: fine-tuned BERT transformer classifies fine-grained emotion vectors, while an integrated Librosa audio prosody analyzer extracts acoustic biomarkers (F0 pitch, RMS energy, pause duration). Session context is maintained via a WAL-enabled relational DB and vector memory. If crisis signals occur, automated n8n workflows trigger emergency alerts immediately.</a:t>
             </a:r>
           </a:p>
         </p:txBody>
@@ -3500,8 +3500,8 @@
         </p:nvSpPr>
         <p:spPr>
           <a:xfrm>
-            <a:off x="4114800" y="1316736"/>
-            <a:ext cx="3931920" cy="2468880"/>
+            <a:off x="5212080" y="4206240"/>
+            <a:ext cx="4754880" cy="3749039"/>
           </a:xfrm>
           <a:prstGeom prst="rect">
             <a:avLst/>
@@ -3515,7 +3515,7 @@
           <a:lstStyle/>
           <a:p>
             <a:pPr algn="l">
-              <a:defRPr sz="1150" b="1">
+              <a:defRPr sz="1500" b="1">
                 <a:solidFill>
                   <a:srgbClr val="0D5050"/>
                 </a:solidFill>
@@ -3529,9 +3529,9 @@
           <a:p>
             <a:pPr algn="l">
               <a:spcAft>
-                <a:spcPts val="250"/>
+                <a:spcPts val="400"/>
               </a:spcAft>
-              <a:defRPr sz="819">
+              <a:defRPr sz="1050">
                 <a:solidFill>
                   <a:srgbClr val="1E293B"/>
                 </a:solidFill>
@@ -3539,15 +3539,15 @@
               </a:defRPr>
             </a:pPr>
             <a:r>
-              <a:t>Step 1: Multimodal Ingestion: Capture user text or voice audio via Web Speech API endpoints.</a:t>
+              <a:t>Step 1: Multimodal Data Ingestion: Capture user text utterance or real-time voice audio via Web Speech API.</a:t>
             </a:r>
           </a:p>
           <a:p>
             <a:pPr algn="l">
               <a:spcAft>
-                <a:spcPts val="250"/>
+                <a:spcPts val="400"/>
               </a:spcAft>
-              <a:defRPr sz="819">
+              <a:defRPr sz="1050">
                 <a:solidFill>
                   <a:srgbClr val="1E293B"/>
                 </a:solidFill>
@@ -3555,15 +3555,15 @@
               </a:defRPr>
             </a:pPr>
             <a:r>
-              <a:t>Step 2: BERT Emotion Classification: Classify input across 96 fine-grained emotional state vectors.</a:t>
+              <a:t>Step 2: BERT Emotion Classification: Tokenize text input and classify across 96 fine-grained clinical emotional state vectors.</a:t>
             </a:r>
           </a:p>
           <a:p>
             <a:pPr algn="l">
               <a:spcAft>
-                <a:spcPts val="250"/>
+                <a:spcPts val="400"/>
               </a:spcAft>
-              <a:defRPr sz="819">
+              <a:defRPr sz="1050">
                 <a:solidFill>
                   <a:srgbClr val="1E293B"/>
                 </a:solidFill>
@@ -3571,15 +3571,15 @@
               </a:defRPr>
             </a:pPr>
             <a:r>
-              <a:t>Step 3: Isolated Context Retrieval: Query WAL database and vector memory using patient ID.</a:t>
+              <a:t>Step 3: Isolated Context Retrieval: Query WAL relational database and vector memory using patient ID.</a:t>
             </a:r>
           </a:p>
           <a:p>
             <a:pPr algn="l">
               <a:spcAft>
-                <a:spcPts val="250"/>
+                <a:spcPts val="400"/>
               </a:spcAft>
-              <a:defRPr sz="819">
+              <a:defRPr sz="1050">
                 <a:solidFill>
                   <a:srgbClr val="1E293B"/>
                 </a:solidFill>
@@ -3587,15 +3587,15 @@
               </a:defRPr>
             </a:pPr>
             <a:r>
-              <a:t>Step 4: 3-Tier Therapeutic Generation: Synthesize Rogerian care, neurobiology, and CBT skills.</a:t>
+              <a:t>Step 4: 3-Tier Therapeutic Response Synthesis: Synthesize Rogerian validation, neurobiology, and CBT exercises.</a:t>
             </a:r>
           </a:p>
           <a:p>
             <a:pPr algn="l">
               <a:spcAft>
-                <a:spcPts val="250"/>
+                <a:spcPts val="400"/>
               </a:spcAft>
-              <a:defRPr sz="819">
+              <a:defRPr sz="1050">
                 <a:solidFill>
                   <a:srgbClr val="1E293B"/>
                 </a:solidFill>
@@ -3603,15 +3603,15 @@
               </a:defRPr>
             </a:pPr>
             <a:r>
-              <a:t>Step 5: Acoustic Prosody &amp; Risk Triage: Compute pitch deltas; trigger n8n crisis alerts if suicidal ideation is flagged.</a:t>
+              <a:t>Step 5: Acoustic Prosody &amp; Risk Triage: Compute pitch variance deltas; trigger automated n8n crisis alerts.</a:t>
             </a:r>
           </a:p>
           <a:p>
             <a:pPr algn="l">
               <a:spcAft>
-                <a:spcPts val="250"/>
+                <a:spcPts val="400"/>
               </a:spcAft>
-              <a:defRPr sz="819">
+              <a:defRPr sz="1050">
                 <a:solidFill>
                   <a:srgbClr val="1E293B"/>
                 </a:solidFill>
@@ -3619,7 +3619,7 @@
               </a:defRPr>
             </a:pPr>
             <a:r>
-              <a:t>Step 6: Clinician Hub Sync: Update Mental Health Quotient (MHQ) telemetry and log transcripts in Admin Hub.</a:t>
+              <a:t>Step 6: Clinician Dashboard Synchronization: Update Mental Health Quotient (MHQ) telemetry and log transcripts in Admin Hub.</a:t>
             </a:r>
           </a:p>
         </p:txBody>
@@ -3632,8 +3632,8 @@
         </p:nvSpPr>
         <p:spPr>
           <a:xfrm>
-            <a:off x="4114800" y="3858768"/>
-            <a:ext cx="3931920" cy="1554480"/>
+            <a:off x="5212080" y="8046720"/>
+            <a:ext cx="4754880" cy="2286000"/>
           </a:xfrm>
           <a:prstGeom prst="rect">
             <a:avLst/>
@@ -3647,7 +3647,7 @@
           <a:lstStyle/>
           <a:p>
             <a:pPr algn="l">
-              <a:defRPr sz="1150" b="1">
+              <a:defRPr sz="1500" b="1">
                 <a:solidFill>
                   <a:srgbClr val="0D5050"/>
                 </a:solidFill>
@@ -3661,9 +3661,9 @@
           <a:p>
             <a:pPr algn="l">
               <a:spcAft>
-                <a:spcPts val="250"/>
+                <a:spcPts val="400"/>
               </a:spcAft>
-              <a:defRPr sz="819">
+              <a:defRPr sz="1050">
                 <a:solidFill>
                   <a:srgbClr val="1E293B"/>
                 </a:solidFill>
@@ -3671,15 +3671,15 @@
               </a:defRPr>
             </a:pPr>
             <a:r>
-              <a:t>• GoEmotions Multi-Label Dataset: 58,000 curated Reddit comments annotated across 27 emotion categories, extended to 96 clinical psychological states for fine-tuning.</a:t>
+              <a:t>• GoEmotions Multi-Label Dataset: 58,000 curated Reddit comments annotated across 27 baseline emotion categories, extended to 96 clinical psychological states for fine-tuning.</a:t>
             </a:r>
           </a:p>
           <a:p>
             <a:pPr algn="l">
               <a:spcAft>
-                <a:spcPts val="250"/>
+                <a:spcPts val="400"/>
               </a:spcAft>
-              <a:defRPr sz="819">
+              <a:defRPr sz="1050">
                 <a:solidFill>
                   <a:srgbClr val="1E293B"/>
                 </a:solidFill>
@@ -3687,7 +3687,7 @@
               </a:defRPr>
             </a:pPr>
             <a:r>
-              <a:t>• DAIC-WOZ Depression Audio Corpus: Clinical interviews containing acoustic voice prosody benchmarks used to calibrate pitch (F0) and speech pause indicators.</a:t>
+              <a:t>• DAIC-WOZ Depression Audio Corpus: Clinical interviews containing acoustic voice prosody benchmarks used to calibrate pitch (F0) variability.</a:t>
             </a:r>
           </a:p>
         </p:txBody>
@@ -3700,8 +3700,8 @@
         </p:nvSpPr>
         <p:spPr>
           <a:xfrm>
-            <a:off x="4114800" y="5468112"/>
-            <a:ext cx="3931920" cy="1188720"/>
+            <a:off x="10241280" y="1737360"/>
+            <a:ext cx="4480560" cy="3200400"/>
           </a:xfrm>
           <a:prstGeom prst="rect">
             <a:avLst/>
@@ -3715,7 +3715,7 @@
           <a:lstStyle/>
           <a:p>
             <a:pPr algn="l">
-              <a:defRPr sz="1150" b="1">
+              <a:defRPr sz="1500" b="1">
                 <a:solidFill>
                   <a:srgbClr val="0D5050"/>
                 </a:solidFill>
@@ -3723,15 +3723,15 @@
               </a:defRPr>
             </a:pPr>
             <a:r>
-              <a:t>7. CONCLUSION</a:t>
+              <a:t>6. INPUT AND OUTPUT</a:t>
             </a:r>
           </a:p>
           <a:p>
             <a:pPr algn="l">
               <a:spcAft>
-                <a:spcPts val="250"/>
+                <a:spcPts val="400"/>
               </a:spcAft>
-              <a:defRPr sz="819">
+              <a:defRPr sz="1050">
                 <a:solidFill>
                   <a:srgbClr val="1E293B"/>
                 </a:solidFill>
@@ -3739,7 +3739,87 @@
               </a:defRPr>
             </a:pPr>
             <a:r>
-              <a:t>Keffi AI validates the integration of fine-grained emotion classification, high-concurrency database storage, hands-free voice therapeutics, and clinician tracking into a unified digital platform, closing the 167-hour weekly care gap.</a:t>
+              <a:t>User Input: Spoken voice audio or written text statement ('I feel completely overwhelmed by exam deadlines, my heart is racing, and I can't sleep.')</a:t>
+            </a:r>
+          </a:p>
+          <a:p>
+            <a:pPr algn="l">
+              <a:spcAft>
+                <a:spcPts val="400"/>
+              </a:spcAft>
+              <a:defRPr sz="1050">
+                <a:solidFill>
+                  <a:srgbClr val="1E293B"/>
+                </a:solidFill>
+                <a:latin typeface="Times New Roman"/>
+              </a:defRPr>
+            </a:pPr>
+            <a:r>
+              <a:t>System Output:</a:t>
+            </a:r>
+          </a:p>
+          <a:p>
+            <a:pPr algn="l">
+              <a:spcAft>
+                <a:spcPts val="400"/>
+              </a:spcAft>
+              <a:defRPr sz="1050">
+                <a:solidFill>
+                  <a:srgbClr val="1E293B"/>
+                </a:solidFill>
+                <a:latin typeface="Times New Roman"/>
+              </a:defRPr>
+            </a:pPr>
+            <a:r>
+              <a:t>• Tier 1 Validation: 'I hear how much pressure you're under. It's valid to feel overwhelmed.'</a:t>
+            </a:r>
+          </a:p>
+          <a:p>
+            <a:pPr algn="l">
+              <a:spcAft>
+                <a:spcPts val="400"/>
+              </a:spcAft>
+              <a:defRPr sz="1050">
+                <a:solidFill>
+                  <a:srgbClr val="1E293B"/>
+                </a:solidFill>
+                <a:latin typeface="Times New Roman"/>
+              </a:defRPr>
+            </a:pPr>
+            <a:r>
+              <a:t>• Tier 2 Psychoeducation: 'Your brain's amygdala is triggering a surge in cortisol.'</a:t>
+            </a:r>
+          </a:p>
+          <a:p>
+            <a:pPr algn="l">
+              <a:spcAft>
+                <a:spcPts val="400"/>
+              </a:spcAft>
+              <a:defRPr sz="1050">
+                <a:solidFill>
+                  <a:srgbClr val="1E293B"/>
+                </a:solidFill>
+                <a:latin typeface="Times New Roman"/>
+              </a:defRPr>
+            </a:pPr>
+            <a:r>
+              <a:t>• Tier 3 CBT Skill: 'Try 4-7-8 breathing: Breathe in for 4s, hold for 7s, exhale for 8s.'</a:t>
+            </a:r>
+          </a:p>
+          <a:p>
+            <a:pPr algn="l">
+              <a:spcAft>
+                <a:spcPts val="400"/>
+              </a:spcAft>
+              <a:defRPr sz="1050">
+                <a:solidFill>
+                  <a:srgbClr val="1E293B"/>
+                </a:solidFill>
+                <a:latin typeface="Times New Roman"/>
+              </a:defRPr>
+            </a:pPr>
+            <a:r>
+              <a:t>• Voice Readout &amp; Chips: Spoken therapeutic readout and interactive grounding chips.</a:t>
             </a:r>
           </a:p>
         </p:txBody>
@@ -3752,8 +3832,8 @@
         </p:nvSpPr>
         <p:spPr>
           <a:xfrm>
-            <a:off x="8229600" y="1316736"/>
-            <a:ext cx="3749039" cy="2560320"/>
+            <a:off x="10241280" y="5029200"/>
+            <a:ext cx="4480560" cy="1645920"/>
           </a:xfrm>
           <a:prstGeom prst="rect">
             <a:avLst/>
@@ -3767,7 +3847,7 @@
           <a:lstStyle/>
           <a:p>
             <a:pPr algn="l">
-              <a:defRPr sz="1150" b="1">
+              <a:defRPr sz="1500" b="1">
                 <a:solidFill>
                   <a:srgbClr val="0D5050"/>
                 </a:solidFill>
@@ -3775,15 +3855,15 @@
               </a:defRPr>
             </a:pPr>
             <a:r>
-              <a:t>6. INPUT AND OUTPUT</a:t>
+              <a:t>7. CONCLUSION</a:t>
             </a:r>
           </a:p>
           <a:p>
             <a:pPr algn="l">
               <a:spcAft>
-                <a:spcPts val="250"/>
+                <a:spcPts val="400"/>
               </a:spcAft>
-              <a:defRPr sz="819">
+              <a:defRPr sz="1050">
                 <a:solidFill>
                   <a:srgbClr val="1E293B"/>
                 </a:solidFill>
@@ -3791,87 +3871,7 @@
               </a:defRPr>
             </a:pPr>
             <a:r>
-              <a:t>User Input: Spoken audio or text statement ('I feel completely overwhelmed by exam deadlines, my heart is racing, and I can't sleep.')</a:t>
-            </a:r>
-          </a:p>
-          <a:p>
-            <a:pPr algn="l">
-              <a:spcAft>
-                <a:spcPts val="250"/>
-              </a:spcAft>
-              <a:defRPr sz="819">
-                <a:solidFill>
-                  <a:srgbClr val="1E293B"/>
-                </a:solidFill>
-                <a:latin typeface="Times New Roman"/>
-              </a:defRPr>
-            </a:pPr>
-            <a:r>
-              <a:t>System Output:</a:t>
-            </a:r>
-          </a:p>
-          <a:p>
-            <a:pPr algn="l">
-              <a:spcAft>
-                <a:spcPts val="250"/>
-              </a:spcAft>
-              <a:defRPr sz="819">
-                <a:solidFill>
-                  <a:srgbClr val="1E293B"/>
-                </a:solidFill>
-                <a:latin typeface="Times New Roman"/>
-              </a:defRPr>
-            </a:pPr>
-            <a:r>
-              <a:t>• Tier 1 Validation: 'I hear how much pressure you're under. It's valid to feel overwhelmed.'</a:t>
-            </a:r>
-          </a:p>
-          <a:p>
-            <a:pPr algn="l">
-              <a:spcAft>
-                <a:spcPts val="250"/>
-              </a:spcAft>
-              <a:defRPr sz="819">
-                <a:solidFill>
-                  <a:srgbClr val="1E293B"/>
-                </a:solidFill>
-                <a:latin typeface="Times New Roman"/>
-              </a:defRPr>
-            </a:pPr>
-            <a:r>
-              <a:t>• Tier 2 Psychoeducation: 'Your brain's amygdala is triggering a surge in cortisol.'</a:t>
-            </a:r>
-          </a:p>
-          <a:p>
-            <a:pPr algn="l">
-              <a:spcAft>
-                <a:spcPts val="250"/>
-              </a:spcAft>
-              <a:defRPr sz="819">
-                <a:solidFill>
-                  <a:srgbClr val="1E293B"/>
-                </a:solidFill>
-                <a:latin typeface="Times New Roman"/>
-              </a:defRPr>
-            </a:pPr>
-            <a:r>
-              <a:t>• Tier 3 CBT Skill: 'Try 4-7-8 breathing: Breathe in for 4s, hold for 7s, exhale for 8s.'</a:t>
-            </a:r>
-          </a:p>
-          <a:p>
-            <a:pPr algn="l">
-              <a:spcAft>
-                <a:spcPts val="250"/>
-              </a:spcAft>
-              <a:defRPr sz="819">
-                <a:solidFill>
-                  <a:srgbClr val="1E293B"/>
-                </a:solidFill>
-                <a:latin typeface="Times New Roman"/>
-              </a:defRPr>
-            </a:pPr>
-            <a:r>
-              <a:t>• Voice Readout &amp; Chips: Spoken therapeutic readout and interactive grounding chips.</a:t>
+              <a:t>Keffi AI successfully validates the integration of fine-grained emotion classification, high-concurrency database storage, hands-free voice therapeutics, and clinician tracking into a unified digital mental health platform, closing the 167-hour weekly care gap.</a:t>
             </a:r>
           </a:p>
         </p:txBody>
@@ -3884,8 +3884,8 @@
         </p:nvSpPr>
         <p:spPr>
           <a:xfrm>
-            <a:off x="8229600" y="3977639"/>
-            <a:ext cx="3749039" cy="320040"/>
+            <a:off x="10241280" y="6766560"/>
+            <a:ext cx="4480560" cy="365760"/>
           </a:xfrm>
           <a:prstGeom prst="rect">
             <a:avLst/>
@@ -3899,7 +3899,7 @@
           <a:lstStyle/>
           <a:p>
             <a:pPr>
-              <a:defRPr sz="1150" b="1">
+              <a:defRPr sz="1500" b="1">
                 <a:solidFill>
                   <a:srgbClr val="0D5050"/>
                 </a:solidFill>
@@ -3914,7 +3914,7 @@
       </p:sp>
       <p:pic>
         <p:nvPicPr>
-          <p:cNvPr id="14" name="Picture 13" descr="new_user_landing_screenshot.png"/>
+          <p:cNvPr id="14" name="Picture 13" descr="new_user_landing_screenshot_v2.png"/>
           <p:cNvPicPr>
             <a:picLocks noChangeAspect="1"/>
           </p:cNvPicPr>
@@ -3928,8 +3928,8 @@
         </p:blipFill>
         <p:spPr>
           <a:xfrm>
-            <a:off x="8229600" y="4343400"/>
-            <a:ext cx="3749039" cy="2331720"/>
+            <a:off x="10241280" y="7223760"/>
+            <a:ext cx="4480560" cy="3108960"/>
           </a:xfrm>
           <a:prstGeom prst="rect">
             <a:avLst/>

</xml_diff>

<commit_message>
Generate perfect original aligned poster layout in 1 to 7 numerical order with card boxes, Times New Roman font, and new landing screenshot for PDF and PPTX
</commit_message>
<xml_diff>
--- a/Final_Submission_Pack/3_Project_Poster.pptx
+++ b/Final_Submission_Pack/3_Project_Poster.pptx
@@ -7,7 +7,7 @@
   <p:sldIdLst>
     <p:sldId id="256" r:id="rId7"/>
   </p:sldIdLst>
-  <p:sldSz cx="15124176" cy="10689336" type="screen4x3"/>
+  <p:sldSz cx="12188952" cy="6858000" type="screen4x3"/>
   <p:notesSz cx="6858000" cy="9144000"/>
   <p:defaultTextStyle>
     <a:defPPr>
@@ -3090,137 +3090,14 @@
       <p:grpSpPr/>
       <p:sp>
         <p:nvSpPr>
-          <p:cNvPr id="2" name="TextBox 1"/>
-          <p:cNvSpPr txBox="1"/>
+          <p:cNvPr id="2" name="Rectangle 1"/>
+          <p:cNvSpPr/>
           <p:nvPr/>
         </p:nvSpPr>
         <p:spPr>
           <a:xfrm>
-            <a:off x="1371600" y="182880"/>
-            <a:ext cx="12380976" cy="1371600"/>
-          </a:xfrm>
-          <a:prstGeom prst="rect">
-            <a:avLst/>
-          </a:prstGeom>
-          <a:noFill/>
-        </p:spPr>
-        <p:txBody>
-          <a:bodyPr wrap="square">
-            <a:spAutoFit/>
-          </a:bodyPr>
-          <a:lstStyle/>
-          <a:p>
-            <a:pPr algn="ctr">
-              <a:defRPr sz="2600" b="1">
-                <a:solidFill>
-                  <a:srgbClr val="0F3838"/>
-                </a:solidFill>
-                <a:latin typeface="Times New Roman"/>
-              </a:defRPr>
-            </a:pPr>
-            <a:r>
-              <a:t>KEFFI AI – A MENTAL HEALTH CHATBOT</a:t>
-            </a:r>
-          </a:p>
-          <a:p>
-            <a:pPr algn="ctr">
-              <a:defRPr sz="1400" b="1">
-                <a:solidFill>
-                  <a:srgbClr val="0D5050"/>
-                </a:solidFill>
-                <a:latin typeface="Times New Roman"/>
-              </a:defRPr>
-            </a:pPr>
-            <a:r>
-              <a:t>UNIVERSITY COLLEGE OF ENGINEERING PANRUTI</a:t>
-            </a:r>
-          </a:p>
-          <a:p>
-            <a:pPr algn="ctr">
-              <a:defRPr sz="1100" i="1">
-                <a:solidFill>
-                  <a:srgbClr val="334155"/>
-                </a:solidFill>
-                <a:latin typeface="Times New Roman"/>
-              </a:defRPr>
-            </a:pPr>
-            <a:r>
-              <a:t>(A Constituent College of Anna University, Chennai) • Department of Computer Science and Engineering</a:t>
-            </a:r>
-          </a:p>
-          <a:p>
-            <a:pPr algn="ctr">
-              <a:defRPr sz="1050" b="1">
-                <a:solidFill>
-                  <a:srgbClr val="1E293B"/>
-                </a:solidFill>
-                <a:latin typeface="Times New Roman"/>
-              </a:defRPr>
-            </a:pPr>
-            <a:r>
-              <a:t>TEAM NAME: HACKERS TEAM   |   MEMBERS: MADHUMATHI S, BALAJI P, MALINI V   |   GUIDE: DR. S. SIVANESH M.Tech., Ph.D.</a:t>
-            </a:r>
-          </a:p>
-        </p:txBody>
-      </p:sp>
-      <p:pic>
-        <p:nvPicPr>
-          <p:cNvPr id="3" name="Picture 2" descr="poster_img_1.png"/>
-          <p:cNvPicPr>
-            <a:picLocks noChangeAspect="1"/>
-          </p:cNvPicPr>
-          <p:nvPr/>
-        </p:nvPicPr>
-        <p:blipFill>
-          <a:blip r:embed="rId2"/>
-          <a:stretch>
-            <a:fillRect/>
-          </a:stretch>
-        </p:blipFill>
-        <p:spPr>
-          <a:xfrm>
-            <a:off x="365760" y="182880"/>
-            <a:ext cx="1188720" cy="1188720"/>
-          </a:xfrm>
-          <a:prstGeom prst="rect">
-            <a:avLst/>
-          </a:prstGeom>
-        </p:spPr>
-      </p:pic>
-      <p:pic>
-        <p:nvPicPr>
-          <p:cNvPr id="4" name="Picture 3" descr="poster_img_3.jpg"/>
-          <p:cNvPicPr>
-            <a:picLocks noChangeAspect="1"/>
-          </p:cNvPicPr>
-          <p:nvPr/>
-        </p:nvPicPr>
-        <p:blipFill>
-          <a:blip r:embed="rId3"/>
-          <a:stretch>
-            <a:fillRect/>
-          </a:stretch>
-        </p:blipFill>
-        <p:spPr>
-          <a:xfrm>
-            <a:off x="13533120" y="182880"/>
-            <a:ext cx="1188720" cy="1188720"/>
-          </a:xfrm>
-          <a:prstGeom prst="rect">
-            <a:avLst/>
-          </a:prstGeom>
-        </p:spPr>
-      </p:pic>
-      <p:sp>
-        <p:nvSpPr>
-          <p:cNvPr id="5" name="Rectangle 4"/>
-          <p:cNvSpPr/>
-          <p:nvPr/>
-        </p:nvSpPr>
-        <p:spPr>
-          <a:xfrm>
-            <a:off x="365760" y="1600200"/>
-            <a:ext cx="14392656" cy="27432"/>
+            <a:off x="182880" y="182880"/>
+            <a:ext cx="11823192" cy="1051560"/>
           </a:xfrm>
           <a:prstGeom prst="rect">
             <a:avLst/>
@@ -3249,105 +3126,169 @@
           </a:fontRef>
         </p:style>
         <p:txBody>
-          <a:bodyPr rtlCol="0" anchor="ctr"/>
-          <a:lstStyle/>
-          <a:p>
-            <a:pPr algn="ctr"/>
-          </a:p>
-        </p:txBody>
-      </p:sp>
-      <p:sp>
-        <p:nvSpPr>
-          <p:cNvPr id="6" name="TextBox 5"/>
-          <p:cNvSpPr txBox="1"/>
+          <a:bodyPr rtlCol="0" anchor="ctr" wrap="square"/>
+          <a:lstStyle/>
+          <a:p>
+            <a:pPr algn="ctr">
+              <a:defRPr sz="1800" b="1">
+                <a:solidFill>
+                  <a:srgbClr val="FFFFFF"/>
+                </a:solidFill>
+                <a:latin typeface="Times New Roman"/>
+              </a:defRPr>
+            </a:pPr>
+            <a:r>
+              <a:t>KEFFI AI – A MENTAL HEALTH CHATBOT</a:t>
+            </a:r>
+          </a:p>
+          <a:p>
+            <a:pPr algn="ctr">
+              <a:defRPr sz="1050" b="1">
+                <a:solidFill>
+                  <a:srgbClr val="FFFFFF"/>
+                </a:solidFill>
+                <a:latin typeface="Times New Roman"/>
+              </a:defRPr>
+            </a:pPr>
+            <a:r>
+              <a:t>UNIVERSITY COLLEGE OF ENGINEERING PANRUTI</a:t>
+            </a:r>
+          </a:p>
+          <a:p>
+            <a:pPr algn="ctr">
+              <a:defRPr sz="850" i="1">
+                <a:solidFill>
+                  <a:srgbClr val="FFFFFF"/>
+                </a:solidFill>
+                <a:latin typeface="Times New Roman"/>
+              </a:defRPr>
+            </a:pPr>
+            <a:r>
+              <a:t>(A Constituent College of Anna University, Chennai) • Department of Computer Science and Engineering</a:t>
+            </a:r>
+          </a:p>
+          <a:p>
+            <a:pPr algn="ctr">
+              <a:defRPr sz="800" b="1">
+                <a:solidFill>
+                  <a:srgbClr val="FFFFFF"/>
+                </a:solidFill>
+                <a:latin typeface="Times New Roman"/>
+              </a:defRPr>
+            </a:pPr>
+            <a:r>
+              <a:t>TEAM: HACKERS TEAM   |   MEMBERS: MADHUMATHI S, BALAJI P, MALINI V   |   GUIDE: DR. S. SIVANESH M.Tech., Ph.D.</a:t>
+            </a:r>
+          </a:p>
+        </p:txBody>
+      </p:sp>
+      <p:pic>
+        <p:nvPicPr>
+          <p:cNvPr id="3" name="Picture 2" descr="poster_img_1.png"/>
+          <p:cNvPicPr>
+            <a:picLocks noChangeAspect="1"/>
+          </p:cNvPicPr>
           <p:nvPr/>
-        </p:nvSpPr>
+        </p:nvPicPr>
+        <p:blipFill>
+          <a:blip r:embed="rId2"/>
+          <a:stretch>
+            <a:fillRect/>
+          </a:stretch>
+        </p:blipFill>
         <p:spPr>
           <a:xfrm>
-            <a:off x="365760" y="1737360"/>
-            <a:ext cx="4572000" cy="2286000"/>
+            <a:off x="274320" y="228600"/>
+            <a:ext cx="914400" cy="914400"/>
           </a:xfrm>
           <a:prstGeom prst="rect">
             <a:avLst/>
           </a:prstGeom>
-          <a:noFill/>
         </p:spPr>
-        <p:txBody>
-          <a:bodyPr wrap="square">
-            <a:spAutoFit/>
-          </a:bodyPr>
-          <a:lstStyle/>
-          <a:p>
-            <a:pPr algn="l">
-              <a:defRPr sz="1500" b="1">
-                <a:solidFill>
-                  <a:srgbClr val="0D5050"/>
-                </a:solidFill>
-                <a:latin typeface="Times New Roman"/>
-              </a:defRPr>
-            </a:pPr>
-            <a:r>
-              <a:t>1. ABSTRACT</a:t>
-            </a:r>
-          </a:p>
-          <a:p>
-            <a:pPr algn="l">
-              <a:spcAft>
-                <a:spcPts val="400"/>
-              </a:spcAft>
-              <a:defRPr sz="1050">
-                <a:solidFill>
-                  <a:srgbClr val="1E293B"/>
-                </a:solidFill>
-                <a:latin typeface="Times New Roman"/>
-              </a:defRPr>
-            </a:pPr>
-            <a:r>
-              <a:t>Mental healthcare accessibility remains a critical global emergency due to exorbitant therapy costs, severe psychiatrist shortages, and persistent social stigma. Standard psychotherapy is restricted to 1 hour per week, leaving patients completely unmonitored during the remaining 167 hours of weekly vulnerability. Keffi AI is a clinically-grounded digital therapeutics platform engineered to bridge this gap, delivering 24/7 continuous affective monitoring, hands-free voice-to-voice therapeutics, and structured cognitive behavioral interventions.</a:t>
-            </a:r>
-          </a:p>
-        </p:txBody>
-      </p:sp>
-      <p:sp>
-        <p:nvSpPr>
-          <p:cNvPr id="7" name="TextBox 6"/>
-          <p:cNvSpPr txBox="1"/>
+      </p:pic>
+      <p:pic>
+        <p:nvPicPr>
+          <p:cNvPr id="4" name="Picture 3" descr="poster_img_3.jpg"/>
+          <p:cNvPicPr>
+            <a:picLocks noChangeAspect="1"/>
+          </p:cNvPicPr>
           <p:nvPr/>
-        </p:nvSpPr>
+        </p:nvPicPr>
+        <p:blipFill>
+          <a:blip r:embed="rId3"/>
+          <a:stretch>
+            <a:fillRect/>
+          </a:stretch>
+        </p:blipFill>
         <p:spPr>
           <a:xfrm>
-            <a:off x="365760" y="4206240"/>
-            <a:ext cx="4572000" cy="5943600"/>
+            <a:off x="10972800" y="228600"/>
+            <a:ext cx="914400" cy="914400"/>
           </a:xfrm>
           <a:prstGeom prst="rect">
             <a:avLst/>
           </a:prstGeom>
-          <a:noFill/>
         </p:spPr>
-        <p:txBody>
-          <a:bodyPr wrap="square">
-            <a:spAutoFit/>
-          </a:bodyPr>
+      </p:pic>
+      <p:sp>
+        <p:nvSpPr>
+          <p:cNvPr id="5" name="Rounded Rectangle 4"/>
+          <p:cNvSpPr/>
+          <p:nvPr/>
+        </p:nvSpPr>
+        <p:spPr>
+          <a:xfrm>
+            <a:off x="182880" y="1325880"/>
+            <a:ext cx="3749039" cy="1371600"/>
+          </a:xfrm>
+          <a:prstGeom prst="roundRect">
+            <a:avLst/>
+          </a:prstGeom>
+          <a:solidFill>
+            <a:srgbClr val="F0F7F5"/>
+          </a:solidFill>
+          <a:ln w="12700">
+            <a:solidFill>
+              <a:srgbClr val="8FA989"/>
+            </a:solidFill>
+          </a:ln>
+        </p:spPr>
+        <p:style>
+          <a:lnRef idx="1">
+            <a:schemeClr val="accent1"/>
+          </a:lnRef>
+          <a:fillRef idx="3">
+            <a:schemeClr val="accent1"/>
+          </a:fillRef>
+          <a:effectRef idx="2">
+            <a:schemeClr val="accent1"/>
+          </a:effectRef>
+          <a:fontRef idx="minor">
+            <a:schemeClr val="lt1"/>
+          </a:fontRef>
+        </p:style>
+        <p:txBody>
+          <a:bodyPr rtlCol="0" anchor="ctr" wrap="square"/>
           <a:lstStyle/>
           <a:p>
             <a:pPr algn="l">
-              <a:defRPr sz="1500" b="1">
-                <a:solidFill>
-                  <a:srgbClr val="0D5050"/>
+              <a:defRPr sz="950" b="1">
+                <a:solidFill>
+                  <a:srgbClr val="0F3838"/>
                 </a:solidFill>
                 <a:latin typeface="Times New Roman"/>
               </a:defRPr>
             </a:pPr>
             <a:r>
-              <a:t>2. HIGHLIGHTS OF THE PROJECT</a:t>
+              <a:t>1. ABSTRACT</a:t>
             </a:r>
           </a:p>
           <a:p>
             <a:pPr algn="l">
               <a:spcAft>
-                <a:spcPts val="400"/>
+                <a:spcPts val="200"/>
               </a:spcAft>
-              <a:defRPr sz="1050">
+              <a:defRPr sz="740">
                 <a:solidFill>
                   <a:srgbClr val="1E293B"/>
                 </a:solidFill>
@@ -3355,15 +3296,70 @@
               </a:defRPr>
             </a:pPr>
             <a:r>
-              <a:t>• Fine-Tuned BERT 96-Emotion Engine: Classifies complex user statements into 96 distinct clinical emotional categories with 94.2% top-3 accuracy.</a:t>
+              <a:t>Mental healthcare accessibility remains a major global challenge due to high therapy costs, psychiatrist shortages, and social stigma. Psychotherapy is restricted to 1 hour per week, leaving patients unmonitored during the remaining 167 hours of weekly vulnerability. Keffi AI is a clinical digital therapeutics platform developed to bridge this gap, providing 24/7 continuous affective monitoring, hands-free voice interaction, and structured psychological interventions.</a:t>
+            </a:r>
+          </a:p>
+        </p:txBody>
+      </p:sp>
+      <p:sp>
+        <p:nvSpPr>
+          <p:cNvPr id="6" name="Rounded Rectangle 5"/>
+          <p:cNvSpPr/>
+          <p:nvPr/>
+        </p:nvSpPr>
+        <p:spPr>
+          <a:xfrm>
+            <a:off x="182880" y="2761488"/>
+            <a:ext cx="3749039" cy="2377440"/>
+          </a:xfrm>
+          <a:prstGeom prst="roundRect">
+            <a:avLst/>
+          </a:prstGeom>
+          <a:solidFill>
+            <a:srgbClr val="F0F7F5"/>
+          </a:solidFill>
+          <a:ln w="12700">
+            <a:solidFill>
+              <a:srgbClr val="8FA989"/>
+            </a:solidFill>
+          </a:ln>
+        </p:spPr>
+        <p:style>
+          <a:lnRef idx="1">
+            <a:schemeClr val="accent1"/>
+          </a:lnRef>
+          <a:fillRef idx="3">
+            <a:schemeClr val="accent1"/>
+          </a:fillRef>
+          <a:effectRef idx="2">
+            <a:schemeClr val="accent1"/>
+          </a:effectRef>
+          <a:fontRef idx="minor">
+            <a:schemeClr val="lt1"/>
+          </a:fontRef>
+        </p:style>
+        <p:txBody>
+          <a:bodyPr rtlCol="0" anchor="ctr" wrap="square"/>
+          <a:lstStyle/>
+          <a:p>
+            <a:pPr algn="l">
+              <a:defRPr sz="950" b="1">
+                <a:solidFill>
+                  <a:srgbClr val="0F3838"/>
+                </a:solidFill>
+                <a:latin typeface="Times New Roman"/>
+              </a:defRPr>
+            </a:pPr>
+            <a:r>
+              <a:t>2. HIGHLIGHTS OF THE PROJECT</a:t>
             </a:r>
           </a:p>
           <a:p>
             <a:pPr algn="l">
               <a:spcAft>
-                <a:spcPts val="400"/>
+                <a:spcPts val="200"/>
               </a:spcAft>
-              <a:defRPr sz="1050">
+              <a:defRPr sz="740">
                 <a:solidFill>
                   <a:srgbClr val="1E293B"/>
                 </a:solidFill>
@@ -3371,15 +3367,15 @@
               </a:defRPr>
             </a:pPr>
             <a:r>
-              <a:t>• 3-Tier Clinical Response Framework: Constructs responses combining Rogerian validation, neurobiology, and CBT grounding skills.</a:t>
+              <a:t>• BERT 96-Emotion Classifier: Classifies complex user statements into 96 distinct emotional categories with 94.2% accuracy.</a:t>
             </a:r>
           </a:p>
           <a:p>
             <a:pPr algn="l">
               <a:spcAft>
-                <a:spcPts val="400"/>
+                <a:spcPts val="200"/>
               </a:spcAft>
-              <a:defRPr sz="1050">
+              <a:defRPr sz="740">
                 <a:solidFill>
                   <a:srgbClr val="1E293B"/>
                 </a:solidFill>
@@ -3387,15 +3383,15 @@
               </a:defRPr>
             </a:pPr>
             <a:r>
-              <a:t>• Hands-Free Real-Time Voice AI: Integrated Web Speech API audio processing for patients in acute panic unable to type.</a:t>
+              <a:t>• 3-Tier Clinical Response: Combines Rogerian empathy, neurobiological psychoeducation, and CBT grounding skills.</a:t>
             </a:r>
           </a:p>
           <a:p>
             <a:pPr algn="l">
               <a:spcAft>
-                <a:spcPts val="400"/>
+                <a:spcPts val="200"/>
               </a:spcAft>
-              <a:defRPr sz="1050">
+              <a:defRPr sz="740">
                 <a:solidFill>
                   <a:srgbClr val="1E293B"/>
                 </a:solidFill>
@@ -3403,15 +3399,15 @@
               </a:defRPr>
             </a:pPr>
             <a:r>
-              <a:t>• High-Concurrency WAL Database Engine: Write-Ahead Logging database architecture eliminating concurrency lock crashes.</a:t>
+              <a:t>• Hands-Free Voice AI: Real-time Web Speech API audio processing for patients in acute panic unable to type.</a:t>
             </a:r>
           </a:p>
           <a:p>
             <a:pPr algn="l">
               <a:spcAft>
-                <a:spcPts val="400"/>
+                <a:spcPts val="200"/>
               </a:spcAft>
-              <a:defRPr sz="1050">
+              <a:defRPr sz="740">
                 <a:solidFill>
                   <a:srgbClr val="1E293B"/>
                 </a:solidFill>
@@ -3419,15 +3415,15 @@
               </a:defRPr>
             </a:pPr>
             <a:r>
-              <a:t>• Explainable AI (SHAP &amp; LIME): Visual feature attribution maps calculating exact token-level weights for psychiatrist auditing.</a:t>
+              <a:t>• Write-Ahead Logging (WAL) DB: High-concurrency database eliminating locking crashes during peak usage.</a:t>
             </a:r>
           </a:p>
           <a:p>
             <a:pPr algn="l">
               <a:spcAft>
-                <a:spcPts val="400"/>
+                <a:spcPts val="200"/>
               </a:spcAft>
-              <a:defRPr sz="1050">
+              <a:defRPr sz="740">
                 <a:solidFill>
                   <a:srgbClr val="1E293B"/>
                 </a:solidFill>
@@ -3435,37 +3431,72 @@
               </a:defRPr>
             </a:pPr>
             <a:r>
-              <a:t>• Admin Clinical Dashboard &amp; Roster: Displays Days Inactive metrics and complete scrollable conversation transcripts.</a:t>
-            </a:r>
-          </a:p>
-        </p:txBody>
-      </p:sp>
-      <p:sp>
-        <p:nvSpPr>
-          <p:cNvPr id="8" name="TextBox 7"/>
-          <p:cNvSpPr txBox="1"/>
+              <a:t>• SHAP / LIME Explainable AI: Visual feature attribution maps empowering psychiatrists to audit decisions.</a:t>
+            </a:r>
+          </a:p>
+          <a:p>
+            <a:pPr algn="l">
+              <a:spcAft>
+                <a:spcPts val="200"/>
+              </a:spcAft>
+              <a:defRPr sz="740">
+                <a:solidFill>
+                  <a:srgbClr val="1E293B"/>
+                </a:solidFill>
+                <a:latin typeface="Times New Roman"/>
+              </a:defRPr>
+            </a:pPr>
+            <a:r>
+              <a:t>• Admin Clinical Hub: Displays Days Inactive metrics and complete scrollable conversation transcripts.</a:t>
+            </a:r>
+          </a:p>
+        </p:txBody>
+      </p:sp>
+      <p:sp>
+        <p:nvSpPr>
+          <p:cNvPr id="7" name="Rounded Rectangle 6"/>
+          <p:cNvSpPr/>
           <p:nvPr/>
         </p:nvSpPr>
         <p:spPr>
           <a:xfrm>
-            <a:off x="5212080" y="1737360"/>
-            <a:ext cx="4754880" cy="2286000"/>
+            <a:off x="182880" y="5193792"/>
+            <a:ext cx="3749039" cy="1463040"/>
           </a:xfrm>
-          <a:prstGeom prst="rect">
+          <a:prstGeom prst="roundRect">
             <a:avLst/>
           </a:prstGeom>
-          <a:noFill/>
+          <a:solidFill>
+            <a:srgbClr val="F0F7F5"/>
+          </a:solidFill>
+          <a:ln w="12700">
+            <a:solidFill>
+              <a:srgbClr val="8FA989"/>
+            </a:solidFill>
+          </a:ln>
         </p:spPr>
-        <p:txBody>
-          <a:bodyPr wrap="square">
-            <a:spAutoFit/>
-          </a:bodyPr>
+        <p:style>
+          <a:lnRef idx="1">
+            <a:schemeClr val="accent1"/>
+          </a:lnRef>
+          <a:fillRef idx="3">
+            <a:schemeClr val="accent1"/>
+          </a:fillRef>
+          <a:effectRef idx="2">
+            <a:schemeClr val="accent1"/>
+          </a:effectRef>
+          <a:fontRef idx="minor">
+            <a:schemeClr val="lt1"/>
+          </a:fontRef>
+        </p:style>
+        <p:txBody>
+          <a:bodyPr rtlCol="0" anchor="ctr" wrap="square"/>
           <a:lstStyle/>
           <a:p>
             <a:pPr algn="l">
-              <a:defRPr sz="1500" b="1">
-                <a:solidFill>
-                  <a:srgbClr val="0D5050"/>
+              <a:defRPr sz="950" b="1">
+                <a:solidFill>
+                  <a:srgbClr val="0F3838"/>
                 </a:solidFill>
                 <a:latin typeface="Times New Roman"/>
               </a:defRPr>
@@ -3477,9 +3508,9 @@
           <a:p>
             <a:pPr algn="l">
               <a:spcAft>
-                <a:spcPts val="400"/>
+                <a:spcPts val="200"/>
               </a:spcAft>
-              <a:defRPr sz="1050">
+              <a:defRPr sz="740">
                 <a:solidFill>
                   <a:srgbClr val="1E293B"/>
                 </a:solidFill>
@@ -3487,37 +3518,56 @@
               </a:defRPr>
             </a:pPr>
             <a:r>
-              <a:t>Keffi AI employs a multi-modal affective computing pipeline. User inputs pass through a dual-model cascade: fine-tuned BERT transformer classifies fine-grained emotion vectors, while an integrated Librosa audio prosody analyzer extracts acoustic biomarkers (F0 pitch, RMS energy, pause duration). Session context is maintained via a WAL-enabled relational DB and vector memory. If crisis signals occur, automated n8n workflows trigger emergency alerts immediately.</a:t>
-            </a:r>
-          </a:p>
-        </p:txBody>
-      </p:sp>
-      <p:sp>
-        <p:nvSpPr>
-          <p:cNvPr id="9" name="TextBox 8"/>
-          <p:cNvSpPr txBox="1"/>
+              <a:t>Keffi AI employs a multi-modal affective computing pipeline. User inputs (text or voice) pass through a dual-model cascade: BERT classifies fine-grained emotion vectors while a Librosa audio prosody analyzer extracts acoustic biomarkers (F0 pitch, RMS energy). Context is maintained via WAL relational DB and vector memory. If crisis signals occur, automated n8n workflows alert emergency contacts immediately.</a:t>
+            </a:r>
+          </a:p>
+        </p:txBody>
+      </p:sp>
+      <p:sp>
+        <p:nvSpPr>
+          <p:cNvPr id="8" name="Rounded Rectangle 7"/>
+          <p:cNvSpPr/>
           <p:nvPr/>
         </p:nvSpPr>
         <p:spPr>
           <a:xfrm>
-            <a:off x="5212080" y="4206240"/>
-            <a:ext cx="4754880" cy="3749039"/>
+            <a:off x="4114800" y="1325880"/>
+            <a:ext cx="3931920" cy="2468880"/>
           </a:xfrm>
-          <a:prstGeom prst="rect">
+          <a:prstGeom prst="roundRect">
             <a:avLst/>
           </a:prstGeom>
-          <a:noFill/>
+          <a:solidFill>
+            <a:srgbClr val="F0F7F5"/>
+          </a:solidFill>
+          <a:ln w="12700">
+            <a:solidFill>
+              <a:srgbClr val="8FA989"/>
+            </a:solidFill>
+          </a:ln>
         </p:spPr>
-        <p:txBody>
-          <a:bodyPr wrap="square">
-            <a:spAutoFit/>
-          </a:bodyPr>
+        <p:style>
+          <a:lnRef idx="1">
+            <a:schemeClr val="accent1"/>
+          </a:lnRef>
+          <a:fillRef idx="3">
+            <a:schemeClr val="accent1"/>
+          </a:fillRef>
+          <a:effectRef idx="2">
+            <a:schemeClr val="accent1"/>
+          </a:effectRef>
+          <a:fontRef idx="minor">
+            <a:schemeClr val="lt1"/>
+          </a:fontRef>
+        </p:style>
+        <p:txBody>
+          <a:bodyPr rtlCol="0" anchor="ctr" wrap="square"/>
           <a:lstStyle/>
           <a:p>
             <a:pPr algn="l">
-              <a:defRPr sz="1500" b="1">
-                <a:solidFill>
-                  <a:srgbClr val="0D5050"/>
+              <a:defRPr sz="950" b="1">
+                <a:solidFill>
+                  <a:srgbClr val="0F3838"/>
                 </a:solidFill>
                 <a:latin typeface="Times New Roman"/>
               </a:defRPr>
@@ -3529,9 +3579,9 @@
           <a:p>
             <a:pPr algn="l">
               <a:spcAft>
-                <a:spcPts val="400"/>
+                <a:spcPts val="200"/>
               </a:spcAft>
-              <a:defRPr sz="1050">
+              <a:defRPr sz="740">
                 <a:solidFill>
                   <a:srgbClr val="1E293B"/>
                 </a:solidFill>
@@ -3539,15 +3589,15 @@
               </a:defRPr>
             </a:pPr>
             <a:r>
-              <a:t>Step 1: Multimodal Data Ingestion: Capture user text utterance or real-time voice audio via Web Speech API.</a:t>
+              <a:t>Step 1: Multimodal Ingestion: Capture user text or voice audio via Web Speech API endpoints.</a:t>
             </a:r>
           </a:p>
           <a:p>
             <a:pPr algn="l">
               <a:spcAft>
-                <a:spcPts val="400"/>
+                <a:spcPts val="200"/>
               </a:spcAft>
-              <a:defRPr sz="1050">
+              <a:defRPr sz="740">
                 <a:solidFill>
                   <a:srgbClr val="1E293B"/>
                 </a:solidFill>
@@ -3555,15 +3605,15 @@
               </a:defRPr>
             </a:pPr>
             <a:r>
-              <a:t>Step 2: BERT Emotion Classification: Tokenize text input and classify across 96 fine-grained clinical emotional state vectors.</a:t>
+              <a:t>Step 2: BERT Emotion Classification: Classify input across 96 fine-grained emotional state vectors.</a:t>
             </a:r>
           </a:p>
           <a:p>
             <a:pPr algn="l">
               <a:spcAft>
-                <a:spcPts val="400"/>
+                <a:spcPts val="200"/>
               </a:spcAft>
-              <a:defRPr sz="1050">
+              <a:defRPr sz="740">
                 <a:solidFill>
                   <a:srgbClr val="1E293B"/>
                 </a:solidFill>
@@ -3571,15 +3621,15 @@
               </a:defRPr>
             </a:pPr>
             <a:r>
-              <a:t>Step 3: Isolated Context Retrieval: Query WAL relational database and vector memory using patient ID.</a:t>
+              <a:t>Step 3: Isolated Context Retrieval: Query WAL database and vector memory using patient ID.</a:t>
             </a:r>
           </a:p>
           <a:p>
             <a:pPr algn="l">
               <a:spcAft>
-                <a:spcPts val="400"/>
+                <a:spcPts val="200"/>
               </a:spcAft>
-              <a:defRPr sz="1050">
+              <a:defRPr sz="740">
                 <a:solidFill>
                   <a:srgbClr val="1E293B"/>
                 </a:solidFill>
@@ -3587,15 +3637,15 @@
               </a:defRPr>
             </a:pPr>
             <a:r>
-              <a:t>Step 4: 3-Tier Therapeutic Response Synthesis: Synthesize Rogerian validation, neurobiology, and CBT exercises.</a:t>
+              <a:t>Step 4: 3-Tier Therapeutic Generation: Synthesize Rogerian care, neurobiology, and CBT skills.</a:t>
             </a:r>
           </a:p>
           <a:p>
             <a:pPr algn="l">
               <a:spcAft>
-                <a:spcPts val="400"/>
+                <a:spcPts val="200"/>
               </a:spcAft>
-              <a:defRPr sz="1050">
+              <a:defRPr sz="740">
                 <a:solidFill>
                   <a:srgbClr val="1E293B"/>
                 </a:solidFill>
@@ -3603,15 +3653,15 @@
               </a:defRPr>
             </a:pPr>
             <a:r>
-              <a:t>Step 5: Acoustic Prosody &amp; Risk Triage: Compute pitch variance deltas; trigger automated n8n crisis alerts.</a:t>
+              <a:t>Step 5: Acoustic Prosody &amp; Risk Triage: Compute pitch deltas; trigger n8n crisis alerts if suicidal ideation is flagged.</a:t>
             </a:r>
           </a:p>
           <a:p>
             <a:pPr algn="l">
               <a:spcAft>
-                <a:spcPts val="400"/>
+                <a:spcPts val="200"/>
               </a:spcAft>
-              <a:defRPr sz="1050">
+              <a:defRPr sz="740">
                 <a:solidFill>
                   <a:srgbClr val="1E293B"/>
                 </a:solidFill>
@@ -3619,37 +3669,56 @@
               </a:defRPr>
             </a:pPr>
             <a:r>
-              <a:t>Step 6: Clinician Dashboard Synchronization: Update Mental Health Quotient (MHQ) telemetry and log transcripts in Admin Hub.</a:t>
-            </a:r>
-          </a:p>
-        </p:txBody>
-      </p:sp>
-      <p:sp>
-        <p:nvSpPr>
-          <p:cNvPr id="10" name="TextBox 9"/>
-          <p:cNvSpPr txBox="1"/>
+              <a:t>Step 6: Clinician Hub Sync: Update Mental Health Quotient (MHQ) telemetry and log transcripts in Admin Hub.</a:t>
+            </a:r>
+          </a:p>
+        </p:txBody>
+      </p:sp>
+      <p:sp>
+        <p:nvSpPr>
+          <p:cNvPr id="9" name="Rounded Rectangle 8"/>
+          <p:cNvSpPr/>
           <p:nvPr/>
         </p:nvSpPr>
         <p:spPr>
           <a:xfrm>
-            <a:off x="5212080" y="8046720"/>
-            <a:ext cx="4754880" cy="2286000"/>
+            <a:off x="4114800" y="3858768"/>
+            <a:ext cx="3931920" cy="1554480"/>
           </a:xfrm>
-          <a:prstGeom prst="rect">
+          <a:prstGeom prst="roundRect">
             <a:avLst/>
           </a:prstGeom>
-          <a:noFill/>
+          <a:solidFill>
+            <a:srgbClr val="F0F7F5"/>
+          </a:solidFill>
+          <a:ln w="12700">
+            <a:solidFill>
+              <a:srgbClr val="8FA989"/>
+            </a:solidFill>
+          </a:ln>
         </p:spPr>
-        <p:txBody>
-          <a:bodyPr wrap="square">
-            <a:spAutoFit/>
-          </a:bodyPr>
+        <p:style>
+          <a:lnRef idx="1">
+            <a:schemeClr val="accent1"/>
+          </a:lnRef>
+          <a:fillRef idx="3">
+            <a:schemeClr val="accent1"/>
+          </a:fillRef>
+          <a:effectRef idx="2">
+            <a:schemeClr val="accent1"/>
+          </a:effectRef>
+          <a:fontRef idx="minor">
+            <a:schemeClr val="lt1"/>
+          </a:fontRef>
+        </p:style>
+        <p:txBody>
+          <a:bodyPr rtlCol="0" anchor="ctr" wrap="square"/>
           <a:lstStyle/>
           <a:p>
             <a:pPr algn="l">
-              <a:defRPr sz="1500" b="1">
-                <a:solidFill>
-                  <a:srgbClr val="0D5050"/>
+              <a:defRPr sz="950" b="1">
+                <a:solidFill>
+                  <a:srgbClr val="0F3838"/>
                 </a:solidFill>
                 <a:latin typeface="Times New Roman"/>
               </a:defRPr>
@@ -3661,9 +3730,9 @@
           <a:p>
             <a:pPr algn="l">
               <a:spcAft>
-                <a:spcPts val="400"/>
+                <a:spcPts val="200"/>
               </a:spcAft>
-              <a:defRPr sz="1050">
+              <a:defRPr sz="740">
                 <a:solidFill>
                   <a:srgbClr val="1E293B"/>
                 </a:solidFill>
@@ -3671,15 +3740,15 @@
               </a:defRPr>
             </a:pPr>
             <a:r>
-              <a:t>• GoEmotions Multi-Label Dataset: 58,000 curated Reddit comments annotated across 27 baseline emotion categories, extended to 96 clinical psychological states for fine-tuning.</a:t>
+              <a:t>• GoEmotions Multi-Label Dataset: 58,000 curated Reddit comments annotated across 27 emotion categories, extended to 96 clinical psychological states for fine-tuning.</a:t>
             </a:r>
           </a:p>
           <a:p>
             <a:pPr algn="l">
               <a:spcAft>
-                <a:spcPts val="400"/>
+                <a:spcPts val="200"/>
               </a:spcAft>
-              <a:defRPr sz="1050">
+              <a:defRPr sz="740">
                 <a:solidFill>
                   <a:srgbClr val="1E293B"/>
                 </a:solidFill>
@@ -3687,51 +3756,70 @@
               </a:defRPr>
             </a:pPr>
             <a:r>
-              <a:t>• DAIC-WOZ Depression Audio Corpus: Clinical interviews containing acoustic voice prosody benchmarks used to calibrate pitch (F0) variability.</a:t>
-            </a:r>
-          </a:p>
-        </p:txBody>
-      </p:sp>
-      <p:sp>
-        <p:nvSpPr>
-          <p:cNvPr id="11" name="TextBox 10"/>
-          <p:cNvSpPr txBox="1"/>
+              <a:t>• DAIC-WOZ Depression Audio Corpus: Clinical interviews containing acoustic voice prosody benchmarks used to calibrate pitch (F0) and speech pause indicators.</a:t>
+            </a:r>
+          </a:p>
+        </p:txBody>
+      </p:sp>
+      <p:sp>
+        <p:nvSpPr>
+          <p:cNvPr id="10" name="Rounded Rectangle 9"/>
+          <p:cNvSpPr/>
           <p:nvPr/>
         </p:nvSpPr>
         <p:spPr>
           <a:xfrm>
-            <a:off x="10241280" y="1737360"/>
-            <a:ext cx="4480560" cy="3200400"/>
+            <a:off x="4114800" y="5468112"/>
+            <a:ext cx="3931920" cy="1188720"/>
           </a:xfrm>
-          <a:prstGeom prst="rect">
+          <a:prstGeom prst="roundRect">
             <a:avLst/>
           </a:prstGeom>
-          <a:noFill/>
+          <a:solidFill>
+            <a:srgbClr val="F0F7F5"/>
+          </a:solidFill>
+          <a:ln w="12700">
+            <a:solidFill>
+              <a:srgbClr val="8FA989"/>
+            </a:solidFill>
+          </a:ln>
         </p:spPr>
-        <p:txBody>
-          <a:bodyPr wrap="square">
-            <a:spAutoFit/>
-          </a:bodyPr>
+        <p:style>
+          <a:lnRef idx="1">
+            <a:schemeClr val="accent1"/>
+          </a:lnRef>
+          <a:fillRef idx="3">
+            <a:schemeClr val="accent1"/>
+          </a:fillRef>
+          <a:effectRef idx="2">
+            <a:schemeClr val="accent1"/>
+          </a:effectRef>
+          <a:fontRef idx="minor">
+            <a:schemeClr val="lt1"/>
+          </a:fontRef>
+        </p:style>
+        <p:txBody>
+          <a:bodyPr rtlCol="0" anchor="ctr" wrap="square"/>
           <a:lstStyle/>
           <a:p>
             <a:pPr algn="l">
-              <a:defRPr sz="1500" b="1">
-                <a:solidFill>
-                  <a:srgbClr val="0D5050"/>
+              <a:defRPr sz="950" b="1">
+                <a:solidFill>
+                  <a:srgbClr val="0F3838"/>
                 </a:solidFill>
                 <a:latin typeface="Times New Roman"/>
               </a:defRPr>
             </a:pPr>
             <a:r>
-              <a:t>6. INPUT AND OUTPUT</a:t>
+              <a:t>7. CONCLUSION</a:t>
             </a:r>
           </a:p>
           <a:p>
             <a:pPr algn="l">
               <a:spcAft>
-                <a:spcPts val="400"/>
+                <a:spcPts val="200"/>
               </a:spcAft>
-              <a:defRPr sz="1050">
+              <a:defRPr sz="740">
                 <a:solidFill>
                   <a:srgbClr val="1E293B"/>
                 </a:solidFill>
@@ -3739,15 +3827,70 @@
               </a:defRPr>
             </a:pPr>
             <a:r>
-              <a:t>User Input: Spoken voice audio or written text statement ('I feel completely overwhelmed by exam deadlines, my heart is racing, and I can't sleep.')</a:t>
+              <a:t>Keffi AI validates the integration of fine-grained emotion classification, high-concurrency database storage, hands-free voice therapeutics, and clinician tracking into a unified digital platform, closing the 167-hour weekly care gap.</a:t>
+            </a:r>
+          </a:p>
+        </p:txBody>
+      </p:sp>
+      <p:sp>
+        <p:nvSpPr>
+          <p:cNvPr id="11" name="Rounded Rectangle 10"/>
+          <p:cNvSpPr/>
+          <p:nvPr/>
+        </p:nvSpPr>
+        <p:spPr>
+          <a:xfrm>
+            <a:off x="8229600" y="1325880"/>
+            <a:ext cx="3749039" cy="2651760"/>
+          </a:xfrm>
+          <a:prstGeom prst="roundRect">
+            <a:avLst/>
+          </a:prstGeom>
+          <a:solidFill>
+            <a:srgbClr val="F0F7F5"/>
+          </a:solidFill>
+          <a:ln w="12700">
+            <a:solidFill>
+              <a:srgbClr val="8FA989"/>
+            </a:solidFill>
+          </a:ln>
+        </p:spPr>
+        <p:style>
+          <a:lnRef idx="1">
+            <a:schemeClr val="accent1"/>
+          </a:lnRef>
+          <a:fillRef idx="3">
+            <a:schemeClr val="accent1"/>
+          </a:fillRef>
+          <a:effectRef idx="2">
+            <a:schemeClr val="accent1"/>
+          </a:effectRef>
+          <a:fontRef idx="minor">
+            <a:schemeClr val="lt1"/>
+          </a:fontRef>
+        </p:style>
+        <p:txBody>
+          <a:bodyPr rtlCol="0" anchor="ctr" wrap="square"/>
+          <a:lstStyle/>
+          <a:p>
+            <a:pPr algn="l">
+              <a:defRPr sz="950" b="1">
+                <a:solidFill>
+                  <a:srgbClr val="0F3838"/>
+                </a:solidFill>
+                <a:latin typeface="Times New Roman"/>
+              </a:defRPr>
+            </a:pPr>
+            <a:r>
+              <a:t>6. INPUT AND OUTPUT</a:t>
             </a:r>
           </a:p>
           <a:p>
             <a:pPr algn="l">
               <a:spcAft>
-                <a:spcPts val="400"/>
+                <a:spcPts val="200"/>
               </a:spcAft>
-              <a:defRPr sz="1050">
+              <a:defRPr sz="740">
                 <a:solidFill>
                   <a:srgbClr val="1E293B"/>
                 </a:solidFill>
@@ -3755,15 +3898,15 @@
               </a:defRPr>
             </a:pPr>
             <a:r>
-              <a:t>System Output:</a:t>
+              <a:t>User Input: Spoken audio or text statement ('I feel completely overwhelmed by exam deadlines, my heart is racing, and I can't sleep.')</a:t>
             </a:r>
           </a:p>
           <a:p>
             <a:pPr algn="l">
               <a:spcAft>
-                <a:spcPts val="400"/>
+                <a:spcPts val="200"/>
               </a:spcAft>
-              <a:defRPr sz="1050">
+              <a:defRPr sz="740">
                 <a:solidFill>
                   <a:srgbClr val="1E293B"/>
                 </a:solidFill>
@@ -3771,15 +3914,15 @@
               </a:defRPr>
             </a:pPr>
             <a:r>
-              <a:t>• Tier 1 Validation: 'I hear how much pressure you're under. It's valid to feel overwhelmed.'</a:t>
+              <a:t>System Output:</a:t>
             </a:r>
           </a:p>
           <a:p>
             <a:pPr algn="l">
               <a:spcAft>
-                <a:spcPts val="400"/>
+                <a:spcPts val="200"/>
               </a:spcAft>
-              <a:defRPr sz="1050">
+              <a:defRPr sz="740">
                 <a:solidFill>
                   <a:srgbClr val="1E293B"/>
                 </a:solidFill>
@@ -3787,15 +3930,15 @@
               </a:defRPr>
             </a:pPr>
             <a:r>
-              <a:t>• Tier 2 Psychoeducation: 'Your brain's amygdala is triggering a surge in cortisol.'</a:t>
+              <a:t>• Tier 1 Validation: 'I hear how much pressure you're under. It's valid to feel overwhelmed.'</a:t>
             </a:r>
           </a:p>
           <a:p>
             <a:pPr algn="l">
               <a:spcAft>
-                <a:spcPts val="400"/>
+                <a:spcPts val="200"/>
               </a:spcAft>
-              <a:defRPr sz="1050">
+              <a:defRPr sz="740">
                 <a:solidFill>
                   <a:srgbClr val="1E293B"/>
                 </a:solidFill>
@@ -3803,15 +3946,15 @@
               </a:defRPr>
             </a:pPr>
             <a:r>
-              <a:t>• Tier 3 CBT Skill: 'Try 4-7-8 breathing: Breathe in for 4s, hold for 7s, exhale for 8s.'</a:t>
+              <a:t>• Tier 2 Psychoeducation: 'Your brain's amygdala is triggering a surge in cortisol.'</a:t>
             </a:r>
           </a:p>
           <a:p>
             <a:pPr algn="l">
               <a:spcAft>
-                <a:spcPts val="400"/>
+                <a:spcPts val="200"/>
               </a:spcAft>
-              <a:defRPr sz="1050">
+              <a:defRPr sz="740">
                 <a:solidFill>
                   <a:srgbClr val="1E293B"/>
                 </a:solidFill>
@@ -3819,6 +3962,22 @@
               </a:defRPr>
             </a:pPr>
             <a:r>
+              <a:t>• Tier 3 CBT Skill: 'Try 4-7-8 breathing: Breathe in for 4s, hold for 7s, exhale for 8s.'</a:t>
+            </a:r>
+          </a:p>
+          <a:p>
+            <a:pPr algn="l">
+              <a:spcAft>
+                <a:spcPts val="200"/>
+              </a:spcAft>
+              <a:defRPr sz="740">
+                <a:solidFill>
+                  <a:srgbClr val="1E293B"/>
+                </a:solidFill>
+                <a:latin typeface="Times New Roman"/>
+              </a:defRPr>
+            </a:pPr>
+            <a:r>
               <a:t>• Voice Readout &amp; Chips: Spoken therapeutic readout and interactive grounding chips.</a:t>
             </a:r>
           </a:p>
@@ -3826,82 +3985,49 @@
       </p:sp>
       <p:sp>
         <p:nvSpPr>
-          <p:cNvPr id="12" name="TextBox 11"/>
-          <p:cNvSpPr txBox="1"/>
+          <p:cNvPr id="12" name="Rounded Rectangle 11"/>
+          <p:cNvSpPr/>
           <p:nvPr/>
         </p:nvSpPr>
         <p:spPr>
           <a:xfrm>
-            <a:off x="10241280" y="5029200"/>
-            <a:ext cx="4480560" cy="1645920"/>
+            <a:off x="8229600" y="4041648"/>
+            <a:ext cx="3749039" cy="2615184"/>
           </a:xfrm>
-          <a:prstGeom prst="rect">
+          <a:prstGeom prst="roundRect">
             <a:avLst/>
           </a:prstGeom>
-          <a:noFill/>
+          <a:solidFill>
+            <a:srgbClr val="F0F7F5"/>
+          </a:solidFill>
+          <a:ln w="12700">
+            <a:solidFill>
+              <a:srgbClr val="8FA989"/>
+            </a:solidFill>
+          </a:ln>
         </p:spPr>
-        <p:txBody>
-          <a:bodyPr wrap="square">
-            <a:spAutoFit/>
-          </a:bodyPr>
-          <a:lstStyle/>
-          <a:p>
-            <a:pPr algn="l">
-              <a:defRPr sz="1500" b="1">
-                <a:solidFill>
-                  <a:srgbClr val="0D5050"/>
-                </a:solidFill>
-                <a:latin typeface="Times New Roman"/>
-              </a:defRPr>
-            </a:pPr>
-            <a:r>
-              <a:t>7. CONCLUSION</a:t>
-            </a:r>
-          </a:p>
-          <a:p>
-            <a:pPr algn="l">
-              <a:spcAft>
-                <a:spcPts val="400"/>
-              </a:spcAft>
-              <a:defRPr sz="1050">
-                <a:solidFill>
-                  <a:srgbClr val="1E293B"/>
-                </a:solidFill>
-                <a:latin typeface="Times New Roman"/>
-              </a:defRPr>
-            </a:pPr>
-            <a:r>
-              <a:t>Keffi AI successfully validates the integration of fine-grained emotion classification, high-concurrency database storage, hands-free voice therapeutics, and clinician tracking into a unified digital mental health platform, closing the 167-hour weekly care gap.</a:t>
-            </a:r>
-          </a:p>
-        </p:txBody>
-      </p:sp>
-      <p:sp>
-        <p:nvSpPr>
-          <p:cNvPr id="13" name="TextBox 12"/>
-          <p:cNvSpPr txBox="1"/>
-          <p:nvPr/>
-        </p:nvSpPr>
-        <p:spPr>
-          <a:xfrm>
-            <a:off x="10241280" y="6766560"/>
-            <a:ext cx="4480560" cy="365760"/>
-          </a:xfrm>
-          <a:prstGeom prst="rect">
-            <a:avLst/>
-          </a:prstGeom>
-          <a:noFill/>
-        </p:spPr>
-        <p:txBody>
-          <a:bodyPr wrap="none">
-            <a:spAutoFit/>
-          </a:bodyPr>
-          <a:lstStyle/>
-          <a:p>
-            <a:pPr>
-              <a:defRPr sz="1500" b="1">
-                <a:solidFill>
-                  <a:srgbClr val="0D5050"/>
+        <p:style>
+          <a:lnRef idx="1">
+            <a:schemeClr val="accent1"/>
+          </a:lnRef>
+          <a:fillRef idx="3">
+            <a:schemeClr val="accent1"/>
+          </a:fillRef>
+          <a:effectRef idx="2">
+            <a:schemeClr val="accent1"/>
+          </a:effectRef>
+          <a:fontRef idx="minor">
+            <a:schemeClr val="lt1"/>
+          </a:fontRef>
+        </p:style>
+        <p:txBody>
+          <a:bodyPr rtlCol="0" anchor="ctr"/>
+          <a:lstStyle/>
+          <a:p>
+            <a:pPr algn="ctr">
+              <a:defRPr sz="950" b="1">
+                <a:solidFill>
+                  <a:srgbClr val="0F3838"/>
                 </a:solidFill>
                 <a:latin typeface="Times New Roman"/>
               </a:defRPr>
@@ -3914,7 +4040,7 @@
       </p:sp>
       <p:pic>
         <p:nvPicPr>
-          <p:cNvPr id="14" name="Picture 13" descr="new_user_landing_screenshot_v2.png"/>
+          <p:cNvPr id="13" name="Picture 12" descr="new_user_landing_screenshot_v2.png"/>
           <p:cNvPicPr>
             <a:picLocks noChangeAspect="1"/>
           </p:cNvPicPr>
@@ -3928,8 +4054,8 @@
         </p:blipFill>
         <p:spPr>
           <a:xfrm>
-            <a:off x="10241280" y="7223760"/>
-            <a:ext cx="4480560" cy="3108960"/>
+            <a:off x="8321040" y="4389120"/>
+            <a:ext cx="3566160" cy="2103120"/>
           </a:xfrm>
           <a:prstGeom prst="rect">
             <a:avLst/>

</xml_diff>

<commit_message>
Restore clean white background Times New Roman poster design with 1 to 7 numerical order alignment, large fonts, and new landing screenshot for PDF and PPTX
</commit_message>
<xml_diff>
--- a/Final_Submission_Pack/3_Project_Poster.pptx
+++ b/Final_Submission_Pack/3_Project_Poster.pptx
@@ -7,7 +7,7 @@
   <p:sldIdLst>
     <p:sldId id="256" r:id="rId7"/>
   </p:sldIdLst>
-  <p:sldSz cx="12188952" cy="6858000" type="screen4x3"/>
+  <p:sldSz cx="15124176" cy="10689336" type="screen4x3"/>
   <p:notesSz cx="6858000" cy="9144000"/>
   <p:defaultTextStyle>
     <a:defPPr>
@@ -3090,14 +3090,137 @@
       <p:grpSpPr/>
       <p:sp>
         <p:nvSpPr>
-          <p:cNvPr id="2" name="Rectangle 1"/>
+          <p:cNvPr id="2" name="TextBox 1"/>
+          <p:cNvSpPr txBox="1"/>
+          <p:nvPr/>
+        </p:nvSpPr>
+        <p:spPr>
+          <a:xfrm>
+            <a:off x="1371600" y="182880"/>
+            <a:ext cx="12380976" cy="1371600"/>
+          </a:xfrm>
+          <a:prstGeom prst="rect">
+            <a:avLst/>
+          </a:prstGeom>
+          <a:noFill/>
+        </p:spPr>
+        <p:txBody>
+          <a:bodyPr wrap="square">
+            <a:spAutoFit/>
+          </a:bodyPr>
+          <a:lstStyle/>
+          <a:p>
+            <a:pPr algn="ctr">
+              <a:defRPr sz="2600" b="1">
+                <a:solidFill>
+                  <a:srgbClr val="0F3838"/>
+                </a:solidFill>
+                <a:latin typeface="Times New Roman"/>
+              </a:defRPr>
+            </a:pPr>
+            <a:r>
+              <a:t>KEFFI AI – A MENTAL HEALTH CHATBOT</a:t>
+            </a:r>
+          </a:p>
+          <a:p>
+            <a:pPr algn="ctr">
+              <a:defRPr sz="1400" b="1">
+                <a:solidFill>
+                  <a:srgbClr val="0D5050"/>
+                </a:solidFill>
+                <a:latin typeface="Times New Roman"/>
+              </a:defRPr>
+            </a:pPr>
+            <a:r>
+              <a:t>UNIVERSITY COLLEGE OF ENGINEERING PANRUTI</a:t>
+            </a:r>
+          </a:p>
+          <a:p>
+            <a:pPr algn="ctr">
+              <a:defRPr sz="1100" i="1">
+                <a:solidFill>
+                  <a:srgbClr val="334155"/>
+                </a:solidFill>
+                <a:latin typeface="Times New Roman"/>
+              </a:defRPr>
+            </a:pPr>
+            <a:r>
+              <a:t>(A Constituent College of Anna University, Chennai) • Department of Computer Science and Engineering</a:t>
+            </a:r>
+          </a:p>
+          <a:p>
+            <a:pPr algn="ctr">
+              <a:defRPr sz="1050" b="1">
+                <a:solidFill>
+                  <a:srgbClr val="1E293B"/>
+                </a:solidFill>
+                <a:latin typeface="Times New Roman"/>
+              </a:defRPr>
+            </a:pPr>
+            <a:r>
+              <a:t>TEAM NAME: HACKERS TEAM   |   MEMBERS: MADHUMATHI S, BALAJI P, MALINI V   |   GUIDE: DR. S. SIVANESH M.Tech., Ph.D.</a:t>
+            </a:r>
+          </a:p>
+        </p:txBody>
+      </p:sp>
+      <p:pic>
+        <p:nvPicPr>
+          <p:cNvPr id="3" name="Picture 2" descr="poster_img_1.png"/>
+          <p:cNvPicPr>
+            <a:picLocks noChangeAspect="1"/>
+          </p:cNvPicPr>
+          <p:nvPr/>
+        </p:nvPicPr>
+        <p:blipFill>
+          <a:blip r:embed="rId2"/>
+          <a:stretch>
+            <a:fillRect/>
+          </a:stretch>
+        </p:blipFill>
+        <p:spPr>
+          <a:xfrm>
+            <a:off x="365760" y="182880"/>
+            <a:ext cx="1188720" cy="1188720"/>
+          </a:xfrm>
+          <a:prstGeom prst="rect">
+            <a:avLst/>
+          </a:prstGeom>
+        </p:spPr>
+      </p:pic>
+      <p:pic>
+        <p:nvPicPr>
+          <p:cNvPr id="4" name="Picture 3" descr="poster_img_3.jpg"/>
+          <p:cNvPicPr>
+            <a:picLocks noChangeAspect="1"/>
+          </p:cNvPicPr>
+          <p:nvPr/>
+        </p:nvPicPr>
+        <p:blipFill>
+          <a:blip r:embed="rId3"/>
+          <a:stretch>
+            <a:fillRect/>
+          </a:stretch>
+        </p:blipFill>
+        <p:spPr>
+          <a:xfrm>
+            <a:off x="13533120" y="182880"/>
+            <a:ext cx="1188720" cy="1188720"/>
+          </a:xfrm>
+          <a:prstGeom prst="rect">
+            <a:avLst/>
+          </a:prstGeom>
+        </p:spPr>
+      </p:pic>
+      <p:sp>
+        <p:nvSpPr>
+          <p:cNvPr id="5" name="Rectangle 4"/>
           <p:cNvSpPr/>
           <p:nvPr/>
         </p:nvSpPr>
         <p:spPr>
           <a:xfrm>
-            <a:off x="182880" y="182880"/>
-            <a:ext cx="11823192" cy="1051560"/>
+            <a:off x="365760" y="1600200"/>
+            <a:ext cx="14392656" cy="27432"/>
           </a:xfrm>
           <a:prstGeom prst="rect">
             <a:avLst/>
@@ -3126,169 +3249,237 @@
           </a:fontRef>
         </p:style>
         <p:txBody>
-          <a:bodyPr rtlCol="0" anchor="ctr" wrap="square"/>
-          <a:lstStyle/>
-          <a:p>
-            <a:pPr algn="ctr">
-              <a:defRPr sz="1800" b="1">
-                <a:solidFill>
-                  <a:srgbClr val="FFFFFF"/>
-                </a:solidFill>
-                <a:latin typeface="Times New Roman"/>
-              </a:defRPr>
-            </a:pPr>
-            <a:r>
-              <a:t>KEFFI AI – A MENTAL HEALTH CHATBOT</a:t>
-            </a:r>
-          </a:p>
-          <a:p>
-            <a:pPr algn="ctr">
-              <a:defRPr sz="1050" b="1">
-                <a:solidFill>
-                  <a:srgbClr val="FFFFFF"/>
-                </a:solidFill>
-                <a:latin typeface="Times New Roman"/>
-              </a:defRPr>
-            </a:pPr>
-            <a:r>
-              <a:t>UNIVERSITY COLLEGE OF ENGINEERING PANRUTI</a:t>
-            </a:r>
-          </a:p>
-          <a:p>
-            <a:pPr algn="ctr">
-              <a:defRPr sz="850" i="1">
-                <a:solidFill>
-                  <a:srgbClr val="FFFFFF"/>
-                </a:solidFill>
-                <a:latin typeface="Times New Roman"/>
-              </a:defRPr>
-            </a:pPr>
-            <a:r>
-              <a:t>(A Constituent College of Anna University, Chennai) • Department of Computer Science and Engineering</a:t>
-            </a:r>
-          </a:p>
-          <a:p>
-            <a:pPr algn="ctr">
-              <a:defRPr sz="800" b="1">
-                <a:solidFill>
-                  <a:srgbClr val="FFFFFF"/>
-                </a:solidFill>
-                <a:latin typeface="Times New Roman"/>
-              </a:defRPr>
-            </a:pPr>
-            <a:r>
-              <a:t>TEAM: HACKERS TEAM   |   MEMBERS: MADHUMATHI S, BALAJI P, MALINI V   |   GUIDE: DR. S. SIVANESH M.Tech., Ph.D.</a:t>
-            </a:r>
-          </a:p>
-        </p:txBody>
-      </p:sp>
-      <p:pic>
-        <p:nvPicPr>
-          <p:cNvPr id="3" name="Picture 2" descr="poster_img_1.png"/>
-          <p:cNvPicPr>
-            <a:picLocks noChangeAspect="1"/>
-          </p:cNvPicPr>
+          <a:bodyPr rtlCol="0" anchor="ctr"/>
+          <a:lstStyle/>
+          <a:p>
+            <a:pPr algn="ctr"/>
+          </a:p>
+        </p:txBody>
+      </p:sp>
+      <p:sp>
+        <p:nvSpPr>
+          <p:cNvPr id="6" name="TextBox 5"/>
+          <p:cNvSpPr txBox="1"/>
           <p:nvPr/>
-        </p:nvPicPr>
-        <p:blipFill>
-          <a:blip r:embed="rId2"/>
-          <a:stretch>
-            <a:fillRect/>
-          </a:stretch>
-        </p:blipFill>
+        </p:nvSpPr>
         <p:spPr>
           <a:xfrm>
-            <a:off x="274320" y="228600"/>
-            <a:ext cx="914400" cy="914400"/>
+            <a:off x="365760" y="1737360"/>
+            <a:ext cx="4572000" cy="2286000"/>
           </a:xfrm>
           <a:prstGeom prst="rect">
             <a:avLst/>
           </a:prstGeom>
+          <a:noFill/>
         </p:spPr>
-      </p:pic>
-      <p:pic>
-        <p:nvPicPr>
-          <p:cNvPr id="4" name="Picture 3" descr="poster_img_3.jpg"/>
-          <p:cNvPicPr>
-            <a:picLocks noChangeAspect="1"/>
-          </p:cNvPicPr>
+        <p:txBody>
+          <a:bodyPr wrap="square">
+            <a:spAutoFit/>
+          </a:bodyPr>
+          <a:lstStyle/>
+          <a:p>
+            <a:pPr algn="l">
+              <a:defRPr sz="1500" b="1">
+                <a:solidFill>
+                  <a:srgbClr val="0D5050"/>
+                </a:solidFill>
+                <a:latin typeface="Times New Roman"/>
+              </a:defRPr>
+            </a:pPr>
+            <a:r>
+              <a:t>1. ABSTRACT</a:t>
+            </a:r>
+          </a:p>
+          <a:p>
+            <a:pPr algn="l">
+              <a:spcAft>
+                <a:spcPts val="400"/>
+              </a:spcAft>
+              <a:defRPr sz="1050">
+                <a:solidFill>
+                  <a:srgbClr val="1E293B"/>
+                </a:solidFill>
+                <a:latin typeface="Times New Roman"/>
+              </a:defRPr>
+            </a:pPr>
+            <a:r>
+              <a:t>Mental healthcare accessibility remains a critical global emergency due to exorbitant therapy costs, severe psychiatrist shortages, and persistent social stigma. Standard psychotherapy is restricted to 1 hour per week, leaving patients completely unmonitored during the remaining 167 hours of weekly vulnerability. Keffi AI is a clinically-grounded digital therapeutics platform engineered to bridge this gap, delivering 24/7 continuous affective monitoring, hands-free voice-to-voice therapeutics, and structured cognitive behavioral interventions.</a:t>
+            </a:r>
+          </a:p>
+        </p:txBody>
+      </p:sp>
+      <p:sp>
+        <p:nvSpPr>
+          <p:cNvPr id="7" name="TextBox 6"/>
+          <p:cNvSpPr txBox="1"/>
           <p:nvPr/>
-        </p:nvPicPr>
-        <p:blipFill>
-          <a:blip r:embed="rId3"/>
-          <a:stretch>
-            <a:fillRect/>
-          </a:stretch>
-        </p:blipFill>
+        </p:nvSpPr>
         <p:spPr>
           <a:xfrm>
-            <a:off x="10972800" y="228600"/>
-            <a:ext cx="914400" cy="914400"/>
+            <a:off x="365760" y="4206240"/>
+            <a:ext cx="4572000" cy="5943600"/>
           </a:xfrm>
           <a:prstGeom prst="rect">
             <a:avLst/>
           </a:prstGeom>
+          <a:noFill/>
         </p:spPr>
-      </p:pic>
-      <p:sp>
-        <p:nvSpPr>
-          <p:cNvPr id="5" name="Rounded Rectangle 4"/>
-          <p:cNvSpPr/>
+        <p:txBody>
+          <a:bodyPr wrap="square">
+            <a:spAutoFit/>
+          </a:bodyPr>
+          <a:lstStyle/>
+          <a:p>
+            <a:pPr algn="l">
+              <a:defRPr sz="1500" b="1">
+                <a:solidFill>
+                  <a:srgbClr val="0D5050"/>
+                </a:solidFill>
+                <a:latin typeface="Times New Roman"/>
+              </a:defRPr>
+            </a:pPr>
+            <a:r>
+              <a:t>2. HIGHLIGHTS OF THE PROJECT</a:t>
+            </a:r>
+          </a:p>
+          <a:p>
+            <a:pPr algn="l">
+              <a:spcAft>
+                <a:spcPts val="400"/>
+              </a:spcAft>
+              <a:defRPr sz="1050">
+                <a:solidFill>
+                  <a:srgbClr val="1E293B"/>
+                </a:solidFill>
+                <a:latin typeface="Times New Roman"/>
+              </a:defRPr>
+            </a:pPr>
+            <a:r>
+              <a:t>• Fine-Tuned BERT 96-Emotion Engine: Classifies complex user statements into 96 distinct clinical emotional categories with 94.2% top-3 accuracy.</a:t>
+            </a:r>
+          </a:p>
+          <a:p>
+            <a:pPr algn="l">
+              <a:spcAft>
+                <a:spcPts val="400"/>
+              </a:spcAft>
+              <a:defRPr sz="1050">
+                <a:solidFill>
+                  <a:srgbClr val="1E293B"/>
+                </a:solidFill>
+                <a:latin typeface="Times New Roman"/>
+              </a:defRPr>
+            </a:pPr>
+            <a:r>
+              <a:t>• 3-Tier Clinical Response Framework: Constructs responses combining Rogerian validation, neurobiology, and CBT grounding skills.</a:t>
+            </a:r>
+          </a:p>
+          <a:p>
+            <a:pPr algn="l">
+              <a:spcAft>
+                <a:spcPts val="400"/>
+              </a:spcAft>
+              <a:defRPr sz="1050">
+                <a:solidFill>
+                  <a:srgbClr val="1E293B"/>
+                </a:solidFill>
+                <a:latin typeface="Times New Roman"/>
+              </a:defRPr>
+            </a:pPr>
+            <a:r>
+              <a:t>• Hands-Free Real-Time Voice AI: Integrated Web Speech API audio processing for patients in acute panic unable to type.</a:t>
+            </a:r>
+          </a:p>
+          <a:p>
+            <a:pPr algn="l">
+              <a:spcAft>
+                <a:spcPts val="400"/>
+              </a:spcAft>
+              <a:defRPr sz="1050">
+                <a:solidFill>
+                  <a:srgbClr val="1E293B"/>
+                </a:solidFill>
+                <a:latin typeface="Times New Roman"/>
+              </a:defRPr>
+            </a:pPr>
+            <a:r>
+              <a:t>• High-Concurrency WAL Database Engine: Write-Ahead Logging database architecture eliminating concurrency lock crashes.</a:t>
+            </a:r>
+          </a:p>
+          <a:p>
+            <a:pPr algn="l">
+              <a:spcAft>
+                <a:spcPts val="400"/>
+              </a:spcAft>
+              <a:defRPr sz="1050">
+                <a:solidFill>
+                  <a:srgbClr val="1E293B"/>
+                </a:solidFill>
+                <a:latin typeface="Times New Roman"/>
+              </a:defRPr>
+            </a:pPr>
+            <a:r>
+              <a:t>• Explainable AI (SHAP &amp; LIME): Visual feature attribution maps calculating exact token-level weights for psychiatrist auditing.</a:t>
+            </a:r>
+          </a:p>
+          <a:p>
+            <a:pPr algn="l">
+              <a:spcAft>
+                <a:spcPts val="400"/>
+              </a:spcAft>
+              <a:defRPr sz="1050">
+                <a:solidFill>
+                  <a:srgbClr val="1E293B"/>
+                </a:solidFill>
+                <a:latin typeface="Times New Roman"/>
+              </a:defRPr>
+            </a:pPr>
+            <a:r>
+              <a:t>• Admin Clinical Dashboard &amp; Roster: Displays Days Inactive metrics and complete scrollable conversation transcripts.</a:t>
+            </a:r>
+          </a:p>
+        </p:txBody>
+      </p:sp>
+      <p:sp>
+        <p:nvSpPr>
+          <p:cNvPr id="8" name="TextBox 7"/>
+          <p:cNvSpPr txBox="1"/>
           <p:nvPr/>
         </p:nvSpPr>
         <p:spPr>
           <a:xfrm>
-            <a:off x="182880" y="1325880"/>
-            <a:ext cx="3749039" cy="1371600"/>
+            <a:off x="5212080" y="1737360"/>
+            <a:ext cx="4754880" cy="2286000"/>
           </a:xfrm>
-          <a:prstGeom prst="roundRect">
+          <a:prstGeom prst="rect">
             <a:avLst/>
           </a:prstGeom>
-          <a:solidFill>
-            <a:srgbClr val="F0F7F5"/>
-          </a:solidFill>
-          <a:ln w="12700">
-            <a:solidFill>
-              <a:srgbClr val="8FA989"/>
-            </a:solidFill>
-          </a:ln>
+          <a:noFill/>
         </p:spPr>
-        <p:style>
-          <a:lnRef idx="1">
-            <a:schemeClr val="accent1"/>
-          </a:lnRef>
-          <a:fillRef idx="3">
-            <a:schemeClr val="accent1"/>
-          </a:fillRef>
-          <a:effectRef idx="2">
-            <a:schemeClr val="accent1"/>
-          </a:effectRef>
-          <a:fontRef idx="minor">
-            <a:schemeClr val="lt1"/>
-          </a:fontRef>
-        </p:style>
-        <p:txBody>
-          <a:bodyPr rtlCol="0" anchor="ctr" wrap="square"/>
+        <p:txBody>
+          <a:bodyPr wrap="square">
+            <a:spAutoFit/>
+          </a:bodyPr>
           <a:lstStyle/>
           <a:p>
             <a:pPr algn="l">
-              <a:defRPr sz="950" b="1">
-                <a:solidFill>
-                  <a:srgbClr val="0F3838"/>
+              <a:defRPr sz="1500" b="1">
+                <a:solidFill>
+                  <a:srgbClr val="0D5050"/>
                 </a:solidFill>
                 <a:latin typeface="Times New Roman"/>
               </a:defRPr>
             </a:pPr>
             <a:r>
-              <a:t>1. ABSTRACT</a:t>
+              <a:t>3. METHODOLOGY</a:t>
             </a:r>
           </a:p>
           <a:p>
             <a:pPr algn="l">
               <a:spcAft>
-                <a:spcPts val="200"/>
+                <a:spcPts val="400"/>
               </a:spcAft>
-              <a:defRPr sz="740">
+              <a:defRPr sz="1050">
                 <a:solidFill>
                   <a:srgbClr val="1E293B"/>
                 </a:solidFill>
@@ -3296,70 +3487,51 @@
               </a:defRPr>
             </a:pPr>
             <a:r>
-              <a:t>Mental healthcare accessibility remains a major global challenge due to high therapy costs, psychiatrist shortages, and social stigma. Psychotherapy is restricted to 1 hour per week, leaving patients unmonitored during the remaining 167 hours of weekly vulnerability. Keffi AI is a clinical digital therapeutics platform developed to bridge this gap, providing 24/7 continuous affective monitoring, hands-free voice interaction, and structured psychological interventions.</a:t>
-            </a:r>
-          </a:p>
-        </p:txBody>
-      </p:sp>
-      <p:sp>
-        <p:nvSpPr>
-          <p:cNvPr id="6" name="Rounded Rectangle 5"/>
-          <p:cNvSpPr/>
+              <a:t>Keffi AI employs a multi-modal affective computing pipeline. User inputs pass through a dual-model cascade: fine-tuned BERT transformer classifies fine-grained emotion vectors, while an integrated Librosa audio prosody analyzer extracts acoustic biomarkers (F0 pitch, RMS energy, pause duration). Session context is maintained via a WAL-enabled relational DB and vector memory. If crisis signals occur, automated n8n workflows trigger emergency alerts immediately.</a:t>
+            </a:r>
+          </a:p>
+        </p:txBody>
+      </p:sp>
+      <p:sp>
+        <p:nvSpPr>
+          <p:cNvPr id="9" name="TextBox 8"/>
+          <p:cNvSpPr txBox="1"/>
           <p:nvPr/>
         </p:nvSpPr>
         <p:spPr>
           <a:xfrm>
-            <a:off x="182880" y="2761488"/>
-            <a:ext cx="3749039" cy="2377440"/>
+            <a:off x="5212080" y="4206240"/>
+            <a:ext cx="4754880" cy="3749039"/>
           </a:xfrm>
-          <a:prstGeom prst="roundRect">
+          <a:prstGeom prst="rect">
             <a:avLst/>
           </a:prstGeom>
-          <a:solidFill>
-            <a:srgbClr val="F0F7F5"/>
-          </a:solidFill>
-          <a:ln w="12700">
-            <a:solidFill>
-              <a:srgbClr val="8FA989"/>
-            </a:solidFill>
-          </a:ln>
+          <a:noFill/>
         </p:spPr>
-        <p:style>
-          <a:lnRef idx="1">
-            <a:schemeClr val="accent1"/>
-          </a:lnRef>
-          <a:fillRef idx="3">
-            <a:schemeClr val="accent1"/>
-          </a:fillRef>
-          <a:effectRef idx="2">
-            <a:schemeClr val="accent1"/>
-          </a:effectRef>
-          <a:fontRef idx="minor">
-            <a:schemeClr val="lt1"/>
-          </a:fontRef>
-        </p:style>
-        <p:txBody>
-          <a:bodyPr rtlCol="0" anchor="ctr" wrap="square"/>
+        <p:txBody>
+          <a:bodyPr wrap="square">
+            <a:spAutoFit/>
+          </a:bodyPr>
           <a:lstStyle/>
           <a:p>
             <a:pPr algn="l">
-              <a:defRPr sz="950" b="1">
-                <a:solidFill>
-                  <a:srgbClr val="0F3838"/>
+              <a:defRPr sz="1500" b="1">
+                <a:solidFill>
+                  <a:srgbClr val="0D5050"/>
                 </a:solidFill>
                 <a:latin typeface="Times New Roman"/>
               </a:defRPr>
             </a:pPr>
             <a:r>
-              <a:t>2. HIGHLIGHTS OF THE PROJECT</a:t>
+              <a:t>4. STEP BY STEP PROCEDURE OR ALGORITHM</a:t>
             </a:r>
           </a:p>
           <a:p>
             <a:pPr algn="l">
               <a:spcAft>
-                <a:spcPts val="200"/>
+                <a:spcPts val="400"/>
               </a:spcAft>
-              <a:defRPr sz="740">
+              <a:defRPr sz="1050">
                 <a:solidFill>
                   <a:srgbClr val="1E293B"/>
                 </a:solidFill>
@@ -3367,15 +3539,15 @@
               </a:defRPr>
             </a:pPr>
             <a:r>
-              <a:t>• BERT 96-Emotion Classifier: Classifies complex user statements into 96 distinct emotional categories with 94.2% accuracy.</a:t>
+              <a:t>Step 1: Multimodal Data Ingestion: Capture user text utterance or real-time voice audio via Web Speech API.</a:t>
             </a:r>
           </a:p>
           <a:p>
             <a:pPr algn="l">
               <a:spcAft>
-                <a:spcPts val="200"/>
+                <a:spcPts val="400"/>
               </a:spcAft>
-              <a:defRPr sz="740">
+              <a:defRPr sz="1050">
                 <a:solidFill>
                   <a:srgbClr val="1E293B"/>
                 </a:solidFill>
@@ -3383,15 +3555,15 @@
               </a:defRPr>
             </a:pPr>
             <a:r>
-              <a:t>• 3-Tier Clinical Response: Combines Rogerian empathy, neurobiological psychoeducation, and CBT grounding skills.</a:t>
+              <a:t>Step 2: BERT Emotion Classification: Tokenize text input and classify across 96 fine-grained clinical emotional state vectors.</a:t>
             </a:r>
           </a:p>
           <a:p>
             <a:pPr algn="l">
               <a:spcAft>
-                <a:spcPts val="200"/>
+                <a:spcPts val="400"/>
               </a:spcAft>
-              <a:defRPr sz="740">
+              <a:defRPr sz="1050">
                 <a:solidFill>
                   <a:srgbClr val="1E293B"/>
                 </a:solidFill>
@@ -3399,15 +3571,15 @@
               </a:defRPr>
             </a:pPr>
             <a:r>
-              <a:t>• Hands-Free Voice AI: Real-time Web Speech API audio processing for patients in acute panic unable to type.</a:t>
+              <a:t>Step 3: Isolated Context Retrieval: Query WAL relational database and vector memory using patient ID.</a:t>
             </a:r>
           </a:p>
           <a:p>
             <a:pPr algn="l">
               <a:spcAft>
-                <a:spcPts val="200"/>
+                <a:spcPts val="400"/>
               </a:spcAft>
-              <a:defRPr sz="740">
+              <a:defRPr sz="1050">
                 <a:solidFill>
                   <a:srgbClr val="1E293B"/>
                 </a:solidFill>
@@ -3415,15 +3587,15 @@
               </a:defRPr>
             </a:pPr>
             <a:r>
-              <a:t>• Write-Ahead Logging (WAL) DB: High-concurrency database eliminating locking crashes during peak usage.</a:t>
+              <a:t>Step 4: 3-Tier Therapeutic Response Synthesis: Synthesize Rogerian validation, neurobiology, and CBT exercises.</a:t>
             </a:r>
           </a:p>
           <a:p>
             <a:pPr algn="l">
               <a:spcAft>
-                <a:spcPts val="200"/>
+                <a:spcPts val="400"/>
               </a:spcAft>
-              <a:defRPr sz="740">
+              <a:defRPr sz="1050">
                 <a:solidFill>
                   <a:srgbClr val="1E293B"/>
                 </a:solidFill>
@@ -3431,15 +3603,15 @@
               </a:defRPr>
             </a:pPr>
             <a:r>
-              <a:t>• SHAP / LIME Explainable AI: Visual feature attribution maps empowering psychiatrists to audit decisions.</a:t>
+              <a:t>Step 5: Acoustic Prosody &amp; Risk Triage: Compute pitch variance deltas; trigger automated n8n crisis alerts.</a:t>
             </a:r>
           </a:p>
           <a:p>
             <a:pPr algn="l">
               <a:spcAft>
-                <a:spcPts val="200"/>
+                <a:spcPts val="400"/>
               </a:spcAft>
-              <a:defRPr sz="740">
+              <a:defRPr sz="1050">
                 <a:solidFill>
                   <a:srgbClr val="1E293B"/>
                 </a:solidFill>
@@ -3447,70 +3619,51 @@
               </a:defRPr>
             </a:pPr>
             <a:r>
-              <a:t>• Admin Clinical Hub: Displays Days Inactive metrics and complete scrollable conversation transcripts.</a:t>
-            </a:r>
-          </a:p>
-        </p:txBody>
-      </p:sp>
-      <p:sp>
-        <p:nvSpPr>
-          <p:cNvPr id="7" name="Rounded Rectangle 6"/>
-          <p:cNvSpPr/>
+              <a:t>Step 6: Clinician Dashboard Synchronization: Update Mental Health Quotient (MHQ) telemetry and log transcripts in Admin Hub.</a:t>
+            </a:r>
+          </a:p>
+        </p:txBody>
+      </p:sp>
+      <p:sp>
+        <p:nvSpPr>
+          <p:cNvPr id="10" name="TextBox 9"/>
+          <p:cNvSpPr txBox="1"/>
           <p:nvPr/>
         </p:nvSpPr>
         <p:spPr>
           <a:xfrm>
-            <a:off x="182880" y="5193792"/>
-            <a:ext cx="3749039" cy="1463040"/>
+            <a:off x="5212080" y="8046720"/>
+            <a:ext cx="4754880" cy="2286000"/>
           </a:xfrm>
-          <a:prstGeom prst="roundRect">
+          <a:prstGeom prst="rect">
             <a:avLst/>
           </a:prstGeom>
-          <a:solidFill>
-            <a:srgbClr val="F0F7F5"/>
-          </a:solidFill>
-          <a:ln w="12700">
-            <a:solidFill>
-              <a:srgbClr val="8FA989"/>
-            </a:solidFill>
-          </a:ln>
+          <a:noFill/>
         </p:spPr>
-        <p:style>
-          <a:lnRef idx="1">
-            <a:schemeClr val="accent1"/>
-          </a:lnRef>
-          <a:fillRef idx="3">
-            <a:schemeClr val="accent1"/>
-          </a:fillRef>
-          <a:effectRef idx="2">
-            <a:schemeClr val="accent1"/>
-          </a:effectRef>
-          <a:fontRef idx="minor">
-            <a:schemeClr val="lt1"/>
-          </a:fontRef>
-        </p:style>
-        <p:txBody>
-          <a:bodyPr rtlCol="0" anchor="ctr" wrap="square"/>
+        <p:txBody>
+          <a:bodyPr wrap="square">
+            <a:spAutoFit/>
+          </a:bodyPr>
           <a:lstStyle/>
           <a:p>
             <a:pPr algn="l">
-              <a:defRPr sz="950" b="1">
-                <a:solidFill>
-                  <a:srgbClr val="0F3838"/>
+              <a:defRPr sz="1500" b="1">
+                <a:solidFill>
+                  <a:srgbClr val="0D5050"/>
                 </a:solidFill>
                 <a:latin typeface="Times New Roman"/>
               </a:defRPr>
             </a:pPr>
             <a:r>
-              <a:t>3. METHODOLOGY</a:t>
+              <a:t>5. DATASET USED IF ANY</a:t>
             </a:r>
           </a:p>
           <a:p>
             <a:pPr algn="l">
               <a:spcAft>
-                <a:spcPts val="200"/>
+                <a:spcPts val="400"/>
               </a:spcAft>
-              <a:defRPr sz="740">
+              <a:defRPr sz="1050">
                 <a:solidFill>
                   <a:srgbClr val="1E293B"/>
                 </a:solidFill>
@@ -3518,70 +3671,67 @@
               </a:defRPr>
             </a:pPr>
             <a:r>
-              <a:t>Keffi AI employs a multi-modal affective computing pipeline. User inputs (text or voice) pass through a dual-model cascade: BERT classifies fine-grained emotion vectors while a Librosa audio prosody analyzer extracts acoustic biomarkers (F0 pitch, RMS energy). Context is maintained via WAL relational DB and vector memory. If crisis signals occur, automated n8n workflows alert emergency contacts immediately.</a:t>
-            </a:r>
-          </a:p>
-        </p:txBody>
-      </p:sp>
-      <p:sp>
-        <p:nvSpPr>
-          <p:cNvPr id="8" name="Rounded Rectangle 7"/>
-          <p:cNvSpPr/>
+              <a:t>• GoEmotions Multi-Label Dataset: 58,000 curated Reddit comments annotated across 27 baseline emotion categories, extended to 96 clinical psychological states for fine-tuning.</a:t>
+            </a:r>
+          </a:p>
+          <a:p>
+            <a:pPr algn="l">
+              <a:spcAft>
+                <a:spcPts val="400"/>
+              </a:spcAft>
+              <a:defRPr sz="1050">
+                <a:solidFill>
+                  <a:srgbClr val="1E293B"/>
+                </a:solidFill>
+                <a:latin typeface="Times New Roman"/>
+              </a:defRPr>
+            </a:pPr>
+            <a:r>
+              <a:t>• DAIC-WOZ Depression Audio Corpus: Clinical interviews containing acoustic voice prosody benchmarks used to calibrate pitch (F0) variability.</a:t>
+            </a:r>
+          </a:p>
+        </p:txBody>
+      </p:sp>
+      <p:sp>
+        <p:nvSpPr>
+          <p:cNvPr id="11" name="TextBox 10"/>
+          <p:cNvSpPr txBox="1"/>
           <p:nvPr/>
         </p:nvSpPr>
         <p:spPr>
           <a:xfrm>
-            <a:off x="4114800" y="1325880"/>
-            <a:ext cx="3931920" cy="2468880"/>
+            <a:off x="10241280" y="1737360"/>
+            <a:ext cx="4480560" cy="3200400"/>
           </a:xfrm>
-          <a:prstGeom prst="roundRect">
+          <a:prstGeom prst="rect">
             <a:avLst/>
           </a:prstGeom>
-          <a:solidFill>
-            <a:srgbClr val="F0F7F5"/>
-          </a:solidFill>
-          <a:ln w="12700">
-            <a:solidFill>
-              <a:srgbClr val="8FA989"/>
-            </a:solidFill>
-          </a:ln>
+          <a:noFill/>
         </p:spPr>
-        <p:style>
-          <a:lnRef idx="1">
-            <a:schemeClr val="accent1"/>
-          </a:lnRef>
-          <a:fillRef idx="3">
-            <a:schemeClr val="accent1"/>
-          </a:fillRef>
-          <a:effectRef idx="2">
-            <a:schemeClr val="accent1"/>
-          </a:effectRef>
-          <a:fontRef idx="minor">
-            <a:schemeClr val="lt1"/>
-          </a:fontRef>
-        </p:style>
-        <p:txBody>
-          <a:bodyPr rtlCol="0" anchor="ctr" wrap="square"/>
+        <p:txBody>
+          <a:bodyPr wrap="square">
+            <a:spAutoFit/>
+          </a:bodyPr>
           <a:lstStyle/>
           <a:p>
             <a:pPr algn="l">
-              <a:defRPr sz="950" b="1">
-                <a:solidFill>
-                  <a:srgbClr val="0F3838"/>
+              <a:defRPr sz="1500" b="1">
+                <a:solidFill>
+                  <a:srgbClr val="0D5050"/>
                 </a:solidFill>
                 <a:latin typeface="Times New Roman"/>
               </a:defRPr>
             </a:pPr>
             <a:r>
-              <a:t>4. STEP BY STEP PROCEDURE OR ALGORITHM</a:t>
+              <a:t>6. INPUT AND OUTPUT</a:t>
             </a:r>
           </a:p>
           <a:p>
             <a:pPr algn="l">
               <a:spcAft>
-                <a:spcPts val="200"/>
+                <a:spcPts val="400"/>
               </a:spcAft>
-              <a:defRPr sz="740">
+              <a:defRPr sz="1050">
                 <a:solidFill>
                   <a:srgbClr val="1E293B"/>
                 </a:solidFill>
@@ -3589,15 +3739,15 @@
               </a:defRPr>
             </a:pPr>
             <a:r>
-              <a:t>Step 1: Multimodal Ingestion: Capture user text or voice audio via Web Speech API endpoints.</a:t>
+              <a:t>User Input: Spoken voice audio or written text statement ('I feel completely overwhelmed by exam deadlines, my heart is racing, and I can't sleep.')</a:t>
             </a:r>
           </a:p>
           <a:p>
             <a:pPr algn="l">
               <a:spcAft>
-                <a:spcPts val="200"/>
+                <a:spcPts val="400"/>
               </a:spcAft>
-              <a:defRPr sz="740">
+              <a:defRPr sz="1050">
                 <a:solidFill>
                   <a:srgbClr val="1E293B"/>
                 </a:solidFill>
@@ -3605,15 +3755,15 @@
               </a:defRPr>
             </a:pPr>
             <a:r>
-              <a:t>Step 2: BERT Emotion Classification: Classify input across 96 fine-grained emotional state vectors.</a:t>
+              <a:t>System Output:</a:t>
             </a:r>
           </a:p>
           <a:p>
             <a:pPr algn="l">
               <a:spcAft>
-                <a:spcPts val="200"/>
+                <a:spcPts val="400"/>
               </a:spcAft>
-              <a:defRPr sz="740">
+              <a:defRPr sz="1050">
                 <a:solidFill>
                   <a:srgbClr val="1E293B"/>
                 </a:solidFill>
@@ -3621,15 +3771,15 @@
               </a:defRPr>
             </a:pPr>
             <a:r>
-              <a:t>Step 3: Isolated Context Retrieval: Query WAL database and vector memory using patient ID.</a:t>
+              <a:t>• Tier 1 Validation: 'I hear how much pressure you're under. It's valid to feel overwhelmed.'</a:t>
             </a:r>
           </a:p>
           <a:p>
             <a:pPr algn="l">
               <a:spcAft>
-                <a:spcPts val="200"/>
+                <a:spcPts val="400"/>
               </a:spcAft>
-              <a:defRPr sz="740">
+              <a:defRPr sz="1050">
                 <a:solidFill>
                   <a:srgbClr val="1E293B"/>
                 </a:solidFill>
@@ -3637,15 +3787,15 @@
               </a:defRPr>
             </a:pPr>
             <a:r>
-              <a:t>Step 4: 3-Tier Therapeutic Generation: Synthesize Rogerian care, neurobiology, and CBT skills.</a:t>
+              <a:t>• Tier 2 Psychoeducation: 'Your brain's amygdala is triggering a surge in cortisol.'</a:t>
             </a:r>
           </a:p>
           <a:p>
             <a:pPr algn="l">
               <a:spcAft>
-                <a:spcPts val="200"/>
+                <a:spcPts val="400"/>
               </a:spcAft>
-              <a:defRPr sz="740">
+              <a:defRPr sz="1050">
                 <a:solidFill>
                   <a:srgbClr val="1E293B"/>
                 </a:solidFill>
@@ -3653,15 +3803,15 @@
               </a:defRPr>
             </a:pPr>
             <a:r>
-              <a:t>Step 5: Acoustic Prosody &amp; Risk Triage: Compute pitch deltas; trigger n8n crisis alerts if suicidal ideation is flagged.</a:t>
+              <a:t>• Tier 3 CBT Skill: 'Try 4-7-8 breathing: Breathe in for 4s, hold for 7s, exhale for 8s.'</a:t>
             </a:r>
           </a:p>
           <a:p>
             <a:pPr algn="l">
               <a:spcAft>
-                <a:spcPts val="200"/>
+                <a:spcPts val="400"/>
               </a:spcAft>
-              <a:defRPr sz="740">
+              <a:defRPr sz="1050">
                 <a:solidFill>
                   <a:srgbClr val="1E293B"/>
                 </a:solidFill>
@@ -3669,70 +3819,51 @@
               </a:defRPr>
             </a:pPr>
             <a:r>
-              <a:t>Step 6: Clinician Hub Sync: Update Mental Health Quotient (MHQ) telemetry and log transcripts in Admin Hub.</a:t>
-            </a:r>
-          </a:p>
-        </p:txBody>
-      </p:sp>
-      <p:sp>
-        <p:nvSpPr>
-          <p:cNvPr id="9" name="Rounded Rectangle 8"/>
-          <p:cNvSpPr/>
+              <a:t>• Voice Readout &amp; Chips: Spoken therapeutic readout and interactive grounding chips.</a:t>
+            </a:r>
+          </a:p>
+        </p:txBody>
+      </p:sp>
+      <p:sp>
+        <p:nvSpPr>
+          <p:cNvPr id="12" name="TextBox 11"/>
+          <p:cNvSpPr txBox="1"/>
           <p:nvPr/>
         </p:nvSpPr>
         <p:spPr>
           <a:xfrm>
-            <a:off x="4114800" y="3858768"/>
-            <a:ext cx="3931920" cy="1554480"/>
+            <a:off x="10241280" y="5029200"/>
+            <a:ext cx="4480560" cy="1645920"/>
           </a:xfrm>
-          <a:prstGeom prst="roundRect">
+          <a:prstGeom prst="rect">
             <a:avLst/>
           </a:prstGeom>
-          <a:solidFill>
-            <a:srgbClr val="F0F7F5"/>
-          </a:solidFill>
-          <a:ln w="12700">
-            <a:solidFill>
-              <a:srgbClr val="8FA989"/>
-            </a:solidFill>
-          </a:ln>
+          <a:noFill/>
         </p:spPr>
-        <p:style>
-          <a:lnRef idx="1">
-            <a:schemeClr val="accent1"/>
-          </a:lnRef>
-          <a:fillRef idx="3">
-            <a:schemeClr val="accent1"/>
-          </a:fillRef>
-          <a:effectRef idx="2">
-            <a:schemeClr val="accent1"/>
-          </a:effectRef>
-          <a:fontRef idx="minor">
-            <a:schemeClr val="lt1"/>
-          </a:fontRef>
-        </p:style>
-        <p:txBody>
-          <a:bodyPr rtlCol="0" anchor="ctr" wrap="square"/>
+        <p:txBody>
+          <a:bodyPr wrap="square">
+            <a:spAutoFit/>
+          </a:bodyPr>
           <a:lstStyle/>
           <a:p>
             <a:pPr algn="l">
-              <a:defRPr sz="950" b="1">
-                <a:solidFill>
-                  <a:srgbClr val="0F3838"/>
+              <a:defRPr sz="1500" b="1">
+                <a:solidFill>
+                  <a:srgbClr val="0D5050"/>
                 </a:solidFill>
                 <a:latin typeface="Times New Roman"/>
               </a:defRPr>
             </a:pPr>
             <a:r>
-              <a:t>5. DATASET USED IF ANY</a:t>
+              <a:t>7. CONCLUSION</a:t>
             </a:r>
           </a:p>
           <a:p>
             <a:pPr algn="l">
               <a:spcAft>
-                <a:spcPts val="200"/>
+                <a:spcPts val="400"/>
               </a:spcAft>
-              <a:defRPr sz="740">
+              <a:defRPr sz="1050">
                 <a:solidFill>
                   <a:srgbClr val="1E293B"/>
                 </a:solidFill>
@@ -3740,294 +3871,37 @@
               </a:defRPr>
             </a:pPr>
             <a:r>
-              <a:t>• GoEmotions Multi-Label Dataset: 58,000 curated Reddit comments annotated across 27 emotion categories, extended to 96 clinical psychological states for fine-tuning.</a:t>
-            </a:r>
-          </a:p>
-          <a:p>
-            <a:pPr algn="l">
-              <a:spcAft>
-                <a:spcPts val="200"/>
-              </a:spcAft>
-              <a:defRPr sz="740">
-                <a:solidFill>
-                  <a:srgbClr val="1E293B"/>
-                </a:solidFill>
-                <a:latin typeface="Times New Roman"/>
-              </a:defRPr>
-            </a:pPr>
-            <a:r>
-              <a:t>• DAIC-WOZ Depression Audio Corpus: Clinical interviews containing acoustic voice prosody benchmarks used to calibrate pitch (F0) and speech pause indicators.</a:t>
-            </a:r>
-          </a:p>
-        </p:txBody>
-      </p:sp>
-      <p:sp>
-        <p:nvSpPr>
-          <p:cNvPr id="10" name="Rounded Rectangle 9"/>
-          <p:cNvSpPr/>
+              <a:t>Keffi AI successfully validates the integration of fine-grained emotion classification, high-concurrency database storage, hands-free voice therapeutics, and clinician tracking into a unified digital mental health platform, closing the 167-hour weekly care gap.</a:t>
+            </a:r>
+          </a:p>
+        </p:txBody>
+      </p:sp>
+      <p:sp>
+        <p:nvSpPr>
+          <p:cNvPr id="13" name="TextBox 12"/>
+          <p:cNvSpPr txBox="1"/>
           <p:nvPr/>
         </p:nvSpPr>
         <p:spPr>
           <a:xfrm>
-            <a:off x="4114800" y="5468112"/>
-            <a:ext cx="3931920" cy="1188720"/>
+            <a:off x="10241280" y="6766560"/>
+            <a:ext cx="4480560" cy="365760"/>
           </a:xfrm>
-          <a:prstGeom prst="roundRect">
+          <a:prstGeom prst="rect">
             <a:avLst/>
           </a:prstGeom>
-          <a:solidFill>
-            <a:srgbClr val="F0F7F5"/>
-          </a:solidFill>
-          <a:ln w="12700">
-            <a:solidFill>
-              <a:srgbClr val="8FA989"/>
-            </a:solidFill>
-          </a:ln>
+          <a:noFill/>
         </p:spPr>
-        <p:style>
-          <a:lnRef idx="1">
-            <a:schemeClr val="accent1"/>
-          </a:lnRef>
-          <a:fillRef idx="3">
-            <a:schemeClr val="accent1"/>
-          </a:fillRef>
-          <a:effectRef idx="2">
-            <a:schemeClr val="accent1"/>
-          </a:effectRef>
-          <a:fontRef idx="minor">
-            <a:schemeClr val="lt1"/>
-          </a:fontRef>
-        </p:style>
-        <p:txBody>
-          <a:bodyPr rtlCol="0" anchor="ctr" wrap="square"/>
-          <a:lstStyle/>
-          <a:p>
-            <a:pPr algn="l">
-              <a:defRPr sz="950" b="1">
-                <a:solidFill>
-                  <a:srgbClr val="0F3838"/>
-                </a:solidFill>
-                <a:latin typeface="Times New Roman"/>
-              </a:defRPr>
-            </a:pPr>
-            <a:r>
-              <a:t>7. CONCLUSION</a:t>
-            </a:r>
-          </a:p>
-          <a:p>
-            <a:pPr algn="l">
-              <a:spcAft>
-                <a:spcPts val="200"/>
-              </a:spcAft>
-              <a:defRPr sz="740">
-                <a:solidFill>
-                  <a:srgbClr val="1E293B"/>
-                </a:solidFill>
-                <a:latin typeface="Times New Roman"/>
-              </a:defRPr>
-            </a:pPr>
-            <a:r>
-              <a:t>Keffi AI validates the integration of fine-grained emotion classification, high-concurrency database storage, hands-free voice therapeutics, and clinician tracking into a unified digital platform, closing the 167-hour weekly care gap.</a:t>
-            </a:r>
-          </a:p>
-        </p:txBody>
-      </p:sp>
-      <p:sp>
-        <p:nvSpPr>
-          <p:cNvPr id="11" name="Rounded Rectangle 10"/>
-          <p:cNvSpPr/>
-          <p:nvPr/>
-        </p:nvSpPr>
-        <p:spPr>
-          <a:xfrm>
-            <a:off x="8229600" y="1325880"/>
-            <a:ext cx="3749039" cy="2651760"/>
-          </a:xfrm>
-          <a:prstGeom prst="roundRect">
-            <a:avLst/>
-          </a:prstGeom>
-          <a:solidFill>
-            <a:srgbClr val="F0F7F5"/>
-          </a:solidFill>
-          <a:ln w="12700">
-            <a:solidFill>
-              <a:srgbClr val="8FA989"/>
-            </a:solidFill>
-          </a:ln>
-        </p:spPr>
-        <p:style>
-          <a:lnRef idx="1">
-            <a:schemeClr val="accent1"/>
-          </a:lnRef>
-          <a:fillRef idx="3">
-            <a:schemeClr val="accent1"/>
-          </a:fillRef>
-          <a:effectRef idx="2">
-            <a:schemeClr val="accent1"/>
-          </a:effectRef>
-          <a:fontRef idx="minor">
-            <a:schemeClr val="lt1"/>
-          </a:fontRef>
-        </p:style>
-        <p:txBody>
-          <a:bodyPr rtlCol="0" anchor="ctr" wrap="square"/>
-          <a:lstStyle/>
-          <a:p>
-            <a:pPr algn="l">
-              <a:defRPr sz="950" b="1">
-                <a:solidFill>
-                  <a:srgbClr val="0F3838"/>
-                </a:solidFill>
-                <a:latin typeface="Times New Roman"/>
-              </a:defRPr>
-            </a:pPr>
-            <a:r>
-              <a:t>6. INPUT AND OUTPUT</a:t>
-            </a:r>
-          </a:p>
-          <a:p>
-            <a:pPr algn="l">
-              <a:spcAft>
-                <a:spcPts val="200"/>
-              </a:spcAft>
-              <a:defRPr sz="740">
-                <a:solidFill>
-                  <a:srgbClr val="1E293B"/>
-                </a:solidFill>
-                <a:latin typeface="Times New Roman"/>
-              </a:defRPr>
-            </a:pPr>
-            <a:r>
-              <a:t>User Input: Spoken audio or text statement ('I feel completely overwhelmed by exam deadlines, my heart is racing, and I can't sleep.')</a:t>
-            </a:r>
-          </a:p>
-          <a:p>
-            <a:pPr algn="l">
-              <a:spcAft>
-                <a:spcPts val="200"/>
-              </a:spcAft>
-              <a:defRPr sz="740">
-                <a:solidFill>
-                  <a:srgbClr val="1E293B"/>
-                </a:solidFill>
-                <a:latin typeface="Times New Roman"/>
-              </a:defRPr>
-            </a:pPr>
-            <a:r>
-              <a:t>System Output:</a:t>
-            </a:r>
-          </a:p>
-          <a:p>
-            <a:pPr algn="l">
-              <a:spcAft>
-                <a:spcPts val="200"/>
-              </a:spcAft>
-              <a:defRPr sz="740">
-                <a:solidFill>
-                  <a:srgbClr val="1E293B"/>
-                </a:solidFill>
-                <a:latin typeface="Times New Roman"/>
-              </a:defRPr>
-            </a:pPr>
-            <a:r>
-              <a:t>• Tier 1 Validation: 'I hear how much pressure you're under. It's valid to feel overwhelmed.'</a:t>
-            </a:r>
-          </a:p>
-          <a:p>
-            <a:pPr algn="l">
-              <a:spcAft>
-                <a:spcPts val="200"/>
-              </a:spcAft>
-              <a:defRPr sz="740">
-                <a:solidFill>
-                  <a:srgbClr val="1E293B"/>
-                </a:solidFill>
-                <a:latin typeface="Times New Roman"/>
-              </a:defRPr>
-            </a:pPr>
-            <a:r>
-              <a:t>• Tier 2 Psychoeducation: 'Your brain's amygdala is triggering a surge in cortisol.'</a:t>
-            </a:r>
-          </a:p>
-          <a:p>
-            <a:pPr algn="l">
-              <a:spcAft>
-                <a:spcPts val="200"/>
-              </a:spcAft>
-              <a:defRPr sz="740">
-                <a:solidFill>
-                  <a:srgbClr val="1E293B"/>
-                </a:solidFill>
-                <a:latin typeface="Times New Roman"/>
-              </a:defRPr>
-            </a:pPr>
-            <a:r>
-              <a:t>• Tier 3 CBT Skill: 'Try 4-7-8 breathing: Breathe in for 4s, hold for 7s, exhale for 8s.'</a:t>
-            </a:r>
-          </a:p>
-          <a:p>
-            <a:pPr algn="l">
-              <a:spcAft>
-                <a:spcPts val="200"/>
-              </a:spcAft>
-              <a:defRPr sz="740">
-                <a:solidFill>
-                  <a:srgbClr val="1E293B"/>
-                </a:solidFill>
-                <a:latin typeface="Times New Roman"/>
-              </a:defRPr>
-            </a:pPr>
-            <a:r>
-              <a:t>• Voice Readout &amp; Chips: Spoken therapeutic readout and interactive grounding chips.</a:t>
-            </a:r>
-          </a:p>
-        </p:txBody>
-      </p:sp>
-      <p:sp>
-        <p:nvSpPr>
-          <p:cNvPr id="12" name="Rounded Rectangle 11"/>
-          <p:cNvSpPr/>
-          <p:nvPr/>
-        </p:nvSpPr>
-        <p:spPr>
-          <a:xfrm>
-            <a:off x="8229600" y="4041648"/>
-            <a:ext cx="3749039" cy="2615184"/>
-          </a:xfrm>
-          <a:prstGeom prst="roundRect">
-            <a:avLst/>
-          </a:prstGeom>
-          <a:solidFill>
-            <a:srgbClr val="F0F7F5"/>
-          </a:solidFill>
-          <a:ln w="12700">
-            <a:solidFill>
-              <a:srgbClr val="8FA989"/>
-            </a:solidFill>
-          </a:ln>
-        </p:spPr>
-        <p:style>
-          <a:lnRef idx="1">
-            <a:schemeClr val="accent1"/>
-          </a:lnRef>
-          <a:fillRef idx="3">
-            <a:schemeClr val="accent1"/>
-          </a:fillRef>
-          <a:effectRef idx="2">
-            <a:schemeClr val="accent1"/>
-          </a:effectRef>
-          <a:fontRef idx="minor">
-            <a:schemeClr val="lt1"/>
-          </a:fontRef>
-        </p:style>
-        <p:txBody>
-          <a:bodyPr rtlCol="0" anchor="ctr"/>
-          <a:lstStyle/>
-          <a:p>
-            <a:pPr algn="ctr">
-              <a:defRPr sz="950" b="1">
-                <a:solidFill>
-                  <a:srgbClr val="0F3838"/>
+        <p:txBody>
+          <a:bodyPr wrap="none">
+            <a:spAutoFit/>
+          </a:bodyPr>
+          <a:lstStyle/>
+          <a:p>
+            <a:pPr>
+              <a:defRPr sz="1500" b="1">
+                <a:solidFill>
+                  <a:srgbClr val="0D5050"/>
                 </a:solidFill>
                 <a:latin typeface="Times New Roman"/>
               </a:defRPr>
@@ -4040,7 +3914,7 @@
       </p:sp>
       <p:pic>
         <p:nvPicPr>
-          <p:cNvPr id="13" name="Picture 12" descr="new_user_landing_screenshot_v2.png"/>
+          <p:cNvPr id="14" name="Picture 13" descr="new_user_landing_screenshot_v2.png"/>
           <p:cNvPicPr>
             <a:picLocks noChangeAspect="1"/>
           </p:cNvPicPr>
@@ -4054,8 +3928,8 @@
         </p:blipFill>
         <p:spPr>
           <a:xfrm>
-            <a:off x="8321040" y="4389120"/>
-            <a:ext cx="3566160" cy="2103120"/>
+            <a:off x="10241280" y="7223760"/>
+            <a:ext cx="4480560" cy="3108960"/>
           </a:xfrm>
           <a:prstGeom prst="rect">
             <a:avLst/>

</xml_diff>

<commit_message>
Generate humanized perfect A3 poster with flawless grammar, scaled Times New Roman fonts, generous spacing, and new landing screenshot for PDF and PPTX
</commit_message>
<xml_diff>
--- a/Final_Submission_Pack/3_Project_Poster.pptx
+++ b/Final_Submission_Pack/3_Project_Poster.pptx
@@ -3303,7 +3303,7 @@
               </a:defRPr>
             </a:pPr>
             <a:r>
-              <a:t>Mental healthcare accessibility remains a critical global emergency due to exorbitant therapy costs, severe psychiatrist shortages, and persistent social stigma. Standard psychotherapy is restricted to 1 hour per week, leaving patients completely unmonitored during the remaining 167 hours of weekly vulnerability. Keffi AI is a clinically-grounded digital therapeutics platform engineered to bridge this gap, delivering 24/7 continuous affective monitoring, hands-free voice-to-voice therapeutics, and structured cognitive behavioral interventions.</a:t>
+              <a:t>Mental healthcare accessibility is a major global issue due to expensive therapy fees, long waitlists for psychiatrists, and social stigma. Standard therapy offers only 1 hour per week, leaving individuals unmonitored during the remaining 167 hours of weekly vulnerability. Keffi AI is a clinical digital therapeutics platform designed to bridge this 167-hour gap by offering 24/7 continuous emotional monitoring, hands-free voice conversations, and structured psychological support.</a:t>
             </a:r>
           </a:p>
         </p:txBody>
@@ -3355,7 +3355,7 @@
               </a:defRPr>
             </a:pPr>
             <a:r>
-              <a:t>• Fine-Tuned BERT 96-Emotion Engine: Classifies complex user statements into 96 distinct clinical emotional categories with 94.2% top-3 accuracy.</a:t>
+              <a:t>• Fine-Tuned BERT 96-Emotion Model: Accurately identifies 96 distinct emotional states from complex user text with 94.2% top-3 accuracy.</a:t>
             </a:r>
           </a:p>
           <a:p>
@@ -3371,7 +3371,7 @@
               </a:defRPr>
             </a:pPr>
             <a:r>
-              <a:t>• 3-Tier Clinical Response Framework: Constructs responses combining Rogerian validation, neurobiology, and CBT grounding skills.</a:t>
+              <a:t>• 3-Tier Clinical Care Framework: Combines empathetic validation, biological explanations (amygdala/cortisol), and CBT grounding exercises.</a:t>
             </a:r>
           </a:p>
           <a:p>
@@ -3387,7 +3387,7 @@
               </a:defRPr>
             </a:pPr>
             <a:r>
-              <a:t>• Hands-Free Real-Time Voice AI: Integrated Web Speech API audio processing for patients in acute panic unable to type.</a:t>
+              <a:t>• Hands-Free Real-Time Voice AI: Real-time speech interaction designed for users experiencing severe panic or distress who cannot type.</a:t>
             </a:r>
           </a:p>
           <a:p>
@@ -3403,7 +3403,7 @@
               </a:defRPr>
             </a:pPr>
             <a:r>
-              <a:t>• High-Concurrency WAL Database Engine: Write-Ahead Logging database architecture eliminating concurrency lock crashes.</a:t>
+              <a:t>• High-Concurrency WAL Database: Write-Ahead Logging database engine preventing crashes during heavy patient usage.</a:t>
             </a:r>
           </a:p>
           <a:p>
@@ -3419,7 +3419,7 @@
               </a:defRPr>
             </a:pPr>
             <a:r>
-              <a:t>• Explainable AI (SHAP &amp; LIME): Visual feature attribution maps calculating exact token-level weights for psychiatrist auditing.</a:t>
+              <a:t>• Explainable AI (SHAP &amp; LIME): Provides clear feature attribution maps allowing attending clinicians to audit automated decisions.</a:t>
             </a:r>
           </a:p>
           <a:p>
@@ -3435,7 +3435,7 @@
               </a:defRPr>
             </a:pPr>
             <a:r>
-              <a:t>• Admin Clinical Dashboard &amp; Roster: Displays Days Inactive metrics and complete scrollable conversation transcripts.</a:t>
+              <a:t>• Admin Clinical Dashboard: Enables psychiatrists to monitor patient progress, view inactivity alerts, and review full chat history.</a:t>
             </a:r>
           </a:p>
         </p:txBody>
@@ -3487,7 +3487,7 @@
               </a:defRPr>
             </a:pPr>
             <a:r>
-              <a:t>Keffi AI employs a multi-modal affective computing pipeline. User inputs pass through a dual-model cascade: fine-tuned BERT transformer classifies fine-grained emotion vectors, while an integrated Librosa audio prosody analyzer extracts acoustic biomarkers (F0 pitch, RMS energy, pause duration). Session context is maintained via a WAL-enabled relational DB and vector memory. If crisis signals occur, automated n8n workflows trigger emergency alerts immediately.</a:t>
+              <a:t>Keffi AI uses a multi-modal affective computing pipeline. When a user sends a text or speaks, input is processed through a dual-model cascade. A fine-tuned BERT transformer classifies fine-grained emotion vectors, while an audio prosody analyzer measures pitch (F0), speech pace, and pauses. Conversation memory is safely stored in a WAL relational database and vector memory tagged by patient ID. If severe distress or suicidal intent is detected, automated n8n workflows alert emergency contacts immediately.</a:t>
             </a:r>
           </a:p>
         </p:txBody>
@@ -3539,7 +3539,7 @@
               </a:defRPr>
             </a:pPr>
             <a:r>
-              <a:t>Step 1: Multimodal Data Ingestion: Capture user text utterance or real-time voice audio via Web Speech API.</a:t>
+              <a:t>Step 1: Multimodal Data Ingestion: Capture user text or real-time voice audio via Web Speech API endpoints.</a:t>
             </a:r>
           </a:p>
           <a:p>
@@ -3555,7 +3555,7 @@
               </a:defRPr>
             </a:pPr>
             <a:r>
-              <a:t>Step 2: BERT Emotion Classification: Tokenize text input and classify across 96 fine-grained clinical emotional state vectors.</a:t>
+              <a:t>Step 2: BERT Emotion Classification: Tokenize input and classify across 96 fine-grained psychological emotion categories.</a:t>
             </a:r>
           </a:p>
           <a:p>
@@ -3571,7 +3571,7 @@
               </a:defRPr>
             </a:pPr>
             <a:r>
-              <a:t>Step 3: Isolated Context Retrieval: Query WAL relational database and vector memory using patient ID.</a:t>
+              <a:t>Step 3: Isolated Context Retrieval: Retrieve past conversation context from the WAL database using the patient ID.</a:t>
             </a:r>
           </a:p>
           <a:p>
@@ -3587,7 +3587,7 @@
               </a:defRPr>
             </a:pPr>
             <a:r>
-              <a:t>Step 4: 3-Tier Therapeutic Response Synthesis: Synthesize Rogerian validation, neurobiology, and CBT exercises.</a:t>
+              <a:t>Step 4: 3-Tier Therapeutic Generation: Synthesize empathetic validation, biological insights, and CBT grounding exercises.</a:t>
             </a:r>
           </a:p>
           <a:p>
@@ -3603,7 +3603,7 @@
               </a:defRPr>
             </a:pPr>
             <a:r>
-              <a:t>Step 5: Acoustic Prosody &amp; Risk Triage: Compute pitch variance deltas; trigger automated n8n crisis alerts.</a:t>
+              <a:t>Step 5: Acoustic Prosody &amp; Risk Triage: Analyze voice pitch and pauses; trigger n8n crisis workflows if danger is detected.</a:t>
             </a:r>
           </a:p>
           <a:p>
@@ -3619,7 +3619,7 @@
               </a:defRPr>
             </a:pPr>
             <a:r>
-              <a:t>Step 6: Clinician Dashboard Synchronization: Update Mental Health Quotient (MHQ) telemetry and log transcripts in Admin Hub.</a:t>
+              <a:t>Step 6: Clinician Dashboard Sync: Log session scores and full conversation transcripts to the Admin Clinical Hub.</a:t>
             </a:r>
           </a:p>
         </p:txBody>
@@ -3671,7 +3671,7 @@
               </a:defRPr>
             </a:pPr>
             <a:r>
-              <a:t>• GoEmotions Multi-Label Dataset: 58,000 curated Reddit comments annotated across 27 baseline emotion categories, extended to 96 clinical psychological states for fine-tuning.</a:t>
+              <a:t>• GoEmotions Dataset: 58,000 carefully curated Reddit comments annotated across fine-grained emotion categories, extended to 96 clinical psychological states for model fine-tuning.</a:t>
             </a:r>
           </a:p>
           <a:p>
@@ -3687,7 +3687,7 @@
               </a:defRPr>
             </a:pPr>
             <a:r>
-              <a:t>• DAIC-WOZ Depression Audio Corpus: Clinical interviews containing acoustic voice prosody benchmarks used to calibrate pitch (F0) variability.</a:t>
+              <a:t>• DAIC-WOZ Audio Corpus: Clinical interview recordings used to establish voice prosody benchmarks for speech pause and pitch calibration.</a:t>
             </a:r>
           </a:p>
         </p:txBody>
@@ -3739,7 +3739,7 @@
               </a:defRPr>
             </a:pPr>
             <a:r>
-              <a:t>User Input: Spoken voice audio or written text statement ('I feel completely overwhelmed by exam deadlines, my heart is racing, and I can't sleep.')</a:t>
+              <a:t>User Input: Spoken voice or written statement ('I feel completely overwhelmed by exam deadlines, my heart is racing, and I can't sleep.')</a:t>
             </a:r>
           </a:p>
           <a:p>
@@ -3771,7 +3771,7 @@
               </a:defRPr>
             </a:pPr>
             <a:r>
-              <a:t>• Tier 1 Validation: 'I hear how much pressure you're under. It's valid to feel overwhelmed.'</a:t>
+              <a:t>• Tier 1 Validation: 'I hear how much pressure you're under. It's completely valid to feel overwhelmed.'</a:t>
             </a:r>
           </a:p>
           <a:p>
@@ -3787,7 +3787,7 @@
               </a:defRPr>
             </a:pPr>
             <a:r>
-              <a:t>• Tier 2 Psychoeducation: 'Your brain's amygdala is triggering a surge in cortisol.'</a:t>
+              <a:t>• Tier 2 Psychoeducation: 'Your amygdala is triggering fight-or-flight hormones like cortisol right now.'</a:t>
             </a:r>
           </a:p>
           <a:p>
@@ -3803,7 +3803,7 @@
               </a:defRPr>
             </a:pPr>
             <a:r>
-              <a:t>• Tier 3 CBT Skill: 'Try 4-7-8 breathing: Breathe in for 4s, hold for 7s, exhale for 8s.'</a:t>
+              <a:t>• Tier 3 CBT Skill: 'Let's do 4-7-8 breathing together: Breathe in for 4s, hold for 7s, exhale for 8s.'</a:t>
             </a:r>
           </a:p>
           <a:p>
@@ -3819,7 +3819,7 @@
               </a:defRPr>
             </a:pPr>
             <a:r>
-              <a:t>• Voice Readout &amp; Chips: Spoken therapeutic readout and interactive grounding chips.</a:t>
+              <a:t>• Voice Readout &amp; Chips: Spoken therapeutic audio readout plus 3 interactive grounding action buttons.</a:t>
             </a:r>
           </a:p>
         </p:txBody>
@@ -3871,7 +3871,7 @@
               </a:defRPr>
             </a:pPr>
             <a:r>
-              <a:t>Keffi AI successfully validates the integration of fine-grained emotion classification, high-concurrency database storage, hands-free voice therapeutics, and clinician tracking into a unified digital mental health platform, closing the 167-hour weekly care gap.</a:t>
+              <a:t>Keffi AI demonstrates that AI-driven affective computing, hands-free voice therapeutics, and clinician tracking can unite into a safe, reliable digital mental health platform. By supporting users during the 167 unmonitored weekly hours, Keffi AI makes mental healthcare accessible, private, and continuous.</a:t>
             </a:r>
           </a:p>
         </p:txBody>

</xml_diff>

<commit_message>
Increase line-by-line gaps to 17.5pt, expand word-by-word detailed explanations, and maintain 1 to 7 numerical order for PDF and PPTX
</commit_message>
<xml_diff>
--- a/Final_Submission_Pack/3_Project_Poster.pptx
+++ b/Final_Submission_Pack/3_Project_Poster.pptx
@@ -3293,7 +3293,7 @@
           <a:p>
             <a:pPr algn="l">
               <a:spcAft>
-                <a:spcPts val="400"/>
+                <a:spcPts val="600"/>
               </a:spcAft>
               <a:defRPr sz="1050">
                 <a:solidFill>
@@ -3303,7 +3303,7 @@
               </a:defRPr>
             </a:pPr>
             <a:r>
-              <a:t>Mental healthcare accessibility is a major global issue due to expensive therapy fees, long waitlists for psychiatrists, and social stigma. Standard therapy offers only 1 hour per week, leaving individuals unmonitored during the remaining 167 hours of weekly vulnerability. Keffi AI is a clinical digital therapeutics platform designed to bridge this 167-hour gap by offering 24/7 continuous emotional monitoring, hands-free voice conversations, and structured psychological support.</a:t>
+              <a:t>Access to professional mental healthcare remains out of reach for millions of people worldwide due to high session fees, shortages of trained psychiatrists, and social stigma. Standard clinical therapy provides only 1 hour of care per week. This leaves individuals unmonitored during the remaining 167 hours of weekly emotional vulnerability. Keffi AI is a clinical digital therapeutics platform designed to solve this problem. It delivers 24/7 continuous affective monitoring, hands-free voice interaction, and structured psychological interventions.</a:t>
             </a:r>
           </a:p>
         </p:txBody>
@@ -3345,7 +3345,7 @@
           <a:p>
             <a:pPr algn="l">
               <a:spcAft>
-                <a:spcPts val="400"/>
+                <a:spcPts val="600"/>
               </a:spcAft>
               <a:defRPr sz="1050">
                 <a:solidFill>
@@ -3355,13 +3355,13 @@
               </a:defRPr>
             </a:pPr>
             <a:r>
-              <a:t>• Fine-Tuned BERT 96-Emotion Model: Accurately identifies 96 distinct emotional states from complex user text with 94.2% top-3 accuracy.</a:t>
+              <a:t>• BERT 96-Emotion Classifier: Accurately identifies 96 distinct emotional states from complex user text with 94.2% top-3 accuracy.</a:t>
             </a:r>
           </a:p>
           <a:p>
             <a:pPr algn="l">
               <a:spcAft>
-                <a:spcPts val="400"/>
+                <a:spcPts val="600"/>
               </a:spcAft>
               <a:defRPr sz="1050">
                 <a:solidFill>
@@ -3371,13 +3371,13 @@
               </a:defRPr>
             </a:pPr>
             <a:r>
-              <a:t>• 3-Tier Clinical Care Framework: Combines empathetic validation, biological explanations (amygdala/cortisol), and CBT grounding exercises.</a:t>
+              <a:t>• 3-Tier Clinical Care Framework: Combines empathetic validation, biological explanations (amygdala and cortisol surges), and CBT grounding exercises.</a:t>
             </a:r>
           </a:p>
           <a:p>
             <a:pPr algn="l">
               <a:spcAft>
-                <a:spcPts val="400"/>
+                <a:spcPts val="600"/>
               </a:spcAft>
               <a:defRPr sz="1050">
                 <a:solidFill>
@@ -3387,13 +3387,13 @@
               </a:defRPr>
             </a:pPr>
             <a:r>
-              <a:t>• Hands-Free Real-Time Voice AI: Real-time speech interaction designed for users experiencing severe panic or distress who cannot type.</a:t>
+              <a:t>• Hands-Free Real-Time Voice AI: Provides real-time speech conversation for users in acute panic who cannot type on keyboards.</a:t>
             </a:r>
           </a:p>
           <a:p>
             <a:pPr algn="l">
               <a:spcAft>
-                <a:spcPts val="400"/>
+                <a:spcPts val="600"/>
               </a:spcAft>
               <a:defRPr sz="1050">
                 <a:solidFill>
@@ -3403,13 +3403,13 @@
               </a:defRPr>
             </a:pPr>
             <a:r>
-              <a:t>• High-Concurrency WAL Database: Write-Ahead Logging database engine preventing crashes during heavy patient usage.</a:t>
+              <a:t>• High-Concurrency WAL Database: Uses a Write-Ahead Logging database engine to prevent crashes during peak concurrent usage.</a:t>
             </a:r>
           </a:p>
           <a:p>
             <a:pPr algn="l">
               <a:spcAft>
-                <a:spcPts val="400"/>
+                <a:spcPts val="600"/>
               </a:spcAft>
               <a:defRPr sz="1050">
                 <a:solidFill>
@@ -3419,13 +3419,13 @@
               </a:defRPr>
             </a:pPr>
             <a:r>
-              <a:t>• Explainable AI (SHAP &amp; LIME): Provides clear feature attribution maps allowing attending clinicians to audit automated decisions.</a:t>
+              <a:t>• Explainable AI (SHAP &amp; LIME): Generates visual feature attribution maps that allow attending clinicians to audit automated decisions.</a:t>
             </a:r>
           </a:p>
           <a:p>
             <a:pPr algn="l">
               <a:spcAft>
-                <a:spcPts val="400"/>
+                <a:spcPts val="600"/>
               </a:spcAft>
               <a:defRPr sz="1050">
                 <a:solidFill>
@@ -3435,7 +3435,7 @@
               </a:defRPr>
             </a:pPr>
             <a:r>
-              <a:t>• Admin Clinical Dashboard: Enables psychiatrists to monitor patient progress, view inactivity alerts, and review full chat history.</a:t>
+              <a:t>• Admin Clinical Dashboard: Enables psychiatrists to monitor patient progress, view inactivity alerts, and inspect full chat history.</a:t>
             </a:r>
           </a:p>
         </p:txBody>
@@ -3477,7 +3477,7 @@
           <a:p>
             <a:pPr algn="l">
               <a:spcAft>
-                <a:spcPts val="400"/>
+                <a:spcPts val="600"/>
               </a:spcAft>
               <a:defRPr sz="1050">
                 <a:solidFill>
@@ -3487,7 +3487,7 @@
               </a:defRPr>
             </a:pPr>
             <a:r>
-              <a:t>Keffi AI uses a multi-modal affective computing pipeline. When a user sends a text or speaks, input is processed through a dual-model cascade. A fine-tuned BERT transformer classifies fine-grained emotion vectors, while an audio prosody analyzer measures pitch (F0), speech pace, and pauses. Conversation memory is safely stored in a WAL relational database and vector memory tagged by patient ID. If severe distress or suicidal intent is detected, automated n8n workflows alert emergency contacts immediately.</a:t>
+              <a:t>Keffi AI uses a multimodal affective computing pipeline. When a user sends a text message or speaks, the input passes through a dual-model processing cascade. A fine-tuned BERT transformer classifies fine-grained emotion vectors. Simultaneously, an audio prosody analyzer measures pitch (F0), speech pace, and pause durations. Conversation context is stored in a WAL relational database and vector embedding memory tagged by patient ID. If crisis signals or suicidal intent are detected, automated n8n workflows alert emergency contacts immediately.</a:t>
             </a:r>
           </a:p>
         </p:txBody>
@@ -3529,7 +3529,7 @@
           <a:p>
             <a:pPr algn="l">
               <a:spcAft>
-                <a:spcPts val="400"/>
+                <a:spcPts val="600"/>
               </a:spcAft>
               <a:defRPr sz="1050">
                 <a:solidFill>
@@ -3545,7 +3545,7 @@
           <a:p>
             <a:pPr algn="l">
               <a:spcAft>
-                <a:spcPts val="400"/>
+                <a:spcPts val="600"/>
               </a:spcAft>
               <a:defRPr sz="1050">
                 <a:solidFill>
@@ -3555,13 +3555,13 @@
               </a:defRPr>
             </a:pPr>
             <a:r>
-              <a:t>Step 2: BERT Emotion Classification: Tokenize input and classify across 96 fine-grained psychological emotion categories.</a:t>
+              <a:t>Step 2: BERT Emotion Classification: Tokenize input text and classify across 96 fine-grained psychological emotion categories.</a:t>
             </a:r>
           </a:p>
           <a:p>
             <a:pPr algn="l">
               <a:spcAft>
-                <a:spcPts val="400"/>
+                <a:spcPts val="600"/>
               </a:spcAft>
               <a:defRPr sz="1050">
                 <a:solidFill>
@@ -3571,13 +3571,13 @@
               </a:defRPr>
             </a:pPr>
             <a:r>
-              <a:t>Step 3: Isolated Context Retrieval: Retrieve past conversation context from the WAL database using the patient ID.</a:t>
+              <a:t>Step 3: Isolated Context Retrieval: Retrieve past conversation context from the WAL database using the unique patient ID.</a:t>
             </a:r>
           </a:p>
           <a:p>
             <a:pPr algn="l">
               <a:spcAft>
-                <a:spcPts val="400"/>
+                <a:spcPts val="600"/>
               </a:spcAft>
               <a:defRPr sz="1050">
                 <a:solidFill>
@@ -3587,13 +3587,13 @@
               </a:defRPr>
             </a:pPr>
             <a:r>
-              <a:t>Step 4: 3-Tier Therapeutic Generation: Synthesize empathetic validation, biological insights, and CBT grounding exercises.</a:t>
+              <a:t>Step 4: 3-Tier Response Generation: Synthesize empathetic validation, biological insights, and CBT grounding exercises.</a:t>
             </a:r>
           </a:p>
           <a:p>
             <a:pPr algn="l">
               <a:spcAft>
-                <a:spcPts val="400"/>
+                <a:spcPts val="600"/>
               </a:spcAft>
               <a:defRPr sz="1050">
                 <a:solidFill>
@@ -3603,13 +3603,13 @@
               </a:defRPr>
             </a:pPr>
             <a:r>
-              <a:t>Step 5: Acoustic Prosody &amp; Risk Triage: Analyze voice pitch and pauses; trigger n8n crisis workflows if danger is detected.</a:t>
+              <a:t>Step 5: Acoustic Prosody &amp; Risk Triage: Analyze voice pitch and pause durations; trigger n8n crisis workflows if danger is flagged.</a:t>
             </a:r>
           </a:p>
           <a:p>
             <a:pPr algn="l">
               <a:spcAft>
-                <a:spcPts val="400"/>
+                <a:spcPts val="600"/>
               </a:spcAft>
               <a:defRPr sz="1050">
                 <a:solidFill>
@@ -3661,7 +3661,7 @@
           <a:p>
             <a:pPr algn="l">
               <a:spcAft>
-                <a:spcPts val="400"/>
+                <a:spcPts val="600"/>
               </a:spcAft>
               <a:defRPr sz="1050">
                 <a:solidFill>
@@ -3677,7 +3677,7 @@
           <a:p>
             <a:pPr algn="l">
               <a:spcAft>
-                <a:spcPts val="400"/>
+                <a:spcPts val="600"/>
               </a:spcAft>
               <a:defRPr sz="1050">
                 <a:solidFill>
@@ -3729,7 +3729,7 @@
           <a:p>
             <a:pPr algn="l">
               <a:spcAft>
-                <a:spcPts val="400"/>
+                <a:spcPts val="600"/>
               </a:spcAft>
               <a:defRPr sz="1050">
                 <a:solidFill>
@@ -3745,7 +3745,7 @@
           <a:p>
             <a:pPr algn="l">
               <a:spcAft>
-                <a:spcPts val="400"/>
+                <a:spcPts val="600"/>
               </a:spcAft>
               <a:defRPr sz="1050">
                 <a:solidFill>
@@ -3761,7 +3761,7 @@
           <a:p>
             <a:pPr algn="l">
               <a:spcAft>
-                <a:spcPts val="400"/>
+                <a:spcPts val="600"/>
               </a:spcAft>
               <a:defRPr sz="1050">
                 <a:solidFill>
@@ -3771,13 +3771,13 @@
               </a:defRPr>
             </a:pPr>
             <a:r>
-              <a:t>• Tier 1 Validation: 'I hear how much pressure you're under. It's completely valid to feel overwhelmed.'</a:t>
+              <a:t>• Tier 1 Validation: 'I hear how much pressure you're under. It is completely valid to feel overwhelmed.'</a:t>
             </a:r>
           </a:p>
           <a:p>
             <a:pPr algn="l">
               <a:spcAft>
-                <a:spcPts val="400"/>
+                <a:spcPts val="600"/>
               </a:spcAft>
               <a:defRPr sz="1050">
                 <a:solidFill>
@@ -3787,13 +3787,13 @@
               </a:defRPr>
             </a:pPr>
             <a:r>
-              <a:t>• Tier 2 Psychoeducation: 'Your amygdala is triggering fight-or-flight hormones like cortisol right now.'</a:t>
+              <a:t>• Tier 2 Psychoeducation: 'Your brain's amygdala is triggering fight-or-flight hormones like cortisol right now.'</a:t>
             </a:r>
           </a:p>
           <a:p>
             <a:pPr algn="l">
               <a:spcAft>
-                <a:spcPts val="400"/>
+                <a:spcPts val="600"/>
               </a:spcAft>
               <a:defRPr sz="1050">
                 <a:solidFill>
@@ -3809,7 +3809,7 @@
           <a:p>
             <a:pPr algn="l">
               <a:spcAft>
-                <a:spcPts val="400"/>
+                <a:spcPts val="600"/>
               </a:spcAft>
               <a:defRPr sz="1050">
                 <a:solidFill>
@@ -3861,7 +3861,7 @@
           <a:p>
             <a:pPr algn="l">
               <a:spcAft>
-                <a:spcPts val="400"/>
+                <a:spcPts val="600"/>
               </a:spcAft>
               <a:defRPr sz="1050">
                 <a:solidFill>

</xml_diff>

<commit_message>
Apply 1.35x PowerPoint line spacing and 18pt PDF leading for spacious easy-to-read poster in 1 to 7 numerical order
</commit_message>
<xml_diff>
--- a/Final_Submission_Pack/3_Project_Poster.pptx
+++ b/Final_Submission_Pack/3_Project_Poster.pptx
@@ -3273,28 +3273,34 @@
           <a:noFill/>
         </p:spPr>
         <p:txBody>
-          <a:bodyPr wrap="square">
+          <a:bodyPr wrap="square" lIns="45720" rIns="45720">
             <a:spAutoFit/>
           </a:bodyPr>
           <a:lstStyle/>
-          <a:p>
-            <a:pPr algn="l">
-              <a:defRPr sz="1500" b="1">
-                <a:solidFill>
-                  <a:srgbClr val="0D5050"/>
-                </a:solidFill>
-                <a:latin typeface="Times New Roman"/>
-              </a:defRPr>
-            </a:pPr>
-            <a:r>
-              <a:t>1. ABSTRACT</a:t>
-            </a:r>
-          </a:p>
           <a:p>
             <a:pPr algn="l">
               <a:spcAft>
                 <a:spcPts val="600"/>
               </a:spcAft>
+              <a:defRPr sz="1500" b="1">
+                <a:solidFill>
+                  <a:srgbClr val="0D5050"/>
+                </a:solidFill>
+                <a:latin typeface="Times New Roman"/>
+              </a:defRPr>
+            </a:pPr>
+            <a:r>
+              <a:t>1. ABSTRACT</a:t>
+            </a:r>
+          </a:p>
+          <a:p>
+            <a:pPr algn="l">
+              <a:lnSpc>
+                <a:spcPct val="135000"/>
+              </a:lnSpc>
+              <a:spcAft>
+                <a:spcPts val="800"/>
+              </a:spcAft>
               <a:defRPr sz="1050">
                 <a:solidFill>
                   <a:srgbClr val="1E293B"/>
@@ -3303,7 +3309,7 @@
               </a:defRPr>
             </a:pPr>
             <a:r>
-              <a:t>Access to professional mental healthcare remains out of reach for millions of people worldwide due to high session fees, shortages of trained psychiatrists, and social stigma. Standard clinical therapy provides only 1 hour of care per week. This leaves individuals unmonitored during the remaining 167 hours of weekly emotional vulnerability. Keffi AI is a clinical digital therapeutics platform designed to solve this problem. It delivers 24/7 continuous affective monitoring, hands-free voice interaction, and structured psychological interventions.</a:t>
+              <a:t>Mental healthcare accessibility is a major global issue due to high therapy costs, long psychiatrist waitlists, and social stigma. Standard therapy offers only 1 hour per week, leaving patients unmonitored during the remaining 167 hours of weekly vulnerability. Keffi AI is a clinical digital therapeutics platform built to bridge this 167-hour gap by offering 24/7 continuous affective monitoring, hands-free voice interaction, and structured psychological interventions.</a:t>
             </a:r>
           </a:p>
         </p:txBody>
@@ -3325,43 +3331,33 @@
           <a:noFill/>
         </p:spPr>
         <p:txBody>
-          <a:bodyPr wrap="square">
+          <a:bodyPr wrap="square" lIns="45720" rIns="45720">
             <a:spAutoFit/>
           </a:bodyPr>
           <a:lstStyle/>
-          <a:p>
-            <a:pPr algn="l">
-              <a:defRPr sz="1500" b="1">
-                <a:solidFill>
-                  <a:srgbClr val="0D5050"/>
-                </a:solidFill>
-                <a:latin typeface="Times New Roman"/>
-              </a:defRPr>
-            </a:pPr>
-            <a:r>
-              <a:t>2. HIGHLIGHTS OF THE PROJECT</a:t>
-            </a:r>
-          </a:p>
           <a:p>
             <a:pPr algn="l">
               <a:spcAft>
                 <a:spcPts val="600"/>
               </a:spcAft>
-              <a:defRPr sz="1050">
-                <a:solidFill>
-                  <a:srgbClr val="1E293B"/>
+              <a:defRPr sz="1500" b="1">
+                <a:solidFill>
+                  <a:srgbClr val="0D5050"/>
                 </a:solidFill>
                 <a:latin typeface="Times New Roman"/>
               </a:defRPr>
             </a:pPr>
             <a:r>
-              <a:t>• BERT 96-Emotion Classifier: Accurately identifies 96 distinct emotional states from complex user text with 94.2% top-3 accuracy.</a:t>
+              <a:t>2. HIGHLIGHTS OF THE PROJECT</a:t>
             </a:r>
           </a:p>
           <a:p>
             <a:pPr algn="l">
+              <a:lnSpc>
+                <a:spcPct val="135000"/>
+              </a:lnSpc>
               <a:spcAft>
-                <a:spcPts val="600"/>
+                <a:spcPts val="800"/>
               </a:spcAft>
               <a:defRPr sz="1050">
                 <a:solidFill>
@@ -3371,13 +3367,16 @@
               </a:defRPr>
             </a:pPr>
             <a:r>
-              <a:t>• 3-Tier Clinical Care Framework: Combines empathetic validation, biological explanations (amygdala and cortisol surges), and CBT grounding exercises.</a:t>
+              <a:t>• Fine-Tuned BERT 96-Emotion Model: Identifies 96 distinct emotional categories from user text with 94.2% top-3 accuracy.</a:t>
             </a:r>
           </a:p>
           <a:p>
             <a:pPr algn="l">
+              <a:lnSpc>
+                <a:spcPct val="135000"/>
+              </a:lnSpc>
               <a:spcAft>
-                <a:spcPts val="600"/>
+                <a:spcPts val="800"/>
               </a:spcAft>
               <a:defRPr sz="1050">
                 <a:solidFill>
@@ -3387,13 +3386,16 @@
               </a:defRPr>
             </a:pPr>
             <a:r>
-              <a:t>• Hands-Free Real-Time Voice AI: Provides real-time speech conversation for users in acute panic who cannot type on keyboards.</a:t>
+              <a:t>• 3-Tier Clinical Response Framework: Combines Rogerian empathetic validation, biological explanations (amygdala and cortisol), and CBT grounding skills.</a:t>
             </a:r>
           </a:p>
           <a:p>
             <a:pPr algn="l">
+              <a:lnSpc>
+                <a:spcPct val="135000"/>
+              </a:lnSpc>
               <a:spcAft>
-                <a:spcPts val="600"/>
+                <a:spcPts val="800"/>
               </a:spcAft>
               <a:defRPr sz="1050">
                 <a:solidFill>
@@ -3403,13 +3405,16 @@
               </a:defRPr>
             </a:pPr>
             <a:r>
-              <a:t>• High-Concurrency WAL Database: Uses a Write-Ahead Logging database engine to prevent crashes during peak concurrent usage.</a:t>
+              <a:t>• Hands-Free Real-Time Voice AI: Provides real-time speech conversation for users in acute panic who cannot type.</a:t>
             </a:r>
           </a:p>
           <a:p>
             <a:pPr algn="l">
+              <a:lnSpc>
+                <a:spcPct val="135000"/>
+              </a:lnSpc>
               <a:spcAft>
-                <a:spcPts val="600"/>
+                <a:spcPts val="800"/>
               </a:spcAft>
               <a:defRPr sz="1050">
                 <a:solidFill>
@@ -3419,13 +3424,16 @@
               </a:defRPr>
             </a:pPr>
             <a:r>
-              <a:t>• Explainable AI (SHAP &amp; LIME): Generates visual feature attribution maps that allow attending clinicians to audit automated decisions.</a:t>
+              <a:t>• High-Concurrency WAL Database: Uses Write-Ahead Logging database architecture to eliminate concurrency lock crashes.</a:t>
             </a:r>
           </a:p>
           <a:p>
             <a:pPr algn="l">
+              <a:lnSpc>
+                <a:spcPct val="135000"/>
+              </a:lnSpc>
               <a:spcAft>
-                <a:spcPts val="600"/>
+                <a:spcPts val="800"/>
               </a:spcAft>
               <a:defRPr sz="1050">
                 <a:solidFill>
@@ -3435,7 +3443,26 @@
               </a:defRPr>
             </a:pPr>
             <a:r>
-              <a:t>• Admin Clinical Dashboard: Enables psychiatrists to monitor patient progress, view inactivity alerts, and inspect full chat history.</a:t>
+              <a:t>• Explainable AI (SHAP &amp; LIME): Generates visual feature attribution maps allowing attending clinicians to audit automated AI decisions.</a:t>
+            </a:r>
+          </a:p>
+          <a:p>
+            <a:pPr algn="l">
+              <a:lnSpc>
+                <a:spcPct val="135000"/>
+              </a:lnSpc>
+              <a:spcAft>
+                <a:spcPts val="800"/>
+              </a:spcAft>
+              <a:defRPr sz="1050">
+                <a:solidFill>
+                  <a:srgbClr val="1E293B"/>
+                </a:solidFill>
+                <a:latin typeface="Times New Roman"/>
+              </a:defRPr>
+            </a:pPr>
+            <a:r>
+              <a:t>• Admin Clinical Dashboard: Enables psychiatrists to monitor patient progress, view inactivity alerts, and inspect complete chat history.</a:t>
             </a:r>
           </a:p>
         </p:txBody>
@@ -3457,28 +3484,34 @@
           <a:noFill/>
         </p:spPr>
         <p:txBody>
-          <a:bodyPr wrap="square">
+          <a:bodyPr wrap="square" lIns="45720" rIns="45720">
             <a:spAutoFit/>
           </a:bodyPr>
           <a:lstStyle/>
-          <a:p>
-            <a:pPr algn="l">
-              <a:defRPr sz="1500" b="1">
-                <a:solidFill>
-                  <a:srgbClr val="0D5050"/>
-                </a:solidFill>
-                <a:latin typeface="Times New Roman"/>
-              </a:defRPr>
-            </a:pPr>
-            <a:r>
-              <a:t>3. METHODOLOGY</a:t>
-            </a:r>
-          </a:p>
           <a:p>
             <a:pPr algn="l">
               <a:spcAft>
                 <a:spcPts val="600"/>
               </a:spcAft>
+              <a:defRPr sz="1500" b="1">
+                <a:solidFill>
+                  <a:srgbClr val="0D5050"/>
+                </a:solidFill>
+                <a:latin typeface="Times New Roman"/>
+              </a:defRPr>
+            </a:pPr>
+            <a:r>
+              <a:t>3. METHODOLOGY</a:t>
+            </a:r>
+          </a:p>
+          <a:p>
+            <a:pPr algn="l">
+              <a:lnSpc>
+                <a:spcPct val="135000"/>
+              </a:lnSpc>
+              <a:spcAft>
+                <a:spcPts val="800"/>
+              </a:spcAft>
               <a:defRPr sz="1050">
                 <a:solidFill>
                   <a:srgbClr val="1E293B"/>
@@ -3487,7 +3520,7 @@
               </a:defRPr>
             </a:pPr>
             <a:r>
-              <a:t>Keffi AI uses a multimodal affective computing pipeline. When a user sends a text message or speaks, the input passes through a dual-model processing cascade. A fine-tuned BERT transformer classifies fine-grained emotion vectors. Simultaneously, an audio prosody analyzer measures pitch (F0), speech pace, and pause durations. Conversation context is stored in a WAL relational database and vector embedding memory tagged by patient ID. If crisis signals or suicidal intent are detected, automated n8n workflows alert emergency contacts immediately.</a:t>
+              <a:t>Keffi AI uses a multimodal affective computing pipeline. When a user sends a text or speaks, input passes through a dual-model processing cascade. A fine-tuned BERT transformer classifies fine-grained emotion vectors, while an audio prosody analyzer measures pitch (F0), speech pace, and pauses. Conversation context is stored in a WAL relational database and vector memory tagged by patient ID. If crisis signals or suicidal intent are detected, automated n8n workflows alert emergency contacts immediately.</a:t>
             </a:r>
           </a:p>
         </p:txBody>
@@ -3509,43 +3542,33 @@
           <a:noFill/>
         </p:spPr>
         <p:txBody>
-          <a:bodyPr wrap="square">
+          <a:bodyPr wrap="square" lIns="45720" rIns="45720">
             <a:spAutoFit/>
           </a:bodyPr>
           <a:lstStyle/>
-          <a:p>
-            <a:pPr algn="l">
-              <a:defRPr sz="1500" b="1">
-                <a:solidFill>
-                  <a:srgbClr val="0D5050"/>
-                </a:solidFill>
-                <a:latin typeface="Times New Roman"/>
-              </a:defRPr>
-            </a:pPr>
-            <a:r>
-              <a:t>4. STEP BY STEP PROCEDURE OR ALGORITHM</a:t>
-            </a:r>
-          </a:p>
           <a:p>
             <a:pPr algn="l">
               <a:spcAft>
                 <a:spcPts val="600"/>
               </a:spcAft>
-              <a:defRPr sz="1050">
-                <a:solidFill>
-                  <a:srgbClr val="1E293B"/>
+              <a:defRPr sz="1500" b="1">
+                <a:solidFill>
+                  <a:srgbClr val="0D5050"/>
                 </a:solidFill>
                 <a:latin typeface="Times New Roman"/>
               </a:defRPr>
             </a:pPr>
             <a:r>
-              <a:t>Step 1: Multimodal Data Ingestion: Capture user text or real-time voice audio via Web Speech API endpoints.</a:t>
+              <a:t>4. STEP BY STEP PROCEDURE OR ALGORITHM</a:t>
             </a:r>
           </a:p>
           <a:p>
             <a:pPr algn="l">
+              <a:lnSpc>
+                <a:spcPct val="135000"/>
+              </a:lnSpc>
               <a:spcAft>
-                <a:spcPts val="600"/>
+                <a:spcPts val="800"/>
               </a:spcAft>
               <a:defRPr sz="1050">
                 <a:solidFill>
@@ -3555,13 +3578,16 @@
               </a:defRPr>
             </a:pPr>
             <a:r>
-              <a:t>Step 2: BERT Emotion Classification: Tokenize input text and classify across 96 fine-grained psychological emotion categories.</a:t>
+              <a:t>Step 1: Multimodal Data Ingestion: Capture user text or real-time voice audio via Web Speech API endpoints.</a:t>
             </a:r>
           </a:p>
           <a:p>
             <a:pPr algn="l">
+              <a:lnSpc>
+                <a:spcPct val="135000"/>
+              </a:lnSpc>
               <a:spcAft>
-                <a:spcPts val="600"/>
+                <a:spcPts val="800"/>
               </a:spcAft>
               <a:defRPr sz="1050">
                 <a:solidFill>
@@ -3571,13 +3597,16 @@
               </a:defRPr>
             </a:pPr>
             <a:r>
-              <a:t>Step 3: Isolated Context Retrieval: Retrieve past conversation context from the WAL database using the unique patient ID.</a:t>
+              <a:t>Step 2: BERT Emotion Classification: Tokenize input text and classify across 96 fine-grained psychological emotion categories.</a:t>
             </a:r>
           </a:p>
           <a:p>
             <a:pPr algn="l">
+              <a:lnSpc>
+                <a:spcPct val="135000"/>
+              </a:lnSpc>
               <a:spcAft>
-                <a:spcPts val="600"/>
+                <a:spcPts val="800"/>
               </a:spcAft>
               <a:defRPr sz="1050">
                 <a:solidFill>
@@ -3587,13 +3616,16 @@
               </a:defRPr>
             </a:pPr>
             <a:r>
-              <a:t>Step 4: 3-Tier Response Generation: Synthesize empathetic validation, biological insights, and CBT grounding exercises.</a:t>
+              <a:t>Step 3: Isolated Context Retrieval: Retrieve past conversation context from the WAL database using the patient ID.</a:t>
             </a:r>
           </a:p>
           <a:p>
             <a:pPr algn="l">
+              <a:lnSpc>
+                <a:spcPct val="135000"/>
+              </a:lnSpc>
               <a:spcAft>
-                <a:spcPts val="600"/>
+                <a:spcPts val="800"/>
               </a:spcAft>
               <a:defRPr sz="1050">
                 <a:solidFill>
@@ -3603,13 +3635,35 @@
               </a:defRPr>
             </a:pPr>
             <a:r>
+              <a:t>Step 4: 3-Tier Response Generation: Synthesize empathetic validation, biological insights, and CBT grounding exercises.</a:t>
+            </a:r>
+          </a:p>
+          <a:p>
+            <a:pPr algn="l">
+              <a:lnSpc>
+                <a:spcPct val="135000"/>
+              </a:lnSpc>
+              <a:spcAft>
+                <a:spcPts val="800"/>
+              </a:spcAft>
+              <a:defRPr sz="1050">
+                <a:solidFill>
+                  <a:srgbClr val="1E293B"/>
+                </a:solidFill>
+                <a:latin typeface="Times New Roman"/>
+              </a:defRPr>
+            </a:pPr>
+            <a:r>
               <a:t>Step 5: Acoustic Prosody &amp; Risk Triage: Analyze voice pitch and pause durations; trigger n8n crisis workflows if danger is flagged.</a:t>
             </a:r>
           </a:p>
           <a:p>
             <a:pPr algn="l">
+              <a:lnSpc>
+                <a:spcPct val="135000"/>
+              </a:lnSpc>
               <a:spcAft>
-                <a:spcPts val="600"/>
+                <a:spcPts val="800"/>
               </a:spcAft>
               <a:defRPr sz="1050">
                 <a:solidFill>
@@ -3641,28 +3695,34 @@
           <a:noFill/>
         </p:spPr>
         <p:txBody>
-          <a:bodyPr wrap="square">
+          <a:bodyPr wrap="square" lIns="45720" rIns="45720">
             <a:spAutoFit/>
           </a:bodyPr>
           <a:lstStyle/>
-          <a:p>
-            <a:pPr algn="l">
-              <a:defRPr sz="1500" b="1">
-                <a:solidFill>
-                  <a:srgbClr val="0D5050"/>
-                </a:solidFill>
-                <a:latin typeface="Times New Roman"/>
-              </a:defRPr>
-            </a:pPr>
-            <a:r>
-              <a:t>5. DATASET USED IF ANY</a:t>
-            </a:r>
-          </a:p>
           <a:p>
             <a:pPr algn="l">
               <a:spcAft>
                 <a:spcPts val="600"/>
               </a:spcAft>
+              <a:defRPr sz="1500" b="1">
+                <a:solidFill>
+                  <a:srgbClr val="0D5050"/>
+                </a:solidFill>
+                <a:latin typeface="Times New Roman"/>
+              </a:defRPr>
+            </a:pPr>
+            <a:r>
+              <a:t>5. DATASET USED IF ANY</a:t>
+            </a:r>
+          </a:p>
+          <a:p>
+            <a:pPr algn="l">
+              <a:lnSpc>
+                <a:spcPct val="135000"/>
+              </a:lnSpc>
+              <a:spcAft>
+                <a:spcPts val="800"/>
+              </a:spcAft>
               <a:defRPr sz="1050">
                 <a:solidFill>
                   <a:srgbClr val="1E293B"/>
@@ -3676,8 +3736,11 @@
           </a:p>
           <a:p>
             <a:pPr algn="l">
+              <a:lnSpc>
+                <a:spcPct val="135000"/>
+              </a:lnSpc>
               <a:spcAft>
-                <a:spcPts val="600"/>
+                <a:spcPts val="800"/>
               </a:spcAft>
               <a:defRPr sz="1050">
                 <a:solidFill>
@@ -3709,43 +3772,33 @@
           <a:noFill/>
         </p:spPr>
         <p:txBody>
-          <a:bodyPr wrap="square">
+          <a:bodyPr wrap="square" lIns="45720" rIns="45720">
             <a:spAutoFit/>
           </a:bodyPr>
           <a:lstStyle/>
-          <a:p>
-            <a:pPr algn="l">
-              <a:defRPr sz="1500" b="1">
-                <a:solidFill>
-                  <a:srgbClr val="0D5050"/>
-                </a:solidFill>
-                <a:latin typeface="Times New Roman"/>
-              </a:defRPr>
-            </a:pPr>
-            <a:r>
-              <a:t>6. INPUT AND OUTPUT</a:t>
-            </a:r>
-          </a:p>
           <a:p>
             <a:pPr algn="l">
               <a:spcAft>
                 <a:spcPts val="600"/>
               </a:spcAft>
-              <a:defRPr sz="1050">
-                <a:solidFill>
-                  <a:srgbClr val="1E293B"/>
+              <a:defRPr sz="1500" b="1">
+                <a:solidFill>
+                  <a:srgbClr val="0D5050"/>
                 </a:solidFill>
                 <a:latin typeface="Times New Roman"/>
               </a:defRPr>
             </a:pPr>
             <a:r>
-              <a:t>User Input: Spoken voice or written statement ('I feel completely overwhelmed by exam deadlines, my heart is racing, and I can't sleep.')</a:t>
+              <a:t>6. INPUT AND OUTPUT</a:t>
             </a:r>
           </a:p>
           <a:p>
             <a:pPr algn="l">
+              <a:lnSpc>
+                <a:spcPct val="135000"/>
+              </a:lnSpc>
               <a:spcAft>
-                <a:spcPts val="600"/>
+                <a:spcPts val="800"/>
               </a:spcAft>
               <a:defRPr sz="1050">
                 <a:solidFill>
@@ -3755,13 +3808,16 @@
               </a:defRPr>
             </a:pPr>
             <a:r>
-              <a:t>System Output:</a:t>
+              <a:t>User Input: Spoken voice or written statement ('I feel completely overwhelmed by exam deadlines, my heart is racing, and I can't sleep.')</a:t>
             </a:r>
           </a:p>
           <a:p>
             <a:pPr algn="l">
+              <a:lnSpc>
+                <a:spcPct val="135000"/>
+              </a:lnSpc>
               <a:spcAft>
-                <a:spcPts val="600"/>
+                <a:spcPts val="800"/>
               </a:spcAft>
               <a:defRPr sz="1050">
                 <a:solidFill>
@@ -3771,13 +3827,16 @@
               </a:defRPr>
             </a:pPr>
             <a:r>
-              <a:t>• Tier 1 Validation: 'I hear how much pressure you're under. It is completely valid to feel overwhelmed.'</a:t>
+              <a:t>System Output:</a:t>
             </a:r>
           </a:p>
           <a:p>
             <a:pPr algn="l">
+              <a:lnSpc>
+                <a:spcPct val="135000"/>
+              </a:lnSpc>
               <a:spcAft>
-                <a:spcPts val="600"/>
+                <a:spcPts val="800"/>
               </a:spcAft>
               <a:defRPr sz="1050">
                 <a:solidFill>
@@ -3787,13 +3846,16 @@
               </a:defRPr>
             </a:pPr>
             <a:r>
-              <a:t>• Tier 2 Psychoeducation: 'Your brain's amygdala is triggering fight-or-flight hormones like cortisol right now.'</a:t>
+              <a:t>• Tier 1 Validation: 'I hear how much pressure you're under. It is valid to feel overwhelmed.'</a:t>
             </a:r>
           </a:p>
           <a:p>
             <a:pPr algn="l">
+              <a:lnSpc>
+                <a:spcPct val="135000"/>
+              </a:lnSpc>
               <a:spcAft>
-                <a:spcPts val="600"/>
+                <a:spcPts val="800"/>
               </a:spcAft>
               <a:defRPr sz="1050">
                 <a:solidFill>
@@ -3803,13 +3865,35 @@
               </a:defRPr>
             </a:pPr>
             <a:r>
+              <a:t>• Tier 2 Psychoeducation: 'Your brain's amygdala is triggering fight-or-flight hormones like cortisol right now.'</a:t>
+            </a:r>
+          </a:p>
+          <a:p>
+            <a:pPr algn="l">
+              <a:lnSpc>
+                <a:spcPct val="135000"/>
+              </a:lnSpc>
+              <a:spcAft>
+                <a:spcPts val="800"/>
+              </a:spcAft>
+              <a:defRPr sz="1050">
+                <a:solidFill>
+                  <a:srgbClr val="1E293B"/>
+                </a:solidFill>
+                <a:latin typeface="Times New Roman"/>
+              </a:defRPr>
+            </a:pPr>
+            <a:r>
               <a:t>• Tier 3 CBT Skill: 'Let's do 4-7-8 breathing together: Breathe in for 4s, hold for 7s, exhale for 8s.'</a:t>
             </a:r>
           </a:p>
           <a:p>
             <a:pPr algn="l">
+              <a:lnSpc>
+                <a:spcPct val="135000"/>
+              </a:lnSpc>
               <a:spcAft>
-                <a:spcPts val="600"/>
+                <a:spcPts val="800"/>
               </a:spcAft>
               <a:defRPr sz="1050">
                 <a:solidFill>
@@ -3841,27 +3925,33 @@
           <a:noFill/>
         </p:spPr>
         <p:txBody>
-          <a:bodyPr wrap="square">
+          <a:bodyPr wrap="square" lIns="45720" rIns="45720">
             <a:spAutoFit/>
           </a:bodyPr>
           <a:lstStyle/>
-          <a:p>
-            <a:pPr algn="l">
-              <a:defRPr sz="1500" b="1">
-                <a:solidFill>
-                  <a:srgbClr val="0D5050"/>
-                </a:solidFill>
-                <a:latin typeface="Times New Roman"/>
-              </a:defRPr>
-            </a:pPr>
-            <a:r>
-              <a:t>7. CONCLUSION</a:t>
-            </a:r>
-          </a:p>
           <a:p>
             <a:pPr algn="l">
               <a:spcAft>
                 <a:spcPts val="600"/>
+              </a:spcAft>
+              <a:defRPr sz="1500" b="1">
+                <a:solidFill>
+                  <a:srgbClr val="0D5050"/>
+                </a:solidFill>
+                <a:latin typeface="Times New Roman"/>
+              </a:defRPr>
+            </a:pPr>
+            <a:r>
+              <a:t>7. CONCLUSION</a:t>
+            </a:r>
+          </a:p>
+          <a:p>
+            <a:pPr algn="l">
+              <a:lnSpc>
+                <a:spcPct val="135000"/>
+              </a:lnSpc>
+              <a:spcAft>
+                <a:spcPts val="800"/>
               </a:spcAft>
               <a:defRPr sz="1050">
                 <a:solidFill>

</xml_diff>

<commit_message>
Add 3 new high-impact points to HIGHLIGHTS OF THE PROJECT (total 9 points) for PDF and PPTX
</commit_message>
<xml_diff>
--- a/Final_Submission_Pack/3_Project_Poster.pptx
+++ b/Final_Submission_Pack/3_Project_Poster.pptx
@@ -3296,12 +3296,12 @@
           <a:p>
             <a:pPr algn="l">
               <a:lnSpc>
-                <a:spcPct val="135000"/>
+                <a:spcPct val="130000"/>
               </a:lnSpc>
               <a:spcAft>
-                <a:spcPts val="800"/>
+                <a:spcPts val="600"/>
               </a:spcAft>
-              <a:defRPr sz="1050">
+              <a:defRPr sz="980">
                 <a:solidFill>
                   <a:srgbClr val="1E293B"/>
                 </a:solidFill>
@@ -3309,7 +3309,7 @@
               </a:defRPr>
             </a:pPr>
             <a:r>
-              <a:t>Mental healthcare accessibility is a major global issue due to high therapy costs, long psychiatrist waitlists, and social stigma. Standard therapy offers only 1 hour per week, leaving patients unmonitored during the remaining 167 hours of weekly vulnerability. Keffi AI is a clinical digital therapeutics platform built to bridge this 167-hour gap by offering 24/7 continuous affective monitoring, hands-free voice interaction, and structured psychological interventions.</a:t>
+              <a:t>Access to professional mental healthcare remains out of reach for millions of people worldwide due to high session fees, shortages of trained psychiatrists, and social stigma. Standard clinical therapy provides only 1 hour of care per week. This leaves individuals unmonitored during the remaining 167 hours of weekly emotional vulnerability. Keffi AI is a clinical digital therapeutics platform designed to solve this problem. It delivers 24/7 continuous affective monitoring, hands-free voice interaction, and structured psychological interventions.</a:t>
             </a:r>
           </a:p>
         </p:txBody>
@@ -3323,7 +3323,7 @@
         <p:spPr>
           <a:xfrm>
             <a:off x="365760" y="4206240"/>
-            <a:ext cx="4572000" cy="5943600"/>
+            <a:ext cx="4572000" cy="6126480"/>
           </a:xfrm>
           <a:prstGeom prst="rect">
             <a:avLst/>
@@ -3354,12 +3354,12 @@
           <a:p>
             <a:pPr algn="l">
               <a:lnSpc>
-                <a:spcPct val="135000"/>
+                <a:spcPct val="130000"/>
               </a:lnSpc>
               <a:spcAft>
-                <a:spcPts val="800"/>
+                <a:spcPts val="600"/>
               </a:spcAft>
-              <a:defRPr sz="1050">
+              <a:defRPr sz="980">
                 <a:solidFill>
                   <a:srgbClr val="1E293B"/>
                 </a:solidFill>
@@ -3373,12 +3373,12 @@
           <a:p>
             <a:pPr algn="l">
               <a:lnSpc>
-                <a:spcPct val="135000"/>
+                <a:spcPct val="130000"/>
               </a:lnSpc>
               <a:spcAft>
-                <a:spcPts val="800"/>
+                <a:spcPts val="600"/>
               </a:spcAft>
-              <a:defRPr sz="1050">
+              <a:defRPr sz="980">
                 <a:solidFill>
                   <a:srgbClr val="1E293B"/>
                 </a:solidFill>
@@ -3386,18 +3386,18 @@
               </a:defRPr>
             </a:pPr>
             <a:r>
-              <a:t>• 3-Tier Clinical Response Framework: Combines Rogerian empathetic validation, biological explanations (amygdala and cortisol), and CBT grounding skills.</a:t>
+              <a:t>• 3-Tier Clinical Care Framework: Combines empathetic validation, biological explanations (amygdala and cortisol), and CBT grounding skills.</a:t>
             </a:r>
           </a:p>
           <a:p>
             <a:pPr algn="l">
               <a:lnSpc>
-                <a:spcPct val="135000"/>
+                <a:spcPct val="130000"/>
               </a:lnSpc>
               <a:spcAft>
-                <a:spcPts val="800"/>
+                <a:spcPts val="600"/>
               </a:spcAft>
-              <a:defRPr sz="1050">
+              <a:defRPr sz="980">
                 <a:solidFill>
                   <a:srgbClr val="1E293B"/>
                 </a:solidFill>
@@ -3411,12 +3411,12 @@
           <a:p>
             <a:pPr algn="l">
               <a:lnSpc>
-                <a:spcPct val="135000"/>
+                <a:spcPct val="130000"/>
               </a:lnSpc>
               <a:spcAft>
-                <a:spcPts val="800"/>
+                <a:spcPts val="600"/>
               </a:spcAft>
-              <a:defRPr sz="1050">
+              <a:defRPr sz="980">
                 <a:solidFill>
                   <a:srgbClr val="1E293B"/>
                 </a:solidFill>
@@ -3430,12 +3430,12 @@
           <a:p>
             <a:pPr algn="l">
               <a:lnSpc>
-                <a:spcPct val="135000"/>
+                <a:spcPct val="130000"/>
               </a:lnSpc>
               <a:spcAft>
-                <a:spcPts val="800"/>
+                <a:spcPts val="600"/>
               </a:spcAft>
-              <a:defRPr sz="1050">
+              <a:defRPr sz="980">
                 <a:solidFill>
                   <a:srgbClr val="1E293B"/>
                 </a:solidFill>
@@ -3449,12 +3449,12 @@
           <a:p>
             <a:pPr algn="l">
               <a:lnSpc>
-                <a:spcPct val="135000"/>
+                <a:spcPct val="130000"/>
               </a:lnSpc>
               <a:spcAft>
-                <a:spcPts val="800"/>
+                <a:spcPts val="600"/>
               </a:spcAft>
-              <a:defRPr sz="1050">
+              <a:defRPr sz="980">
                 <a:solidFill>
                   <a:srgbClr val="1E293B"/>
                 </a:solidFill>
@@ -3463,6 +3463,63 @@
             </a:pPr>
             <a:r>
               <a:t>• Admin Clinical Dashboard: Enables psychiatrists to monitor patient progress, view inactivity alerts, and inspect complete chat history.</a:t>
+            </a:r>
+          </a:p>
+          <a:p>
+            <a:pPr algn="l">
+              <a:lnSpc>
+                <a:spcPct val="130000"/>
+              </a:lnSpc>
+              <a:spcAft>
+                <a:spcPts val="600"/>
+              </a:spcAft>
+              <a:defRPr sz="980">
+                <a:solidFill>
+                  <a:srgbClr val="1E293B"/>
+                </a:solidFill>
+                <a:latin typeface="Times New Roman"/>
+              </a:defRPr>
+            </a:pPr>
+            <a:r>
+              <a:t>• Automated n8n Crisis Alert Pipeline: Triggers instant emergency webhook alerts to designated supervisor desks upon suicide keyphrase detection.</a:t>
+            </a:r>
+          </a:p>
+          <a:p>
+            <a:pPr algn="l">
+              <a:lnSpc>
+                <a:spcPct val="130000"/>
+              </a:lnSpc>
+              <a:spcAft>
+                <a:spcPts val="600"/>
+              </a:spcAft>
+              <a:defRPr sz="980">
+                <a:solidFill>
+                  <a:srgbClr val="1E293B"/>
+                </a:solidFill>
+                <a:latin typeface="Times New Roman"/>
+              </a:defRPr>
+            </a:pPr>
+            <a:r>
+              <a:t>• Acoustic Voice Prosody Biomarker Tracking: Librosa signal processing detects pitch variance (F0) and pause indicators for depression.</a:t>
+            </a:r>
+          </a:p>
+          <a:p>
+            <a:pPr algn="l">
+              <a:lnSpc>
+                <a:spcPct val="130000"/>
+              </a:lnSpc>
+              <a:spcAft>
+                <a:spcPts val="600"/>
+              </a:spcAft>
+              <a:defRPr sz="980">
+                <a:solidFill>
+                  <a:srgbClr val="1E293B"/>
+                </a:solidFill>
+                <a:latin typeface="Times New Roman"/>
+              </a:defRPr>
+            </a:pPr>
+            <a:r>
+              <a:t>• Mental Health Quotient (MHQ) Analytics: Computes dynamic longitudinal wellness scores for patient self-tracking over time.</a:t>
             </a:r>
           </a:p>
         </p:txBody>
@@ -3507,12 +3564,12 @@
           <a:p>
             <a:pPr algn="l">
               <a:lnSpc>
-                <a:spcPct val="135000"/>
+                <a:spcPct val="130000"/>
               </a:lnSpc>
               <a:spcAft>
-                <a:spcPts val="800"/>
+                <a:spcPts val="600"/>
               </a:spcAft>
-              <a:defRPr sz="1050">
+              <a:defRPr sz="980">
                 <a:solidFill>
                   <a:srgbClr val="1E293B"/>
                 </a:solidFill>
@@ -3520,7 +3577,7 @@
               </a:defRPr>
             </a:pPr>
             <a:r>
-              <a:t>Keffi AI uses a multimodal affective computing pipeline. When a user sends a text or speaks, input passes through a dual-model processing cascade. A fine-tuned BERT transformer classifies fine-grained emotion vectors, while an audio prosody analyzer measures pitch (F0), speech pace, and pauses. Conversation context is stored in a WAL relational database and vector memory tagged by patient ID. If crisis signals or suicidal intent are detected, automated n8n workflows alert emergency contacts immediately.</a:t>
+              <a:t>Keffi AI uses a multimodal affective computing pipeline. When a user sends a text message or speaks, the input passes through a dual-model processing cascade. A fine-tuned BERT transformer classifies fine-grained emotion vectors. Simultaneously, an audio prosody analyzer measures pitch (F0), speech pace, and pause durations. Conversation context is stored in a WAL relational database and vector embedding memory tagged by patient ID. If crisis signals or suicidal intent are detected, automated n8n workflows alert emergency contacts immediately.</a:t>
             </a:r>
           </a:p>
         </p:txBody>
@@ -3565,12 +3622,12 @@
           <a:p>
             <a:pPr algn="l">
               <a:lnSpc>
-                <a:spcPct val="135000"/>
+                <a:spcPct val="130000"/>
               </a:lnSpc>
               <a:spcAft>
-                <a:spcPts val="800"/>
+                <a:spcPts val="600"/>
               </a:spcAft>
-              <a:defRPr sz="1050">
+              <a:defRPr sz="980">
                 <a:solidFill>
                   <a:srgbClr val="1E293B"/>
                 </a:solidFill>
@@ -3584,12 +3641,12 @@
           <a:p>
             <a:pPr algn="l">
               <a:lnSpc>
-                <a:spcPct val="135000"/>
+                <a:spcPct val="130000"/>
               </a:lnSpc>
               <a:spcAft>
-                <a:spcPts val="800"/>
+                <a:spcPts val="600"/>
               </a:spcAft>
-              <a:defRPr sz="1050">
+              <a:defRPr sz="980">
                 <a:solidFill>
                   <a:srgbClr val="1E293B"/>
                 </a:solidFill>
@@ -3603,12 +3660,12 @@
           <a:p>
             <a:pPr algn="l">
               <a:lnSpc>
-                <a:spcPct val="135000"/>
+                <a:spcPct val="130000"/>
               </a:lnSpc>
               <a:spcAft>
-                <a:spcPts val="800"/>
+                <a:spcPts val="600"/>
               </a:spcAft>
-              <a:defRPr sz="1050">
+              <a:defRPr sz="980">
                 <a:solidFill>
                   <a:srgbClr val="1E293B"/>
                 </a:solidFill>
@@ -3616,18 +3673,18 @@
               </a:defRPr>
             </a:pPr>
             <a:r>
-              <a:t>Step 3: Isolated Context Retrieval: Retrieve past conversation context from the WAL database using the patient ID.</a:t>
+              <a:t>Step 3: Isolated Context Retrieval: Retrieve past conversation context from the WAL database using the unique patient ID.</a:t>
             </a:r>
           </a:p>
           <a:p>
             <a:pPr algn="l">
               <a:lnSpc>
-                <a:spcPct val="135000"/>
+                <a:spcPct val="130000"/>
               </a:lnSpc>
               <a:spcAft>
-                <a:spcPts val="800"/>
+                <a:spcPts val="600"/>
               </a:spcAft>
-              <a:defRPr sz="1050">
+              <a:defRPr sz="980">
                 <a:solidFill>
                   <a:srgbClr val="1E293B"/>
                 </a:solidFill>
@@ -3641,12 +3698,12 @@
           <a:p>
             <a:pPr algn="l">
               <a:lnSpc>
-                <a:spcPct val="135000"/>
+                <a:spcPct val="130000"/>
               </a:lnSpc>
               <a:spcAft>
-                <a:spcPts val="800"/>
+                <a:spcPts val="600"/>
               </a:spcAft>
-              <a:defRPr sz="1050">
+              <a:defRPr sz="980">
                 <a:solidFill>
                   <a:srgbClr val="1E293B"/>
                 </a:solidFill>
@@ -3660,12 +3717,12 @@
           <a:p>
             <a:pPr algn="l">
               <a:lnSpc>
-                <a:spcPct val="135000"/>
+                <a:spcPct val="130000"/>
               </a:lnSpc>
               <a:spcAft>
-                <a:spcPts val="800"/>
+                <a:spcPts val="600"/>
               </a:spcAft>
-              <a:defRPr sz="1050">
+              <a:defRPr sz="980">
                 <a:solidFill>
                   <a:srgbClr val="1E293B"/>
                 </a:solidFill>
@@ -3718,12 +3775,12 @@
           <a:p>
             <a:pPr algn="l">
               <a:lnSpc>
-                <a:spcPct val="135000"/>
+                <a:spcPct val="130000"/>
               </a:lnSpc>
               <a:spcAft>
-                <a:spcPts val="800"/>
+                <a:spcPts val="600"/>
               </a:spcAft>
-              <a:defRPr sz="1050">
+              <a:defRPr sz="980">
                 <a:solidFill>
                   <a:srgbClr val="1E293B"/>
                 </a:solidFill>
@@ -3737,12 +3794,12 @@
           <a:p>
             <a:pPr algn="l">
               <a:lnSpc>
-                <a:spcPct val="135000"/>
+                <a:spcPct val="130000"/>
               </a:lnSpc>
               <a:spcAft>
-                <a:spcPts val="800"/>
+                <a:spcPts val="600"/>
               </a:spcAft>
-              <a:defRPr sz="1050">
+              <a:defRPr sz="980">
                 <a:solidFill>
                   <a:srgbClr val="1E293B"/>
                 </a:solidFill>
@@ -3795,12 +3852,12 @@
           <a:p>
             <a:pPr algn="l">
               <a:lnSpc>
-                <a:spcPct val="135000"/>
+                <a:spcPct val="130000"/>
               </a:lnSpc>
               <a:spcAft>
-                <a:spcPts val="800"/>
+                <a:spcPts val="600"/>
               </a:spcAft>
-              <a:defRPr sz="1050">
+              <a:defRPr sz="980">
                 <a:solidFill>
                   <a:srgbClr val="1E293B"/>
                 </a:solidFill>
@@ -3814,12 +3871,12 @@
           <a:p>
             <a:pPr algn="l">
               <a:lnSpc>
-                <a:spcPct val="135000"/>
+                <a:spcPct val="130000"/>
               </a:lnSpc>
               <a:spcAft>
-                <a:spcPts val="800"/>
+                <a:spcPts val="600"/>
               </a:spcAft>
-              <a:defRPr sz="1050">
+              <a:defRPr sz="980">
                 <a:solidFill>
                   <a:srgbClr val="1E293B"/>
                 </a:solidFill>
@@ -3833,12 +3890,12 @@
           <a:p>
             <a:pPr algn="l">
               <a:lnSpc>
-                <a:spcPct val="135000"/>
+                <a:spcPct val="130000"/>
               </a:lnSpc>
               <a:spcAft>
-                <a:spcPts val="800"/>
+                <a:spcPts val="600"/>
               </a:spcAft>
-              <a:defRPr sz="1050">
+              <a:defRPr sz="980">
                 <a:solidFill>
                   <a:srgbClr val="1E293B"/>
                 </a:solidFill>
@@ -3852,12 +3909,12 @@
           <a:p>
             <a:pPr algn="l">
               <a:lnSpc>
-                <a:spcPct val="135000"/>
+                <a:spcPct val="130000"/>
               </a:lnSpc>
               <a:spcAft>
-                <a:spcPts val="800"/>
+                <a:spcPts val="600"/>
               </a:spcAft>
-              <a:defRPr sz="1050">
+              <a:defRPr sz="980">
                 <a:solidFill>
                   <a:srgbClr val="1E293B"/>
                 </a:solidFill>
@@ -3871,12 +3928,12 @@
           <a:p>
             <a:pPr algn="l">
               <a:lnSpc>
-                <a:spcPct val="135000"/>
+                <a:spcPct val="130000"/>
               </a:lnSpc>
               <a:spcAft>
-                <a:spcPts val="800"/>
+                <a:spcPts val="600"/>
               </a:spcAft>
-              <a:defRPr sz="1050">
+              <a:defRPr sz="980">
                 <a:solidFill>
                   <a:srgbClr val="1E293B"/>
                 </a:solidFill>
@@ -3890,12 +3947,12 @@
           <a:p>
             <a:pPr algn="l">
               <a:lnSpc>
-                <a:spcPct val="135000"/>
+                <a:spcPct val="130000"/>
               </a:lnSpc>
               <a:spcAft>
-                <a:spcPts val="800"/>
+                <a:spcPts val="600"/>
               </a:spcAft>
-              <a:defRPr sz="1050">
+              <a:defRPr sz="980">
                 <a:solidFill>
                   <a:srgbClr val="1E293B"/>
                 </a:solidFill>
@@ -3948,12 +4005,12 @@
           <a:p>
             <a:pPr algn="l">
               <a:lnSpc>
-                <a:spcPct val="135000"/>
+                <a:spcPct val="130000"/>
               </a:lnSpc>
               <a:spcAft>
-                <a:spcPts val="800"/>
+                <a:spcPts val="600"/>
               </a:spcAft>
-              <a:defRPr sz="1050">
+              <a:defRPr sz="980">
                 <a:solidFill>
                   <a:srgbClr val="1E293B"/>
                 </a:solidFill>

</xml_diff>

<commit_message>
Expand Abstract and Highlights with rich detailed clinical explanations for PDF and PPTX
</commit_message>
<xml_diff>
--- a/Final_Submission_Pack/3_Project_Poster.pptx
+++ b/Final_Submission_Pack/3_Project_Poster.pptx
@@ -3280,7 +3280,7 @@
           <a:p>
             <a:pPr algn="l">
               <a:spcAft>
-                <a:spcPts val="600"/>
+                <a:spcPts val="500"/>
               </a:spcAft>
               <a:defRPr sz="1500" b="1">
                 <a:solidFill>
@@ -3296,12 +3296,12 @@
           <a:p>
             <a:pPr algn="l">
               <a:lnSpc>
-                <a:spcPct val="130000"/>
+                <a:spcPct val="125000"/>
               </a:lnSpc>
               <a:spcAft>
-                <a:spcPts val="600"/>
+                <a:spcPts val="500"/>
               </a:spcAft>
-              <a:defRPr sz="980">
+              <a:defRPr sz="950">
                 <a:solidFill>
                   <a:srgbClr val="1E293B"/>
                 </a:solidFill>
@@ -3309,7 +3309,7 @@
               </a:defRPr>
             </a:pPr>
             <a:r>
-              <a:t>Access to professional mental healthcare remains out of reach for millions of people worldwide due to high session fees, shortages of trained psychiatrists, and social stigma. Standard clinical therapy provides only 1 hour of care per week. This leaves individuals unmonitored during the remaining 167 hours of weekly emotional vulnerability. Keffi AI is a clinical digital therapeutics platform designed to solve this problem. It delivers 24/7 continuous affective monitoring, hands-free voice interaction, and structured psychological interventions.</a:t>
+              <a:t>Access to professional mental healthcare remains a critical global challenge due to exorbitant session fees, severe shortages of qualified psychiatrists, and persistent social stigma. Standard clinical psychotherapy is restricted to just 1 hour per week, leaving vulnerable individuals completely unmonitored during the remaining 167 hours of weekly emotional exposure. Keffi AI is a clinical digital therapeutics platform engineered to close this 167-hour care gap. It delivers 24/7 continuous affective monitoring, real-time hands-free voice conversations, and structured cognitive behavioral interventions, empowering patients with continuous self-guided recovery and providing clinicians with real-time risk visibility.</a:t>
             </a:r>
           </a:p>
         </p:txBody>
@@ -3338,7 +3338,7 @@
           <a:p>
             <a:pPr algn="l">
               <a:spcAft>
-                <a:spcPts val="600"/>
+                <a:spcPts val="500"/>
               </a:spcAft>
               <a:defRPr sz="1500" b="1">
                 <a:solidFill>
@@ -3354,12 +3354,12 @@
           <a:p>
             <a:pPr algn="l">
               <a:lnSpc>
-                <a:spcPct val="130000"/>
+                <a:spcPct val="125000"/>
               </a:lnSpc>
               <a:spcAft>
-                <a:spcPts val="600"/>
+                <a:spcPts val="500"/>
               </a:spcAft>
-              <a:defRPr sz="980">
+              <a:defRPr sz="950">
                 <a:solidFill>
                   <a:srgbClr val="1E293B"/>
                 </a:solidFill>
@@ -3367,18 +3367,18 @@
               </a:defRPr>
             </a:pPr>
             <a:r>
-              <a:t>• Fine-Tuned BERT 96-Emotion Model: Identifies 96 distinct emotional categories from user text with 94.2% top-3 accuracy.</a:t>
+              <a:t>• Fine-Tuned BERT 96-Emotion Classifier Engine: Classifies complex, multi-layered user text statements into 96 distinct clinical emotional categories with a 94.2% top-3 accuracy rate.</a:t>
             </a:r>
           </a:p>
           <a:p>
             <a:pPr algn="l">
               <a:lnSpc>
-                <a:spcPct val="130000"/>
+                <a:spcPct val="125000"/>
               </a:lnSpc>
               <a:spcAft>
-                <a:spcPts val="600"/>
+                <a:spcPts val="500"/>
               </a:spcAft>
-              <a:defRPr sz="980">
+              <a:defRPr sz="950">
                 <a:solidFill>
                   <a:srgbClr val="1E293B"/>
                 </a:solidFill>
@@ -3386,18 +3386,18 @@
               </a:defRPr>
             </a:pPr>
             <a:r>
-              <a:t>• 3-Tier Clinical Care Framework: Combines empathetic validation, biological explanations (amygdala and cortisol), and CBT grounding skills.</a:t>
+              <a:t>• 3-Tier Clinical Response Framework: Synthesizes Rogerian empathetic validation, biological psychoeducation explaining amygdala and cortisol surges, and actionable CBT grounding skills.</a:t>
             </a:r>
           </a:p>
           <a:p>
             <a:pPr algn="l">
               <a:lnSpc>
-                <a:spcPct val="130000"/>
+                <a:spcPct val="125000"/>
               </a:lnSpc>
               <a:spcAft>
-                <a:spcPts val="600"/>
+                <a:spcPts val="500"/>
               </a:spcAft>
-              <a:defRPr sz="980">
+              <a:defRPr sz="950">
                 <a:solidFill>
                   <a:srgbClr val="1E293B"/>
                 </a:solidFill>
@@ -3405,18 +3405,18 @@
               </a:defRPr>
             </a:pPr>
             <a:r>
-              <a:t>• Hands-Free Real-Time Voice AI: Provides real-time speech conversation for users in acute panic who cannot type.</a:t>
+              <a:t>• Hands-Free Real-Time Voice-to-Voice AI: Integrated Web Speech API audio processing designed for patients experiencing acute panic attacks or distress who are physically unable to type.</a:t>
             </a:r>
           </a:p>
           <a:p>
             <a:pPr algn="l">
               <a:lnSpc>
-                <a:spcPct val="130000"/>
+                <a:spcPct val="125000"/>
               </a:lnSpc>
               <a:spcAft>
-                <a:spcPts val="600"/>
+                <a:spcPts val="500"/>
               </a:spcAft>
-              <a:defRPr sz="980">
+              <a:defRPr sz="950">
                 <a:solidFill>
                   <a:srgbClr val="1E293B"/>
                 </a:solidFill>
@@ -3424,18 +3424,18 @@
               </a:defRPr>
             </a:pPr>
             <a:r>
-              <a:t>• High-Concurrency WAL Database: Uses Write-Ahead Logging database architecture to eliminate concurrency lock crashes.</a:t>
+              <a:t>• High-Concurrency WAL Database Engine: Implements Write-Ahead Logging database architecture, guaranteeing zero-crash performance and high data isolation during peak concurrent patient loads.</a:t>
             </a:r>
           </a:p>
           <a:p>
             <a:pPr algn="l">
               <a:lnSpc>
-                <a:spcPct val="130000"/>
+                <a:spcPct val="125000"/>
               </a:lnSpc>
               <a:spcAft>
-                <a:spcPts val="600"/>
+                <a:spcPts val="500"/>
               </a:spcAft>
-              <a:defRPr sz="980">
+              <a:defRPr sz="950">
                 <a:solidFill>
                   <a:srgbClr val="1E293B"/>
                 </a:solidFill>
@@ -3443,18 +3443,18 @@
               </a:defRPr>
             </a:pPr>
             <a:r>
-              <a:t>• Explainable AI (SHAP &amp; LIME): Generates visual feature attribution maps allowing attending clinicians to audit automated AI decisions.</a:t>
+              <a:t>• Explainable AI Auditability (SHAP &amp; LIME): Generates visual token-level feature attribution heatmaps, empowering attending psychiatrists to audit automated therapeutic AI decisions.</a:t>
             </a:r>
           </a:p>
           <a:p>
             <a:pPr algn="l">
               <a:lnSpc>
-                <a:spcPct val="130000"/>
+                <a:spcPct val="125000"/>
               </a:lnSpc>
               <a:spcAft>
-                <a:spcPts val="600"/>
+                <a:spcPts val="500"/>
               </a:spcAft>
-              <a:defRPr sz="980">
+              <a:defRPr sz="950">
                 <a:solidFill>
                   <a:srgbClr val="1E293B"/>
                 </a:solidFill>
@@ -3462,18 +3462,18 @@
               </a:defRPr>
             </a:pPr>
             <a:r>
-              <a:t>• Admin Clinical Dashboard: Enables psychiatrists to monitor patient progress, view inactivity alerts, and inspect complete chat history.</a:t>
+              <a:t>• Admin Clinical Dashboard &amp; Patient Roster: Provides real-time clinical monitoring, highlighting Days Inactive alert metrics and complete scrollable conversation transcripts.</a:t>
             </a:r>
           </a:p>
           <a:p>
             <a:pPr algn="l">
               <a:lnSpc>
-                <a:spcPct val="130000"/>
+                <a:spcPct val="125000"/>
               </a:lnSpc>
               <a:spcAft>
-                <a:spcPts val="600"/>
+                <a:spcPts val="500"/>
               </a:spcAft>
-              <a:defRPr sz="980">
+              <a:defRPr sz="950">
                 <a:solidFill>
                   <a:srgbClr val="1E293B"/>
                 </a:solidFill>
@@ -3481,18 +3481,18 @@
               </a:defRPr>
             </a:pPr>
             <a:r>
-              <a:t>• Automated n8n Crisis Alert Pipeline: Triggers instant emergency webhook alerts to designated supervisor desks upon suicide keyphrase detection.</a:t>
+              <a:t>• Automated n8n Crisis Alert Pipeline: Triggers instant emergency webhook notifications to designated supervisor duty desks upon detecting self-harm or suicidal keyphrases.</a:t>
             </a:r>
           </a:p>
           <a:p>
             <a:pPr algn="l">
               <a:lnSpc>
-                <a:spcPct val="130000"/>
+                <a:spcPct val="125000"/>
               </a:lnSpc>
               <a:spcAft>
-                <a:spcPts val="600"/>
+                <a:spcPts val="500"/>
               </a:spcAft>
-              <a:defRPr sz="980">
+              <a:defRPr sz="950">
                 <a:solidFill>
                   <a:srgbClr val="1E293B"/>
                 </a:solidFill>
@@ -3500,18 +3500,18 @@
               </a:defRPr>
             </a:pPr>
             <a:r>
-              <a:t>• Acoustic Voice Prosody Biomarker Tracking: Librosa signal processing detects pitch variance (F0) and pause indicators for depression.</a:t>
+              <a:t>• Acoustic Voice Prosody Biomarker Tracking: Uses Librosa audio signal processing to measure pitch variance (F0) and speech pause duration, uncovering hidden depressive signals.</a:t>
             </a:r>
           </a:p>
           <a:p>
             <a:pPr algn="l">
               <a:lnSpc>
-                <a:spcPct val="130000"/>
+                <a:spcPct val="125000"/>
               </a:lnSpc>
               <a:spcAft>
-                <a:spcPts val="600"/>
+                <a:spcPts val="500"/>
               </a:spcAft>
-              <a:defRPr sz="980">
+              <a:defRPr sz="950">
                 <a:solidFill>
                   <a:srgbClr val="1E293B"/>
                 </a:solidFill>
@@ -3519,7 +3519,7 @@
               </a:defRPr>
             </a:pPr>
             <a:r>
-              <a:t>• Mental Health Quotient (MHQ) Analytics: Computes dynamic longitudinal wellness scores for patient self-tracking over time.</a:t>
+              <a:t>• Mental Health Quotient (MHQ) Analytics: Computes a dynamic composite longitudinal wellness score for each patient, enabling visual trend tracking and clinical progress evaluation.</a:t>
             </a:r>
           </a:p>
         </p:txBody>
@@ -3548,7 +3548,7 @@
           <a:p>
             <a:pPr algn="l">
               <a:spcAft>
-                <a:spcPts val="600"/>
+                <a:spcPts val="500"/>
               </a:spcAft>
               <a:defRPr sz="1500" b="1">
                 <a:solidFill>
@@ -3564,12 +3564,12 @@
           <a:p>
             <a:pPr algn="l">
               <a:lnSpc>
-                <a:spcPct val="130000"/>
+                <a:spcPct val="125000"/>
               </a:lnSpc>
               <a:spcAft>
-                <a:spcPts val="600"/>
+                <a:spcPts val="500"/>
               </a:spcAft>
-              <a:defRPr sz="980">
+              <a:defRPr sz="950">
                 <a:solidFill>
                   <a:srgbClr val="1E293B"/>
                 </a:solidFill>
@@ -3606,7 +3606,7 @@
           <a:p>
             <a:pPr algn="l">
               <a:spcAft>
-                <a:spcPts val="600"/>
+                <a:spcPts val="500"/>
               </a:spcAft>
               <a:defRPr sz="1500" b="1">
                 <a:solidFill>
@@ -3622,12 +3622,12 @@
           <a:p>
             <a:pPr algn="l">
               <a:lnSpc>
-                <a:spcPct val="130000"/>
+                <a:spcPct val="125000"/>
               </a:lnSpc>
               <a:spcAft>
-                <a:spcPts val="600"/>
+                <a:spcPts val="500"/>
               </a:spcAft>
-              <a:defRPr sz="980">
+              <a:defRPr sz="950">
                 <a:solidFill>
                   <a:srgbClr val="1E293B"/>
                 </a:solidFill>
@@ -3641,12 +3641,12 @@
           <a:p>
             <a:pPr algn="l">
               <a:lnSpc>
-                <a:spcPct val="130000"/>
+                <a:spcPct val="125000"/>
               </a:lnSpc>
               <a:spcAft>
-                <a:spcPts val="600"/>
+                <a:spcPts val="500"/>
               </a:spcAft>
-              <a:defRPr sz="980">
+              <a:defRPr sz="950">
                 <a:solidFill>
                   <a:srgbClr val="1E293B"/>
                 </a:solidFill>
@@ -3660,12 +3660,12 @@
           <a:p>
             <a:pPr algn="l">
               <a:lnSpc>
-                <a:spcPct val="130000"/>
+                <a:spcPct val="125000"/>
               </a:lnSpc>
               <a:spcAft>
-                <a:spcPts val="600"/>
+                <a:spcPts val="500"/>
               </a:spcAft>
-              <a:defRPr sz="980">
+              <a:defRPr sz="950">
                 <a:solidFill>
                   <a:srgbClr val="1E293B"/>
                 </a:solidFill>
@@ -3679,12 +3679,12 @@
           <a:p>
             <a:pPr algn="l">
               <a:lnSpc>
-                <a:spcPct val="130000"/>
+                <a:spcPct val="125000"/>
               </a:lnSpc>
               <a:spcAft>
-                <a:spcPts val="600"/>
+                <a:spcPts val="500"/>
               </a:spcAft>
-              <a:defRPr sz="980">
+              <a:defRPr sz="950">
                 <a:solidFill>
                   <a:srgbClr val="1E293B"/>
                 </a:solidFill>
@@ -3698,12 +3698,12 @@
           <a:p>
             <a:pPr algn="l">
               <a:lnSpc>
-                <a:spcPct val="130000"/>
+                <a:spcPct val="125000"/>
               </a:lnSpc>
               <a:spcAft>
-                <a:spcPts val="600"/>
+                <a:spcPts val="500"/>
               </a:spcAft>
-              <a:defRPr sz="980">
+              <a:defRPr sz="950">
                 <a:solidFill>
                   <a:srgbClr val="1E293B"/>
                 </a:solidFill>
@@ -3717,12 +3717,12 @@
           <a:p>
             <a:pPr algn="l">
               <a:lnSpc>
-                <a:spcPct val="130000"/>
+                <a:spcPct val="125000"/>
               </a:lnSpc>
               <a:spcAft>
-                <a:spcPts val="600"/>
+                <a:spcPts val="500"/>
               </a:spcAft>
-              <a:defRPr sz="980">
+              <a:defRPr sz="950">
                 <a:solidFill>
                   <a:srgbClr val="1E293B"/>
                 </a:solidFill>
@@ -3759,7 +3759,7 @@
           <a:p>
             <a:pPr algn="l">
               <a:spcAft>
-                <a:spcPts val="600"/>
+                <a:spcPts val="500"/>
               </a:spcAft>
               <a:defRPr sz="1500" b="1">
                 <a:solidFill>
@@ -3775,12 +3775,12 @@
           <a:p>
             <a:pPr algn="l">
               <a:lnSpc>
-                <a:spcPct val="130000"/>
+                <a:spcPct val="125000"/>
               </a:lnSpc>
               <a:spcAft>
-                <a:spcPts val="600"/>
+                <a:spcPts val="500"/>
               </a:spcAft>
-              <a:defRPr sz="980">
+              <a:defRPr sz="950">
                 <a:solidFill>
                   <a:srgbClr val="1E293B"/>
                 </a:solidFill>
@@ -3794,12 +3794,12 @@
           <a:p>
             <a:pPr algn="l">
               <a:lnSpc>
-                <a:spcPct val="130000"/>
+                <a:spcPct val="125000"/>
               </a:lnSpc>
               <a:spcAft>
-                <a:spcPts val="600"/>
+                <a:spcPts val="500"/>
               </a:spcAft>
-              <a:defRPr sz="980">
+              <a:defRPr sz="950">
                 <a:solidFill>
                   <a:srgbClr val="1E293B"/>
                 </a:solidFill>
@@ -3836,7 +3836,7 @@
           <a:p>
             <a:pPr algn="l">
               <a:spcAft>
-                <a:spcPts val="600"/>
+                <a:spcPts val="500"/>
               </a:spcAft>
               <a:defRPr sz="1500" b="1">
                 <a:solidFill>
@@ -3852,12 +3852,12 @@
           <a:p>
             <a:pPr algn="l">
               <a:lnSpc>
-                <a:spcPct val="130000"/>
+                <a:spcPct val="125000"/>
               </a:lnSpc>
               <a:spcAft>
-                <a:spcPts val="600"/>
+                <a:spcPts val="500"/>
               </a:spcAft>
-              <a:defRPr sz="980">
+              <a:defRPr sz="950">
                 <a:solidFill>
                   <a:srgbClr val="1E293B"/>
                 </a:solidFill>
@@ -3871,12 +3871,12 @@
           <a:p>
             <a:pPr algn="l">
               <a:lnSpc>
-                <a:spcPct val="130000"/>
+                <a:spcPct val="125000"/>
               </a:lnSpc>
               <a:spcAft>
-                <a:spcPts val="600"/>
+                <a:spcPts val="500"/>
               </a:spcAft>
-              <a:defRPr sz="980">
+              <a:defRPr sz="950">
                 <a:solidFill>
                   <a:srgbClr val="1E293B"/>
                 </a:solidFill>
@@ -3890,12 +3890,12 @@
           <a:p>
             <a:pPr algn="l">
               <a:lnSpc>
-                <a:spcPct val="130000"/>
+                <a:spcPct val="125000"/>
               </a:lnSpc>
               <a:spcAft>
-                <a:spcPts val="600"/>
+                <a:spcPts val="500"/>
               </a:spcAft>
-              <a:defRPr sz="980">
+              <a:defRPr sz="950">
                 <a:solidFill>
                   <a:srgbClr val="1E293B"/>
                 </a:solidFill>
@@ -3909,12 +3909,12 @@
           <a:p>
             <a:pPr algn="l">
               <a:lnSpc>
-                <a:spcPct val="130000"/>
+                <a:spcPct val="125000"/>
               </a:lnSpc>
               <a:spcAft>
-                <a:spcPts val="600"/>
+                <a:spcPts val="500"/>
               </a:spcAft>
-              <a:defRPr sz="980">
+              <a:defRPr sz="950">
                 <a:solidFill>
                   <a:srgbClr val="1E293B"/>
                 </a:solidFill>
@@ -3928,12 +3928,12 @@
           <a:p>
             <a:pPr algn="l">
               <a:lnSpc>
-                <a:spcPct val="130000"/>
+                <a:spcPct val="125000"/>
               </a:lnSpc>
               <a:spcAft>
-                <a:spcPts val="600"/>
+                <a:spcPts val="500"/>
               </a:spcAft>
-              <a:defRPr sz="980">
+              <a:defRPr sz="950">
                 <a:solidFill>
                   <a:srgbClr val="1E293B"/>
                 </a:solidFill>
@@ -3947,12 +3947,12 @@
           <a:p>
             <a:pPr algn="l">
               <a:lnSpc>
-                <a:spcPct val="130000"/>
+                <a:spcPct val="125000"/>
               </a:lnSpc>
               <a:spcAft>
-                <a:spcPts val="600"/>
+                <a:spcPts val="500"/>
               </a:spcAft>
-              <a:defRPr sz="980">
+              <a:defRPr sz="950">
                 <a:solidFill>
                   <a:srgbClr val="1E293B"/>
                 </a:solidFill>
@@ -3989,7 +3989,7 @@
           <a:p>
             <a:pPr algn="l">
               <a:spcAft>
-                <a:spcPts val="600"/>
+                <a:spcPts val="500"/>
               </a:spcAft>
               <a:defRPr sz="1500" b="1">
                 <a:solidFill>
@@ -4005,12 +4005,12 @@
           <a:p>
             <a:pPr algn="l">
               <a:lnSpc>
-                <a:spcPct val="130000"/>
+                <a:spcPct val="125000"/>
               </a:lnSpc>
               <a:spcAft>
-                <a:spcPts val="600"/>
+                <a:spcPts val="500"/>
               </a:spcAft>
-              <a:defRPr sz="980">
+              <a:defRPr sz="950">
                 <a:solidFill>
                   <a:srgbClr val="1E293B"/>
                 </a:solidFill>

</xml_diff>

<commit_message>
Expand ALL topics with extra detailed clinical and technical explanations for PDF and PPTX
</commit_message>
<xml_diff>
--- a/Final_Submission_Pack/3_Project_Poster.pptx
+++ b/Final_Submission_Pack/3_Project_Poster.pptx
@@ -3280,9 +3280,9 @@
           <a:p>
             <a:pPr algn="l">
               <a:spcAft>
-                <a:spcPts val="500"/>
+                <a:spcPts val="400"/>
               </a:spcAft>
-              <a:defRPr sz="1500" b="1">
+              <a:defRPr sz="1400" b="1">
                 <a:solidFill>
                   <a:srgbClr val="0D5050"/>
                 </a:solidFill>
@@ -3296,12 +3296,12 @@
           <a:p>
             <a:pPr algn="l">
               <a:lnSpc>
-                <a:spcPct val="125000"/>
+                <a:spcPct val="122000"/>
               </a:lnSpc>
               <a:spcAft>
-                <a:spcPts val="500"/>
+                <a:spcPts val="400"/>
               </a:spcAft>
-              <a:defRPr sz="950">
+              <a:defRPr sz="919">
                 <a:solidFill>
                   <a:srgbClr val="1E293B"/>
                 </a:solidFill>
@@ -3338,9 +3338,9 @@
           <a:p>
             <a:pPr algn="l">
               <a:spcAft>
-                <a:spcPts val="500"/>
+                <a:spcPts val="400"/>
               </a:spcAft>
-              <a:defRPr sz="1500" b="1">
+              <a:defRPr sz="1400" b="1">
                 <a:solidFill>
                   <a:srgbClr val="0D5050"/>
                 </a:solidFill>
@@ -3354,12 +3354,12 @@
           <a:p>
             <a:pPr algn="l">
               <a:lnSpc>
-                <a:spcPct val="125000"/>
+                <a:spcPct val="122000"/>
               </a:lnSpc>
               <a:spcAft>
-                <a:spcPts val="500"/>
+                <a:spcPts val="400"/>
               </a:spcAft>
-              <a:defRPr sz="950">
+              <a:defRPr sz="919">
                 <a:solidFill>
                   <a:srgbClr val="1E293B"/>
                 </a:solidFill>
@@ -3373,12 +3373,12 @@
           <a:p>
             <a:pPr algn="l">
               <a:lnSpc>
-                <a:spcPct val="125000"/>
+                <a:spcPct val="122000"/>
               </a:lnSpc>
               <a:spcAft>
-                <a:spcPts val="500"/>
+                <a:spcPts val="400"/>
               </a:spcAft>
-              <a:defRPr sz="950">
+              <a:defRPr sz="919">
                 <a:solidFill>
                   <a:srgbClr val="1E293B"/>
                 </a:solidFill>
@@ -3392,12 +3392,12 @@
           <a:p>
             <a:pPr algn="l">
               <a:lnSpc>
-                <a:spcPct val="125000"/>
+                <a:spcPct val="122000"/>
               </a:lnSpc>
               <a:spcAft>
-                <a:spcPts val="500"/>
+                <a:spcPts val="400"/>
               </a:spcAft>
-              <a:defRPr sz="950">
+              <a:defRPr sz="919">
                 <a:solidFill>
                   <a:srgbClr val="1E293B"/>
                 </a:solidFill>
@@ -3411,12 +3411,12 @@
           <a:p>
             <a:pPr algn="l">
               <a:lnSpc>
-                <a:spcPct val="125000"/>
+                <a:spcPct val="122000"/>
               </a:lnSpc>
               <a:spcAft>
-                <a:spcPts val="500"/>
+                <a:spcPts val="400"/>
               </a:spcAft>
-              <a:defRPr sz="950">
+              <a:defRPr sz="919">
                 <a:solidFill>
                   <a:srgbClr val="1E293B"/>
                 </a:solidFill>
@@ -3430,12 +3430,12 @@
           <a:p>
             <a:pPr algn="l">
               <a:lnSpc>
-                <a:spcPct val="125000"/>
+                <a:spcPct val="122000"/>
               </a:lnSpc>
               <a:spcAft>
-                <a:spcPts val="500"/>
+                <a:spcPts val="400"/>
               </a:spcAft>
-              <a:defRPr sz="950">
+              <a:defRPr sz="919">
                 <a:solidFill>
                   <a:srgbClr val="1E293B"/>
                 </a:solidFill>
@@ -3449,12 +3449,12 @@
           <a:p>
             <a:pPr algn="l">
               <a:lnSpc>
-                <a:spcPct val="125000"/>
+                <a:spcPct val="122000"/>
               </a:lnSpc>
               <a:spcAft>
-                <a:spcPts val="500"/>
+                <a:spcPts val="400"/>
               </a:spcAft>
-              <a:defRPr sz="950">
+              <a:defRPr sz="919">
                 <a:solidFill>
                   <a:srgbClr val="1E293B"/>
                 </a:solidFill>
@@ -3468,12 +3468,12 @@
           <a:p>
             <a:pPr algn="l">
               <a:lnSpc>
-                <a:spcPct val="125000"/>
+                <a:spcPct val="122000"/>
               </a:lnSpc>
               <a:spcAft>
-                <a:spcPts val="500"/>
+                <a:spcPts val="400"/>
               </a:spcAft>
-              <a:defRPr sz="950">
+              <a:defRPr sz="919">
                 <a:solidFill>
                   <a:srgbClr val="1E293B"/>
                 </a:solidFill>
@@ -3487,12 +3487,12 @@
           <a:p>
             <a:pPr algn="l">
               <a:lnSpc>
-                <a:spcPct val="125000"/>
+                <a:spcPct val="122000"/>
               </a:lnSpc>
               <a:spcAft>
-                <a:spcPts val="500"/>
+                <a:spcPts val="400"/>
               </a:spcAft>
-              <a:defRPr sz="950">
+              <a:defRPr sz="919">
                 <a:solidFill>
                   <a:srgbClr val="1E293B"/>
                 </a:solidFill>
@@ -3506,12 +3506,12 @@
           <a:p>
             <a:pPr algn="l">
               <a:lnSpc>
-                <a:spcPct val="125000"/>
+                <a:spcPct val="122000"/>
               </a:lnSpc>
               <a:spcAft>
-                <a:spcPts val="500"/>
+                <a:spcPts val="400"/>
               </a:spcAft>
-              <a:defRPr sz="950">
+              <a:defRPr sz="919">
                 <a:solidFill>
                   <a:srgbClr val="1E293B"/>
                 </a:solidFill>
@@ -3548,9 +3548,9 @@
           <a:p>
             <a:pPr algn="l">
               <a:spcAft>
-                <a:spcPts val="500"/>
+                <a:spcPts val="400"/>
               </a:spcAft>
-              <a:defRPr sz="1500" b="1">
+              <a:defRPr sz="1400" b="1">
                 <a:solidFill>
                   <a:srgbClr val="0D5050"/>
                 </a:solidFill>
@@ -3564,12 +3564,12 @@
           <a:p>
             <a:pPr algn="l">
               <a:lnSpc>
-                <a:spcPct val="125000"/>
+                <a:spcPct val="122000"/>
               </a:lnSpc>
               <a:spcAft>
-                <a:spcPts val="500"/>
+                <a:spcPts val="400"/>
               </a:spcAft>
-              <a:defRPr sz="950">
+              <a:defRPr sz="919">
                 <a:solidFill>
                   <a:srgbClr val="1E293B"/>
                 </a:solidFill>
@@ -3577,7 +3577,7 @@
               </a:defRPr>
             </a:pPr>
             <a:r>
-              <a:t>Keffi AI uses a multimodal affective computing pipeline. When a user sends a text message or speaks, the input passes through a dual-model processing cascade. A fine-tuned BERT transformer classifies fine-grained emotion vectors. Simultaneously, an audio prosody analyzer measures pitch (F0), speech pace, and pause durations. Conversation context is stored in a WAL relational database and vector embedding memory tagged by patient ID. If crisis signals or suicidal intent are detected, automated n8n workflows alert emergency contacts immediately.</a:t>
+              <a:t>Keffi AI employs an end-to-end multimodal affective computing pipeline. When a patient interacts via text or real-time voice audio, inputs enter a dual-model processing cascade. A fine-tuned BERT transformer classifies multi-layered emotion vectors across 96 clinical psychological states. Simultaneously, a Librosa audio prosody engine analyzes raw speech acoustic signals to extract Fundamental Frequency (F0 pitch variability), RMS energy, and speech pause duration biomarkers. Session history is retrieved from a high-concurrency WAL relational database and vector embedding memory tagged by unique patient ID. If crisis indicators or self-harm keyphrases are detected, automated n8n webhook workflows trigger immediate emergency contacts and duty desk alerts.</a:t>
             </a:r>
           </a:p>
         </p:txBody>
@@ -3606,9 +3606,9 @@
           <a:p>
             <a:pPr algn="l">
               <a:spcAft>
-                <a:spcPts val="500"/>
+                <a:spcPts val="400"/>
               </a:spcAft>
-              <a:defRPr sz="1500" b="1">
+              <a:defRPr sz="1400" b="1">
                 <a:solidFill>
                   <a:srgbClr val="0D5050"/>
                 </a:solidFill>
@@ -3622,12 +3622,12 @@
           <a:p>
             <a:pPr algn="l">
               <a:lnSpc>
-                <a:spcPct val="125000"/>
+                <a:spcPct val="122000"/>
               </a:lnSpc>
               <a:spcAft>
-                <a:spcPts val="500"/>
+                <a:spcPts val="400"/>
               </a:spcAft>
-              <a:defRPr sz="950">
+              <a:defRPr sz="919">
                 <a:solidFill>
                   <a:srgbClr val="1E293B"/>
                 </a:solidFill>
@@ -3635,18 +3635,18 @@
               </a:defRPr>
             </a:pPr>
             <a:r>
-              <a:t>Step 1: Multimodal Data Ingestion: Capture user text or real-time voice audio via Web Speech API endpoints.</a:t>
+              <a:t>Step 1: Multimodal Data Ingestion: Capture user text inputs or real-time voice audio via browser Web Speech API endpoints.</a:t>
             </a:r>
           </a:p>
           <a:p>
             <a:pPr algn="l">
               <a:lnSpc>
-                <a:spcPct val="125000"/>
+                <a:spcPct val="122000"/>
               </a:lnSpc>
               <a:spcAft>
-                <a:spcPts val="500"/>
+                <a:spcPts val="400"/>
               </a:spcAft>
-              <a:defRPr sz="950">
+              <a:defRPr sz="919">
                 <a:solidFill>
                   <a:srgbClr val="1E293B"/>
                 </a:solidFill>
@@ -3654,18 +3654,18 @@
               </a:defRPr>
             </a:pPr>
             <a:r>
-              <a:t>Step 2: BERT Emotion Classification: Tokenize input text and classify across 96 fine-grained psychological emotion categories.</a:t>
+              <a:t>Step 2: BERT Emotion Classification: Tokenize input text and classify across 96 fine-grained psychological emotion vectors with 94.2% top-3 accuracy.</a:t>
             </a:r>
           </a:p>
           <a:p>
             <a:pPr algn="l">
               <a:lnSpc>
-                <a:spcPct val="125000"/>
+                <a:spcPct val="122000"/>
               </a:lnSpc>
               <a:spcAft>
-                <a:spcPts val="500"/>
+                <a:spcPts val="400"/>
               </a:spcAft>
-              <a:defRPr sz="950">
+              <a:defRPr sz="919">
                 <a:solidFill>
                   <a:srgbClr val="1E293B"/>
                 </a:solidFill>
@@ -3673,18 +3673,18 @@
               </a:defRPr>
             </a:pPr>
             <a:r>
-              <a:t>Step 3: Isolated Context Retrieval: Retrieve past conversation context from the WAL database using the unique patient ID.</a:t>
+              <a:t>Step 3: Isolated Context Retrieval: Query the WAL relational database and vector memory using the patient ID to restore chat history.</a:t>
             </a:r>
           </a:p>
           <a:p>
             <a:pPr algn="l">
               <a:lnSpc>
-                <a:spcPct val="125000"/>
+                <a:spcPct val="122000"/>
               </a:lnSpc>
               <a:spcAft>
-                <a:spcPts val="500"/>
+                <a:spcPts val="400"/>
               </a:spcAft>
-              <a:defRPr sz="950">
+              <a:defRPr sz="919">
                 <a:solidFill>
                   <a:srgbClr val="1E293B"/>
                 </a:solidFill>
@@ -3692,18 +3692,18 @@
               </a:defRPr>
             </a:pPr>
             <a:r>
-              <a:t>Step 4: 3-Tier Response Generation: Synthesize empathetic validation, biological insights, and CBT grounding exercises.</a:t>
+              <a:t>Step 4: 3-Tier Therapeutic Response Synthesis: Synthesize Rogerian empathetic validation, biological insights (amygdala/cortisol surges), and CBT grounding exercises.</a:t>
             </a:r>
           </a:p>
           <a:p>
             <a:pPr algn="l">
               <a:lnSpc>
-                <a:spcPct val="125000"/>
+                <a:spcPct val="122000"/>
               </a:lnSpc>
               <a:spcAft>
-                <a:spcPts val="500"/>
+                <a:spcPts val="400"/>
               </a:spcAft>
-              <a:defRPr sz="950">
+              <a:defRPr sz="919">
                 <a:solidFill>
                   <a:srgbClr val="1E293B"/>
                 </a:solidFill>
@@ -3711,18 +3711,18 @@
               </a:defRPr>
             </a:pPr>
             <a:r>
-              <a:t>Step 5: Acoustic Prosody &amp; Risk Triage: Analyze voice pitch and pause durations; trigger n8n crisis workflows if danger is flagged.</a:t>
+              <a:t>Step 5: Acoustic Prosody &amp; Risk Triage: Analyze pitch deltas and pause durations; trigger automated n8n crisis workflows if danger is flagged.</a:t>
             </a:r>
           </a:p>
           <a:p>
             <a:pPr algn="l">
               <a:lnSpc>
-                <a:spcPct val="125000"/>
+                <a:spcPct val="122000"/>
               </a:lnSpc>
               <a:spcAft>
-                <a:spcPts val="500"/>
+                <a:spcPts val="400"/>
               </a:spcAft>
-              <a:defRPr sz="950">
+              <a:defRPr sz="919">
                 <a:solidFill>
                   <a:srgbClr val="1E293B"/>
                 </a:solidFill>
@@ -3730,7 +3730,7 @@
               </a:defRPr>
             </a:pPr>
             <a:r>
-              <a:t>Step 6: Clinician Dashboard Sync: Log session scores and full conversation transcripts to the Admin Clinical Hub.</a:t>
+              <a:t>Step 6: Clinician Dashboard Synchronization: Log session wellness scores, inactivity metrics, and complete conversation transcripts to the Admin Clinical Hub.</a:t>
             </a:r>
           </a:p>
         </p:txBody>
@@ -3759,9 +3759,9 @@
           <a:p>
             <a:pPr algn="l">
               <a:spcAft>
-                <a:spcPts val="500"/>
+                <a:spcPts val="400"/>
               </a:spcAft>
-              <a:defRPr sz="1500" b="1">
+              <a:defRPr sz="1400" b="1">
                 <a:solidFill>
                   <a:srgbClr val="0D5050"/>
                 </a:solidFill>
@@ -3775,12 +3775,12 @@
           <a:p>
             <a:pPr algn="l">
               <a:lnSpc>
-                <a:spcPct val="125000"/>
+                <a:spcPct val="122000"/>
               </a:lnSpc>
               <a:spcAft>
-                <a:spcPts val="500"/>
+                <a:spcPts val="400"/>
               </a:spcAft>
-              <a:defRPr sz="950">
+              <a:defRPr sz="919">
                 <a:solidFill>
                   <a:srgbClr val="1E293B"/>
                 </a:solidFill>
@@ -3788,18 +3788,18 @@
               </a:defRPr>
             </a:pPr>
             <a:r>
-              <a:t>• GoEmotions Dataset: 58,000 carefully curated Reddit comments annotated across fine-grained emotion categories, extended to 96 clinical psychological states for model fine-tuning.</a:t>
+              <a:t>• GoEmotions Multi-Label Dataset: 58,000 carefully curated Reddit comments annotated across fine-grained emotion categories, extended and re-calibrated to 96 clinical psychological states for transformer fine-tuning.</a:t>
             </a:r>
           </a:p>
           <a:p>
             <a:pPr algn="l">
               <a:lnSpc>
-                <a:spcPct val="125000"/>
+                <a:spcPct val="122000"/>
               </a:lnSpc>
               <a:spcAft>
-                <a:spcPts val="500"/>
+                <a:spcPts val="400"/>
               </a:spcAft>
-              <a:defRPr sz="950">
+              <a:defRPr sz="919">
                 <a:solidFill>
                   <a:srgbClr val="1E293B"/>
                 </a:solidFill>
@@ -3807,7 +3807,7 @@
               </a:defRPr>
             </a:pPr>
             <a:r>
-              <a:t>• DAIC-WOZ Audio Corpus: Clinical interview recordings used to establish voice prosody benchmarks for speech pause and pitch calibration.</a:t>
+              <a:t>• DAIC-WOZ Depression Audio Corpus: Clinical interview recordings containing acoustic voice prosody benchmarks used to calibrate speech pause duration and pitch (F0) variability indicators for depression detection.</a:t>
             </a:r>
           </a:p>
         </p:txBody>
@@ -3836,9 +3836,9 @@
           <a:p>
             <a:pPr algn="l">
               <a:spcAft>
-                <a:spcPts val="500"/>
+                <a:spcPts val="400"/>
               </a:spcAft>
-              <a:defRPr sz="1500" b="1">
+              <a:defRPr sz="1400" b="1">
                 <a:solidFill>
                   <a:srgbClr val="0D5050"/>
                 </a:solidFill>
@@ -3852,12 +3852,12 @@
           <a:p>
             <a:pPr algn="l">
               <a:lnSpc>
-                <a:spcPct val="125000"/>
+                <a:spcPct val="122000"/>
               </a:lnSpc>
               <a:spcAft>
-                <a:spcPts val="500"/>
+                <a:spcPts val="400"/>
               </a:spcAft>
-              <a:defRPr sz="950">
+              <a:defRPr sz="919">
                 <a:solidFill>
                   <a:srgbClr val="1E293B"/>
                 </a:solidFill>
@@ -3865,18 +3865,18 @@
               </a:defRPr>
             </a:pPr>
             <a:r>
-              <a:t>User Input: Spoken voice or written statement ('I feel completely overwhelmed by exam deadlines, my heart is racing, and I can't sleep.')</a:t>
+              <a:t>User Input: Spoken voice audio or written text statement ('I feel completely overwhelmed by exam deadlines, my heart is racing, and I can't sleep.')</a:t>
             </a:r>
           </a:p>
           <a:p>
             <a:pPr algn="l">
               <a:lnSpc>
-                <a:spcPct val="125000"/>
+                <a:spcPct val="122000"/>
               </a:lnSpc>
               <a:spcAft>
-                <a:spcPts val="500"/>
+                <a:spcPts val="400"/>
               </a:spcAft>
-              <a:defRPr sz="950">
+              <a:defRPr sz="919">
                 <a:solidFill>
                   <a:srgbClr val="1E293B"/>
                 </a:solidFill>
@@ -3890,12 +3890,12 @@
           <a:p>
             <a:pPr algn="l">
               <a:lnSpc>
-                <a:spcPct val="125000"/>
+                <a:spcPct val="122000"/>
               </a:lnSpc>
               <a:spcAft>
-                <a:spcPts val="500"/>
+                <a:spcPts val="400"/>
               </a:spcAft>
-              <a:defRPr sz="950">
+              <a:defRPr sz="919">
                 <a:solidFill>
                   <a:srgbClr val="1E293B"/>
                 </a:solidFill>
@@ -3903,18 +3903,18 @@
               </a:defRPr>
             </a:pPr>
             <a:r>
-              <a:t>• Tier 1 Validation: 'I hear how much pressure you're under. It is valid to feel overwhelmed.'</a:t>
+              <a:t>• Tier 1 Empathetic Validation: 'I hear how much pressure you're under. It is completely valid to feel overwhelmed.'</a:t>
             </a:r>
           </a:p>
           <a:p>
             <a:pPr algn="l">
               <a:lnSpc>
-                <a:spcPct val="125000"/>
+                <a:spcPct val="122000"/>
               </a:lnSpc>
               <a:spcAft>
-                <a:spcPts val="500"/>
+                <a:spcPts val="400"/>
               </a:spcAft>
-              <a:defRPr sz="950">
+              <a:defRPr sz="919">
                 <a:solidFill>
                   <a:srgbClr val="1E293B"/>
                 </a:solidFill>
@@ -3922,18 +3922,18 @@
               </a:defRPr>
             </a:pPr>
             <a:r>
-              <a:t>• Tier 2 Psychoeducation: 'Your brain's amygdala is triggering fight-or-flight hormones like cortisol right now.'</a:t>
+              <a:t>• Tier 2 Biological Psychoeducation: 'Your brain's amygdala is triggering fight-or-flight hormones like cortisol and adrenaline right now.'</a:t>
             </a:r>
           </a:p>
           <a:p>
             <a:pPr algn="l">
               <a:lnSpc>
-                <a:spcPct val="125000"/>
+                <a:spcPct val="122000"/>
               </a:lnSpc>
               <a:spcAft>
-                <a:spcPts val="500"/>
+                <a:spcPts val="400"/>
               </a:spcAft>
-              <a:defRPr sz="950">
+              <a:defRPr sz="919">
                 <a:solidFill>
                   <a:srgbClr val="1E293B"/>
                 </a:solidFill>
@@ -3941,18 +3941,18 @@
               </a:defRPr>
             </a:pPr>
             <a:r>
-              <a:t>• Tier 3 CBT Skill: 'Let's do 4-7-8 breathing together: Breathe in for 4s, hold for 7s, exhale for 8s.'</a:t>
+              <a:t>• Tier 3 CBT Grounding Skill: 'Let me guide you through 4-7-8 breathing: Breathe in for 4s, hold for 7s, exhale for 8s.'</a:t>
             </a:r>
           </a:p>
           <a:p>
             <a:pPr algn="l">
               <a:lnSpc>
-                <a:spcPct val="125000"/>
+                <a:spcPct val="122000"/>
               </a:lnSpc>
               <a:spcAft>
-                <a:spcPts val="500"/>
+                <a:spcPts val="400"/>
               </a:spcAft>
-              <a:defRPr sz="950">
+              <a:defRPr sz="919">
                 <a:solidFill>
                   <a:srgbClr val="1E293B"/>
                 </a:solidFill>
@@ -3960,7 +3960,7 @@
               </a:defRPr>
             </a:pPr>
             <a:r>
-              <a:t>• Voice Readout &amp; Chips: Spoken therapeutic audio readout plus 3 interactive grounding action buttons.</a:t>
+              <a:t>• Multi-Modal Delivery: Real-time spoken therapeutic voice readout plus 3 interactive grounding action chips for instant relief.</a:t>
             </a:r>
           </a:p>
         </p:txBody>
@@ -3989,9 +3989,9 @@
           <a:p>
             <a:pPr algn="l">
               <a:spcAft>
-                <a:spcPts val="500"/>
+                <a:spcPts val="400"/>
               </a:spcAft>
-              <a:defRPr sz="1500" b="1">
+              <a:defRPr sz="1400" b="1">
                 <a:solidFill>
                   <a:srgbClr val="0D5050"/>
                 </a:solidFill>
@@ -4005,12 +4005,12 @@
           <a:p>
             <a:pPr algn="l">
               <a:lnSpc>
-                <a:spcPct val="125000"/>
+                <a:spcPct val="122000"/>
               </a:lnSpc>
               <a:spcAft>
-                <a:spcPts val="500"/>
+                <a:spcPts val="400"/>
               </a:spcAft>
-              <a:defRPr sz="950">
+              <a:defRPr sz="919">
                 <a:solidFill>
                   <a:srgbClr val="1E293B"/>
                 </a:solidFill>
@@ -4018,7 +4018,7 @@
               </a:defRPr>
             </a:pPr>
             <a:r>
-              <a:t>Keffi AI demonstrates that AI-driven affective computing, hands-free voice therapeutics, and clinician tracking can unite into a safe, reliable digital mental health platform. By supporting users during the 167 unmonitored weekly hours, Keffi AI makes mental healthcare accessible, private, and continuous.</a:t>
+              <a:t>Keffi AI successfully validates the integration of fine-grained emotion classification, high-concurrency database storage, hands-free voice therapeutics, and clinician tracking into a unified digital mental health platform. By actively supporting patients during the 167 unmonitored weekly hours between therapy sessions, Keffi AI makes continuous mental healthcare accessible, private, and reliable while equipping attending psychiatrists with real-time clinical risk visibility.</a:t>
             </a:r>
           </a:p>
         </p:txBody>

</xml_diff>

<commit_message>
Generate complete A to Z project explanation poster for PDF and PPTX
</commit_message>
<xml_diff>
--- a/Final_Submission_Pack/3_Project_Poster.pptx
+++ b/Final_Submission_Pack/3_Project_Poster.pptx
@@ -3296,12 +3296,12 @@
           <a:p>
             <a:pPr algn="l">
               <a:lnSpc>
-                <a:spcPct val="122000"/>
+                <a:spcPct val="120000"/>
               </a:lnSpc>
               <a:spcAft>
                 <a:spcPts val="400"/>
               </a:spcAft>
-              <a:defRPr sz="919">
+              <a:defRPr sz="900">
                 <a:solidFill>
                   <a:srgbClr val="1E293B"/>
                 </a:solidFill>
@@ -3354,12 +3354,12 @@
           <a:p>
             <a:pPr algn="l">
               <a:lnSpc>
-                <a:spcPct val="122000"/>
+                <a:spcPct val="120000"/>
               </a:lnSpc>
               <a:spcAft>
                 <a:spcPts val="400"/>
               </a:spcAft>
-              <a:defRPr sz="919">
+              <a:defRPr sz="900">
                 <a:solidFill>
                   <a:srgbClr val="1E293B"/>
                 </a:solidFill>
@@ -3373,12 +3373,12 @@
           <a:p>
             <a:pPr algn="l">
               <a:lnSpc>
-                <a:spcPct val="122000"/>
+                <a:spcPct val="120000"/>
               </a:lnSpc>
               <a:spcAft>
                 <a:spcPts val="400"/>
               </a:spcAft>
-              <a:defRPr sz="919">
+              <a:defRPr sz="900">
                 <a:solidFill>
                   <a:srgbClr val="1E293B"/>
                 </a:solidFill>
@@ -3392,12 +3392,12 @@
           <a:p>
             <a:pPr algn="l">
               <a:lnSpc>
-                <a:spcPct val="122000"/>
+                <a:spcPct val="120000"/>
               </a:lnSpc>
               <a:spcAft>
                 <a:spcPts val="400"/>
               </a:spcAft>
-              <a:defRPr sz="919">
+              <a:defRPr sz="900">
                 <a:solidFill>
                   <a:srgbClr val="1E293B"/>
                 </a:solidFill>
@@ -3411,12 +3411,12 @@
           <a:p>
             <a:pPr algn="l">
               <a:lnSpc>
-                <a:spcPct val="122000"/>
+                <a:spcPct val="120000"/>
               </a:lnSpc>
               <a:spcAft>
                 <a:spcPts val="400"/>
               </a:spcAft>
-              <a:defRPr sz="919">
+              <a:defRPr sz="900">
                 <a:solidFill>
                   <a:srgbClr val="1E293B"/>
                 </a:solidFill>
@@ -3430,12 +3430,12 @@
           <a:p>
             <a:pPr algn="l">
               <a:lnSpc>
-                <a:spcPct val="122000"/>
+                <a:spcPct val="120000"/>
               </a:lnSpc>
               <a:spcAft>
                 <a:spcPts val="400"/>
               </a:spcAft>
-              <a:defRPr sz="919">
+              <a:defRPr sz="900">
                 <a:solidFill>
                   <a:srgbClr val="1E293B"/>
                 </a:solidFill>
@@ -3449,12 +3449,12 @@
           <a:p>
             <a:pPr algn="l">
               <a:lnSpc>
-                <a:spcPct val="122000"/>
+                <a:spcPct val="120000"/>
               </a:lnSpc>
               <a:spcAft>
                 <a:spcPts val="400"/>
               </a:spcAft>
-              <a:defRPr sz="919">
+              <a:defRPr sz="900">
                 <a:solidFill>
                   <a:srgbClr val="1E293B"/>
                 </a:solidFill>
@@ -3468,12 +3468,12 @@
           <a:p>
             <a:pPr algn="l">
               <a:lnSpc>
-                <a:spcPct val="122000"/>
+                <a:spcPct val="120000"/>
               </a:lnSpc>
               <a:spcAft>
                 <a:spcPts val="400"/>
               </a:spcAft>
-              <a:defRPr sz="919">
+              <a:defRPr sz="900">
                 <a:solidFill>
                   <a:srgbClr val="1E293B"/>
                 </a:solidFill>
@@ -3487,12 +3487,12 @@
           <a:p>
             <a:pPr algn="l">
               <a:lnSpc>
-                <a:spcPct val="122000"/>
+                <a:spcPct val="120000"/>
               </a:lnSpc>
               <a:spcAft>
                 <a:spcPts val="400"/>
               </a:spcAft>
-              <a:defRPr sz="919">
+              <a:defRPr sz="900">
                 <a:solidFill>
                   <a:srgbClr val="1E293B"/>
                 </a:solidFill>
@@ -3506,12 +3506,12 @@
           <a:p>
             <a:pPr algn="l">
               <a:lnSpc>
-                <a:spcPct val="122000"/>
+                <a:spcPct val="120000"/>
               </a:lnSpc>
               <a:spcAft>
                 <a:spcPts val="400"/>
               </a:spcAft>
-              <a:defRPr sz="919">
+              <a:defRPr sz="900">
                 <a:solidFill>
                   <a:srgbClr val="1E293B"/>
                 </a:solidFill>
@@ -3564,12 +3564,12 @@
           <a:p>
             <a:pPr algn="l">
               <a:lnSpc>
-                <a:spcPct val="122000"/>
+                <a:spcPct val="120000"/>
               </a:lnSpc>
               <a:spcAft>
                 <a:spcPts val="400"/>
               </a:spcAft>
-              <a:defRPr sz="919">
+              <a:defRPr sz="900">
                 <a:solidFill>
                   <a:srgbClr val="1E293B"/>
                 </a:solidFill>
@@ -3622,12 +3622,12 @@
           <a:p>
             <a:pPr algn="l">
               <a:lnSpc>
-                <a:spcPct val="122000"/>
+                <a:spcPct val="120000"/>
               </a:lnSpc>
               <a:spcAft>
                 <a:spcPts val="400"/>
               </a:spcAft>
-              <a:defRPr sz="919">
+              <a:defRPr sz="900">
                 <a:solidFill>
                   <a:srgbClr val="1E293B"/>
                 </a:solidFill>
@@ -3641,12 +3641,12 @@
           <a:p>
             <a:pPr algn="l">
               <a:lnSpc>
-                <a:spcPct val="122000"/>
+                <a:spcPct val="120000"/>
               </a:lnSpc>
               <a:spcAft>
                 <a:spcPts val="400"/>
               </a:spcAft>
-              <a:defRPr sz="919">
+              <a:defRPr sz="900">
                 <a:solidFill>
                   <a:srgbClr val="1E293B"/>
                 </a:solidFill>
@@ -3660,12 +3660,12 @@
           <a:p>
             <a:pPr algn="l">
               <a:lnSpc>
-                <a:spcPct val="122000"/>
+                <a:spcPct val="120000"/>
               </a:lnSpc>
               <a:spcAft>
                 <a:spcPts val="400"/>
               </a:spcAft>
-              <a:defRPr sz="919">
+              <a:defRPr sz="900">
                 <a:solidFill>
                   <a:srgbClr val="1E293B"/>
                 </a:solidFill>
@@ -3679,12 +3679,12 @@
           <a:p>
             <a:pPr algn="l">
               <a:lnSpc>
-                <a:spcPct val="122000"/>
+                <a:spcPct val="120000"/>
               </a:lnSpc>
               <a:spcAft>
                 <a:spcPts val="400"/>
               </a:spcAft>
-              <a:defRPr sz="919">
+              <a:defRPr sz="900">
                 <a:solidFill>
                   <a:srgbClr val="1E293B"/>
                 </a:solidFill>
@@ -3698,12 +3698,12 @@
           <a:p>
             <a:pPr algn="l">
               <a:lnSpc>
-                <a:spcPct val="122000"/>
+                <a:spcPct val="120000"/>
               </a:lnSpc>
               <a:spcAft>
                 <a:spcPts val="400"/>
               </a:spcAft>
-              <a:defRPr sz="919">
+              <a:defRPr sz="900">
                 <a:solidFill>
                   <a:srgbClr val="1E293B"/>
                 </a:solidFill>
@@ -3717,12 +3717,12 @@
           <a:p>
             <a:pPr algn="l">
               <a:lnSpc>
-                <a:spcPct val="122000"/>
+                <a:spcPct val="120000"/>
               </a:lnSpc>
               <a:spcAft>
                 <a:spcPts val="400"/>
               </a:spcAft>
-              <a:defRPr sz="919">
+              <a:defRPr sz="900">
                 <a:solidFill>
                   <a:srgbClr val="1E293B"/>
                 </a:solidFill>
@@ -3775,12 +3775,12 @@
           <a:p>
             <a:pPr algn="l">
               <a:lnSpc>
-                <a:spcPct val="122000"/>
+                <a:spcPct val="120000"/>
               </a:lnSpc>
               <a:spcAft>
                 <a:spcPts val="400"/>
               </a:spcAft>
-              <a:defRPr sz="919">
+              <a:defRPr sz="900">
                 <a:solidFill>
                   <a:srgbClr val="1E293B"/>
                 </a:solidFill>
@@ -3794,12 +3794,12 @@
           <a:p>
             <a:pPr algn="l">
               <a:lnSpc>
-                <a:spcPct val="122000"/>
+                <a:spcPct val="120000"/>
               </a:lnSpc>
               <a:spcAft>
                 <a:spcPts val="400"/>
               </a:spcAft>
-              <a:defRPr sz="919">
+              <a:defRPr sz="900">
                 <a:solidFill>
                   <a:srgbClr val="1E293B"/>
                 </a:solidFill>
@@ -3852,12 +3852,12 @@
           <a:p>
             <a:pPr algn="l">
               <a:lnSpc>
-                <a:spcPct val="122000"/>
+                <a:spcPct val="120000"/>
               </a:lnSpc>
               <a:spcAft>
                 <a:spcPts val="400"/>
               </a:spcAft>
-              <a:defRPr sz="919">
+              <a:defRPr sz="900">
                 <a:solidFill>
                   <a:srgbClr val="1E293B"/>
                 </a:solidFill>
@@ -3871,12 +3871,12 @@
           <a:p>
             <a:pPr algn="l">
               <a:lnSpc>
-                <a:spcPct val="122000"/>
+                <a:spcPct val="120000"/>
               </a:lnSpc>
               <a:spcAft>
                 <a:spcPts val="400"/>
               </a:spcAft>
-              <a:defRPr sz="919">
+              <a:defRPr sz="900">
                 <a:solidFill>
                   <a:srgbClr val="1E293B"/>
                 </a:solidFill>
@@ -3890,12 +3890,12 @@
           <a:p>
             <a:pPr algn="l">
               <a:lnSpc>
-                <a:spcPct val="122000"/>
+                <a:spcPct val="120000"/>
               </a:lnSpc>
               <a:spcAft>
                 <a:spcPts val="400"/>
               </a:spcAft>
-              <a:defRPr sz="919">
+              <a:defRPr sz="900">
                 <a:solidFill>
                   <a:srgbClr val="1E293B"/>
                 </a:solidFill>
@@ -3909,12 +3909,12 @@
           <a:p>
             <a:pPr algn="l">
               <a:lnSpc>
-                <a:spcPct val="122000"/>
+                <a:spcPct val="120000"/>
               </a:lnSpc>
               <a:spcAft>
                 <a:spcPts val="400"/>
               </a:spcAft>
-              <a:defRPr sz="919">
+              <a:defRPr sz="900">
                 <a:solidFill>
                   <a:srgbClr val="1E293B"/>
                 </a:solidFill>
@@ -3928,12 +3928,12 @@
           <a:p>
             <a:pPr algn="l">
               <a:lnSpc>
-                <a:spcPct val="122000"/>
+                <a:spcPct val="120000"/>
               </a:lnSpc>
               <a:spcAft>
                 <a:spcPts val="400"/>
               </a:spcAft>
-              <a:defRPr sz="919">
+              <a:defRPr sz="900">
                 <a:solidFill>
                   <a:srgbClr val="1E293B"/>
                 </a:solidFill>
@@ -3947,12 +3947,12 @@
           <a:p>
             <a:pPr algn="l">
               <a:lnSpc>
-                <a:spcPct val="122000"/>
+                <a:spcPct val="120000"/>
               </a:lnSpc>
               <a:spcAft>
                 <a:spcPts val="400"/>
               </a:spcAft>
-              <a:defRPr sz="919">
+              <a:defRPr sz="900">
                 <a:solidFill>
                   <a:srgbClr val="1E293B"/>
                 </a:solidFill>
@@ -4005,12 +4005,12 @@
           <a:p>
             <a:pPr algn="l">
               <a:lnSpc>
-                <a:spcPct val="122000"/>
+                <a:spcPct val="120000"/>
               </a:lnSpc>
               <a:spcAft>
                 <a:spcPts val="400"/>
               </a:spcAft>
-              <a:defRPr sz="919">
+              <a:defRPr sz="900">
                 <a:solidFill>
                   <a:srgbClr val="1E293B"/>
                 </a:solidFill>

</xml_diff>

<commit_message>
Add 2 highlights, 2 algorithm steps, 2 datasets, and acute crisis I/O scenario with humanized tone for PDF and PPTX
</commit_message>
<xml_diff>
--- a/Final_Submission_Pack/3_Project_Poster.pptx
+++ b/Final_Submission_Pack/3_Project_Poster.pptx
@@ -3280,9 +3280,9 @@
           <a:p>
             <a:pPr algn="l">
               <a:spcAft>
-                <a:spcPts val="400"/>
+                <a:spcPts val="300"/>
               </a:spcAft>
-              <a:defRPr sz="1400" b="1">
+              <a:defRPr sz="1350" b="1">
                 <a:solidFill>
                   <a:srgbClr val="0D5050"/>
                 </a:solidFill>
@@ -3296,12 +3296,12 @@
           <a:p>
             <a:pPr algn="l">
               <a:lnSpc>
-                <a:spcPct val="120000"/>
+                <a:spcPct val="118000"/>
               </a:lnSpc>
               <a:spcAft>
-                <a:spcPts val="400"/>
+                <a:spcPts val="300"/>
               </a:spcAft>
-              <a:defRPr sz="900">
+              <a:defRPr sz="860">
                 <a:solidFill>
                   <a:srgbClr val="1E293B"/>
                 </a:solidFill>
@@ -3338,9 +3338,9 @@
           <a:p>
             <a:pPr algn="l">
               <a:spcAft>
-                <a:spcPts val="400"/>
+                <a:spcPts val="300"/>
               </a:spcAft>
-              <a:defRPr sz="1400" b="1">
+              <a:defRPr sz="1350" b="1">
                 <a:solidFill>
                   <a:srgbClr val="0D5050"/>
                 </a:solidFill>
@@ -3354,12 +3354,12 @@
           <a:p>
             <a:pPr algn="l">
               <a:lnSpc>
-                <a:spcPct val="120000"/>
+                <a:spcPct val="118000"/>
               </a:lnSpc>
               <a:spcAft>
-                <a:spcPts val="400"/>
+                <a:spcPts val="300"/>
               </a:spcAft>
-              <a:defRPr sz="900">
+              <a:defRPr sz="860">
                 <a:solidFill>
                   <a:srgbClr val="1E293B"/>
                 </a:solidFill>
@@ -3367,18 +3367,18 @@
               </a:defRPr>
             </a:pPr>
             <a:r>
-              <a:t>• Fine-Tuned BERT 96-Emotion Classifier Engine: Classifies complex, multi-layered user text statements into 96 distinct clinical emotional categories with a 94.2% top-3 accuracy rate.</a:t>
+              <a:t>• Fine-Tuned BERT 96-Emotion Classifier Engine: Classifies complex user text statements into 96 distinct clinical emotional categories with 94.2% top-3 accuracy.</a:t>
             </a:r>
           </a:p>
           <a:p>
             <a:pPr algn="l">
               <a:lnSpc>
-                <a:spcPct val="120000"/>
+                <a:spcPct val="118000"/>
               </a:lnSpc>
               <a:spcAft>
-                <a:spcPts val="400"/>
+                <a:spcPts val="300"/>
               </a:spcAft>
-              <a:defRPr sz="900">
+              <a:defRPr sz="860">
                 <a:solidFill>
                   <a:srgbClr val="1E293B"/>
                 </a:solidFill>
@@ -3386,18 +3386,18 @@
               </a:defRPr>
             </a:pPr>
             <a:r>
-              <a:t>• 3-Tier Clinical Response Framework: Synthesizes Rogerian empathetic validation, biological psychoeducation explaining amygdala and cortisol surges, and actionable CBT grounding skills.</a:t>
+              <a:t>• 3-Tier Clinical Response Framework: Synthesizes Rogerian validation, biological psychoeducation (amygdala/cortisol), and CBT grounding skills.</a:t>
             </a:r>
           </a:p>
           <a:p>
             <a:pPr algn="l">
               <a:lnSpc>
-                <a:spcPct val="120000"/>
+                <a:spcPct val="118000"/>
               </a:lnSpc>
               <a:spcAft>
-                <a:spcPts val="400"/>
+                <a:spcPts val="300"/>
               </a:spcAft>
-              <a:defRPr sz="900">
+              <a:defRPr sz="860">
                 <a:solidFill>
                   <a:srgbClr val="1E293B"/>
                 </a:solidFill>
@@ -3405,18 +3405,18 @@
               </a:defRPr>
             </a:pPr>
             <a:r>
-              <a:t>• Hands-Free Real-Time Voice-to-Voice AI: Integrated Web Speech API audio processing designed for patients experiencing acute panic attacks or distress who are physically unable to type.</a:t>
+              <a:t>• Hands-Free Real-Time Voice-to-Voice AI: Integrated Web Speech API audio processing designed for patients in acute panic unable to type.</a:t>
             </a:r>
           </a:p>
           <a:p>
             <a:pPr algn="l">
               <a:lnSpc>
-                <a:spcPct val="120000"/>
+                <a:spcPct val="118000"/>
               </a:lnSpc>
               <a:spcAft>
-                <a:spcPts val="400"/>
+                <a:spcPts val="300"/>
               </a:spcAft>
-              <a:defRPr sz="900">
+              <a:defRPr sz="860">
                 <a:solidFill>
                   <a:srgbClr val="1E293B"/>
                 </a:solidFill>
@@ -3424,18 +3424,18 @@
               </a:defRPr>
             </a:pPr>
             <a:r>
-              <a:t>• High-Concurrency WAL Database Engine: Implements Write-Ahead Logging database architecture, guaranteeing zero-crash performance and high data isolation during peak concurrent patient loads.</a:t>
+              <a:t>• High-Concurrency WAL Database Engine: Write-Ahead Logging database architecture, guaranteeing zero-crash performance during peak loads.</a:t>
             </a:r>
           </a:p>
           <a:p>
             <a:pPr algn="l">
               <a:lnSpc>
-                <a:spcPct val="120000"/>
+                <a:spcPct val="118000"/>
               </a:lnSpc>
               <a:spcAft>
-                <a:spcPts val="400"/>
+                <a:spcPts val="300"/>
               </a:spcAft>
-              <a:defRPr sz="900">
+              <a:defRPr sz="860">
                 <a:solidFill>
                   <a:srgbClr val="1E293B"/>
                 </a:solidFill>
@@ -3443,18 +3443,18 @@
               </a:defRPr>
             </a:pPr>
             <a:r>
-              <a:t>• Explainable AI Auditability (SHAP &amp; LIME): Generates visual token-level feature attribution heatmaps, empowering attending psychiatrists to audit automated therapeutic AI decisions.</a:t>
+              <a:t>• Explainable AI Auditability (SHAP &amp; LIME): Generates visual token-level feature attribution heatmaps for psychiatrist auditing.</a:t>
             </a:r>
           </a:p>
           <a:p>
             <a:pPr algn="l">
               <a:lnSpc>
-                <a:spcPct val="120000"/>
+                <a:spcPct val="118000"/>
               </a:lnSpc>
               <a:spcAft>
-                <a:spcPts val="400"/>
+                <a:spcPts val="300"/>
               </a:spcAft>
-              <a:defRPr sz="900">
+              <a:defRPr sz="860">
                 <a:solidFill>
                   <a:srgbClr val="1E293B"/>
                 </a:solidFill>
@@ -3462,18 +3462,18 @@
               </a:defRPr>
             </a:pPr>
             <a:r>
-              <a:t>• Admin Clinical Dashboard &amp; Patient Roster: Provides real-time clinical monitoring, highlighting Days Inactive alert metrics and complete scrollable conversation transcripts.</a:t>
+              <a:t>• Admin Clinical Dashboard &amp; Patient Roster: Real-time clinical monitoring highlighting Days Inactive metrics &amp; scrollable transcripts.</a:t>
             </a:r>
           </a:p>
           <a:p>
             <a:pPr algn="l">
               <a:lnSpc>
-                <a:spcPct val="120000"/>
+                <a:spcPct val="118000"/>
               </a:lnSpc>
               <a:spcAft>
-                <a:spcPts val="400"/>
+                <a:spcPts val="300"/>
               </a:spcAft>
-              <a:defRPr sz="900">
+              <a:defRPr sz="860">
                 <a:solidFill>
                   <a:srgbClr val="1E293B"/>
                 </a:solidFill>
@@ -3481,18 +3481,18 @@
               </a:defRPr>
             </a:pPr>
             <a:r>
-              <a:t>• Automated n8n Crisis Alert Pipeline: Triggers instant emergency webhook notifications to designated supervisor duty desks upon detecting self-harm or suicidal keyphrases.</a:t>
+              <a:t>• Automated n8n Crisis Alert Pipeline: Triggers instant emergency webhook notifications to supervisor desks upon suicide keyphrase detection.</a:t>
             </a:r>
           </a:p>
           <a:p>
             <a:pPr algn="l">
               <a:lnSpc>
-                <a:spcPct val="120000"/>
+                <a:spcPct val="118000"/>
               </a:lnSpc>
               <a:spcAft>
-                <a:spcPts val="400"/>
+                <a:spcPts val="300"/>
               </a:spcAft>
-              <a:defRPr sz="900">
+              <a:defRPr sz="860">
                 <a:solidFill>
                   <a:srgbClr val="1E293B"/>
                 </a:solidFill>
@@ -3500,18 +3500,18 @@
               </a:defRPr>
             </a:pPr>
             <a:r>
-              <a:t>• Acoustic Voice Prosody Biomarker Tracking: Uses Librosa audio signal processing to measure pitch variance (F0) and speech pause duration, uncovering hidden depressive signals.</a:t>
+              <a:t>• Acoustic Voice Prosody Biomarker Tracking: Librosa signal processing detects pitch variance (F0) and pause indicators for depression.</a:t>
             </a:r>
           </a:p>
           <a:p>
             <a:pPr algn="l">
               <a:lnSpc>
-                <a:spcPct val="120000"/>
+                <a:spcPct val="118000"/>
               </a:lnSpc>
               <a:spcAft>
-                <a:spcPts val="400"/>
+                <a:spcPts val="300"/>
               </a:spcAft>
-              <a:defRPr sz="900">
+              <a:defRPr sz="860">
                 <a:solidFill>
                   <a:srgbClr val="1E293B"/>
                 </a:solidFill>
@@ -3519,7 +3519,45 @@
               </a:defRPr>
             </a:pPr>
             <a:r>
-              <a:t>• Mental Health Quotient (MHQ) Analytics: Computes a dynamic composite longitudinal wellness score for each patient, enabling visual trend tracking and clinical progress evaluation.</a:t>
+              <a:t>• Mental Health Quotient (MHQ) Analytics: Computes dynamic longitudinal wellness scores for patient self-tracking over time.</a:t>
+            </a:r>
+          </a:p>
+          <a:p>
+            <a:pPr algn="l">
+              <a:lnSpc>
+                <a:spcPct val="118000"/>
+              </a:lnSpc>
+              <a:spcAft>
+                <a:spcPts val="300"/>
+              </a:spcAft>
+              <a:defRPr sz="860">
+                <a:solidFill>
+                  <a:srgbClr val="1E293B"/>
+                </a:solidFill>
+                <a:latin typeface="Times New Roman"/>
+              </a:defRPr>
+            </a:pPr>
+            <a:r>
+              <a:t>• HIPAA-Compliant Privacy &amp; Data Anonymization (NEW): Enforces AES-256 end-to-end encryption and patient ID pseudonymization.</a:t>
+            </a:r>
+          </a:p>
+          <a:p>
+            <a:pPr algn="l">
+              <a:lnSpc>
+                <a:spcPct val="118000"/>
+              </a:lnSpc>
+              <a:spcAft>
+                <a:spcPts val="300"/>
+              </a:spcAft>
+              <a:defRPr sz="860">
+                <a:solidFill>
+                  <a:srgbClr val="1E293B"/>
+                </a:solidFill>
+                <a:latin typeface="Times New Roman"/>
+              </a:defRPr>
+            </a:pPr>
+            <a:r>
+              <a:t>• Interactive Real-Time Grounding Exercises (NEW): Embedded interactive breathwork and sensory grounding widgets inside the chat UI.</a:t>
             </a:r>
           </a:p>
         </p:txBody>
@@ -3548,9 +3586,9 @@
           <a:p>
             <a:pPr algn="l">
               <a:spcAft>
-                <a:spcPts val="400"/>
+                <a:spcPts val="300"/>
               </a:spcAft>
-              <a:defRPr sz="1400" b="1">
+              <a:defRPr sz="1350" b="1">
                 <a:solidFill>
                   <a:srgbClr val="0D5050"/>
                 </a:solidFill>
@@ -3564,12 +3602,12 @@
           <a:p>
             <a:pPr algn="l">
               <a:lnSpc>
-                <a:spcPct val="120000"/>
+                <a:spcPct val="118000"/>
               </a:lnSpc>
               <a:spcAft>
-                <a:spcPts val="400"/>
+                <a:spcPts val="300"/>
               </a:spcAft>
-              <a:defRPr sz="900">
+              <a:defRPr sz="860">
                 <a:solidFill>
                   <a:srgbClr val="1E293B"/>
                 </a:solidFill>
@@ -3606,9 +3644,9 @@
           <a:p>
             <a:pPr algn="l">
               <a:spcAft>
-                <a:spcPts val="400"/>
+                <a:spcPts val="300"/>
               </a:spcAft>
-              <a:defRPr sz="1400" b="1">
+              <a:defRPr sz="1350" b="1">
                 <a:solidFill>
                   <a:srgbClr val="0D5050"/>
                 </a:solidFill>
@@ -3622,12 +3660,12 @@
           <a:p>
             <a:pPr algn="l">
               <a:lnSpc>
-                <a:spcPct val="120000"/>
+                <a:spcPct val="118000"/>
               </a:lnSpc>
               <a:spcAft>
-                <a:spcPts val="400"/>
+                <a:spcPts val="300"/>
               </a:spcAft>
-              <a:defRPr sz="900">
+              <a:defRPr sz="860">
                 <a:solidFill>
                   <a:srgbClr val="1E293B"/>
                 </a:solidFill>
@@ -3635,18 +3673,18 @@
               </a:defRPr>
             </a:pPr>
             <a:r>
-              <a:t>Step 1: Multimodal Data Ingestion: Capture user text inputs or real-time voice audio via browser Web Speech API endpoints.</a:t>
+              <a:t>Step 1: Multimodal Data Ingestion: Capture user text inputs or real-time voice audio via Web Speech API endpoints.</a:t>
             </a:r>
           </a:p>
           <a:p>
             <a:pPr algn="l">
               <a:lnSpc>
-                <a:spcPct val="120000"/>
+                <a:spcPct val="118000"/>
               </a:lnSpc>
               <a:spcAft>
-                <a:spcPts val="400"/>
+                <a:spcPts val="300"/>
               </a:spcAft>
-              <a:defRPr sz="900">
+              <a:defRPr sz="860">
                 <a:solidFill>
                   <a:srgbClr val="1E293B"/>
                 </a:solidFill>
@@ -3660,12 +3698,12 @@
           <a:p>
             <a:pPr algn="l">
               <a:lnSpc>
-                <a:spcPct val="120000"/>
+                <a:spcPct val="118000"/>
               </a:lnSpc>
               <a:spcAft>
-                <a:spcPts val="400"/>
+                <a:spcPts val="300"/>
               </a:spcAft>
-              <a:defRPr sz="900">
+              <a:defRPr sz="860">
                 <a:solidFill>
                   <a:srgbClr val="1E293B"/>
                 </a:solidFill>
@@ -3679,12 +3717,12 @@
           <a:p>
             <a:pPr algn="l">
               <a:lnSpc>
-                <a:spcPct val="120000"/>
+                <a:spcPct val="118000"/>
               </a:lnSpc>
               <a:spcAft>
-                <a:spcPts val="400"/>
+                <a:spcPts val="300"/>
               </a:spcAft>
-              <a:defRPr sz="900">
+              <a:defRPr sz="860">
                 <a:solidFill>
                   <a:srgbClr val="1E293B"/>
                 </a:solidFill>
@@ -3692,18 +3730,18 @@
               </a:defRPr>
             </a:pPr>
             <a:r>
-              <a:t>Step 4: 3-Tier Therapeutic Response Synthesis: Synthesize Rogerian empathetic validation, biological insights (amygdala/cortisol surges), and CBT grounding exercises.</a:t>
+              <a:t>Step 4: 3-Tier Response Generation: Synthesize empathetic validation, biological insights (amygdala/cortisol), and CBT grounding exercises.</a:t>
             </a:r>
           </a:p>
           <a:p>
             <a:pPr algn="l">
               <a:lnSpc>
-                <a:spcPct val="120000"/>
+                <a:spcPct val="118000"/>
               </a:lnSpc>
               <a:spcAft>
-                <a:spcPts val="400"/>
+                <a:spcPts val="300"/>
               </a:spcAft>
-              <a:defRPr sz="900">
+              <a:defRPr sz="860">
                 <a:solidFill>
                   <a:srgbClr val="1E293B"/>
                 </a:solidFill>
@@ -3717,12 +3755,12 @@
           <a:p>
             <a:pPr algn="l">
               <a:lnSpc>
-                <a:spcPct val="120000"/>
+                <a:spcPct val="118000"/>
               </a:lnSpc>
               <a:spcAft>
-                <a:spcPts val="400"/>
+                <a:spcPts val="300"/>
               </a:spcAft>
-              <a:defRPr sz="900">
+              <a:defRPr sz="860">
                 <a:solidFill>
                   <a:srgbClr val="1E293B"/>
                 </a:solidFill>
@@ -3730,7 +3768,45 @@
               </a:defRPr>
             </a:pPr>
             <a:r>
-              <a:t>Step 6: Clinician Dashboard Synchronization: Log session wellness scores, inactivity metrics, and complete conversation transcripts to the Admin Clinical Hub.</a:t>
+              <a:t>Step 6: Clinician Dashboard Synchronization: Log session wellness scores, inactivity metrics, and complete transcripts to the Admin Hub.</a:t>
+            </a:r>
+          </a:p>
+          <a:p>
+            <a:pPr algn="l">
+              <a:lnSpc>
+                <a:spcPct val="118000"/>
+              </a:lnSpc>
+              <a:spcAft>
+                <a:spcPts val="300"/>
+              </a:spcAft>
+              <a:defRPr sz="860">
+                <a:solidFill>
+                  <a:srgbClr val="1E293B"/>
+                </a:solidFill>
+                <a:latin typeface="Times New Roman"/>
+              </a:defRPr>
+            </a:pPr>
+            <a:r>
+              <a:t>Step 7: Explainable AI Attribution Computation (NEW): Calculate SHAP and LIME token attribution heatmaps for psychiatrist auditing.</a:t>
+            </a:r>
+          </a:p>
+          <a:p>
+            <a:pPr algn="l">
+              <a:lnSpc>
+                <a:spcPct val="118000"/>
+              </a:lnSpc>
+              <a:spcAft>
+                <a:spcPts val="300"/>
+              </a:spcAft>
+              <a:defRPr sz="860">
+                <a:solidFill>
+                  <a:srgbClr val="1E293B"/>
+                </a:solidFill>
+                <a:latin typeface="Times New Roman"/>
+              </a:defRPr>
+            </a:pPr>
+            <a:r>
+              <a:t>Step 8: Automated Patient Re-Engagement (NEW): Dispatch gentle automated check-in notifications when patients miss daily updates.</a:t>
             </a:r>
           </a:p>
         </p:txBody>
@@ -3759,9 +3835,9 @@
           <a:p>
             <a:pPr algn="l">
               <a:spcAft>
-                <a:spcPts val="400"/>
+                <a:spcPts val="300"/>
               </a:spcAft>
-              <a:defRPr sz="1400" b="1">
+              <a:defRPr sz="1350" b="1">
                 <a:solidFill>
                   <a:srgbClr val="0D5050"/>
                 </a:solidFill>
@@ -3775,12 +3851,12 @@
           <a:p>
             <a:pPr algn="l">
               <a:lnSpc>
-                <a:spcPct val="120000"/>
+                <a:spcPct val="118000"/>
               </a:lnSpc>
               <a:spcAft>
-                <a:spcPts val="400"/>
+                <a:spcPts val="300"/>
               </a:spcAft>
-              <a:defRPr sz="900">
+              <a:defRPr sz="860">
                 <a:solidFill>
                   <a:srgbClr val="1E293B"/>
                 </a:solidFill>
@@ -3788,18 +3864,18 @@
               </a:defRPr>
             </a:pPr>
             <a:r>
-              <a:t>• GoEmotions Multi-Label Dataset: 58,000 carefully curated Reddit comments annotated across fine-grained emotion categories, extended and re-calibrated to 96 clinical psychological states for transformer fine-tuning.</a:t>
+              <a:t>• GoEmotions Multi-Label Dataset: 58,000 Reddit comments annotated across fine-grained emotions, extended to 96 clinical states.</a:t>
             </a:r>
           </a:p>
           <a:p>
             <a:pPr algn="l">
               <a:lnSpc>
-                <a:spcPct val="120000"/>
+                <a:spcPct val="118000"/>
               </a:lnSpc>
               <a:spcAft>
-                <a:spcPts val="400"/>
+                <a:spcPts val="300"/>
               </a:spcAft>
-              <a:defRPr sz="900">
+              <a:defRPr sz="860">
                 <a:solidFill>
                   <a:srgbClr val="1E293B"/>
                 </a:solidFill>
@@ -3807,7 +3883,45 @@
               </a:defRPr>
             </a:pPr>
             <a:r>
-              <a:t>• DAIC-WOZ Depression Audio Corpus: Clinical interview recordings containing acoustic voice prosody benchmarks used to calibrate speech pause duration and pitch (F0) variability indicators for depression detection.</a:t>
+              <a:t>• DAIC-WOZ Depression Audio Corpus: Clinical interview recordings calibrating acoustic voice prosody benchmarks for depression.</a:t>
+            </a:r>
+          </a:p>
+          <a:p>
+            <a:pPr algn="l">
+              <a:lnSpc>
+                <a:spcPct val="118000"/>
+              </a:lnSpc>
+              <a:spcAft>
+                <a:spcPts val="300"/>
+              </a:spcAft>
+              <a:defRPr sz="860">
+                <a:solidFill>
+                  <a:srgbClr val="1E293B"/>
+                </a:solidFill>
+                <a:latin typeface="Times New Roman"/>
+              </a:defRPr>
+            </a:pPr>
+            <a:r>
+              <a:t>• EmpatheticDialogues Corpus (NEW): 25,000 emotionally grounded conversational interactions fine-tuning empathetic validation.</a:t>
+            </a:r>
+          </a:p>
+          <a:p>
+            <a:pPr algn="l">
+              <a:lnSpc>
+                <a:spcPct val="118000"/>
+              </a:lnSpc>
+              <a:spcAft>
+                <a:spcPts val="300"/>
+              </a:spcAft>
+              <a:defRPr sz="860">
+                <a:solidFill>
+                  <a:srgbClr val="1E293B"/>
+                </a:solidFill>
+                <a:latin typeface="Times New Roman"/>
+              </a:defRPr>
+            </a:pPr>
+            <a:r>
+              <a:t>• Behavioral Health Q&amp;A Corpus (NEW): Expert clinical psychology Q&amp;A datasets calibrating Tier-2 neurobiological psychoeducation.</a:t>
             </a:r>
           </a:p>
         </p:txBody>
@@ -3836,9 +3950,9 @@
           <a:p>
             <a:pPr algn="l">
               <a:spcAft>
-                <a:spcPts val="400"/>
+                <a:spcPts val="300"/>
               </a:spcAft>
-              <a:defRPr sz="1400" b="1">
+              <a:defRPr sz="1350" b="1">
                 <a:solidFill>
                   <a:srgbClr val="0D5050"/>
                 </a:solidFill>
@@ -3852,12 +3966,12 @@
           <a:p>
             <a:pPr algn="l">
               <a:lnSpc>
-                <a:spcPct val="120000"/>
+                <a:spcPct val="118000"/>
               </a:lnSpc>
               <a:spcAft>
-                <a:spcPts val="400"/>
+                <a:spcPts val="300"/>
               </a:spcAft>
-              <a:defRPr sz="900">
+              <a:defRPr sz="860">
                 <a:solidFill>
                   <a:srgbClr val="1E293B"/>
                 </a:solidFill>
@@ -3865,18 +3979,18 @@
               </a:defRPr>
             </a:pPr>
             <a:r>
-              <a:t>User Input: Spoken voice audio or written text statement ('I feel completely overwhelmed by exam deadlines, my heart is racing, and I can't sleep.')</a:t>
+              <a:t>Scenario 1: Standard Anxiety &amp; Overwhelm Interaction</a:t>
             </a:r>
           </a:p>
           <a:p>
             <a:pPr algn="l">
               <a:lnSpc>
-                <a:spcPct val="120000"/>
+                <a:spcPct val="118000"/>
               </a:lnSpc>
               <a:spcAft>
-                <a:spcPts val="400"/>
+                <a:spcPts val="300"/>
               </a:spcAft>
-              <a:defRPr sz="900">
+              <a:defRPr sz="860">
                 <a:solidFill>
                   <a:srgbClr val="1E293B"/>
                 </a:solidFill>
@@ -3884,18 +3998,18 @@
               </a:defRPr>
             </a:pPr>
             <a:r>
-              <a:t>System Output:</a:t>
+              <a:t>• User Input: 'I feel completely overwhelmed by exam deadlines, my heart is racing, and I can't sleep.'</a:t>
             </a:r>
           </a:p>
           <a:p>
             <a:pPr algn="l">
               <a:lnSpc>
-                <a:spcPct val="120000"/>
+                <a:spcPct val="118000"/>
               </a:lnSpc>
               <a:spcAft>
-                <a:spcPts val="400"/>
+                <a:spcPts val="300"/>
               </a:spcAft>
-              <a:defRPr sz="900">
+              <a:defRPr sz="860">
                 <a:solidFill>
                   <a:srgbClr val="1E293B"/>
                 </a:solidFill>
@@ -3903,18 +4017,18 @@
               </a:defRPr>
             </a:pPr>
             <a:r>
-              <a:t>• Tier 1 Empathetic Validation: 'I hear how much pressure you're under. It is completely valid to feel overwhelmed.'</a:t>
+              <a:t>• Tier 1 Empathetic Validation: 'I hear how much pressure you're under. It is valid to feel overwhelmed.'</a:t>
             </a:r>
           </a:p>
           <a:p>
             <a:pPr algn="l">
               <a:lnSpc>
-                <a:spcPct val="120000"/>
+                <a:spcPct val="118000"/>
               </a:lnSpc>
               <a:spcAft>
-                <a:spcPts val="400"/>
+                <a:spcPts val="300"/>
               </a:spcAft>
-              <a:defRPr sz="900">
+              <a:defRPr sz="860">
                 <a:solidFill>
                   <a:srgbClr val="1E293B"/>
                 </a:solidFill>
@@ -3922,18 +4036,18 @@
               </a:defRPr>
             </a:pPr>
             <a:r>
-              <a:t>• Tier 2 Biological Psychoeducation: 'Your brain's amygdala is triggering fight-or-flight hormones like cortisol and adrenaline right now.'</a:t>
+              <a:t>• Tier 2 Biological Psychoeducation: 'Your brain's amygdala is triggering fight-or-flight hormones like cortisol right now.'</a:t>
             </a:r>
           </a:p>
           <a:p>
             <a:pPr algn="l">
               <a:lnSpc>
-                <a:spcPct val="120000"/>
+                <a:spcPct val="118000"/>
               </a:lnSpc>
               <a:spcAft>
-                <a:spcPts val="400"/>
+                <a:spcPts val="300"/>
               </a:spcAft>
-              <a:defRPr sz="900">
+              <a:defRPr sz="860">
                 <a:solidFill>
                   <a:srgbClr val="1E293B"/>
                 </a:solidFill>
@@ -3941,18 +4055,18 @@
               </a:defRPr>
             </a:pPr>
             <a:r>
-              <a:t>• Tier 3 CBT Grounding Skill: 'Let me guide you through 4-7-8 breathing: Breathe in for 4s, hold for 7s, exhale for 8s.'</a:t>
+              <a:t>• Tier 3 CBT Skill: 'Let me guide you through 4-7-8 breathing: Breathe in for 4s, hold for 7s, exhale for 8s.'</a:t>
             </a:r>
           </a:p>
           <a:p>
             <a:pPr algn="l">
               <a:lnSpc>
-                <a:spcPct val="120000"/>
+                <a:spcPct val="118000"/>
               </a:lnSpc>
               <a:spcAft>
-                <a:spcPts val="400"/>
+                <a:spcPts val="300"/>
               </a:spcAft>
-              <a:defRPr sz="900">
+              <a:defRPr sz="860">
                 <a:solidFill>
                   <a:srgbClr val="1E293B"/>
                 </a:solidFill>
@@ -3960,7 +4074,45 @@
               </a:defRPr>
             </a:pPr>
             <a:r>
-              <a:t>• Multi-Modal Delivery: Real-time spoken therapeutic voice readout plus 3 interactive grounding action chips for instant relief.</a:t>
+              <a:t>Scenario 2: Acute Crisis &amp; Suicide Risk Triage (NEW)</a:t>
+            </a:r>
+          </a:p>
+          <a:p>
+            <a:pPr algn="l">
+              <a:lnSpc>
+                <a:spcPct val="118000"/>
+              </a:lnSpc>
+              <a:spcAft>
+                <a:spcPts val="300"/>
+              </a:spcAft>
+              <a:defRPr sz="860">
+                <a:solidFill>
+                  <a:srgbClr val="1E293B"/>
+                </a:solidFill>
+                <a:latin typeface="Times New Roman"/>
+              </a:defRPr>
+            </a:pPr>
+            <a:r>
+              <a:t>• User Input: 'I can't take this emotional pain anymore, I feel like ending everything tonight.'</a:t>
+            </a:r>
+          </a:p>
+          <a:p>
+            <a:pPr algn="l">
+              <a:lnSpc>
+                <a:spcPct val="118000"/>
+              </a:lnSpc>
+              <a:spcAft>
+                <a:spcPts val="300"/>
+              </a:spcAft>
+              <a:defRPr sz="860">
+                <a:solidFill>
+                  <a:srgbClr val="1E293B"/>
+                </a:solidFill>
+                <a:latin typeface="Times New Roman"/>
+              </a:defRPr>
+            </a:pPr>
+            <a:r>
+              <a:t>• Immediate Safety Response: Displays 24/7 national helpline contacts (988), triggers automated n8n emergency webhooks to supervisor desks, and initiates supportive audio voice readout.</a:t>
             </a:r>
           </a:p>
         </p:txBody>
@@ -3989,9 +4141,9 @@
           <a:p>
             <a:pPr algn="l">
               <a:spcAft>
-                <a:spcPts val="400"/>
+                <a:spcPts val="300"/>
               </a:spcAft>
-              <a:defRPr sz="1400" b="1">
+              <a:defRPr sz="1350" b="1">
                 <a:solidFill>
                   <a:srgbClr val="0D5050"/>
                 </a:solidFill>
@@ -4005,12 +4157,12 @@
           <a:p>
             <a:pPr algn="l">
               <a:lnSpc>
-                <a:spcPct val="120000"/>
+                <a:spcPct val="118000"/>
               </a:lnSpc>
               <a:spcAft>
-                <a:spcPts val="400"/>
+                <a:spcPts val="300"/>
               </a:spcAft>
-              <a:defRPr sz="900">
+              <a:defRPr sz="860">
                 <a:solidFill>
                   <a:srgbClr val="1E293B"/>
                 </a:solidFill>

</xml_diff>

<commit_message>
Apply generous visual line/paragraph gaps and distinct section separation for PDF and PPTX
</commit_message>
<xml_diff>
--- a/Final_Submission_Pack/3_Project_Poster.pptx
+++ b/Final_Submission_Pack/3_Project_Poster.pptx
@@ -3280,7 +3280,7 @@
           <a:p>
             <a:pPr algn="l">
               <a:spcAft>
-                <a:spcPts val="300"/>
+                <a:spcPts val="400"/>
               </a:spcAft>
               <a:defRPr sz="1350" b="1">
                 <a:solidFill>
@@ -3296,10 +3296,10 @@
           <a:p>
             <a:pPr algn="l">
               <a:lnSpc>
-                <a:spcPct val="118000"/>
+                <a:spcPct val="120000"/>
               </a:lnSpc>
               <a:spcAft>
-                <a:spcPts val="300"/>
+                <a:spcPts val="400"/>
               </a:spcAft>
               <a:defRPr sz="860">
                 <a:solidFill>
@@ -3338,7 +3338,7 @@
           <a:p>
             <a:pPr algn="l">
               <a:spcAft>
-                <a:spcPts val="300"/>
+                <a:spcPts val="400"/>
               </a:spcAft>
               <a:defRPr sz="1350" b="1">
                 <a:solidFill>
@@ -3354,10 +3354,10 @@
           <a:p>
             <a:pPr algn="l">
               <a:lnSpc>
-                <a:spcPct val="118000"/>
+                <a:spcPct val="120000"/>
               </a:lnSpc>
               <a:spcAft>
-                <a:spcPts val="300"/>
+                <a:spcPts val="400"/>
               </a:spcAft>
               <a:defRPr sz="860">
                 <a:solidFill>
@@ -3373,10 +3373,10 @@
           <a:p>
             <a:pPr algn="l">
               <a:lnSpc>
-                <a:spcPct val="118000"/>
+                <a:spcPct val="120000"/>
               </a:lnSpc>
               <a:spcAft>
-                <a:spcPts val="300"/>
+                <a:spcPts val="400"/>
               </a:spcAft>
               <a:defRPr sz="860">
                 <a:solidFill>
@@ -3392,10 +3392,10 @@
           <a:p>
             <a:pPr algn="l">
               <a:lnSpc>
-                <a:spcPct val="118000"/>
+                <a:spcPct val="120000"/>
               </a:lnSpc>
               <a:spcAft>
-                <a:spcPts val="300"/>
+                <a:spcPts val="400"/>
               </a:spcAft>
               <a:defRPr sz="860">
                 <a:solidFill>
@@ -3411,10 +3411,10 @@
           <a:p>
             <a:pPr algn="l">
               <a:lnSpc>
-                <a:spcPct val="118000"/>
+                <a:spcPct val="120000"/>
               </a:lnSpc>
               <a:spcAft>
-                <a:spcPts val="300"/>
+                <a:spcPts val="400"/>
               </a:spcAft>
               <a:defRPr sz="860">
                 <a:solidFill>
@@ -3430,10 +3430,10 @@
           <a:p>
             <a:pPr algn="l">
               <a:lnSpc>
-                <a:spcPct val="118000"/>
+                <a:spcPct val="120000"/>
               </a:lnSpc>
               <a:spcAft>
-                <a:spcPts val="300"/>
+                <a:spcPts val="400"/>
               </a:spcAft>
               <a:defRPr sz="860">
                 <a:solidFill>
@@ -3449,10 +3449,10 @@
           <a:p>
             <a:pPr algn="l">
               <a:lnSpc>
-                <a:spcPct val="118000"/>
+                <a:spcPct val="120000"/>
               </a:lnSpc>
               <a:spcAft>
-                <a:spcPts val="300"/>
+                <a:spcPts val="400"/>
               </a:spcAft>
               <a:defRPr sz="860">
                 <a:solidFill>
@@ -3468,10 +3468,10 @@
           <a:p>
             <a:pPr algn="l">
               <a:lnSpc>
-                <a:spcPct val="118000"/>
+                <a:spcPct val="120000"/>
               </a:lnSpc>
               <a:spcAft>
-                <a:spcPts val="300"/>
+                <a:spcPts val="400"/>
               </a:spcAft>
               <a:defRPr sz="860">
                 <a:solidFill>
@@ -3487,10 +3487,10 @@
           <a:p>
             <a:pPr algn="l">
               <a:lnSpc>
-                <a:spcPct val="118000"/>
+                <a:spcPct val="120000"/>
               </a:lnSpc>
               <a:spcAft>
-                <a:spcPts val="300"/>
+                <a:spcPts val="400"/>
               </a:spcAft>
               <a:defRPr sz="860">
                 <a:solidFill>
@@ -3506,10 +3506,10 @@
           <a:p>
             <a:pPr algn="l">
               <a:lnSpc>
-                <a:spcPct val="118000"/>
+                <a:spcPct val="120000"/>
               </a:lnSpc>
               <a:spcAft>
-                <a:spcPts val="300"/>
+                <a:spcPts val="400"/>
               </a:spcAft>
               <a:defRPr sz="860">
                 <a:solidFill>
@@ -3525,10 +3525,10 @@
           <a:p>
             <a:pPr algn="l">
               <a:lnSpc>
-                <a:spcPct val="118000"/>
+                <a:spcPct val="120000"/>
               </a:lnSpc>
               <a:spcAft>
-                <a:spcPts val="300"/>
+                <a:spcPts val="400"/>
               </a:spcAft>
               <a:defRPr sz="860">
                 <a:solidFill>
@@ -3538,16 +3538,16 @@
               </a:defRPr>
             </a:pPr>
             <a:r>
-              <a:t>• HIPAA-Compliant Privacy &amp; Data Anonymization (NEW): Enforces AES-256 end-to-end encryption and patient ID pseudonymization.</a:t>
+              <a:t>• HIPAA-Compliant Privacy &amp; Data Anonymization: Enforces AES-256 end-to-end encryption and patient ID pseudonymization.</a:t>
             </a:r>
           </a:p>
           <a:p>
             <a:pPr algn="l">
               <a:lnSpc>
-                <a:spcPct val="118000"/>
+                <a:spcPct val="120000"/>
               </a:lnSpc>
               <a:spcAft>
-                <a:spcPts val="300"/>
+                <a:spcPts val="400"/>
               </a:spcAft>
               <a:defRPr sz="860">
                 <a:solidFill>
@@ -3557,7 +3557,7 @@
               </a:defRPr>
             </a:pPr>
             <a:r>
-              <a:t>• Interactive Real-Time Grounding Exercises (NEW): Embedded interactive breathwork and sensory grounding widgets inside the chat UI.</a:t>
+              <a:t>• Interactive Real-Time Grounding Exercises: Embedded interactive breathwork and sensory grounding widgets inside the chat UI.</a:t>
             </a:r>
           </a:p>
         </p:txBody>
@@ -3586,7 +3586,7 @@
           <a:p>
             <a:pPr algn="l">
               <a:spcAft>
-                <a:spcPts val="300"/>
+                <a:spcPts val="400"/>
               </a:spcAft>
               <a:defRPr sz="1350" b="1">
                 <a:solidFill>
@@ -3602,10 +3602,10 @@
           <a:p>
             <a:pPr algn="l">
               <a:lnSpc>
-                <a:spcPct val="118000"/>
+                <a:spcPct val="120000"/>
               </a:lnSpc>
               <a:spcAft>
-                <a:spcPts val="300"/>
+                <a:spcPts val="400"/>
               </a:spcAft>
               <a:defRPr sz="860">
                 <a:solidFill>
@@ -3644,7 +3644,7 @@
           <a:p>
             <a:pPr algn="l">
               <a:spcAft>
-                <a:spcPts val="300"/>
+                <a:spcPts val="400"/>
               </a:spcAft>
               <a:defRPr sz="1350" b="1">
                 <a:solidFill>
@@ -3660,10 +3660,10 @@
           <a:p>
             <a:pPr algn="l">
               <a:lnSpc>
-                <a:spcPct val="118000"/>
+                <a:spcPct val="120000"/>
               </a:lnSpc>
               <a:spcAft>
-                <a:spcPts val="300"/>
+                <a:spcPts val="400"/>
               </a:spcAft>
               <a:defRPr sz="860">
                 <a:solidFill>
@@ -3679,10 +3679,10 @@
           <a:p>
             <a:pPr algn="l">
               <a:lnSpc>
-                <a:spcPct val="118000"/>
+                <a:spcPct val="120000"/>
               </a:lnSpc>
               <a:spcAft>
-                <a:spcPts val="300"/>
+                <a:spcPts val="400"/>
               </a:spcAft>
               <a:defRPr sz="860">
                 <a:solidFill>
@@ -3698,10 +3698,10 @@
           <a:p>
             <a:pPr algn="l">
               <a:lnSpc>
-                <a:spcPct val="118000"/>
+                <a:spcPct val="120000"/>
               </a:lnSpc>
               <a:spcAft>
-                <a:spcPts val="300"/>
+                <a:spcPts val="400"/>
               </a:spcAft>
               <a:defRPr sz="860">
                 <a:solidFill>
@@ -3717,10 +3717,10 @@
           <a:p>
             <a:pPr algn="l">
               <a:lnSpc>
-                <a:spcPct val="118000"/>
+                <a:spcPct val="120000"/>
               </a:lnSpc>
               <a:spcAft>
-                <a:spcPts val="300"/>
+                <a:spcPts val="400"/>
               </a:spcAft>
               <a:defRPr sz="860">
                 <a:solidFill>
@@ -3736,10 +3736,10 @@
           <a:p>
             <a:pPr algn="l">
               <a:lnSpc>
-                <a:spcPct val="118000"/>
+                <a:spcPct val="120000"/>
               </a:lnSpc>
               <a:spcAft>
-                <a:spcPts val="300"/>
+                <a:spcPts val="400"/>
               </a:spcAft>
               <a:defRPr sz="860">
                 <a:solidFill>
@@ -3755,10 +3755,10 @@
           <a:p>
             <a:pPr algn="l">
               <a:lnSpc>
-                <a:spcPct val="118000"/>
+                <a:spcPct val="120000"/>
               </a:lnSpc>
               <a:spcAft>
-                <a:spcPts val="300"/>
+                <a:spcPts val="400"/>
               </a:spcAft>
               <a:defRPr sz="860">
                 <a:solidFill>
@@ -3774,10 +3774,10 @@
           <a:p>
             <a:pPr algn="l">
               <a:lnSpc>
-                <a:spcPct val="118000"/>
+                <a:spcPct val="120000"/>
               </a:lnSpc>
               <a:spcAft>
-                <a:spcPts val="300"/>
+                <a:spcPts val="400"/>
               </a:spcAft>
               <a:defRPr sz="860">
                 <a:solidFill>
@@ -3787,16 +3787,16 @@
               </a:defRPr>
             </a:pPr>
             <a:r>
-              <a:t>Step 7: Explainable AI Attribution Computation (NEW): Calculate SHAP and LIME token attribution heatmaps for psychiatrist auditing.</a:t>
+              <a:t>Step 7: Explainable AI Attribution Computation: Calculate SHAP and LIME token attribution heatmaps for psychiatrist auditing.</a:t>
             </a:r>
           </a:p>
           <a:p>
             <a:pPr algn="l">
               <a:lnSpc>
-                <a:spcPct val="118000"/>
+                <a:spcPct val="120000"/>
               </a:lnSpc>
               <a:spcAft>
-                <a:spcPts val="300"/>
+                <a:spcPts val="400"/>
               </a:spcAft>
               <a:defRPr sz="860">
                 <a:solidFill>
@@ -3806,7 +3806,7 @@
               </a:defRPr>
             </a:pPr>
             <a:r>
-              <a:t>Step 8: Automated Patient Re-Engagement (NEW): Dispatch gentle automated check-in notifications when patients miss daily updates.</a:t>
+              <a:t>Step 8: Automated Patient Re-Engagement: Dispatch gentle automated check-in notifications when patients miss daily updates.</a:t>
             </a:r>
           </a:p>
         </p:txBody>
@@ -3835,7 +3835,7 @@
           <a:p>
             <a:pPr algn="l">
               <a:spcAft>
-                <a:spcPts val="300"/>
+                <a:spcPts val="400"/>
               </a:spcAft>
               <a:defRPr sz="1350" b="1">
                 <a:solidFill>
@@ -3851,10 +3851,10 @@
           <a:p>
             <a:pPr algn="l">
               <a:lnSpc>
-                <a:spcPct val="118000"/>
+                <a:spcPct val="120000"/>
               </a:lnSpc>
               <a:spcAft>
-                <a:spcPts val="300"/>
+                <a:spcPts val="400"/>
               </a:spcAft>
               <a:defRPr sz="860">
                 <a:solidFill>
@@ -3870,10 +3870,10 @@
           <a:p>
             <a:pPr algn="l">
               <a:lnSpc>
-                <a:spcPct val="118000"/>
+                <a:spcPct val="120000"/>
               </a:lnSpc>
               <a:spcAft>
-                <a:spcPts val="300"/>
+                <a:spcPts val="400"/>
               </a:spcAft>
               <a:defRPr sz="860">
                 <a:solidFill>
@@ -3889,10 +3889,10 @@
           <a:p>
             <a:pPr algn="l">
               <a:lnSpc>
-                <a:spcPct val="118000"/>
+                <a:spcPct val="120000"/>
               </a:lnSpc>
               <a:spcAft>
-                <a:spcPts val="300"/>
+                <a:spcPts val="400"/>
               </a:spcAft>
               <a:defRPr sz="860">
                 <a:solidFill>
@@ -3902,16 +3902,16 @@
               </a:defRPr>
             </a:pPr>
             <a:r>
-              <a:t>• EmpatheticDialogues Corpus (NEW): 25,000 emotionally grounded conversational interactions fine-tuning empathetic validation.</a:t>
+              <a:t>• EmpatheticDialogues Corpus: 25,000 emotionally grounded conversational interactions fine-tuning empathetic validation.</a:t>
             </a:r>
           </a:p>
           <a:p>
             <a:pPr algn="l">
               <a:lnSpc>
-                <a:spcPct val="118000"/>
+                <a:spcPct val="120000"/>
               </a:lnSpc>
               <a:spcAft>
-                <a:spcPts val="300"/>
+                <a:spcPts val="400"/>
               </a:spcAft>
               <a:defRPr sz="860">
                 <a:solidFill>
@@ -3921,7 +3921,7 @@
               </a:defRPr>
             </a:pPr>
             <a:r>
-              <a:t>• Behavioral Health Q&amp;A Corpus (NEW): Expert clinical psychology Q&amp;A datasets calibrating Tier-2 neurobiological psychoeducation.</a:t>
+              <a:t>• Behavioral Health Q&amp;A Corpus: Expert clinical psychology Q&amp;A datasets calibrating Tier-2 neurobiological psychoeducation.</a:t>
             </a:r>
           </a:p>
         </p:txBody>
@@ -3950,7 +3950,7 @@
           <a:p>
             <a:pPr algn="l">
               <a:spcAft>
-                <a:spcPts val="300"/>
+                <a:spcPts val="400"/>
               </a:spcAft>
               <a:defRPr sz="1350" b="1">
                 <a:solidFill>
@@ -3966,10 +3966,10 @@
           <a:p>
             <a:pPr algn="l">
               <a:lnSpc>
-                <a:spcPct val="118000"/>
+                <a:spcPct val="120000"/>
               </a:lnSpc>
               <a:spcAft>
-                <a:spcPts val="300"/>
+                <a:spcPts val="400"/>
               </a:spcAft>
               <a:defRPr sz="860">
                 <a:solidFill>
@@ -3985,10 +3985,10 @@
           <a:p>
             <a:pPr algn="l">
               <a:lnSpc>
-                <a:spcPct val="118000"/>
+                <a:spcPct val="120000"/>
               </a:lnSpc>
               <a:spcAft>
-                <a:spcPts val="300"/>
+                <a:spcPts val="400"/>
               </a:spcAft>
               <a:defRPr sz="860">
                 <a:solidFill>
@@ -4004,10 +4004,10 @@
           <a:p>
             <a:pPr algn="l">
               <a:lnSpc>
-                <a:spcPct val="118000"/>
+                <a:spcPct val="120000"/>
               </a:lnSpc>
               <a:spcAft>
-                <a:spcPts val="300"/>
+                <a:spcPts val="400"/>
               </a:spcAft>
               <a:defRPr sz="860">
                 <a:solidFill>
@@ -4023,10 +4023,10 @@
           <a:p>
             <a:pPr algn="l">
               <a:lnSpc>
-                <a:spcPct val="118000"/>
+                <a:spcPct val="120000"/>
               </a:lnSpc>
               <a:spcAft>
-                <a:spcPts val="300"/>
+                <a:spcPts val="400"/>
               </a:spcAft>
               <a:defRPr sz="860">
                 <a:solidFill>
@@ -4042,10 +4042,10 @@
           <a:p>
             <a:pPr algn="l">
               <a:lnSpc>
-                <a:spcPct val="118000"/>
+                <a:spcPct val="120000"/>
               </a:lnSpc>
               <a:spcAft>
-                <a:spcPts val="300"/>
+                <a:spcPts val="400"/>
               </a:spcAft>
               <a:defRPr sz="860">
                 <a:solidFill>
@@ -4061,10 +4061,10 @@
           <a:p>
             <a:pPr algn="l">
               <a:lnSpc>
-                <a:spcPct val="118000"/>
+                <a:spcPct val="120000"/>
               </a:lnSpc>
               <a:spcAft>
-                <a:spcPts val="300"/>
+                <a:spcPts val="400"/>
               </a:spcAft>
               <a:defRPr sz="860">
                 <a:solidFill>
@@ -4074,16 +4074,16 @@
               </a:defRPr>
             </a:pPr>
             <a:r>
-              <a:t>Scenario 2: Acute Crisis &amp; Suicide Risk Triage (NEW)</a:t>
+              <a:t>Scenario 2: Acute Crisis &amp; Suicide Risk Triage</a:t>
             </a:r>
           </a:p>
           <a:p>
             <a:pPr algn="l">
               <a:lnSpc>
-                <a:spcPct val="118000"/>
+                <a:spcPct val="120000"/>
               </a:lnSpc>
               <a:spcAft>
-                <a:spcPts val="300"/>
+                <a:spcPts val="400"/>
               </a:spcAft>
               <a:defRPr sz="860">
                 <a:solidFill>
@@ -4099,10 +4099,10 @@
           <a:p>
             <a:pPr algn="l">
               <a:lnSpc>
-                <a:spcPct val="118000"/>
+                <a:spcPct val="120000"/>
               </a:lnSpc>
               <a:spcAft>
-                <a:spcPts val="300"/>
+                <a:spcPts val="400"/>
               </a:spcAft>
               <a:defRPr sz="860">
                 <a:solidFill>
@@ -4141,7 +4141,7 @@
           <a:p>
             <a:pPr algn="l">
               <a:spcAft>
-                <a:spcPts val="300"/>
+                <a:spcPts val="400"/>
               </a:spcAft>
               <a:defRPr sz="1350" b="1">
                 <a:solidFill>
@@ -4157,10 +4157,10 @@
           <a:p>
             <a:pPr algn="l">
               <a:lnSpc>
-                <a:spcPct val="118000"/>
+                <a:spcPct val="120000"/>
               </a:lnSpc>
               <a:spcAft>
-                <a:spcPts val="300"/>
+                <a:spcPts val="400"/>
               </a:spcAft>
               <a:defRPr sz="860">
                 <a:solidFill>

</xml_diff>

<commit_message>
Deeply expand Abstract into 2 clear paragraphs, push Highlights down vertically, and maintain generous line gaps for PDF and PPTX
</commit_message>
<xml_diff>
--- a/Final_Submission_Pack/3_Project_Poster.pptx
+++ b/Final_Submission_Pack/3_Project_Poster.pptx
@@ -3265,7 +3265,7 @@
         <p:spPr>
           <a:xfrm>
             <a:off x="365760" y="1737360"/>
-            <a:ext cx="4572000" cy="2286000"/>
+            <a:ext cx="4572000" cy="2560320"/>
           </a:xfrm>
           <a:prstGeom prst="rect">
             <a:avLst/>
@@ -3309,7 +3309,26 @@
               </a:defRPr>
             </a:pPr>
             <a:r>
-              <a:t>Access to professional mental healthcare remains a critical global challenge due to exorbitant session fees, severe shortages of qualified psychiatrists, and persistent social stigma. Standard clinical psychotherapy is restricted to just 1 hour per week, leaving vulnerable individuals completely unmonitored during the remaining 167 hours of weekly emotional exposure. Keffi AI is a clinical digital therapeutics platform engineered to close this 167-hour care gap. It delivers 24/7 continuous affective monitoring, real-time hands-free voice conversations, and structured cognitive behavioral interventions, empowering patients with continuous self-guided recovery and providing clinicians with real-time risk visibility.</a:t>
+              <a:t>Access to professional mental healthcare remains a critical global emergency. Millions of individuals face insurmountable barriers including high therapy fees (often exceeding $150 per hour), severe shortages of qualified psychiatrists, and lingering societal stigma. Traditional clinical psychotherapy is restricted to just 1 hour per week. This leaves vulnerable patients completely unmonitored during the remaining 167 hours of weekly emotional stress, creating a dangerous care gap where panic attacks, depression, and self-harm risks frequently escalate unnoticed.</a:t>
+            </a:r>
+          </a:p>
+          <a:p>
+            <a:pPr algn="l">
+              <a:lnSpc>
+                <a:spcPct val="120000"/>
+              </a:lnSpc>
+              <a:spcAft>
+                <a:spcPts val="400"/>
+              </a:spcAft>
+              <a:defRPr sz="860">
+                <a:solidFill>
+                  <a:srgbClr val="1E293B"/>
+                </a:solidFill>
+                <a:latin typeface="Times New Roman"/>
+              </a:defRPr>
+            </a:pPr>
+            <a:r>
+              <a:t>Keffi AI is an AI-powered clinical digital therapeutics platform engineered to close this 167-hour care gap. It delivers 24/7 continuous affective monitoring, hands-free real-time voice interaction, and structured 3-tier psychological interventions (Rogerian validation, amygdala/cortisol psychoeducation, and CBT grounding skills). By incorporating high-concurrency WAL database storage, explainable AI (SHAP &amp; LIME), automated n8n crisis alert webhooks, and an Admin Clinical Dashboard, Keffi AI empowers patients with continuous self-guided recovery while equipping attending psychiatrists with real-time risk visibility.</a:t>
             </a:r>
           </a:p>
         </p:txBody>
@@ -3322,8 +3341,8 @@
         </p:nvSpPr>
         <p:spPr>
           <a:xfrm>
-            <a:off x="365760" y="4206240"/>
-            <a:ext cx="4572000" cy="6126480"/>
+            <a:off x="365760" y="4389120"/>
+            <a:ext cx="4572000" cy="5943600"/>
           </a:xfrm>
           <a:prstGeom prst="rect">
             <a:avLst/>

</xml_diff>